<commit_message>
Update presentation: Belbin roles, evidence images, agenda + sprint outcomes + prof dev slides
</commit_message>
<xml_diff>
--- a/NinjaQuiz-Presentation.pptx
+++ b/NinjaQuiz-Presentation.pptx
@@ -9,6 +9,7 @@
   </p:notesMasterIdLst>
   <p:sldIdLst>
     <p:sldId id="256" r:id="rId2"/>
+    <p:sldId id="274" r:id="rId25"/>
     <p:sldId id="257" r:id="rId3"/>
     <p:sldId id="258" r:id="rId4"/>
     <p:sldId id="259" r:id="rId5"/>
@@ -17,6 +18,7 @@
     <p:sldId id="262" r:id="rId8"/>
     <p:sldId id="263" r:id="rId9"/>
     <p:sldId id="264" r:id="rId10"/>
+    <p:sldId id="275" r:id="rId26"/>
     <p:sldId id="265" r:id="rId11"/>
     <p:sldId id="266" r:id="rId12"/>
     <p:sldId id="267" r:id="rId13"/>
@@ -25,6 +27,7 @@
     <p:sldId id="270" r:id="rId16"/>
     <p:sldId id="271" r:id="rId17"/>
     <p:sldId id="272" r:id="rId18"/>
+    <p:sldId id="276" r:id="rId27"/>
     <p:sldId id="273" r:id="rId19"/>
   </p:sldIdLst>
   <p:sldSz cx="9144000" cy="5143500" type="screen16x9"/>
@@ -2350,6 +2353,1498 @@
 
 <file path=ppt/slides/slide10.xml><?xml version="1.0" encoding="utf-8"?>
 <p:sld xmlns:a="http://schemas.openxmlformats.org/drawingml/2006/main" xmlns:r="http://schemas.openxmlformats.org/officeDocument/2006/relationships" xmlns:p="http://schemas.openxmlformats.org/presentationml/2006/main">
+  <p:cSld name="Slide 9">
+    <p:bg>
+      <p:bgPr>
+        <a:solidFill>
+          <a:srgbClr val="FFFFFF"/>
+        </a:solidFill>
+        <a:effectLst/>
+      </p:bgPr>
+    </p:bg>
+    <p:spTree>
+      <p:nvGrpSpPr>
+        <p:cNvPr id="1" name=""/>
+        <p:cNvGrpSpPr/>
+        <p:nvPr/>
+      </p:nvGrpSpPr>
+      <p:grpSpPr>
+        <a:xfrm>
+          <a:off x="0" y="0"/>
+          <a:ext cx="0" cy="0"/>
+          <a:chOff x="0" y="0"/>
+          <a:chExt cx="0" cy="0"/>
+        </a:xfrm>
+      </p:grpSpPr>
+      <p:sp>
+        <p:nvSpPr>
+          <p:cNvPr id="2" name="Shape 0"/>
+          <p:cNvSpPr/>
+          <p:nvPr/>
+        </p:nvSpPr>
+        <p:spPr>
+          <a:xfrm>
+            <a:off x="8458200" y="201168"/>
+            <a:ext cx="256032" cy="256032"/>
+          </a:xfrm>
+          <a:prstGeom prst="ellipse">
+            <a:avLst/>
+          </a:prstGeom>
+          <a:solidFill>
+            <a:srgbClr val="DDDDDD"/>
+          </a:solidFill>
+          <a:ln/>
+        </p:spPr>
+        <p:txBody>
+          <a:bodyPr/>
+          <a:lstStyle/>
+          <a:p>
+            <a:endParaRPr lang="en-GB"/>
+          </a:p>
+        </p:txBody>
+      </p:sp>
+      <p:sp>
+        <p:nvSpPr>
+          <p:cNvPr id="3" name="Text 1"/>
+          <p:cNvSpPr/>
+          <p:nvPr/>
+        </p:nvSpPr>
+        <p:spPr>
+          <a:xfrm>
+            <a:off x="457200" y="274320"/>
+            <a:ext cx="6400800" cy="228600"/>
+          </a:xfrm>
+          <a:prstGeom prst="rect">
+            <a:avLst/>
+          </a:prstGeom>
+          <a:noFill/>
+          <a:ln/>
+        </p:spPr>
+        <p:txBody>
+          <a:bodyPr wrap="square" rtlCol="0" anchor="ctr"/>
+          <a:lstStyle/>
+          <a:p>
+            <a:pPr marL="0" indent="0">
+              <a:buNone/>
+            </a:pPr>
+            <a:r>
+              <a:rPr lang="en-US" sz="1000" b="1" kern="0" spc="200" dirty="0">
+                <a:solidFill>
+                  <a:srgbClr val="888888"/>
+                </a:solidFill>
+                <a:latin typeface="Arial" pitchFamily="34" charset="0"/>
+                <a:ea typeface="Arial" pitchFamily="34" charset="-122"/>
+                <a:cs typeface="Arial" pitchFamily="34" charset="-120"/>
+              </a:rPr>
+              <a:t>DELIVERY PROCESS</a:t>
+            </a:r>
+            <a:endParaRPr lang="en-US" sz="1000" dirty="0"/>
+          </a:p>
+        </p:txBody>
+      </p:sp>
+      <p:sp>
+        <p:nvSpPr>
+          <p:cNvPr id="4" name="Text 2"/>
+          <p:cNvSpPr/>
+          <p:nvPr/>
+        </p:nvSpPr>
+        <p:spPr>
+          <a:xfrm>
+            <a:off x="3657600" y="4919472"/>
+            <a:ext cx="5212080" cy="182880"/>
+          </a:xfrm>
+          <a:prstGeom prst="rect">
+            <a:avLst/>
+          </a:prstGeom>
+          <a:noFill/>
+          <a:ln/>
+        </p:spPr>
+        <p:txBody>
+          <a:bodyPr wrap="square" rtlCol="0" anchor="ctr"/>
+          <a:lstStyle/>
+          <a:p>
+            <a:pPr marL="0" indent="0" algn="r">
+              <a:buNone/>
+            </a:pPr>
+            <a:r>
+              <a:rPr lang="en-US" sz="900" dirty="0">
+                <a:solidFill>
+                  <a:srgbClr val="888888"/>
+                </a:solidFill>
+                <a:latin typeface="Arial" pitchFamily="34" charset="0"/>
+                <a:ea typeface="Arial" pitchFamily="34" charset="-122"/>
+                <a:cs typeface="Arial" pitchFamily="34" charset="-120"/>
+              </a:rPr>
+              <a:t>NINJA QUIZ  ·  503IT  ·  09 / 18</a:t>
+            </a:r>
+            <a:endParaRPr lang="en-US" sz="900" dirty="0"/>
+          </a:p>
+        </p:txBody>
+      </p:sp>
+      <p:sp>
+        <p:nvSpPr>
+          <p:cNvPr id="5" name="Text 3"/>
+          <p:cNvSpPr/>
+          <p:nvPr/>
+        </p:nvSpPr>
+        <p:spPr>
+          <a:xfrm>
+            <a:off x="457200" y="685800"/>
+            <a:ext cx="8229600" cy="812800"/>
+          </a:xfrm>
+          <a:prstGeom prst="rect">
+            <a:avLst/>
+          </a:prstGeom>
+          <a:noFill/>
+          <a:ln/>
+        </p:spPr>
+        <p:txBody>
+          <a:bodyPr wrap="square" rtlCol="0" anchor="ctr"/>
+          <a:lstStyle/>
+          <a:p>
+            <a:pPr marL="0" indent="0">
+              <a:buNone/>
+            </a:pPr>
+            <a:r>
+              <a:rPr lang="en-US" sz="3200" b="1" dirty="0">
+                <a:solidFill>
+                  <a:srgbClr val="111111"/>
+                </a:solidFill>
+                <a:latin typeface="Arial Black" pitchFamily="34" charset="0"/>
+                <a:ea typeface="Arial Black" pitchFamily="34" charset="-122"/>
+                <a:cs typeface="Arial Black" pitchFamily="34" charset="-120"/>
+              </a:rPr>
+              <a:t>Built in five sprints.</a:t>
+            </a:r>
+            <a:endParaRPr lang="en-US" sz="3200" dirty="0"/>
+          </a:p>
+        </p:txBody>
+      </p:sp>
+      <p:sp>
+        <p:nvSpPr>
+          <p:cNvPr id="6" name="Shape 4"/>
+          <p:cNvSpPr/>
+          <p:nvPr/>
+        </p:nvSpPr>
+        <p:spPr>
+          <a:xfrm>
+            <a:off x="457200" y="1463040"/>
+            <a:ext cx="8229600" cy="10973"/>
+          </a:xfrm>
+          <a:prstGeom prst="rect">
+            <a:avLst/>
+          </a:prstGeom>
+          <a:solidFill>
+            <a:srgbClr val="EEEEEE"/>
+          </a:solidFill>
+          <a:ln/>
+        </p:spPr>
+        <p:txBody>
+          <a:bodyPr/>
+          <a:lstStyle/>
+          <a:p>
+            <a:endParaRPr lang="en-GB"/>
+          </a:p>
+        </p:txBody>
+      </p:sp>
+      <p:sp>
+        <p:nvSpPr>
+          <p:cNvPr id="7" name="Text 5"/>
+          <p:cNvSpPr/>
+          <p:nvPr/>
+        </p:nvSpPr>
+        <p:spPr>
+          <a:xfrm>
+            <a:off x="457200" y="1609344"/>
+            <a:ext cx="868680" cy="411480"/>
+          </a:xfrm>
+          <a:prstGeom prst="rect">
+            <a:avLst/>
+          </a:prstGeom>
+          <a:noFill/>
+          <a:ln/>
+        </p:spPr>
+        <p:txBody>
+          <a:bodyPr wrap="square" rtlCol="0" anchor="ctr">
+            <a:normAutofit/>
+          </a:bodyPr>
+          <a:lstStyle/>
+          <a:p>
+            <a:pPr marL="0" indent="0">
+              <a:buNone/>
+            </a:pPr>
+            <a:r>
+              <a:rPr lang="en-US" sz="2000" b="1" dirty="0">
+                <a:solidFill>
+                  <a:srgbClr val="FFCD00"/>
+                </a:solidFill>
+                <a:latin typeface="Arial Black" pitchFamily="34" charset="0"/>
+                <a:ea typeface="Arial Black" pitchFamily="34" charset="-122"/>
+                <a:cs typeface="Arial Black" pitchFamily="34" charset="-120"/>
+              </a:rPr>
+              <a:t>01</a:t>
+            </a:r>
+            <a:endParaRPr lang="en-US" sz="2000" dirty="0"/>
+          </a:p>
+        </p:txBody>
+      </p:sp>
+      <p:sp>
+        <p:nvSpPr>
+          <p:cNvPr id="8" name="Text 6"/>
+          <p:cNvSpPr/>
+          <p:nvPr/>
+        </p:nvSpPr>
+        <p:spPr>
+          <a:xfrm>
+            <a:off x="1371600" y="1591056"/>
+            <a:ext cx="7315200" cy="292608"/>
+          </a:xfrm>
+          <a:prstGeom prst="rect">
+            <a:avLst/>
+          </a:prstGeom>
+          <a:noFill/>
+          <a:ln/>
+        </p:spPr>
+        <p:txBody>
+          <a:bodyPr wrap="square" rtlCol="0" anchor="ctr"/>
+          <a:lstStyle/>
+          <a:p>
+            <a:pPr marL="0" indent="0">
+              <a:buNone/>
+            </a:pPr>
+            <a:r>
+              <a:rPr lang="en-US" sz="1700" b="1" dirty="0">
+                <a:solidFill>
+                  <a:srgbClr val="111111"/>
+                </a:solidFill>
+                <a:latin typeface="Arial Black" pitchFamily="34" charset="0"/>
+                <a:ea typeface="Arial Black" pitchFamily="34" charset="-122"/>
+                <a:cs typeface="Arial Black" pitchFamily="34" charset="-120"/>
+              </a:rPr>
+              <a:t>Sprint 1  —  Login &amp; menu</a:t>
+            </a:r>
+            <a:endParaRPr lang="en-US" sz="1700" dirty="0"/>
+          </a:p>
+        </p:txBody>
+      </p:sp>
+      <p:sp>
+        <p:nvSpPr>
+          <p:cNvPr id="9" name="Text 7"/>
+          <p:cNvSpPr/>
+          <p:nvPr/>
+        </p:nvSpPr>
+        <p:spPr>
+          <a:xfrm>
+            <a:off x="1371600" y="1892808"/>
+            <a:ext cx="7315200" cy="228600"/>
+          </a:xfrm>
+          <a:prstGeom prst="rect">
+            <a:avLst/>
+          </a:prstGeom>
+          <a:noFill/>
+          <a:ln/>
+        </p:spPr>
+        <p:txBody>
+          <a:bodyPr wrap="square" rtlCol="0" anchor="ctr"/>
+          <a:lstStyle/>
+          <a:p>
+            <a:pPr marL="0" indent="0">
+              <a:buNone/>
+            </a:pPr>
+            <a:r>
+              <a:rPr lang="en-US" sz="1200" dirty="0">
+                <a:solidFill>
+                  <a:srgbClr val="888888"/>
+                </a:solidFill>
+                <a:latin typeface="Arial" pitchFamily="34" charset="0"/>
+                <a:ea typeface="Arial" pitchFamily="34" charset="-122"/>
+                <a:cs typeface="Arial" pitchFamily="34" charset="-120"/>
+              </a:rPr>
+              <a:t>Foundation. Every member set up. GitHub branches created.</a:t>
+            </a:r>
+            <a:endParaRPr lang="en-US" sz="1200" dirty="0"/>
+          </a:p>
+        </p:txBody>
+      </p:sp>
+      <p:sp>
+        <p:nvSpPr>
+          <p:cNvPr id="10" name="Text 8"/>
+          <p:cNvSpPr/>
+          <p:nvPr/>
+        </p:nvSpPr>
+        <p:spPr>
+          <a:xfrm>
+            <a:off x="457200" y="2231136"/>
+            <a:ext cx="868680" cy="411480"/>
+          </a:xfrm>
+          <a:prstGeom prst="rect">
+            <a:avLst/>
+          </a:prstGeom>
+          <a:noFill/>
+          <a:ln/>
+        </p:spPr>
+        <p:txBody>
+          <a:bodyPr wrap="square" rtlCol="0" anchor="ctr">
+            <a:normAutofit/>
+          </a:bodyPr>
+          <a:lstStyle/>
+          <a:p>
+            <a:pPr marL="0" indent="0">
+              <a:buNone/>
+            </a:pPr>
+            <a:r>
+              <a:rPr lang="en-US" sz="2000" b="1" dirty="0">
+                <a:solidFill>
+                  <a:srgbClr val="FFCD00"/>
+                </a:solidFill>
+                <a:latin typeface="Arial Black" pitchFamily="34" charset="0"/>
+                <a:ea typeface="Arial Black" pitchFamily="34" charset="-122"/>
+                <a:cs typeface="Arial Black" pitchFamily="34" charset="-120"/>
+              </a:rPr>
+              <a:t>02</a:t>
+            </a:r>
+            <a:endParaRPr lang="en-US" sz="2000" dirty="0"/>
+          </a:p>
+        </p:txBody>
+      </p:sp>
+      <p:sp>
+        <p:nvSpPr>
+          <p:cNvPr id="11" name="Text 9"/>
+          <p:cNvSpPr/>
+          <p:nvPr/>
+        </p:nvSpPr>
+        <p:spPr>
+          <a:xfrm>
+            <a:off x="1371600" y="2212848"/>
+            <a:ext cx="7315200" cy="292608"/>
+          </a:xfrm>
+          <a:prstGeom prst="rect">
+            <a:avLst/>
+          </a:prstGeom>
+          <a:noFill/>
+          <a:ln/>
+        </p:spPr>
+        <p:txBody>
+          <a:bodyPr wrap="square" rtlCol="0" anchor="ctr"/>
+          <a:lstStyle/>
+          <a:p>
+            <a:pPr marL="0" indent="0">
+              <a:buNone/>
+            </a:pPr>
+            <a:r>
+              <a:rPr lang="en-US" sz="1700" b="1" dirty="0">
+                <a:solidFill>
+                  <a:srgbClr val="111111"/>
+                </a:solidFill>
+                <a:latin typeface="Arial Black" pitchFamily="34" charset="0"/>
+                <a:ea typeface="Arial Black" pitchFamily="34" charset="-122"/>
+                <a:cs typeface="Arial Black" pitchFamily="34" charset="-120"/>
+              </a:rPr>
+              <a:t>Sprint 2  —  Game engine</a:t>
+            </a:r>
+            <a:endParaRPr lang="en-US" sz="1700" dirty="0"/>
+          </a:p>
+        </p:txBody>
+      </p:sp>
+      <p:sp>
+        <p:nvSpPr>
+          <p:cNvPr id="12" name="Text 10"/>
+          <p:cNvSpPr/>
+          <p:nvPr/>
+        </p:nvSpPr>
+        <p:spPr>
+          <a:xfrm>
+            <a:off x="1371600" y="2514600"/>
+            <a:ext cx="7315200" cy="228600"/>
+          </a:xfrm>
+          <a:prstGeom prst="rect">
+            <a:avLst/>
+          </a:prstGeom>
+          <a:noFill/>
+          <a:ln/>
+        </p:spPr>
+        <p:txBody>
+          <a:bodyPr wrap="square" rtlCol="0" anchor="ctr"/>
+          <a:lstStyle/>
+          <a:p>
+            <a:pPr marL="0" indent="0">
+              <a:buNone/>
+            </a:pPr>
+            <a:r>
+              <a:rPr lang="en-US" sz="1200" dirty="0">
+                <a:solidFill>
+                  <a:srgbClr val="888888"/>
+                </a:solidFill>
+                <a:latin typeface="Arial" pitchFamily="34" charset="0"/>
+                <a:ea typeface="Arial" pitchFamily="34" charset="-122"/>
+                <a:cs typeface="Arial" pitchFamily="34" charset="-120"/>
+              </a:rPr>
+              <a:t>Core mechanics built. Daily check-ins via WhatsApp.</a:t>
+            </a:r>
+            <a:endParaRPr lang="en-US" sz="1200" dirty="0"/>
+          </a:p>
+        </p:txBody>
+      </p:sp>
+      <p:sp>
+        <p:nvSpPr>
+          <p:cNvPr id="13" name="Text 11"/>
+          <p:cNvSpPr/>
+          <p:nvPr/>
+        </p:nvSpPr>
+        <p:spPr>
+          <a:xfrm>
+            <a:off x="457200" y="2852928"/>
+            <a:ext cx="868680" cy="411480"/>
+          </a:xfrm>
+          <a:prstGeom prst="rect">
+            <a:avLst/>
+          </a:prstGeom>
+          <a:noFill/>
+          <a:ln/>
+        </p:spPr>
+        <p:txBody>
+          <a:bodyPr wrap="square" rtlCol="0" anchor="ctr">
+            <a:normAutofit/>
+          </a:bodyPr>
+          <a:lstStyle/>
+          <a:p>
+            <a:pPr marL="0" indent="0">
+              <a:buNone/>
+            </a:pPr>
+            <a:r>
+              <a:rPr lang="en-US" sz="2000" b="1" dirty="0">
+                <a:solidFill>
+                  <a:srgbClr val="FFCD00"/>
+                </a:solidFill>
+                <a:latin typeface="Arial Black" pitchFamily="34" charset="0"/>
+                <a:ea typeface="Arial Black" pitchFamily="34" charset="-122"/>
+                <a:cs typeface="Arial Black" pitchFamily="34" charset="-120"/>
+              </a:rPr>
+              <a:t>03</a:t>
+            </a:r>
+            <a:endParaRPr lang="en-US" sz="2000" dirty="0"/>
+          </a:p>
+        </p:txBody>
+      </p:sp>
+      <p:sp>
+        <p:nvSpPr>
+          <p:cNvPr id="14" name="Text 12"/>
+          <p:cNvSpPr/>
+          <p:nvPr/>
+        </p:nvSpPr>
+        <p:spPr>
+          <a:xfrm>
+            <a:off x="1371600" y="2834640"/>
+            <a:ext cx="7315200" cy="292608"/>
+          </a:xfrm>
+          <a:prstGeom prst="rect">
+            <a:avLst/>
+          </a:prstGeom>
+          <a:noFill/>
+          <a:ln/>
+        </p:spPr>
+        <p:txBody>
+          <a:bodyPr wrap="square" rtlCol="0" anchor="ctr"/>
+          <a:lstStyle/>
+          <a:p>
+            <a:pPr marL="0" indent="0">
+              <a:buNone/>
+            </a:pPr>
+            <a:r>
+              <a:rPr lang="en-US" sz="1700" b="1" dirty="0">
+                <a:solidFill>
+                  <a:srgbClr val="111111"/>
+                </a:solidFill>
+                <a:latin typeface="Arial Black" pitchFamily="34" charset="0"/>
+                <a:ea typeface="Arial Black" pitchFamily="34" charset="-122"/>
+                <a:cs typeface="Arial Black" pitchFamily="34" charset="-120"/>
+              </a:rPr>
+              <a:t>Sprint 3  —  Slicing &amp; sound</a:t>
+            </a:r>
+            <a:endParaRPr lang="en-US" sz="1700" dirty="0"/>
+          </a:p>
+        </p:txBody>
+      </p:sp>
+      <p:sp>
+        <p:nvSpPr>
+          <p:cNvPr id="15" name="Text 13"/>
+          <p:cNvSpPr/>
+          <p:nvPr/>
+        </p:nvSpPr>
+        <p:spPr>
+          <a:xfrm>
+            <a:off x="1371600" y="3136392"/>
+            <a:ext cx="7315200" cy="228600"/>
+          </a:xfrm>
+          <a:prstGeom prst="rect">
+            <a:avLst/>
+          </a:prstGeom>
+          <a:noFill/>
+          <a:ln/>
+        </p:spPr>
+        <p:txBody>
+          <a:bodyPr wrap="square" rtlCol="0" anchor="ctr"/>
+          <a:lstStyle/>
+          <a:p>
+            <a:pPr marL="0" indent="0">
+              <a:buNone/>
+            </a:pPr>
+            <a:r>
+              <a:rPr lang="en-US" sz="1200" dirty="0">
+                <a:solidFill>
+                  <a:srgbClr val="888888"/>
+                </a:solidFill>
+                <a:latin typeface="Arial" pitchFamily="34" charset="0"/>
+                <a:ea typeface="Arial" pitchFamily="34" charset="-122"/>
+                <a:cs typeface="Arial" pitchFamily="34" charset="-120"/>
+              </a:rPr>
+              <a:t>Visual integration. First merge conflicts resolved.</a:t>
+            </a:r>
+            <a:endParaRPr lang="en-US" sz="1200" dirty="0"/>
+          </a:p>
+        </p:txBody>
+      </p:sp>
+      <p:sp>
+        <p:nvSpPr>
+          <p:cNvPr id="16" name="Text 14"/>
+          <p:cNvSpPr/>
+          <p:nvPr/>
+        </p:nvSpPr>
+        <p:spPr>
+          <a:xfrm>
+            <a:off x="457200" y="3474720"/>
+            <a:ext cx="868680" cy="411480"/>
+          </a:xfrm>
+          <a:prstGeom prst="rect">
+            <a:avLst/>
+          </a:prstGeom>
+          <a:noFill/>
+          <a:ln/>
+        </p:spPr>
+        <p:txBody>
+          <a:bodyPr wrap="square" rtlCol="0" anchor="ctr">
+            <a:normAutofit/>
+          </a:bodyPr>
+          <a:lstStyle/>
+          <a:p>
+            <a:pPr marL="0" indent="0">
+              <a:buNone/>
+            </a:pPr>
+            <a:r>
+              <a:rPr lang="en-US" sz="2000" b="1" dirty="0">
+                <a:solidFill>
+                  <a:srgbClr val="FFCD00"/>
+                </a:solidFill>
+                <a:latin typeface="Arial Black" pitchFamily="34" charset="0"/>
+                <a:ea typeface="Arial Black" pitchFamily="34" charset="-122"/>
+                <a:cs typeface="Arial Black" pitchFamily="34" charset="-120"/>
+              </a:rPr>
+              <a:t>04</a:t>
+            </a:r>
+            <a:endParaRPr lang="en-US" sz="2000" dirty="0"/>
+          </a:p>
+        </p:txBody>
+      </p:sp>
+      <p:sp>
+        <p:nvSpPr>
+          <p:cNvPr id="17" name="Text 15"/>
+          <p:cNvSpPr/>
+          <p:nvPr/>
+        </p:nvSpPr>
+        <p:spPr>
+          <a:xfrm>
+            <a:off x="1371600" y="3456432"/>
+            <a:ext cx="7315200" cy="292608"/>
+          </a:xfrm>
+          <a:prstGeom prst="rect">
+            <a:avLst/>
+          </a:prstGeom>
+          <a:noFill/>
+          <a:ln/>
+        </p:spPr>
+        <p:txBody>
+          <a:bodyPr wrap="square" rtlCol="0" anchor="ctr"/>
+          <a:lstStyle/>
+          <a:p>
+            <a:pPr marL="0" indent="0">
+              <a:buNone/>
+            </a:pPr>
+            <a:r>
+              <a:rPr lang="en-US" sz="1700" b="1" dirty="0">
+                <a:solidFill>
+                  <a:srgbClr val="111111"/>
+                </a:solidFill>
+                <a:latin typeface="Arial Black" pitchFamily="34" charset="0"/>
+                <a:ea typeface="Arial Black" pitchFamily="34" charset="-122"/>
+                <a:cs typeface="Arial Black" pitchFamily="34" charset="-120"/>
+              </a:rPr>
+              <a:t>Sprint 4  —  Leaderboard</a:t>
+            </a:r>
+            <a:endParaRPr lang="en-US" sz="1700" dirty="0"/>
+          </a:p>
+        </p:txBody>
+      </p:sp>
+      <p:sp>
+        <p:nvSpPr>
+          <p:cNvPr id="18" name="Text 16"/>
+          <p:cNvSpPr/>
+          <p:nvPr/>
+        </p:nvSpPr>
+        <p:spPr>
+          <a:xfrm>
+            <a:off x="1371600" y="3758184"/>
+            <a:ext cx="7315200" cy="228600"/>
+          </a:xfrm>
+          <a:prstGeom prst="rect">
+            <a:avLst/>
+          </a:prstGeom>
+          <a:noFill/>
+          <a:ln/>
+        </p:spPr>
+        <p:txBody>
+          <a:bodyPr wrap="square" rtlCol="0" anchor="ctr"/>
+          <a:lstStyle/>
+          <a:p>
+            <a:pPr marL="0" indent="0">
+              <a:buNone/>
+            </a:pPr>
+            <a:r>
+              <a:rPr lang="en-US" sz="1200" dirty="0">
+                <a:solidFill>
+                  <a:srgbClr val="888888"/>
+                </a:solidFill>
+                <a:latin typeface="Arial" pitchFamily="34" charset="0"/>
+                <a:ea typeface="Arial" pitchFamily="34" charset="-122"/>
+                <a:cs typeface="Arial" pitchFamily="34" charset="-120"/>
+              </a:rPr>
+              <a:t>Peer testing begins. Feedback collected and logged.</a:t>
+            </a:r>
+            <a:endParaRPr lang="en-US" sz="1200" dirty="0"/>
+          </a:p>
+        </p:txBody>
+      </p:sp>
+      <p:sp>
+        <p:nvSpPr>
+          <p:cNvPr id="19" name="Text 17"/>
+          <p:cNvSpPr/>
+          <p:nvPr/>
+        </p:nvSpPr>
+        <p:spPr>
+          <a:xfrm>
+            <a:off x="457200" y="4096512"/>
+            <a:ext cx="868680" cy="411480"/>
+          </a:xfrm>
+          <a:prstGeom prst="rect">
+            <a:avLst/>
+          </a:prstGeom>
+          <a:noFill/>
+          <a:ln/>
+        </p:spPr>
+        <p:txBody>
+          <a:bodyPr wrap="square" rtlCol="0" anchor="ctr">
+            <a:normAutofit/>
+          </a:bodyPr>
+          <a:lstStyle/>
+          <a:p>
+            <a:pPr marL="0" indent="0">
+              <a:buNone/>
+            </a:pPr>
+            <a:r>
+              <a:rPr lang="en-US" sz="2000" b="1" dirty="0">
+                <a:solidFill>
+                  <a:srgbClr val="FFCD00"/>
+                </a:solidFill>
+                <a:latin typeface="Arial Black" pitchFamily="34" charset="0"/>
+                <a:ea typeface="Arial Black" pitchFamily="34" charset="-122"/>
+                <a:cs typeface="Arial Black" pitchFamily="34" charset="-120"/>
+              </a:rPr>
+              <a:t>05</a:t>
+            </a:r>
+            <a:endParaRPr lang="en-US" sz="2000" dirty="0"/>
+          </a:p>
+        </p:txBody>
+      </p:sp>
+      <p:sp>
+        <p:nvSpPr>
+          <p:cNvPr id="20" name="Text 18"/>
+          <p:cNvSpPr/>
+          <p:nvPr/>
+        </p:nvSpPr>
+        <p:spPr>
+          <a:xfrm>
+            <a:off x="1371600" y="4078224"/>
+            <a:ext cx="7315200" cy="292608"/>
+          </a:xfrm>
+          <a:prstGeom prst="rect">
+            <a:avLst/>
+          </a:prstGeom>
+          <a:noFill/>
+          <a:ln/>
+        </p:spPr>
+        <p:txBody>
+          <a:bodyPr wrap="square" rtlCol="0" anchor="ctr"/>
+          <a:lstStyle/>
+          <a:p>
+            <a:pPr marL="0" indent="0">
+              <a:buNone/>
+            </a:pPr>
+            <a:r>
+              <a:rPr lang="en-US" sz="1700" b="1" dirty="0">
+                <a:solidFill>
+                  <a:srgbClr val="111111"/>
+                </a:solidFill>
+                <a:latin typeface="Arial Black" pitchFamily="34" charset="0"/>
+                <a:ea typeface="Arial Black" pitchFamily="34" charset="-122"/>
+                <a:cs typeface="Arial Black" pitchFamily="34" charset="-120"/>
+              </a:rPr>
+              <a:t>Sprint 5  —  Testing &amp; polish</a:t>
+            </a:r>
+            <a:endParaRPr lang="en-US" sz="1700" dirty="0"/>
+          </a:p>
+        </p:txBody>
+      </p:sp>
+      <p:sp>
+        <p:nvSpPr>
+          <p:cNvPr id="21" name="Text 19"/>
+          <p:cNvSpPr/>
+          <p:nvPr/>
+        </p:nvSpPr>
+        <p:spPr>
+          <a:xfrm>
+            <a:off x="1371600" y="4379976"/>
+            <a:ext cx="7315200" cy="228600"/>
+          </a:xfrm>
+          <a:prstGeom prst="rect">
+            <a:avLst/>
+          </a:prstGeom>
+          <a:noFill/>
+          <a:ln/>
+        </p:spPr>
+        <p:txBody>
+          <a:bodyPr wrap="square" rtlCol="0" anchor="ctr"/>
+          <a:lstStyle/>
+          <a:p>
+            <a:pPr marL="0" indent="0">
+              <a:buNone/>
+            </a:pPr>
+            <a:r>
+              <a:rPr lang="en-US" sz="1200" dirty="0">
+                <a:solidFill>
+                  <a:srgbClr val="888888"/>
+                </a:solidFill>
+                <a:latin typeface="Arial" pitchFamily="34" charset="0"/>
+                <a:ea typeface="Arial" pitchFamily="34" charset="-122"/>
+                <a:cs typeface="Arial" pitchFamily="34" charset="-120"/>
+              </a:rPr>
+              <a:t>Bug hunt, final fixes, review before submission.</a:t>
+            </a:r>
+            <a:endParaRPr lang="en-US" sz="1200" dirty="0"/>
+          </a:p>
+        </p:txBody>
+      </p:sp>
+    </p:spTree>
+  </p:cSld>
+  <p:clrMapOvr>
+    <a:masterClrMapping/>
+  </p:clrMapOvr>
+</p:sld>
+</file>
+
+<file path=ppt/slides/slide11.xml><?xml version="1.0" encoding="utf-8"?>
+<p:sld xmlns:a="http://schemas.openxmlformats.org/drawingml/2006/main" xmlns:p="http://schemas.openxmlformats.org/presentationml/2006/main" xmlns:r="http://schemas.openxmlformats.org/officeDocument/2006/relationships">
+  <p:cSld>
+    <p:bg>
+      <p:bgPr>
+        <a:solidFill>
+          <a:srgbClr val="FFFFFF"/>
+        </a:solidFill>
+        <a:effectLst/>
+      </p:bgPr>
+    </p:bg>
+    <p:spTree>
+      <p:nvGrpSpPr>
+        <p:cNvPr id="1" name=""/>
+        <p:cNvGrpSpPr/>
+        <p:nvPr/>
+      </p:nvGrpSpPr>
+      <p:grpSpPr/>
+      <p:sp>
+        <p:nvSpPr>
+          <p:cNvPr id="2" name="TextBox 1"/>
+          <p:cNvSpPr txBox="1"/>
+          <p:nvPr/>
+        </p:nvSpPr>
+        <p:spPr>
+          <a:xfrm>
+            <a:off x="457200" y="256032"/>
+            <a:ext cx="6400800" cy="256032"/>
+          </a:xfrm>
+          <a:prstGeom prst="rect">
+            <a:avLst/>
+          </a:prstGeom>
+          <a:noFill/>
+        </p:spPr>
+        <p:txBody>
+          <a:bodyPr wrap="square">
+            <a:spAutoFit/>
+          </a:bodyPr>
+          <a:lstStyle/>
+          <a:p>
+            <a:pPr algn="l"/>
+            <a:r>
+              <a:rPr sz="1000" b="1" i="0">
+                <a:solidFill>
+                  <a:srgbClr val="888888"/>
+                </a:solidFill>
+              </a:rPr>
+              <a:t>SPRINT OUTCOMES</a:t>
+            </a:r>
+          </a:p>
+        </p:txBody>
+      </p:sp>
+      <p:sp>
+        <p:nvSpPr>
+          <p:cNvPr id="3" name="TextBox 2"/>
+          <p:cNvSpPr txBox="1"/>
+          <p:nvPr/>
+        </p:nvSpPr>
+        <p:spPr>
+          <a:xfrm>
+            <a:off x="3657600" y="4919472"/>
+            <a:ext cx="5212080" cy="182880"/>
+          </a:xfrm>
+          <a:prstGeom prst="rect">
+            <a:avLst/>
+          </a:prstGeom>
+          <a:noFill/>
+        </p:spPr>
+        <p:txBody>
+          <a:bodyPr wrap="square">
+            <a:spAutoFit/>
+          </a:bodyPr>
+          <a:lstStyle/>
+          <a:p>
+            <a:pPr algn="l"/>
+            <a:r>
+              <a:rPr sz="800" b="0" i="0">
+                <a:solidFill>
+                  <a:srgbClr val="888888"/>
+                </a:solidFill>
+              </a:rPr>
+              <a:t>NINJA QUIZ  .  503IT</a:t>
+            </a:r>
+          </a:p>
+        </p:txBody>
+      </p:sp>
+      <p:sp>
+        <p:nvSpPr>
+          <p:cNvPr id="4" name="TextBox 3"/>
+          <p:cNvSpPr txBox="1"/>
+          <p:nvPr/>
+        </p:nvSpPr>
+        <p:spPr>
+          <a:xfrm>
+            <a:off x="457200" y="658368"/>
+            <a:ext cx="8229600" cy="365760"/>
+          </a:xfrm>
+          <a:prstGeom prst="rect">
+            <a:avLst/>
+          </a:prstGeom>
+          <a:noFill/>
+        </p:spPr>
+        <p:txBody>
+          <a:bodyPr wrap="square">
+            <a:spAutoFit/>
+          </a:bodyPr>
+          <a:lstStyle/>
+          <a:p>
+            <a:pPr algn="l"/>
+            <a:r>
+              <a:rPr sz="1500" b="1" i="0">
+                <a:solidFill>
+                  <a:srgbClr val="111111"/>
+                </a:solidFill>
+              </a:rPr>
+              <a:t>What each sprint delivered — and what it taught the team.</a:t>
+            </a:r>
+          </a:p>
+        </p:txBody>
+      </p:sp>
+      <p:sp>
+        <p:nvSpPr>
+          <p:cNvPr id="5" name="TextBox 4"/>
+          <p:cNvSpPr txBox="1"/>
+          <p:nvPr/>
+        </p:nvSpPr>
+        <p:spPr>
+          <a:xfrm>
+            <a:off x="457200" y="1188720"/>
+            <a:ext cx="640080" cy="274320"/>
+          </a:xfrm>
+          <a:prstGeom prst="rect">
+            <a:avLst/>
+          </a:prstGeom>
+          <a:noFill/>
+        </p:spPr>
+        <p:txBody>
+          <a:bodyPr wrap="square">
+            <a:spAutoFit/>
+          </a:bodyPr>
+          <a:lstStyle/>
+          <a:p>
+            <a:pPr algn="l"/>
+            <a:r>
+              <a:rPr sz="1200" b="1" i="0">
+                <a:solidFill>
+                  <a:srgbClr val="FFCD00"/>
+                </a:solidFill>
+              </a:rPr>
+              <a:t>01</a:t>
+            </a:r>
+          </a:p>
+        </p:txBody>
+      </p:sp>
+      <p:sp>
+        <p:nvSpPr>
+          <p:cNvPr id="6" name="TextBox 5"/>
+          <p:cNvSpPr txBox="1"/>
+          <p:nvPr/>
+        </p:nvSpPr>
+        <p:spPr>
+          <a:xfrm>
+            <a:off x="1188720" y="1188720"/>
+            <a:ext cx="3657600" cy="256032"/>
+          </a:xfrm>
+          <a:prstGeom prst="rect">
+            <a:avLst/>
+          </a:prstGeom>
+          <a:noFill/>
+        </p:spPr>
+        <p:txBody>
+          <a:bodyPr wrap="square">
+            <a:spAutoFit/>
+          </a:bodyPr>
+          <a:lstStyle/>
+          <a:p>
+            <a:pPr algn="l"/>
+            <a:r>
+              <a:rPr sz="1200" b="1" i="0">
+                <a:solidFill>
+                  <a:srgbClr val="111111"/>
+                </a:solidFill>
+              </a:rPr>
+              <a:t>Sprint 1 — Setup &amp; Login</a:t>
+            </a:r>
+          </a:p>
+        </p:txBody>
+      </p:sp>
+      <p:sp>
+        <p:nvSpPr>
+          <p:cNvPr id="7" name="TextBox 6"/>
+          <p:cNvSpPr txBox="1"/>
+          <p:nvPr/>
+        </p:nvSpPr>
+        <p:spPr>
+          <a:xfrm>
+            <a:off x="1188720" y="1463040"/>
+            <a:ext cx="7680960" cy="457200"/>
+          </a:xfrm>
+          <a:prstGeom prst="rect">
+            <a:avLst/>
+          </a:prstGeom>
+          <a:noFill/>
+        </p:spPr>
+        <p:txBody>
+          <a:bodyPr wrap="square">
+            <a:spAutoFit/>
+          </a:bodyPr>
+          <a:lstStyle/>
+          <a:p>
+            <a:pPr algn="l"/>
+            <a:r>
+              <a:rPr sz="900" b="0" i="0">
+                <a:solidFill>
+                  <a:srgbClr val="555555"/>
+                </a:solidFill>
+              </a:rPr>
+              <a:t>Built: auth system, GitHub branches, role structure.</a:t>
+            </a:r>
+          </a:p>
+          <a:p>
+            <a:pPr algn="l"/>
+            <a:r>
+              <a:rPr sz="900" b="0" i="0">
+                <a:solidFill>
+                  <a:srgbClr val="555555"/>
+                </a:solidFill>
+              </a:rPr>
+              <a:t>Learned: agreeing roles before coding prevented overlap and blame.</a:t>
+            </a:r>
+          </a:p>
+        </p:txBody>
+      </p:sp>
+      <p:sp>
+        <p:nvSpPr>
+          <p:cNvPr id="8" name="TextBox 7"/>
+          <p:cNvSpPr txBox="1"/>
+          <p:nvPr/>
+        </p:nvSpPr>
+        <p:spPr>
+          <a:xfrm>
+            <a:off x="457200" y="1938528"/>
+            <a:ext cx="640080" cy="274320"/>
+          </a:xfrm>
+          <a:prstGeom prst="rect">
+            <a:avLst/>
+          </a:prstGeom>
+          <a:noFill/>
+        </p:spPr>
+        <p:txBody>
+          <a:bodyPr wrap="square">
+            <a:spAutoFit/>
+          </a:bodyPr>
+          <a:lstStyle/>
+          <a:p>
+            <a:pPr algn="l"/>
+            <a:r>
+              <a:rPr sz="1200" b="1" i="0">
+                <a:solidFill>
+                  <a:srgbClr val="FFCD00"/>
+                </a:solidFill>
+              </a:rPr>
+              <a:t>02</a:t>
+            </a:r>
+          </a:p>
+        </p:txBody>
+      </p:sp>
+      <p:sp>
+        <p:nvSpPr>
+          <p:cNvPr id="9" name="TextBox 8"/>
+          <p:cNvSpPr txBox="1"/>
+          <p:nvPr/>
+        </p:nvSpPr>
+        <p:spPr>
+          <a:xfrm>
+            <a:off x="1188720" y="1938528"/>
+            <a:ext cx="3657600" cy="256032"/>
+          </a:xfrm>
+          <a:prstGeom prst="rect">
+            <a:avLst/>
+          </a:prstGeom>
+          <a:noFill/>
+        </p:spPr>
+        <p:txBody>
+          <a:bodyPr wrap="square">
+            <a:spAutoFit/>
+          </a:bodyPr>
+          <a:lstStyle/>
+          <a:p>
+            <a:pPr algn="l"/>
+            <a:r>
+              <a:rPr sz="1200" b="1" i="0">
+                <a:solidFill>
+                  <a:srgbClr val="111111"/>
+                </a:solidFill>
+              </a:rPr>
+              <a:t>Sprint 2 — Game Engine</a:t>
+            </a:r>
+          </a:p>
+        </p:txBody>
+      </p:sp>
+      <p:sp>
+        <p:nvSpPr>
+          <p:cNvPr id="10" name="TextBox 9"/>
+          <p:cNvSpPr txBox="1"/>
+          <p:nvPr/>
+        </p:nvSpPr>
+        <p:spPr>
+          <a:xfrm>
+            <a:off x="1188720" y="2212848"/>
+            <a:ext cx="7680960" cy="457200"/>
+          </a:xfrm>
+          <a:prstGeom prst="rect">
+            <a:avLst/>
+          </a:prstGeom>
+          <a:noFill/>
+        </p:spPr>
+        <p:txBody>
+          <a:bodyPr wrap="square">
+            <a:spAutoFit/>
+          </a:bodyPr>
+          <a:lstStyle/>
+          <a:p>
+            <a:pPr algn="l"/>
+            <a:r>
+              <a:rPr sz="900" b="0" i="0">
+                <a:solidFill>
+                  <a:srgbClr val="555555"/>
+                </a:solidFill>
+              </a:rPr>
+              <a:t>Built: core quiz loop, slash mechanic.</a:t>
+            </a:r>
+          </a:p>
+          <a:p>
+            <a:pPr algn="l"/>
+            <a:r>
+              <a:rPr sz="900" b="0" i="0">
+                <a:solidFill>
+                  <a:srgbClr val="555555"/>
+                </a:solidFill>
+              </a:rPr>
+              <a:t>Learned: daily WhatsApp check-ins replaced long weekly catch-ups and kept everyone unblocked.</a:t>
+            </a:r>
+          </a:p>
+        </p:txBody>
+      </p:sp>
+      <p:sp>
+        <p:nvSpPr>
+          <p:cNvPr id="11" name="TextBox 10"/>
+          <p:cNvSpPr txBox="1"/>
+          <p:nvPr/>
+        </p:nvSpPr>
+        <p:spPr>
+          <a:xfrm>
+            <a:off x="457200" y="2688336"/>
+            <a:ext cx="640080" cy="274320"/>
+          </a:xfrm>
+          <a:prstGeom prst="rect">
+            <a:avLst/>
+          </a:prstGeom>
+          <a:noFill/>
+        </p:spPr>
+        <p:txBody>
+          <a:bodyPr wrap="square">
+            <a:spAutoFit/>
+          </a:bodyPr>
+          <a:lstStyle/>
+          <a:p>
+            <a:pPr algn="l"/>
+            <a:r>
+              <a:rPr sz="1200" b="1" i="0">
+                <a:solidFill>
+                  <a:srgbClr val="FFCD00"/>
+                </a:solidFill>
+              </a:rPr>
+              <a:t>03</a:t>
+            </a:r>
+          </a:p>
+        </p:txBody>
+      </p:sp>
+      <p:sp>
+        <p:nvSpPr>
+          <p:cNvPr id="12" name="TextBox 11"/>
+          <p:cNvSpPr txBox="1"/>
+          <p:nvPr/>
+        </p:nvSpPr>
+        <p:spPr>
+          <a:xfrm>
+            <a:off x="1188720" y="2688336"/>
+            <a:ext cx="3657600" cy="256032"/>
+          </a:xfrm>
+          <a:prstGeom prst="rect">
+            <a:avLst/>
+          </a:prstGeom>
+          <a:noFill/>
+        </p:spPr>
+        <p:txBody>
+          <a:bodyPr wrap="square">
+            <a:spAutoFit/>
+          </a:bodyPr>
+          <a:lstStyle/>
+          <a:p>
+            <a:pPr algn="l"/>
+            <a:r>
+              <a:rPr sz="1200" b="1" i="0">
+                <a:solidFill>
+                  <a:srgbClr val="111111"/>
+                </a:solidFill>
+              </a:rPr>
+              <a:t>Sprint 3 — Slicing &amp; Sound</a:t>
+            </a:r>
+          </a:p>
+        </p:txBody>
+      </p:sp>
+      <p:sp>
+        <p:nvSpPr>
+          <p:cNvPr id="13" name="TextBox 12"/>
+          <p:cNvSpPr txBox="1"/>
+          <p:nvPr/>
+        </p:nvSpPr>
+        <p:spPr>
+          <a:xfrm>
+            <a:off x="1188720" y="2962656"/>
+            <a:ext cx="7680960" cy="457200"/>
+          </a:xfrm>
+          <a:prstGeom prst="rect">
+            <a:avLst/>
+          </a:prstGeom>
+          <a:noFill/>
+        </p:spPr>
+        <p:txBody>
+          <a:bodyPr wrap="square">
+            <a:spAutoFit/>
+          </a:bodyPr>
+          <a:lstStyle/>
+          <a:p>
+            <a:pPr algn="l"/>
+            <a:r>
+              <a:rPr sz="900" b="0" i="0">
+                <a:solidFill>
+                  <a:srgbClr val="555555"/>
+                </a:solidFill>
+              </a:rPr>
+              <a:t>Built: animations, visual effects, audio.</a:t>
+            </a:r>
+          </a:p>
+          <a:p>
+            <a:pPr algn="l"/>
+            <a:r>
+              <a:rPr sz="900" b="0" i="0">
+                <a:solidFill>
+                  <a:srgbClr val="555555"/>
+                </a:solidFill>
+              </a:rPr>
+              <a:t>Learned: first merge conflicts taught us to always pull before push — a discipline we kept.</a:t>
+            </a:r>
+          </a:p>
+        </p:txBody>
+      </p:sp>
+      <p:sp>
+        <p:nvSpPr>
+          <p:cNvPr id="14" name="TextBox 13"/>
+          <p:cNvSpPr txBox="1"/>
+          <p:nvPr/>
+        </p:nvSpPr>
+        <p:spPr>
+          <a:xfrm>
+            <a:off x="457200" y="3438144"/>
+            <a:ext cx="640080" cy="274320"/>
+          </a:xfrm>
+          <a:prstGeom prst="rect">
+            <a:avLst/>
+          </a:prstGeom>
+          <a:noFill/>
+        </p:spPr>
+        <p:txBody>
+          <a:bodyPr wrap="square">
+            <a:spAutoFit/>
+          </a:bodyPr>
+          <a:lstStyle/>
+          <a:p>
+            <a:pPr algn="l"/>
+            <a:r>
+              <a:rPr sz="1200" b="1" i="0">
+                <a:solidFill>
+                  <a:srgbClr val="FFCD00"/>
+                </a:solidFill>
+              </a:rPr>
+              <a:t>04</a:t>
+            </a:r>
+          </a:p>
+        </p:txBody>
+      </p:sp>
+      <p:sp>
+        <p:nvSpPr>
+          <p:cNvPr id="15" name="TextBox 14"/>
+          <p:cNvSpPr txBox="1"/>
+          <p:nvPr/>
+        </p:nvSpPr>
+        <p:spPr>
+          <a:xfrm>
+            <a:off x="1188720" y="3438144"/>
+            <a:ext cx="3657600" cy="256032"/>
+          </a:xfrm>
+          <a:prstGeom prst="rect">
+            <a:avLst/>
+          </a:prstGeom>
+          <a:noFill/>
+        </p:spPr>
+        <p:txBody>
+          <a:bodyPr wrap="square">
+            <a:spAutoFit/>
+          </a:bodyPr>
+          <a:lstStyle/>
+          <a:p>
+            <a:pPr algn="l"/>
+            <a:r>
+              <a:rPr sz="1200" b="1" i="0">
+                <a:solidFill>
+                  <a:srgbClr val="111111"/>
+                </a:solidFill>
+              </a:rPr>
+              <a:t>Sprint 4 — Leaderboard &amp; Test</a:t>
+            </a:r>
+          </a:p>
+        </p:txBody>
+      </p:sp>
+      <p:sp>
+        <p:nvSpPr>
+          <p:cNvPr id="16" name="TextBox 15"/>
+          <p:cNvSpPr txBox="1"/>
+          <p:nvPr/>
+        </p:nvSpPr>
+        <p:spPr>
+          <a:xfrm>
+            <a:off x="1188720" y="3712463"/>
+            <a:ext cx="7680960" cy="457200"/>
+          </a:xfrm>
+          <a:prstGeom prst="rect">
+            <a:avLst/>
+          </a:prstGeom>
+          <a:noFill/>
+        </p:spPr>
+        <p:txBody>
+          <a:bodyPr wrap="square">
+            <a:spAutoFit/>
+          </a:bodyPr>
+          <a:lstStyle/>
+          <a:p>
+            <a:pPr algn="l"/>
+            <a:r>
+              <a:rPr sz="900" b="0" i="0">
+                <a:solidFill>
+                  <a:srgbClr val="555555"/>
+                </a:solidFill>
+              </a:rPr>
+              <a:t>Built: scoring, peer testing sessions.</a:t>
+            </a:r>
+          </a:p>
+          <a:p>
+            <a:pPr algn="l"/>
+            <a:r>
+              <a:rPr sz="900" b="0" i="0">
+                <a:solidFill>
+                  <a:srgbClr val="555555"/>
+                </a:solidFill>
+              </a:rPr>
+              <a:t>Learned: external testers found issues we missed — peer testing is essential, not optional.</a:t>
+            </a:r>
+          </a:p>
+        </p:txBody>
+      </p:sp>
+      <p:sp>
+        <p:nvSpPr>
+          <p:cNvPr id="17" name="TextBox 16"/>
+          <p:cNvSpPr txBox="1"/>
+          <p:nvPr/>
+        </p:nvSpPr>
+        <p:spPr>
+          <a:xfrm>
+            <a:off x="457200" y="4187952"/>
+            <a:ext cx="640080" cy="274320"/>
+          </a:xfrm>
+          <a:prstGeom prst="rect">
+            <a:avLst/>
+          </a:prstGeom>
+          <a:noFill/>
+        </p:spPr>
+        <p:txBody>
+          <a:bodyPr wrap="square">
+            <a:spAutoFit/>
+          </a:bodyPr>
+          <a:lstStyle/>
+          <a:p>
+            <a:pPr algn="l"/>
+            <a:r>
+              <a:rPr sz="1200" b="1" i="0">
+                <a:solidFill>
+                  <a:srgbClr val="FFCD00"/>
+                </a:solidFill>
+              </a:rPr>
+              <a:t>05</a:t>
+            </a:r>
+          </a:p>
+        </p:txBody>
+      </p:sp>
+      <p:sp>
+        <p:nvSpPr>
+          <p:cNvPr id="18" name="TextBox 17"/>
+          <p:cNvSpPr txBox="1"/>
+          <p:nvPr/>
+        </p:nvSpPr>
+        <p:spPr>
+          <a:xfrm>
+            <a:off x="1188720" y="4187952"/>
+            <a:ext cx="3657600" cy="256032"/>
+          </a:xfrm>
+          <a:prstGeom prst="rect">
+            <a:avLst/>
+          </a:prstGeom>
+          <a:noFill/>
+        </p:spPr>
+        <p:txBody>
+          <a:bodyPr wrap="square">
+            <a:spAutoFit/>
+          </a:bodyPr>
+          <a:lstStyle/>
+          <a:p>
+            <a:pPr algn="l"/>
+            <a:r>
+              <a:rPr sz="1200" b="1" i="0">
+                <a:solidFill>
+                  <a:srgbClr val="111111"/>
+                </a:solidFill>
+              </a:rPr>
+              <a:t>Sprint 5 — Polish &amp; Submit</a:t>
+            </a:r>
+          </a:p>
+        </p:txBody>
+      </p:sp>
+      <p:sp>
+        <p:nvSpPr>
+          <p:cNvPr id="19" name="TextBox 18"/>
+          <p:cNvSpPr txBox="1"/>
+          <p:nvPr/>
+        </p:nvSpPr>
+        <p:spPr>
+          <a:xfrm>
+            <a:off x="1188720" y="4462272"/>
+            <a:ext cx="7680960" cy="457200"/>
+          </a:xfrm>
+          <a:prstGeom prst="rect">
+            <a:avLst/>
+          </a:prstGeom>
+          <a:noFill/>
+        </p:spPr>
+        <p:txBody>
+          <a:bodyPr wrap="square">
+            <a:spAutoFit/>
+          </a:bodyPr>
+          <a:lstStyle/>
+          <a:p>
+            <a:pPr algn="l"/>
+            <a:r>
+              <a:rPr sz="900" b="0" i="0">
+                <a:solidFill>
+                  <a:srgbClr val="555555"/>
+                </a:solidFill>
+              </a:rPr>
+              <a:t>Built: final bug fixes, documentation.</a:t>
+            </a:r>
+          </a:p>
+          <a:p>
+            <a:pPr algn="l"/>
+            <a:r>
+              <a:rPr sz="900" b="0" i="0">
+                <a:solidFill>
+                  <a:srgbClr val="555555"/>
+                </a:solidFill>
+              </a:rPr>
+              <a:t>Learned: a team that communicates daily ships on time. We did.</a:t>
+            </a:r>
+          </a:p>
+        </p:txBody>
+      </p:sp>
+    </p:spTree>
+  </p:cSld>
+  <p:clrMapOvr>
+    <a:masterClrMapping/>
+  </p:clrMapOvr>
+</p:sld>
+</file>
+
+<file path=ppt/slides/slide12.xml><?xml version="1.0" encoding="utf-8"?>
+<p:sld xmlns:a="http://schemas.openxmlformats.org/drawingml/2006/main" xmlns:r="http://schemas.openxmlformats.org/officeDocument/2006/relationships" xmlns:p="http://schemas.openxmlformats.org/presentationml/2006/main">
   <p:cSld name="Slide 10">
     <p:bg>
       <p:bgPr>
@@ -2553,7 +4048,7 @@
 </p:sld>
 </file>
 
-<file path=ppt/slides/slide11.xml><?xml version="1.0" encoding="utf-8"?>
+<file path=ppt/slides/slide13.xml><?xml version="1.0" encoding="utf-8"?>
 <p:sld xmlns:a="http://schemas.openxmlformats.org/drawingml/2006/main" xmlns:r="http://schemas.openxmlformats.org/officeDocument/2006/relationships" xmlns:p="http://schemas.openxmlformats.org/presentationml/2006/main">
   <p:cSld name="Slide 11">
     <p:bg>
@@ -3228,7 +4723,7 @@
 </p:sld>
 </file>
 
-<file path=ppt/slides/slide12.xml><?xml version="1.0" encoding="utf-8"?>
+<file path=ppt/slides/slide14.xml><?xml version="1.0" encoding="utf-8"?>
 <p:sld xmlns:a="http://schemas.openxmlformats.org/drawingml/2006/main" xmlns:r="http://schemas.openxmlformats.org/officeDocument/2006/relationships" xmlns:p="http://schemas.openxmlformats.org/presentationml/2006/main">
   <p:cSld name="Slide 12">
     <p:bg>
@@ -3828,7 +5323,7 @@
 </p:sld>
 </file>
 
-<file path=ppt/slides/slide13.xml><?xml version="1.0" encoding="utf-8"?>
+<file path=ppt/slides/slide15.xml><?xml version="1.0" encoding="utf-8"?>
 <p:sld xmlns:a="http://schemas.openxmlformats.org/drawingml/2006/main" xmlns:r="http://schemas.openxmlformats.org/officeDocument/2006/relationships" xmlns:p="http://schemas.openxmlformats.org/presentationml/2006/main">
   <p:cSld name="Slide 13">
     <p:bg>
@@ -4033,7 +5528,7 @@
 </p:sld>
 </file>
 
-<file path=ppt/slides/slide14.xml><?xml version="1.0" encoding="utf-8"?>
+<file path=ppt/slides/slide16.xml><?xml version="1.0" encoding="utf-8"?>
 <p:sld xmlns:a="http://schemas.openxmlformats.org/drawingml/2006/main" xmlns:r="http://schemas.openxmlformats.org/officeDocument/2006/relationships" xmlns:p="http://schemas.openxmlformats.org/presentationml/2006/main">
   <p:cSld name="Slide 14">
     <p:bg>
@@ -4897,7 +6392,7 @@
 </p:sld>
 </file>
 
-<file path=ppt/slides/slide15.xml><?xml version="1.0" encoding="utf-8"?>
+<file path=ppt/slides/slide17.xml><?xml version="1.0" encoding="utf-8"?>
 <p:sld xmlns:a="http://schemas.openxmlformats.org/drawingml/2006/main" xmlns:r="http://schemas.openxmlformats.org/officeDocument/2006/relationships" xmlns:p="http://schemas.openxmlformats.org/presentationml/2006/main">
   <p:cSld name="Slide 15">
     <p:bg>
@@ -5590,7 +7085,7 @@
 </p:sld>
 </file>
 
-<file path=ppt/slides/slide16.xml><?xml version="1.0" encoding="utf-8"?>
+<file path=ppt/slides/slide18.xml><?xml version="1.0" encoding="utf-8"?>
 <p:sld xmlns:a="http://schemas.openxmlformats.org/drawingml/2006/main" xmlns:r="http://schemas.openxmlformats.org/officeDocument/2006/relationships" xmlns:p="http://schemas.openxmlformats.org/presentationml/2006/main">
   <p:cSld name="Slide 16">
     <p:bg>
@@ -5759,51 +7254,24 @@
           </a:p>
         </p:txBody>
       </p:sp>
-      <p:sp>
-        <p:nvSpPr>
-          <p:cNvPr id="6" name="Shape 4"/>
-          <p:cNvSpPr/>
-          <p:nvPr/>
-        </p:nvSpPr>
-        <p:spPr>
-          <a:xfrm>
-            <a:off x="1682496" y="1170432"/>
-            <a:ext cx="5779008" cy="3639312"/>
-          </a:xfrm>
-          <a:prstGeom prst="rect">
-            <a:avLst/>
-          </a:prstGeom>
-          <a:solidFill>
-            <a:srgbClr val="FFCD00"/>
-          </a:solidFill>
-          <a:ln/>
-        </p:spPr>
-        <p:txBody>
-          <a:bodyPr/>
-          <a:lstStyle/>
-          <a:p>
-            <a:endParaRPr lang="en-GB"/>
-          </a:p>
-        </p:txBody>
-      </p:sp>
       <p:pic>
         <p:nvPicPr>
-          <p:cNvPr id="7" name="Image 0" descr="C:/Ninja Quiz/shots/03-game.png"/>
+          <p:cNvPr id="6" name="Picture 5" descr="Game ss.png"/>
           <p:cNvPicPr>
             <a:picLocks noChangeAspect="1"/>
           </p:cNvPicPr>
           <p:nvPr/>
         </p:nvPicPr>
         <p:blipFill>
-          <a:blip r:embed="rId3"/>
+          <a:blip r:embed="rId4"/>
           <a:stretch>
             <a:fillRect/>
           </a:stretch>
         </p:blipFill>
         <p:spPr>
           <a:xfrm>
-            <a:off x="1719072" y="1207008"/>
-            <a:ext cx="5705856" cy="3566160"/>
+            <a:off x="365760" y="1005840"/>
+            <a:ext cx="8412480" cy="3931920"/>
           </a:xfrm>
           <a:prstGeom prst="rect">
             <a:avLst/>
@@ -5818,7 +7286,7 @@
 </p:sld>
 </file>
 
-<file path=ppt/slides/slide17.xml><?xml version="1.0" encoding="utf-8"?>
+<file path=ppt/slides/slide19.xml><?xml version="1.0" encoding="utf-8"?>
 <p:sld xmlns:a="http://schemas.openxmlformats.org/drawingml/2006/main" xmlns:r="http://schemas.openxmlformats.org/officeDocument/2006/relationships" xmlns:p="http://schemas.openxmlformats.org/presentationml/2006/main">
   <p:cSld name="Slide 17">
     <p:bg>
@@ -6078,7 +7546,554 @@
 </p:sld>
 </file>
 
-<file path=ppt/slides/slide18.xml><?xml version="1.0" encoding="utf-8"?>
+<file path=ppt/slides/slide2.xml><?xml version="1.0" encoding="utf-8"?>
+<p:sld xmlns:a="http://schemas.openxmlformats.org/drawingml/2006/main" xmlns:p="http://schemas.openxmlformats.org/presentationml/2006/main" xmlns:r="http://schemas.openxmlformats.org/officeDocument/2006/relationships">
+  <p:cSld>
+    <p:bg>
+      <p:bgPr>
+        <a:solidFill>
+          <a:srgbClr val="0D0D0D"/>
+        </a:solidFill>
+        <a:effectLst/>
+      </p:bgPr>
+    </p:bg>
+    <p:spTree>
+      <p:nvGrpSpPr>
+        <p:cNvPr id="1" name=""/>
+        <p:cNvGrpSpPr/>
+        <p:nvPr/>
+      </p:nvGrpSpPr>
+      <p:grpSpPr/>
+      <p:sp>
+        <p:nvSpPr>
+          <p:cNvPr id="2" name="TextBox 1"/>
+          <p:cNvSpPr txBox="1"/>
+          <p:nvPr/>
+        </p:nvSpPr>
+        <p:spPr>
+          <a:xfrm>
+            <a:off x="457200" y="256032"/>
+            <a:ext cx="6400800" cy="256032"/>
+          </a:xfrm>
+          <a:prstGeom prst="rect">
+            <a:avLst/>
+          </a:prstGeom>
+          <a:noFill/>
+        </p:spPr>
+        <p:txBody>
+          <a:bodyPr wrap="square">
+            <a:spAutoFit/>
+          </a:bodyPr>
+          <a:lstStyle/>
+          <a:p>
+            <a:pPr algn="l"/>
+            <a:r>
+              <a:rPr sz="1000" b="1" i="0">
+                <a:solidFill>
+                  <a:srgbClr val="888888"/>
+                </a:solidFill>
+              </a:rPr>
+              <a:t>WHAT WE WILL COVER</a:t>
+            </a:r>
+          </a:p>
+        </p:txBody>
+      </p:sp>
+      <p:sp>
+        <p:nvSpPr>
+          <p:cNvPr id="3" name="TextBox 2"/>
+          <p:cNvSpPr txBox="1"/>
+          <p:nvPr/>
+        </p:nvSpPr>
+        <p:spPr>
+          <a:xfrm>
+            <a:off x="3657600" y="4919472"/>
+            <a:ext cx="5212080" cy="182880"/>
+          </a:xfrm>
+          <a:prstGeom prst="rect">
+            <a:avLst/>
+          </a:prstGeom>
+          <a:noFill/>
+        </p:spPr>
+        <p:txBody>
+          <a:bodyPr wrap="square">
+            <a:spAutoFit/>
+          </a:bodyPr>
+          <a:lstStyle/>
+          <a:p>
+            <a:pPr algn="l"/>
+            <a:r>
+              <a:rPr sz="800" b="0" i="0">
+                <a:solidFill>
+                  <a:srgbClr val="444444"/>
+                </a:solidFill>
+              </a:rPr>
+              <a:t>NINJA QUIZ  .  503IT</a:t>
+            </a:r>
+          </a:p>
+        </p:txBody>
+      </p:sp>
+      <p:sp>
+        <p:nvSpPr>
+          <p:cNvPr id="4" name="TextBox 3"/>
+          <p:cNvSpPr txBox="1"/>
+          <p:nvPr/>
+        </p:nvSpPr>
+        <p:spPr>
+          <a:xfrm>
+            <a:off x="457200" y="594360"/>
+            <a:ext cx="8229600" cy="1097280"/>
+          </a:xfrm>
+          <a:prstGeom prst="rect">
+            <a:avLst/>
+          </a:prstGeom>
+          <a:noFill/>
+        </p:spPr>
+        <p:txBody>
+          <a:bodyPr wrap="square">
+            <a:spAutoFit/>
+          </a:bodyPr>
+          <a:lstStyle/>
+          <a:p>
+            <a:pPr algn="l"/>
+            <a:r>
+              <a:rPr sz="3400" b="1" i="0">
+                <a:solidFill>
+                  <a:srgbClr val="FFFFFF"/>
+                </a:solidFill>
+              </a:rPr>
+              <a:t>15 minutes.</a:t>
+            </a:r>
+          </a:p>
+          <a:p>
+            <a:pPr algn="l"/>
+            <a:r>
+              <a:rPr sz="3400" b="1" i="0">
+                <a:solidFill>
+                  <a:srgbClr val="FFFFFF"/>
+                </a:solidFill>
+              </a:rPr>
+              <a:t>One story.</a:t>
+            </a:r>
+          </a:p>
+        </p:txBody>
+      </p:sp>
+      <p:sp>
+        <p:nvSpPr>
+          <p:cNvPr id="5" name="TextBox 4"/>
+          <p:cNvSpPr txBox="1"/>
+          <p:nvPr/>
+        </p:nvSpPr>
+        <p:spPr>
+          <a:xfrm>
+            <a:off x="457200" y="1874519"/>
+            <a:ext cx="640080" cy="292608"/>
+          </a:xfrm>
+          <a:prstGeom prst="rect">
+            <a:avLst/>
+          </a:prstGeom>
+          <a:noFill/>
+        </p:spPr>
+        <p:txBody>
+          <a:bodyPr wrap="square">
+            <a:spAutoFit/>
+          </a:bodyPr>
+          <a:lstStyle/>
+          <a:p>
+            <a:pPr algn="l"/>
+            <a:r>
+              <a:rPr sz="1200" b="1" i="0">
+                <a:solidFill>
+                  <a:srgbClr val="FFCD00"/>
+                </a:solidFill>
+              </a:rPr>
+              <a:t>01</a:t>
+            </a:r>
+          </a:p>
+        </p:txBody>
+      </p:sp>
+      <p:sp>
+        <p:nvSpPr>
+          <p:cNvPr id="6" name="TextBox 5"/>
+          <p:cNvSpPr txBox="1"/>
+          <p:nvPr/>
+        </p:nvSpPr>
+        <p:spPr>
+          <a:xfrm>
+            <a:off x="1188720" y="1874519"/>
+            <a:ext cx="7680960" cy="292608"/>
+          </a:xfrm>
+          <a:prstGeom prst="rect">
+            <a:avLst/>
+          </a:prstGeom>
+          <a:noFill/>
+        </p:spPr>
+        <p:txBody>
+          <a:bodyPr wrap="square">
+            <a:spAutoFit/>
+          </a:bodyPr>
+          <a:lstStyle/>
+          <a:p>
+            <a:pPr algn="l"/>
+            <a:r>
+              <a:rPr sz="1200" b="0" i="0">
+                <a:solidFill>
+                  <a:srgbClr val="DDDDDD"/>
+                </a:solidFill>
+              </a:rPr>
+              <a:t>The brief — and why we chose this audience</a:t>
+            </a:r>
+          </a:p>
+        </p:txBody>
+      </p:sp>
+      <p:sp>
+        <p:nvSpPr>
+          <p:cNvPr id="7" name="TextBox 6"/>
+          <p:cNvSpPr txBox="1"/>
+          <p:nvPr/>
+        </p:nvSpPr>
+        <p:spPr>
+          <a:xfrm>
+            <a:off x="457200" y="2331720"/>
+            <a:ext cx="640080" cy="292608"/>
+          </a:xfrm>
+          <a:prstGeom prst="rect">
+            <a:avLst/>
+          </a:prstGeom>
+          <a:noFill/>
+        </p:spPr>
+        <p:txBody>
+          <a:bodyPr wrap="square">
+            <a:spAutoFit/>
+          </a:bodyPr>
+          <a:lstStyle/>
+          <a:p>
+            <a:pPr algn="l"/>
+            <a:r>
+              <a:rPr sz="1200" b="1" i="0">
+                <a:solidFill>
+                  <a:srgbClr val="FFCD00"/>
+                </a:solidFill>
+              </a:rPr>
+              <a:t>02</a:t>
+            </a:r>
+          </a:p>
+        </p:txBody>
+      </p:sp>
+      <p:sp>
+        <p:nvSpPr>
+          <p:cNvPr id="8" name="TextBox 7"/>
+          <p:cNvSpPr txBox="1"/>
+          <p:nvPr/>
+        </p:nvSpPr>
+        <p:spPr>
+          <a:xfrm>
+            <a:off x="1188720" y="2331720"/>
+            <a:ext cx="7680960" cy="292608"/>
+          </a:xfrm>
+          <a:prstGeom prst="rect">
+            <a:avLst/>
+          </a:prstGeom>
+          <a:noFill/>
+        </p:spPr>
+        <p:txBody>
+          <a:bodyPr wrap="square">
+            <a:spAutoFit/>
+          </a:bodyPr>
+          <a:lstStyle/>
+          <a:p>
+            <a:pPr algn="l"/>
+            <a:r>
+              <a:rPr sz="1200" b="0" i="0">
+                <a:solidFill>
+                  <a:srgbClr val="DDDDDD"/>
+                </a:solidFill>
+              </a:rPr>
+              <a:t>Our team — roles and Belbin framework</a:t>
+            </a:r>
+          </a:p>
+        </p:txBody>
+      </p:sp>
+      <p:sp>
+        <p:nvSpPr>
+          <p:cNvPr id="9" name="TextBox 8"/>
+          <p:cNvSpPr txBox="1"/>
+          <p:nvPr/>
+        </p:nvSpPr>
+        <p:spPr>
+          <a:xfrm>
+            <a:off x="457200" y="2788920"/>
+            <a:ext cx="640080" cy="292608"/>
+          </a:xfrm>
+          <a:prstGeom prst="rect">
+            <a:avLst/>
+          </a:prstGeom>
+          <a:noFill/>
+        </p:spPr>
+        <p:txBody>
+          <a:bodyPr wrap="square">
+            <a:spAutoFit/>
+          </a:bodyPr>
+          <a:lstStyle/>
+          <a:p>
+            <a:pPr algn="l"/>
+            <a:r>
+              <a:rPr sz="1200" b="1" i="0">
+                <a:solidFill>
+                  <a:srgbClr val="FFCD00"/>
+                </a:solidFill>
+              </a:rPr>
+              <a:t>03</a:t>
+            </a:r>
+          </a:p>
+        </p:txBody>
+      </p:sp>
+      <p:sp>
+        <p:nvSpPr>
+          <p:cNvPr id="10" name="TextBox 9"/>
+          <p:cNvSpPr txBox="1"/>
+          <p:nvPr/>
+        </p:nvSpPr>
+        <p:spPr>
+          <a:xfrm>
+            <a:off x="1188720" y="2788920"/>
+            <a:ext cx="7680960" cy="292608"/>
+          </a:xfrm>
+          <a:prstGeom prst="rect">
+            <a:avLst/>
+          </a:prstGeom>
+          <a:noFill/>
+        </p:spPr>
+        <p:txBody>
+          <a:bodyPr wrap="square">
+            <a:spAutoFit/>
+          </a:bodyPr>
+          <a:lstStyle/>
+          <a:p>
+            <a:pPr algn="l"/>
+            <a:r>
+              <a:rPr sz="1200" b="0" i="0">
+                <a:solidFill>
+                  <a:srgbClr val="DDDDDD"/>
+                </a:solidFill>
+              </a:rPr>
+              <a:t>How we planned, communicated and tracked work</a:t>
+            </a:r>
+          </a:p>
+        </p:txBody>
+      </p:sp>
+      <p:sp>
+        <p:nvSpPr>
+          <p:cNvPr id="11" name="TextBox 10"/>
+          <p:cNvSpPr txBox="1"/>
+          <p:nvPr/>
+        </p:nvSpPr>
+        <p:spPr>
+          <a:xfrm>
+            <a:off x="457200" y="3246120"/>
+            <a:ext cx="640080" cy="292608"/>
+          </a:xfrm>
+          <a:prstGeom prst="rect">
+            <a:avLst/>
+          </a:prstGeom>
+          <a:noFill/>
+        </p:spPr>
+        <p:txBody>
+          <a:bodyPr wrap="square">
+            <a:spAutoFit/>
+          </a:bodyPr>
+          <a:lstStyle/>
+          <a:p>
+            <a:pPr algn="l"/>
+            <a:r>
+              <a:rPr sz="1200" b="1" i="0">
+                <a:solidFill>
+                  <a:srgbClr val="FFCD00"/>
+                </a:solidFill>
+              </a:rPr>
+              <a:t>04</a:t>
+            </a:r>
+          </a:p>
+        </p:txBody>
+      </p:sp>
+      <p:sp>
+        <p:nvSpPr>
+          <p:cNvPr id="12" name="TextBox 11"/>
+          <p:cNvSpPr txBox="1"/>
+          <p:nvPr/>
+        </p:nvSpPr>
+        <p:spPr>
+          <a:xfrm>
+            <a:off x="1188720" y="3246120"/>
+            <a:ext cx="7680960" cy="292608"/>
+          </a:xfrm>
+          <a:prstGeom prst="rect">
+            <a:avLst/>
+          </a:prstGeom>
+          <a:noFill/>
+        </p:spPr>
+        <p:txBody>
+          <a:bodyPr wrap="square">
+            <a:spAutoFit/>
+          </a:bodyPr>
+          <a:lstStyle/>
+          <a:p>
+            <a:pPr algn="l"/>
+            <a:r>
+              <a:rPr sz="1200" b="0" i="0">
+                <a:solidFill>
+                  <a:srgbClr val="DDDDDD"/>
+                </a:solidFill>
+              </a:rPr>
+              <a:t>Our delivery — 5 sprints and what each taught us</a:t>
+            </a:r>
+          </a:p>
+        </p:txBody>
+      </p:sp>
+      <p:sp>
+        <p:nvSpPr>
+          <p:cNvPr id="13" name="TextBox 12"/>
+          <p:cNvSpPr txBox="1"/>
+          <p:nvPr/>
+        </p:nvSpPr>
+        <p:spPr>
+          <a:xfrm>
+            <a:off x="457200" y="3703320"/>
+            <a:ext cx="640080" cy="292608"/>
+          </a:xfrm>
+          <a:prstGeom prst="rect">
+            <a:avLst/>
+          </a:prstGeom>
+          <a:noFill/>
+        </p:spPr>
+        <p:txBody>
+          <a:bodyPr wrap="square">
+            <a:spAutoFit/>
+          </a:bodyPr>
+          <a:lstStyle/>
+          <a:p>
+            <a:pPr algn="l"/>
+            <a:r>
+              <a:rPr sz="1200" b="1" i="0">
+                <a:solidFill>
+                  <a:srgbClr val="FFCD00"/>
+                </a:solidFill>
+              </a:rPr>
+              <a:t>05</a:t>
+            </a:r>
+          </a:p>
+        </p:txBody>
+      </p:sp>
+      <p:sp>
+        <p:nvSpPr>
+          <p:cNvPr id="14" name="TextBox 13"/>
+          <p:cNvSpPr txBox="1"/>
+          <p:nvPr/>
+        </p:nvSpPr>
+        <p:spPr>
+          <a:xfrm>
+            <a:off x="1188720" y="3703320"/>
+            <a:ext cx="7680960" cy="292608"/>
+          </a:xfrm>
+          <a:prstGeom prst="rect">
+            <a:avLst/>
+          </a:prstGeom>
+          <a:noFill/>
+        </p:spPr>
+        <p:txBody>
+          <a:bodyPr wrap="square">
+            <a:spAutoFit/>
+          </a:bodyPr>
+          <a:lstStyle/>
+          <a:p>
+            <a:pPr algn="l"/>
+            <a:r>
+              <a:rPr sz="1200" b="0" i="0">
+                <a:solidFill>
+                  <a:srgbClr val="DDDDDD"/>
+                </a:solidFill>
+              </a:rPr>
+              <a:t>The product — a live, playable prototype</a:t>
+            </a:r>
+          </a:p>
+        </p:txBody>
+      </p:sp>
+      <p:sp>
+        <p:nvSpPr>
+          <p:cNvPr id="15" name="TextBox 14"/>
+          <p:cNvSpPr txBox="1"/>
+          <p:nvPr/>
+        </p:nvSpPr>
+        <p:spPr>
+          <a:xfrm>
+            <a:off x="457200" y="4160520"/>
+            <a:ext cx="640080" cy="292608"/>
+          </a:xfrm>
+          <a:prstGeom prst="rect">
+            <a:avLst/>
+          </a:prstGeom>
+          <a:noFill/>
+        </p:spPr>
+        <p:txBody>
+          <a:bodyPr wrap="square">
+            <a:spAutoFit/>
+          </a:bodyPr>
+          <a:lstStyle/>
+          <a:p>
+            <a:pPr algn="l"/>
+            <a:r>
+              <a:rPr sz="1200" b="1" i="0">
+                <a:solidFill>
+                  <a:srgbClr val="FFCD00"/>
+                </a:solidFill>
+              </a:rPr>
+              <a:t>06</a:t>
+            </a:r>
+          </a:p>
+        </p:txBody>
+      </p:sp>
+      <p:sp>
+        <p:nvSpPr>
+          <p:cNvPr id="16" name="TextBox 15"/>
+          <p:cNvSpPr txBox="1"/>
+          <p:nvPr/>
+        </p:nvSpPr>
+        <p:spPr>
+          <a:xfrm>
+            <a:off x="1188720" y="4160520"/>
+            <a:ext cx="7680960" cy="292608"/>
+          </a:xfrm>
+          <a:prstGeom prst="rect">
+            <a:avLst/>
+          </a:prstGeom>
+          <a:noFill/>
+        </p:spPr>
+        <p:txBody>
+          <a:bodyPr wrap="square">
+            <a:spAutoFit/>
+          </a:bodyPr>
+          <a:lstStyle/>
+          <a:p>
+            <a:pPr algn="l"/>
+            <a:r>
+              <a:rPr sz="1200" b="0" i="0">
+                <a:solidFill>
+                  <a:srgbClr val="DDDDDD"/>
+                </a:solidFill>
+              </a:rPr>
+              <a:t>What we learned — and how it shapes our careers</a:t>
+            </a:r>
+          </a:p>
+        </p:txBody>
+      </p:sp>
+    </p:spTree>
+  </p:cSld>
+  <p:clrMapOvr>
+    <a:masterClrMapping/>
+  </p:clrMapOvr>
+</p:sld>
+</file>
+
+<file path=ppt/slides/slide20.xml><?xml version="1.0" encoding="utf-8"?>
 <p:sld xmlns:a="http://schemas.openxmlformats.org/drawingml/2006/main" xmlns:r="http://schemas.openxmlformats.org/officeDocument/2006/relationships" xmlns:p="http://schemas.openxmlformats.org/presentationml/2006/main">
   <p:cSld name="Slide 18">
     <p:bg>
@@ -6282,7 +8297,418 @@
 </p:sld>
 </file>
 
-<file path=ppt/slides/slide2.xml><?xml version="1.0" encoding="utf-8"?>
+<file path=ppt/slides/slide21.xml><?xml version="1.0" encoding="utf-8"?>
+<p:sld xmlns:a="http://schemas.openxmlformats.org/drawingml/2006/main" xmlns:p="http://schemas.openxmlformats.org/presentationml/2006/main" xmlns:r="http://schemas.openxmlformats.org/officeDocument/2006/relationships">
+  <p:cSld>
+    <p:bg>
+      <p:bgPr>
+        <a:solidFill>
+          <a:srgbClr val="0D0D0D"/>
+        </a:solidFill>
+        <a:effectLst/>
+      </p:bgPr>
+    </p:bg>
+    <p:spTree>
+      <p:nvGrpSpPr>
+        <p:cNvPr id="1" name=""/>
+        <p:cNvGrpSpPr/>
+        <p:nvPr/>
+      </p:nvGrpSpPr>
+      <p:grpSpPr/>
+      <p:sp>
+        <p:nvSpPr>
+          <p:cNvPr id="2" name="TextBox 1"/>
+          <p:cNvSpPr txBox="1"/>
+          <p:nvPr/>
+        </p:nvSpPr>
+        <p:spPr>
+          <a:xfrm>
+            <a:off x="457200" y="256032"/>
+            <a:ext cx="6858000" cy="256032"/>
+          </a:xfrm>
+          <a:prstGeom prst="rect">
+            <a:avLst/>
+          </a:prstGeom>
+          <a:noFill/>
+        </p:spPr>
+        <p:txBody>
+          <a:bodyPr wrap="square">
+            <a:spAutoFit/>
+          </a:bodyPr>
+          <a:lstStyle/>
+          <a:p>
+            <a:pPr algn="l"/>
+            <a:r>
+              <a:rPr sz="1000" b="1" i="0">
+                <a:solidFill>
+                  <a:srgbClr val="888888"/>
+                </a:solidFill>
+              </a:rPr>
+              <a:t>PROFESSIONAL DEVELOPMENT</a:t>
+            </a:r>
+          </a:p>
+        </p:txBody>
+      </p:sp>
+      <p:sp>
+        <p:nvSpPr>
+          <p:cNvPr id="3" name="TextBox 2"/>
+          <p:cNvSpPr txBox="1"/>
+          <p:nvPr/>
+        </p:nvSpPr>
+        <p:spPr>
+          <a:xfrm>
+            <a:off x="3657600" y="4919472"/>
+            <a:ext cx="5212080" cy="182880"/>
+          </a:xfrm>
+          <a:prstGeom prst="rect">
+            <a:avLst/>
+          </a:prstGeom>
+          <a:noFill/>
+        </p:spPr>
+        <p:txBody>
+          <a:bodyPr wrap="square">
+            <a:spAutoFit/>
+          </a:bodyPr>
+          <a:lstStyle/>
+          <a:p>
+            <a:pPr algn="l"/>
+            <a:r>
+              <a:rPr sz="800" b="0" i="0">
+                <a:solidFill>
+                  <a:srgbClr val="444444"/>
+                </a:solidFill>
+              </a:rPr>
+              <a:t>NINJA QUIZ  .  503IT</a:t>
+            </a:r>
+          </a:p>
+        </p:txBody>
+      </p:sp>
+      <p:sp>
+        <p:nvSpPr>
+          <p:cNvPr id="4" name="TextBox 3"/>
+          <p:cNvSpPr txBox="1"/>
+          <p:nvPr/>
+        </p:nvSpPr>
+        <p:spPr>
+          <a:xfrm>
+            <a:off x="457200" y="594360"/>
+            <a:ext cx="8229600" cy="1097280"/>
+          </a:xfrm>
+          <a:prstGeom prst="rect">
+            <a:avLst/>
+          </a:prstGeom>
+          <a:noFill/>
+        </p:spPr>
+        <p:txBody>
+          <a:bodyPr wrap="square">
+            <a:spAutoFit/>
+          </a:bodyPr>
+          <a:lstStyle/>
+          <a:p>
+            <a:pPr algn="l"/>
+            <a:r>
+              <a:rPr sz="2800" b="1" i="0">
+                <a:solidFill>
+                  <a:srgbClr val="FFFFFF"/>
+                </a:solidFill>
+              </a:rPr>
+              <a:t>This project taught us how</a:t>
+            </a:r>
+          </a:p>
+          <a:p>
+            <a:pPr algn="l"/>
+            <a:r>
+              <a:rPr sz="2800" b="1" i="0">
+                <a:solidFill>
+                  <a:srgbClr val="FFFFFF"/>
+                </a:solidFill>
+              </a:rPr>
+              <a:t>industry teams actually work.</a:t>
+            </a:r>
+          </a:p>
+        </p:txBody>
+      </p:sp>
+      <p:sp>
+        <p:nvSpPr>
+          <p:cNvPr id="5" name="TextBox 4"/>
+          <p:cNvSpPr txBox="1"/>
+          <p:nvPr/>
+        </p:nvSpPr>
+        <p:spPr>
+          <a:xfrm>
+            <a:off x="457200" y="1874519"/>
+            <a:ext cx="3840480" cy="256032"/>
+          </a:xfrm>
+          <a:prstGeom prst="rect">
+            <a:avLst/>
+          </a:prstGeom>
+          <a:noFill/>
+        </p:spPr>
+        <p:txBody>
+          <a:bodyPr wrap="square">
+            <a:spAutoFit/>
+          </a:bodyPr>
+          <a:lstStyle/>
+          <a:p>
+            <a:pPr algn="l"/>
+            <a:r>
+              <a:rPr sz="1300" b="1" i="0">
+                <a:solidFill>
+                  <a:srgbClr val="FFCD00"/>
+                </a:solidFill>
+              </a:rPr>
+              <a:t>Structured communication</a:t>
+            </a:r>
+          </a:p>
+        </p:txBody>
+      </p:sp>
+      <p:sp>
+        <p:nvSpPr>
+          <p:cNvPr id="6" name="TextBox 5"/>
+          <p:cNvSpPr txBox="1"/>
+          <p:nvPr/>
+        </p:nvSpPr>
+        <p:spPr>
+          <a:xfrm>
+            <a:off x="457200" y="2148839"/>
+            <a:ext cx="8229600" cy="411480"/>
+          </a:xfrm>
+          <a:prstGeom prst="rect">
+            <a:avLst/>
+          </a:prstGeom>
+          <a:noFill/>
+        </p:spPr>
+        <p:txBody>
+          <a:bodyPr wrap="square">
+            <a:spAutoFit/>
+          </a:bodyPr>
+          <a:lstStyle/>
+          <a:p>
+            <a:pPr algn="l"/>
+            <a:r>
+              <a:rPr sz="1100" b="0" i="0">
+                <a:solidFill>
+                  <a:srgbClr val="AAAAAA"/>
+                </a:solidFill>
+              </a:rPr>
+              <a:t>Raising issues immediately, logging decisions in Trello and meeting minutes — these are professional standards, not student habits.</a:t>
+            </a:r>
+          </a:p>
+        </p:txBody>
+      </p:sp>
+      <p:sp>
+        <p:nvSpPr>
+          <p:cNvPr id="7" name="TextBox 6"/>
+          <p:cNvSpPr txBox="1"/>
+          <p:nvPr/>
+        </p:nvSpPr>
+        <p:spPr>
+          <a:xfrm>
+            <a:off x="457200" y="2697479"/>
+            <a:ext cx="3840480" cy="256032"/>
+          </a:xfrm>
+          <a:prstGeom prst="rect">
+            <a:avLst/>
+          </a:prstGeom>
+          <a:noFill/>
+        </p:spPr>
+        <p:txBody>
+          <a:bodyPr wrap="square">
+            <a:spAutoFit/>
+          </a:bodyPr>
+          <a:lstStyle/>
+          <a:p>
+            <a:pPr algn="l"/>
+            <a:r>
+              <a:rPr sz="1300" b="1" i="0">
+                <a:solidFill>
+                  <a:srgbClr val="FFCD00"/>
+                </a:solidFill>
+              </a:rPr>
+              <a:t>Real version control</a:t>
+            </a:r>
+          </a:p>
+        </p:txBody>
+      </p:sp>
+      <p:sp>
+        <p:nvSpPr>
+          <p:cNvPr id="8" name="TextBox 7"/>
+          <p:cNvSpPr txBox="1"/>
+          <p:nvPr/>
+        </p:nvSpPr>
+        <p:spPr>
+          <a:xfrm>
+            <a:off x="457200" y="2971799"/>
+            <a:ext cx="8229600" cy="411480"/>
+          </a:xfrm>
+          <a:prstGeom prst="rect">
+            <a:avLst/>
+          </a:prstGeom>
+          <a:noFill/>
+        </p:spPr>
+        <p:txBody>
+          <a:bodyPr wrap="square">
+            <a:spAutoFit/>
+          </a:bodyPr>
+          <a:lstStyle/>
+          <a:p>
+            <a:pPr algn="l"/>
+            <a:r>
+              <a:rPr sz="1100" b="0" i="0">
+                <a:solidFill>
+                  <a:srgbClr val="AAAAAA"/>
+                </a:solidFill>
+              </a:rPr>
+              <a:t>Feature branches, no pushing to main without review. We left this project with actual Git workflow experience.</a:t>
+            </a:r>
+          </a:p>
+        </p:txBody>
+      </p:sp>
+      <p:sp>
+        <p:nvSpPr>
+          <p:cNvPr id="9" name="TextBox 8"/>
+          <p:cNvSpPr txBox="1"/>
+          <p:nvPr/>
+        </p:nvSpPr>
+        <p:spPr>
+          <a:xfrm>
+            <a:off x="457200" y="3520439"/>
+            <a:ext cx="3840480" cy="256032"/>
+          </a:xfrm>
+          <a:prstGeom prst="rect">
+            <a:avLst/>
+          </a:prstGeom>
+          <a:noFill/>
+        </p:spPr>
+        <p:txBody>
+          <a:bodyPr wrap="square">
+            <a:spAutoFit/>
+          </a:bodyPr>
+          <a:lstStyle/>
+          <a:p>
+            <a:pPr algn="l"/>
+            <a:r>
+              <a:rPr sz="1300" b="1" i="0">
+                <a:solidFill>
+                  <a:srgbClr val="FFCD00"/>
+                </a:solidFill>
+              </a:rPr>
+              <a:t>Agile delivery mindset</a:t>
+            </a:r>
+          </a:p>
+        </p:txBody>
+      </p:sp>
+      <p:sp>
+        <p:nvSpPr>
+          <p:cNvPr id="10" name="TextBox 9"/>
+          <p:cNvSpPr txBox="1"/>
+          <p:nvPr/>
+        </p:nvSpPr>
+        <p:spPr>
+          <a:xfrm>
+            <a:off x="457200" y="3794759"/>
+            <a:ext cx="8229600" cy="411480"/>
+          </a:xfrm>
+          <a:prstGeom prst="rect">
+            <a:avLst/>
+          </a:prstGeom>
+          <a:noFill/>
+        </p:spPr>
+        <p:txBody>
+          <a:bodyPr wrap="square">
+            <a:spAutoFit/>
+          </a:bodyPr>
+          <a:lstStyle/>
+          <a:p>
+            <a:pPr algn="l"/>
+            <a:r>
+              <a:rPr sz="1100" b="0" i="0">
+                <a:solidFill>
+                  <a:srgbClr val="AAAAAA"/>
+                </a:solidFill>
+              </a:rPr>
+              <a:t>Five sprints with goals, retrospectives, and user testing mirrors how software teams ship in industry.</a:t>
+            </a:r>
+          </a:p>
+        </p:txBody>
+      </p:sp>
+      <p:sp>
+        <p:nvSpPr>
+          <p:cNvPr id="11" name="TextBox 10"/>
+          <p:cNvSpPr txBox="1"/>
+          <p:nvPr/>
+        </p:nvSpPr>
+        <p:spPr>
+          <a:xfrm>
+            <a:off x="457200" y="4343400"/>
+            <a:ext cx="3840480" cy="256032"/>
+          </a:xfrm>
+          <a:prstGeom prst="rect">
+            <a:avLst/>
+          </a:prstGeom>
+          <a:noFill/>
+        </p:spPr>
+        <p:txBody>
+          <a:bodyPr wrap="square">
+            <a:spAutoFit/>
+          </a:bodyPr>
+          <a:lstStyle/>
+          <a:p>
+            <a:pPr algn="l"/>
+            <a:r>
+              <a:rPr sz="1300" b="1" i="0">
+                <a:solidFill>
+                  <a:srgbClr val="FFCD00"/>
+                </a:solidFill>
+              </a:rPr>
+              <a:t>Resilience under pressure</a:t>
+            </a:r>
+          </a:p>
+        </p:txBody>
+      </p:sp>
+      <p:sp>
+        <p:nvSpPr>
+          <p:cNvPr id="12" name="TextBox 11"/>
+          <p:cNvSpPr txBox="1"/>
+          <p:nvPr/>
+        </p:nvSpPr>
+        <p:spPr>
+          <a:xfrm>
+            <a:off x="457200" y="4617720"/>
+            <a:ext cx="8229600" cy="411480"/>
+          </a:xfrm>
+          <a:prstGeom prst="rect">
+            <a:avLst/>
+          </a:prstGeom>
+          <a:noFill/>
+        </p:spPr>
+        <p:txBody>
+          <a:bodyPr wrap="square">
+            <a:spAutoFit/>
+          </a:bodyPr>
+          <a:lstStyle/>
+          <a:p>
+            <a:pPr algn="l"/>
+            <a:r>
+              <a:rPr sz="1100" b="0" i="0">
+                <a:solidFill>
+                  <a:srgbClr val="AAAAAA"/>
+                </a:solidFill>
+              </a:rPr>
+              <a:t>When the game broke 2 weeks before submission, we diagnosed and fixed it in one day — as a team. That experience is irreplaceable.</a:t>
+            </a:r>
+          </a:p>
+        </p:txBody>
+      </p:sp>
+    </p:spTree>
+  </p:cSld>
+  <p:clrMapOvr>
+    <a:masterClrMapping/>
+  </p:clrMapOvr>
+</p:sld>
+</file>
+
+<file path=ppt/slides/slide3.xml><?xml version="1.0" encoding="utf-8"?>
 <p:sld xmlns:a="http://schemas.openxmlformats.org/drawingml/2006/main" xmlns:r="http://schemas.openxmlformats.org/officeDocument/2006/relationships" xmlns:p="http://schemas.openxmlformats.org/presentationml/2006/main">
   <p:cSld name="Slide 2">
     <p:bg>
@@ -6537,7 +8963,7 @@
 </p:sld>
 </file>
 
-<file path=ppt/slides/slide3.xml><?xml version="1.0" encoding="utf-8"?>
+<file path=ppt/slides/slide4.xml><?xml version="1.0" encoding="utf-8"?>
 <p:sld xmlns:a="http://schemas.openxmlformats.org/drawingml/2006/main" xmlns:r="http://schemas.openxmlformats.org/officeDocument/2006/relationships" xmlns:p="http://schemas.openxmlformats.org/presentationml/2006/main">
   <p:cSld name="Slide 3">
     <p:bg>
@@ -6742,7 +9168,7 @@
 </p:sld>
 </file>
 
-<file path=ppt/slides/slide4.xml><?xml version="1.0" encoding="utf-8"?>
+<file path=ppt/slides/slide5.xml><?xml version="1.0" encoding="utf-8"?>
 <p:sld xmlns:a="http://schemas.openxmlformats.org/drawingml/2006/main" xmlns:r="http://schemas.openxmlformats.org/officeDocument/2006/relationships" xmlns:p="http://schemas.openxmlformats.org/presentationml/2006/main">
   <p:cSld name="Slide 4">
     <p:bg>
@@ -6988,7 +9414,7 @@
         <p:spPr>
           <a:xfrm>
             <a:off x="1371600" y="1591056"/>
-            <a:ext cx="7315200" cy="292608"/>
+            <a:ext cx="3474720" cy="292608"/>
           </a:xfrm>
           <a:prstGeom prst="rect">
             <a:avLst/>
@@ -7027,7 +9453,7 @@
         <p:spPr>
           <a:xfrm>
             <a:off x="1371600" y="1892808"/>
-            <a:ext cx="7315200" cy="228600"/>
+            <a:ext cx="3474720" cy="228600"/>
           </a:xfrm>
           <a:prstGeom prst="rect">
             <a:avLst/>
@@ -7107,7 +9533,7 @@
         <p:spPr>
           <a:xfrm>
             <a:off x="1371600" y="2258568"/>
-            <a:ext cx="7315200" cy="292608"/>
+            <a:ext cx="3474720" cy="292608"/>
           </a:xfrm>
           <a:prstGeom prst="rect">
             <a:avLst/>
@@ -7146,7 +9572,7 @@
         <p:spPr>
           <a:xfrm>
             <a:off x="1371600" y="2560320"/>
-            <a:ext cx="7315200" cy="228600"/>
+            <a:ext cx="3474720" cy="228600"/>
           </a:xfrm>
           <a:prstGeom prst="rect">
             <a:avLst/>
@@ -7226,7 +9652,7 @@
         <p:spPr>
           <a:xfrm>
             <a:off x="1371600" y="2926080"/>
-            <a:ext cx="7315200" cy="292608"/>
+            <a:ext cx="3474720" cy="292608"/>
           </a:xfrm>
           <a:prstGeom prst="rect">
             <a:avLst/>
@@ -7265,7 +9691,7 @@
         <p:spPr>
           <a:xfrm>
             <a:off x="1371600" y="3227832"/>
-            <a:ext cx="7315200" cy="228600"/>
+            <a:ext cx="3474720" cy="228600"/>
           </a:xfrm>
           <a:prstGeom prst="rect">
             <a:avLst/>
@@ -7345,7 +9771,7 @@
         <p:spPr>
           <a:xfrm>
             <a:off x="1371600" y="3593592"/>
-            <a:ext cx="7315200" cy="292608"/>
+            <a:ext cx="3474720" cy="292608"/>
           </a:xfrm>
           <a:prstGeom prst="rect">
             <a:avLst/>
@@ -7384,7 +9810,7 @@
         <p:spPr>
           <a:xfrm>
             <a:off x="1371600" y="3895344"/>
-            <a:ext cx="7315200" cy="228600"/>
+            <a:ext cx="3474720" cy="228600"/>
           </a:xfrm>
           <a:prstGeom prst="rect">
             <a:avLst/>
@@ -7464,7 +9890,7 @@
         <p:spPr>
           <a:xfrm>
             <a:off x="1371600" y="4261104"/>
-            <a:ext cx="7315200" cy="292608"/>
+            <a:ext cx="3474720" cy="292608"/>
           </a:xfrm>
           <a:prstGeom prst="rect">
             <a:avLst/>
@@ -7503,7 +9929,7 @@
         <p:spPr>
           <a:xfrm>
             <a:off x="1371600" y="4562856"/>
-            <a:ext cx="7315200" cy="228600"/>
+            <a:ext cx="3474720" cy="228600"/>
           </a:xfrm>
           <a:prstGeom prst="rect">
             <a:avLst/>
@@ -7530,6 +9956,210 @@
               <a:t>Scoring system and results screen</a:t>
             </a:r>
             <a:endParaRPr lang="en-US" sz="1200" dirty="0"/>
+          </a:p>
+        </p:txBody>
+      </p:sp>
+      <p:sp>
+        <p:nvSpPr>
+          <p:cNvPr id="22" name="TextBox 21"/>
+          <p:cNvSpPr txBox="1"/>
+          <p:nvPr/>
+        </p:nvSpPr>
+        <p:spPr>
+          <a:xfrm>
+            <a:off x="5303520" y="1298448"/>
+            <a:ext cx="3474720" cy="256032"/>
+          </a:xfrm>
+          <a:prstGeom prst="rect">
+            <a:avLst/>
+          </a:prstGeom>
+          <a:noFill/>
+        </p:spPr>
+        <p:txBody>
+          <a:bodyPr wrap="square">
+            <a:spAutoFit/>
+          </a:bodyPr>
+          <a:lstStyle/>
+          <a:p>
+            <a:pPr algn="l"/>
+            <a:r>
+              <a:rPr sz="900" b="1" i="0">
+                <a:solidFill>
+                  <a:srgbClr val="888888"/>
+                </a:solidFill>
+              </a:rPr>
+              <a:t>BELBIN ROLE</a:t>
+            </a:r>
+          </a:p>
+        </p:txBody>
+      </p:sp>
+      <p:sp>
+        <p:nvSpPr>
+          <p:cNvPr id="23" name="TextBox 22"/>
+          <p:cNvSpPr txBox="1"/>
+          <p:nvPr/>
+        </p:nvSpPr>
+        <p:spPr>
+          <a:xfrm>
+            <a:off x="5303520" y="1591056"/>
+            <a:ext cx="3474720" cy="292608"/>
+          </a:xfrm>
+          <a:prstGeom prst="rect">
+            <a:avLst/>
+          </a:prstGeom>
+          <a:noFill/>
+        </p:spPr>
+        <p:txBody>
+          <a:bodyPr wrap="square">
+            <a:spAutoFit/>
+          </a:bodyPr>
+          <a:lstStyle/>
+          <a:p>
+            <a:pPr algn="l"/>
+            <a:r>
+              <a:rPr sz="1200" b="1" i="0">
+                <a:solidFill>
+                  <a:srgbClr val="FFCD00"/>
+                </a:solidFill>
+              </a:rPr>
+              <a:t>Coordinator</a:t>
+            </a:r>
+          </a:p>
+        </p:txBody>
+      </p:sp>
+      <p:sp>
+        <p:nvSpPr>
+          <p:cNvPr id="24" name="TextBox 23"/>
+          <p:cNvSpPr txBox="1"/>
+          <p:nvPr/>
+        </p:nvSpPr>
+        <p:spPr>
+          <a:xfrm>
+            <a:off x="5303520" y="2258568"/>
+            <a:ext cx="3474720" cy="292608"/>
+          </a:xfrm>
+          <a:prstGeom prst="rect">
+            <a:avLst/>
+          </a:prstGeom>
+          <a:noFill/>
+        </p:spPr>
+        <p:txBody>
+          <a:bodyPr wrap="square">
+            <a:spAutoFit/>
+          </a:bodyPr>
+          <a:lstStyle/>
+          <a:p>
+            <a:pPr algn="l"/>
+            <a:r>
+              <a:rPr sz="1200" b="1" i="0">
+                <a:solidFill>
+                  <a:srgbClr val="FFCD00"/>
+                </a:solidFill>
+              </a:rPr>
+              <a:t>Implementer</a:t>
+            </a:r>
+          </a:p>
+        </p:txBody>
+      </p:sp>
+      <p:sp>
+        <p:nvSpPr>
+          <p:cNvPr id="25" name="TextBox 24"/>
+          <p:cNvSpPr txBox="1"/>
+          <p:nvPr/>
+        </p:nvSpPr>
+        <p:spPr>
+          <a:xfrm>
+            <a:off x="5303520" y="2926080"/>
+            <a:ext cx="3474720" cy="292608"/>
+          </a:xfrm>
+          <a:prstGeom prst="rect">
+            <a:avLst/>
+          </a:prstGeom>
+          <a:noFill/>
+        </p:spPr>
+        <p:txBody>
+          <a:bodyPr wrap="square">
+            <a:spAutoFit/>
+          </a:bodyPr>
+          <a:lstStyle/>
+          <a:p>
+            <a:pPr algn="l"/>
+            <a:r>
+              <a:rPr sz="1200" b="1" i="0">
+                <a:solidFill>
+                  <a:srgbClr val="FFCD00"/>
+                </a:solidFill>
+              </a:rPr>
+              <a:t>Specialist</a:t>
+            </a:r>
+          </a:p>
+        </p:txBody>
+      </p:sp>
+      <p:sp>
+        <p:nvSpPr>
+          <p:cNvPr id="26" name="TextBox 25"/>
+          <p:cNvSpPr txBox="1"/>
+          <p:nvPr/>
+        </p:nvSpPr>
+        <p:spPr>
+          <a:xfrm>
+            <a:off x="5303520" y="3593592"/>
+            <a:ext cx="3474720" cy="292608"/>
+          </a:xfrm>
+          <a:prstGeom prst="rect">
+            <a:avLst/>
+          </a:prstGeom>
+          <a:noFill/>
+        </p:spPr>
+        <p:txBody>
+          <a:bodyPr wrap="square">
+            <a:spAutoFit/>
+          </a:bodyPr>
+          <a:lstStyle/>
+          <a:p>
+            <a:pPr algn="l"/>
+            <a:r>
+              <a:rPr sz="1200" b="1" i="0">
+                <a:solidFill>
+                  <a:srgbClr val="FFCD00"/>
+                </a:solidFill>
+              </a:rPr>
+              <a:t>Plant</a:t>
+            </a:r>
+          </a:p>
+        </p:txBody>
+      </p:sp>
+      <p:sp>
+        <p:nvSpPr>
+          <p:cNvPr id="27" name="TextBox 26"/>
+          <p:cNvSpPr txBox="1"/>
+          <p:nvPr/>
+        </p:nvSpPr>
+        <p:spPr>
+          <a:xfrm>
+            <a:off x="5303520" y="4261104"/>
+            <a:ext cx="3474720" cy="292608"/>
+          </a:xfrm>
+          <a:prstGeom prst="rect">
+            <a:avLst/>
+          </a:prstGeom>
+          <a:noFill/>
+        </p:spPr>
+        <p:txBody>
+          <a:bodyPr wrap="square">
+            <a:spAutoFit/>
+          </a:bodyPr>
+          <a:lstStyle/>
+          <a:p>
+            <a:pPr algn="l"/>
+            <a:r>
+              <a:rPr sz="1200" b="1" i="0">
+                <a:solidFill>
+                  <a:srgbClr val="FFCD00"/>
+                </a:solidFill>
+              </a:rPr>
+              <a:t>Completer Finisher</a:t>
+            </a:r>
           </a:p>
         </p:txBody>
       </p:sp>
@@ -7541,7 +10171,7 @@
 </p:sld>
 </file>
 
-<file path=ppt/slides/slide5.xml><?xml version="1.0" encoding="utf-8"?>
+<file path=ppt/slides/slide6.xml><?xml version="1.0" encoding="utf-8"?>
 <p:sld xmlns:a="http://schemas.openxmlformats.org/drawingml/2006/main" xmlns:r="http://schemas.openxmlformats.org/officeDocument/2006/relationships" xmlns:p="http://schemas.openxmlformats.org/presentationml/2006/main">
   <p:cSld name="Slide 5">
     <p:bg>
@@ -7768,7 +10398,7 @@
 </p:sld>
 </file>
 
-<file path=ppt/slides/slide6.xml><?xml version="1.0" encoding="utf-8"?>
+<file path=ppt/slides/slide7.xml><?xml version="1.0" encoding="utf-8"?>
 <p:sld xmlns:a="http://schemas.openxmlformats.org/drawingml/2006/main" xmlns:r="http://schemas.openxmlformats.org/officeDocument/2006/relationships" xmlns:p="http://schemas.openxmlformats.org/presentationml/2006/main">
   <p:cSld name="Slide 6">
     <p:bg>
@@ -8014,7 +10644,7 @@
         <p:spPr>
           <a:xfrm>
             <a:off x="1371600" y="1591056"/>
-            <a:ext cx="7315200" cy="292608"/>
+            <a:ext cx="3840480" cy="292608"/>
           </a:xfrm>
           <a:prstGeom prst="rect">
             <a:avLst/>
@@ -8053,7 +10683,7 @@
         <p:spPr>
           <a:xfrm>
             <a:off x="1371600" y="1892808"/>
-            <a:ext cx="7315200" cy="228600"/>
+            <a:ext cx="3840480" cy="228600"/>
           </a:xfrm>
           <a:prstGeom prst="rect">
             <a:avLst/>
@@ -8133,7 +10763,7 @@
         <p:spPr>
           <a:xfrm>
             <a:off x="1371600" y="2414016"/>
-            <a:ext cx="7315200" cy="292608"/>
+            <a:ext cx="3840480" cy="292608"/>
           </a:xfrm>
           <a:prstGeom prst="rect">
             <a:avLst/>
@@ -8172,7 +10802,7 @@
         <p:spPr>
           <a:xfrm>
             <a:off x="1371600" y="2715768"/>
-            <a:ext cx="7315200" cy="228600"/>
+            <a:ext cx="3840480" cy="228600"/>
           </a:xfrm>
           <a:prstGeom prst="rect">
             <a:avLst/>
@@ -8252,7 +10882,7 @@
         <p:spPr>
           <a:xfrm>
             <a:off x="1371600" y="3236976"/>
-            <a:ext cx="7315200" cy="292608"/>
+            <a:ext cx="3840480" cy="292608"/>
           </a:xfrm>
           <a:prstGeom prst="rect">
             <a:avLst/>
@@ -8291,7 +10921,7 @@
         <p:spPr>
           <a:xfrm>
             <a:off x="1371600" y="3538728"/>
-            <a:ext cx="7315200" cy="228600"/>
+            <a:ext cx="3840480" cy="228600"/>
           </a:xfrm>
           <a:prstGeom prst="rect">
             <a:avLst/>
@@ -8330,7 +10960,7 @@
         <p:spPr>
           <a:xfrm>
             <a:off x="457200" y="4160520"/>
-            <a:ext cx="7772400" cy="320040"/>
+            <a:ext cx="3840480" cy="320040"/>
           </a:xfrm>
           <a:prstGeom prst="rect">
             <a:avLst/>
@@ -8357,6 +10987,88 @@
               <a:t>Every tool had one purpose. No tool was used for everything.</a:t>
             </a:r>
             <a:endParaRPr lang="en-US" sz="1400" dirty="0"/>
+          </a:p>
+        </p:txBody>
+      </p:sp>
+      <p:pic>
+        <p:nvPicPr>
+          <p:cNvPr id="17" name="Picture 16" descr="Trello.png"/>
+          <p:cNvPicPr>
+            <a:picLocks noChangeAspect="1"/>
+          </p:cNvPicPr>
+          <p:nvPr/>
+        </p:nvPicPr>
+        <p:blipFill>
+          <a:blip r:embed="rId3"/>
+          <a:stretch>
+            <a:fillRect/>
+          </a:stretch>
+        </p:blipFill>
+        <p:spPr>
+          <a:xfrm>
+            <a:off x="4572000" y="1417320"/>
+            <a:ext cx="4297680" cy="2514600"/>
+          </a:xfrm>
+          <a:prstGeom prst="rect">
+            <a:avLst/>
+          </a:prstGeom>
+        </p:spPr>
+      </p:pic>
+      <p:pic>
+        <p:nvPicPr>
+          <p:cNvPr id="18" name="Picture 17" descr="Call in whatsapp.jpeg"/>
+          <p:cNvPicPr>
+            <a:picLocks noChangeAspect="1"/>
+          </p:cNvPicPr>
+          <p:nvPr/>
+        </p:nvPicPr>
+        <p:blipFill>
+          <a:blip r:embed="rId4"/>
+          <a:stretch>
+            <a:fillRect/>
+          </a:stretch>
+        </p:blipFill>
+        <p:spPr>
+          <a:xfrm>
+            <a:off x="4572000" y="4023360"/>
+            <a:ext cx="960120" cy="914400"/>
+          </a:xfrm>
+          <a:prstGeom prst="rect">
+            <a:avLst/>
+          </a:prstGeom>
+        </p:spPr>
+      </p:pic>
+      <p:sp>
+        <p:nvSpPr>
+          <p:cNvPr id="19" name="TextBox 18"/>
+          <p:cNvSpPr txBox="1"/>
+          <p:nvPr/>
+        </p:nvSpPr>
+        <p:spPr>
+          <a:xfrm>
+            <a:off x="5577840" y="4160520"/>
+            <a:ext cx="3291840" cy="274320"/>
+          </a:xfrm>
+          <a:prstGeom prst="rect">
+            <a:avLst/>
+          </a:prstGeom>
+          <a:noFill/>
+        </p:spPr>
+        <p:txBody>
+          <a:bodyPr wrap="square">
+            <a:spAutoFit/>
+          </a:bodyPr>
+          <a:lstStyle/>
+          <a:p>
+            <a:pPr algn="l"/>
+            <a:r>
+              <a:rPr sz="900" b="0" i="1">
+                <a:solidFill>
+                  <a:srgbClr val="888888"/>
+                </a:solidFill>
+              </a:rPr>
+              <a:t>WhatsApp team call — 4 of 5 members</a:t>
+            </a:r>
           </a:p>
         </p:txBody>
       </p:sp>
@@ -8368,7 +11080,7 @@
 </p:sld>
 </file>
 
-<file path=ppt/slides/slide7.xml><?xml version="1.0" encoding="utf-8"?>
+<file path=ppt/slides/slide8.xml><?xml version="1.0" encoding="utf-8"?>
 <p:sld xmlns:a="http://schemas.openxmlformats.org/drawingml/2006/main" xmlns:r="http://schemas.openxmlformats.org/officeDocument/2006/relationships" xmlns:p="http://schemas.openxmlformats.org/presentationml/2006/main">
   <p:cSld name="Slide 7">
     <p:bg>
@@ -8507,7 +11219,7 @@
         <p:spPr>
           <a:xfrm>
             <a:off x="457200" y="777240"/>
-            <a:ext cx="8229600" cy="1117600"/>
+            <a:ext cx="4114800" cy="1117600"/>
           </a:xfrm>
           <a:prstGeom prst="rect">
             <a:avLst/>
@@ -8629,7 +11341,7 @@
         <p:spPr>
           <a:xfrm>
             <a:off x="1143000" y="2606040"/>
-            <a:ext cx="6858000" cy="411480"/>
+            <a:ext cx="4114800" cy="411480"/>
           </a:xfrm>
           <a:prstGeom prst="rect">
             <a:avLst/>
@@ -8707,7 +11419,7 @@
         <p:spPr>
           <a:xfrm>
             <a:off x="1143000" y="3264408"/>
-            <a:ext cx="6858000" cy="411480"/>
+            <a:ext cx="4114800" cy="411480"/>
           </a:xfrm>
           <a:prstGeom prst="rect">
             <a:avLst/>
@@ -8785,7 +11497,7 @@
         <p:spPr>
           <a:xfrm>
             <a:off x="1143000" y="3922776"/>
-            <a:ext cx="6858000" cy="411480"/>
+            <a:ext cx="4114800" cy="411480"/>
           </a:xfrm>
           <a:prstGeom prst="rect">
             <a:avLst/>
@@ -8815,6 +11527,30 @@
           </a:p>
         </p:txBody>
       </p:sp>
+      <p:pic>
+        <p:nvPicPr>
+          <p:cNvPr id="13" name="Picture 12" descr="team live meeting.jpeg"/>
+          <p:cNvPicPr>
+            <a:picLocks noChangeAspect="1"/>
+          </p:cNvPicPr>
+          <p:nvPr/>
+        </p:nvPicPr>
+        <p:blipFill>
+          <a:blip r:embed="rId3"/>
+          <a:stretch>
+            <a:fillRect/>
+          </a:stretch>
+        </p:blipFill>
+        <p:spPr>
+          <a:xfrm>
+            <a:off x="4572000" y="731520"/>
+            <a:ext cx="4389120" cy="4023360"/>
+          </a:xfrm>
+          <a:prstGeom prst="rect">
+            <a:avLst/>
+          </a:prstGeom>
+        </p:spPr>
+      </p:pic>
     </p:spTree>
   </p:cSld>
   <p:clrMapOvr>
@@ -8823,7 +11559,7 @@
 </p:sld>
 </file>
 
-<file path=ppt/slides/slide8.xml><?xml version="1.0" encoding="utf-8"?>
+<file path=ppt/slides/slide9.xml><?xml version="1.0" encoding="utf-8"?>
 <p:sld xmlns:a="http://schemas.openxmlformats.org/drawingml/2006/main" xmlns:r="http://schemas.openxmlformats.org/officeDocument/2006/relationships" xmlns:p="http://schemas.openxmlformats.org/presentationml/2006/main">
   <p:cSld name="Slide 8">
     <p:bg>
@@ -9571,805 +12307,6 @@
               <a:t>Everyone had a vote</a:t>
             </a:r>
             <a:endParaRPr lang="en-US" sz="1400" dirty="0"/>
-          </a:p>
-        </p:txBody>
-      </p:sp>
-    </p:spTree>
-  </p:cSld>
-  <p:clrMapOvr>
-    <a:masterClrMapping/>
-  </p:clrMapOvr>
-</p:sld>
-</file>
-
-<file path=ppt/slides/slide9.xml><?xml version="1.0" encoding="utf-8"?>
-<p:sld xmlns:a="http://schemas.openxmlformats.org/drawingml/2006/main" xmlns:r="http://schemas.openxmlformats.org/officeDocument/2006/relationships" xmlns:p="http://schemas.openxmlformats.org/presentationml/2006/main">
-  <p:cSld name="Slide 9">
-    <p:bg>
-      <p:bgPr>
-        <a:solidFill>
-          <a:srgbClr val="FFFFFF"/>
-        </a:solidFill>
-        <a:effectLst/>
-      </p:bgPr>
-    </p:bg>
-    <p:spTree>
-      <p:nvGrpSpPr>
-        <p:cNvPr id="1" name=""/>
-        <p:cNvGrpSpPr/>
-        <p:nvPr/>
-      </p:nvGrpSpPr>
-      <p:grpSpPr>
-        <a:xfrm>
-          <a:off x="0" y="0"/>
-          <a:ext cx="0" cy="0"/>
-          <a:chOff x="0" y="0"/>
-          <a:chExt cx="0" cy="0"/>
-        </a:xfrm>
-      </p:grpSpPr>
-      <p:sp>
-        <p:nvSpPr>
-          <p:cNvPr id="2" name="Shape 0"/>
-          <p:cNvSpPr/>
-          <p:nvPr/>
-        </p:nvSpPr>
-        <p:spPr>
-          <a:xfrm>
-            <a:off x="8458200" y="201168"/>
-            <a:ext cx="256032" cy="256032"/>
-          </a:xfrm>
-          <a:prstGeom prst="ellipse">
-            <a:avLst/>
-          </a:prstGeom>
-          <a:solidFill>
-            <a:srgbClr val="DDDDDD"/>
-          </a:solidFill>
-          <a:ln/>
-        </p:spPr>
-        <p:txBody>
-          <a:bodyPr/>
-          <a:lstStyle/>
-          <a:p>
-            <a:endParaRPr lang="en-GB"/>
-          </a:p>
-        </p:txBody>
-      </p:sp>
-      <p:sp>
-        <p:nvSpPr>
-          <p:cNvPr id="3" name="Text 1"/>
-          <p:cNvSpPr/>
-          <p:nvPr/>
-        </p:nvSpPr>
-        <p:spPr>
-          <a:xfrm>
-            <a:off x="457200" y="274320"/>
-            <a:ext cx="6400800" cy="228600"/>
-          </a:xfrm>
-          <a:prstGeom prst="rect">
-            <a:avLst/>
-          </a:prstGeom>
-          <a:noFill/>
-          <a:ln/>
-        </p:spPr>
-        <p:txBody>
-          <a:bodyPr wrap="square" rtlCol="0" anchor="ctr"/>
-          <a:lstStyle/>
-          <a:p>
-            <a:pPr marL="0" indent="0">
-              <a:buNone/>
-            </a:pPr>
-            <a:r>
-              <a:rPr lang="en-US" sz="1000" b="1" kern="0" spc="200" dirty="0">
-                <a:solidFill>
-                  <a:srgbClr val="888888"/>
-                </a:solidFill>
-                <a:latin typeface="Arial" pitchFamily="34" charset="0"/>
-                <a:ea typeface="Arial" pitchFamily="34" charset="-122"/>
-                <a:cs typeface="Arial" pitchFamily="34" charset="-120"/>
-              </a:rPr>
-              <a:t>DELIVERY PROCESS</a:t>
-            </a:r>
-            <a:endParaRPr lang="en-US" sz="1000" dirty="0"/>
-          </a:p>
-        </p:txBody>
-      </p:sp>
-      <p:sp>
-        <p:nvSpPr>
-          <p:cNvPr id="4" name="Text 2"/>
-          <p:cNvSpPr/>
-          <p:nvPr/>
-        </p:nvSpPr>
-        <p:spPr>
-          <a:xfrm>
-            <a:off x="3657600" y="4919472"/>
-            <a:ext cx="5212080" cy="182880"/>
-          </a:xfrm>
-          <a:prstGeom prst="rect">
-            <a:avLst/>
-          </a:prstGeom>
-          <a:noFill/>
-          <a:ln/>
-        </p:spPr>
-        <p:txBody>
-          <a:bodyPr wrap="square" rtlCol="0" anchor="ctr"/>
-          <a:lstStyle/>
-          <a:p>
-            <a:pPr marL="0" indent="0" algn="r">
-              <a:buNone/>
-            </a:pPr>
-            <a:r>
-              <a:rPr lang="en-US" sz="900" dirty="0">
-                <a:solidFill>
-                  <a:srgbClr val="888888"/>
-                </a:solidFill>
-                <a:latin typeface="Arial" pitchFamily="34" charset="0"/>
-                <a:ea typeface="Arial" pitchFamily="34" charset="-122"/>
-                <a:cs typeface="Arial" pitchFamily="34" charset="-120"/>
-              </a:rPr>
-              <a:t>NINJA QUIZ  ·  503IT  ·  09 / 18</a:t>
-            </a:r>
-            <a:endParaRPr lang="en-US" sz="900" dirty="0"/>
-          </a:p>
-        </p:txBody>
-      </p:sp>
-      <p:sp>
-        <p:nvSpPr>
-          <p:cNvPr id="5" name="Text 3"/>
-          <p:cNvSpPr/>
-          <p:nvPr/>
-        </p:nvSpPr>
-        <p:spPr>
-          <a:xfrm>
-            <a:off x="457200" y="685800"/>
-            <a:ext cx="8229600" cy="812800"/>
-          </a:xfrm>
-          <a:prstGeom prst="rect">
-            <a:avLst/>
-          </a:prstGeom>
-          <a:noFill/>
-          <a:ln/>
-        </p:spPr>
-        <p:txBody>
-          <a:bodyPr wrap="square" rtlCol="0" anchor="ctr"/>
-          <a:lstStyle/>
-          <a:p>
-            <a:pPr marL="0" indent="0">
-              <a:buNone/>
-            </a:pPr>
-            <a:r>
-              <a:rPr lang="en-US" sz="3200" b="1" dirty="0">
-                <a:solidFill>
-                  <a:srgbClr val="111111"/>
-                </a:solidFill>
-                <a:latin typeface="Arial Black" pitchFamily="34" charset="0"/>
-                <a:ea typeface="Arial Black" pitchFamily="34" charset="-122"/>
-                <a:cs typeface="Arial Black" pitchFamily="34" charset="-120"/>
-              </a:rPr>
-              <a:t>Built in five sprints.</a:t>
-            </a:r>
-            <a:endParaRPr lang="en-US" sz="3200" dirty="0"/>
-          </a:p>
-        </p:txBody>
-      </p:sp>
-      <p:sp>
-        <p:nvSpPr>
-          <p:cNvPr id="6" name="Shape 4"/>
-          <p:cNvSpPr/>
-          <p:nvPr/>
-        </p:nvSpPr>
-        <p:spPr>
-          <a:xfrm>
-            <a:off x="457200" y="1463040"/>
-            <a:ext cx="8229600" cy="10973"/>
-          </a:xfrm>
-          <a:prstGeom prst="rect">
-            <a:avLst/>
-          </a:prstGeom>
-          <a:solidFill>
-            <a:srgbClr val="EEEEEE"/>
-          </a:solidFill>
-          <a:ln/>
-        </p:spPr>
-        <p:txBody>
-          <a:bodyPr/>
-          <a:lstStyle/>
-          <a:p>
-            <a:endParaRPr lang="en-GB"/>
-          </a:p>
-        </p:txBody>
-      </p:sp>
-      <p:sp>
-        <p:nvSpPr>
-          <p:cNvPr id="7" name="Text 5"/>
-          <p:cNvSpPr/>
-          <p:nvPr/>
-        </p:nvSpPr>
-        <p:spPr>
-          <a:xfrm>
-            <a:off x="457200" y="1609344"/>
-            <a:ext cx="868680" cy="411480"/>
-          </a:xfrm>
-          <a:prstGeom prst="rect">
-            <a:avLst/>
-          </a:prstGeom>
-          <a:noFill/>
-          <a:ln/>
-        </p:spPr>
-        <p:txBody>
-          <a:bodyPr wrap="square" rtlCol="0" anchor="ctr">
-            <a:normAutofit/>
-          </a:bodyPr>
-          <a:lstStyle/>
-          <a:p>
-            <a:pPr marL="0" indent="0">
-              <a:buNone/>
-            </a:pPr>
-            <a:r>
-              <a:rPr lang="en-US" sz="2000" b="1" dirty="0">
-                <a:solidFill>
-                  <a:srgbClr val="FFCD00"/>
-                </a:solidFill>
-                <a:latin typeface="Arial Black" pitchFamily="34" charset="0"/>
-                <a:ea typeface="Arial Black" pitchFamily="34" charset="-122"/>
-                <a:cs typeface="Arial Black" pitchFamily="34" charset="-120"/>
-              </a:rPr>
-              <a:t>01</a:t>
-            </a:r>
-            <a:endParaRPr lang="en-US" sz="2000" dirty="0"/>
-          </a:p>
-        </p:txBody>
-      </p:sp>
-      <p:sp>
-        <p:nvSpPr>
-          <p:cNvPr id="8" name="Text 6"/>
-          <p:cNvSpPr/>
-          <p:nvPr/>
-        </p:nvSpPr>
-        <p:spPr>
-          <a:xfrm>
-            <a:off x="1371600" y="1591056"/>
-            <a:ext cx="7315200" cy="292608"/>
-          </a:xfrm>
-          <a:prstGeom prst="rect">
-            <a:avLst/>
-          </a:prstGeom>
-          <a:noFill/>
-          <a:ln/>
-        </p:spPr>
-        <p:txBody>
-          <a:bodyPr wrap="square" rtlCol="0" anchor="ctr"/>
-          <a:lstStyle/>
-          <a:p>
-            <a:pPr marL="0" indent="0">
-              <a:buNone/>
-            </a:pPr>
-            <a:r>
-              <a:rPr lang="en-US" sz="1700" b="1" dirty="0">
-                <a:solidFill>
-                  <a:srgbClr val="111111"/>
-                </a:solidFill>
-                <a:latin typeface="Arial Black" pitchFamily="34" charset="0"/>
-                <a:ea typeface="Arial Black" pitchFamily="34" charset="-122"/>
-                <a:cs typeface="Arial Black" pitchFamily="34" charset="-120"/>
-              </a:rPr>
-              <a:t>Sprint 1  —  Login &amp; menu</a:t>
-            </a:r>
-            <a:endParaRPr lang="en-US" sz="1700" dirty="0"/>
-          </a:p>
-        </p:txBody>
-      </p:sp>
-      <p:sp>
-        <p:nvSpPr>
-          <p:cNvPr id="9" name="Text 7"/>
-          <p:cNvSpPr/>
-          <p:nvPr/>
-        </p:nvSpPr>
-        <p:spPr>
-          <a:xfrm>
-            <a:off x="1371600" y="1892808"/>
-            <a:ext cx="7315200" cy="228600"/>
-          </a:xfrm>
-          <a:prstGeom prst="rect">
-            <a:avLst/>
-          </a:prstGeom>
-          <a:noFill/>
-          <a:ln/>
-        </p:spPr>
-        <p:txBody>
-          <a:bodyPr wrap="square" rtlCol="0" anchor="ctr"/>
-          <a:lstStyle/>
-          <a:p>
-            <a:pPr marL="0" indent="0">
-              <a:buNone/>
-            </a:pPr>
-            <a:r>
-              <a:rPr lang="en-US" sz="1200" dirty="0">
-                <a:solidFill>
-                  <a:srgbClr val="888888"/>
-                </a:solidFill>
-                <a:latin typeface="Arial" pitchFamily="34" charset="0"/>
-                <a:ea typeface="Arial" pitchFamily="34" charset="-122"/>
-                <a:cs typeface="Arial" pitchFamily="34" charset="-120"/>
-              </a:rPr>
-              <a:t>Foundation. Every member set up. GitHub branches created.</a:t>
-            </a:r>
-            <a:endParaRPr lang="en-US" sz="1200" dirty="0"/>
-          </a:p>
-        </p:txBody>
-      </p:sp>
-      <p:sp>
-        <p:nvSpPr>
-          <p:cNvPr id="10" name="Text 8"/>
-          <p:cNvSpPr/>
-          <p:nvPr/>
-        </p:nvSpPr>
-        <p:spPr>
-          <a:xfrm>
-            <a:off x="457200" y="2231136"/>
-            <a:ext cx="868680" cy="411480"/>
-          </a:xfrm>
-          <a:prstGeom prst="rect">
-            <a:avLst/>
-          </a:prstGeom>
-          <a:noFill/>
-          <a:ln/>
-        </p:spPr>
-        <p:txBody>
-          <a:bodyPr wrap="square" rtlCol="0" anchor="ctr">
-            <a:normAutofit/>
-          </a:bodyPr>
-          <a:lstStyle/>
-          <a:p>
-            <a:pPr marL="0" indent="0">
-              <a:buNone/>
-            </a:pPr>
-            <a:r>
-              <a:rPr lang="en-US" sz="2000" b="1" dirty="0">
-                <a:solidFill>
-                  <a:srgbClr val="FFCD00"/>
-                </a:solidFill>
-                <a:latin typeface="Arial Black" pitchFamily="34" charset="0"/>
-                <a:ea typeface="Arial Black" pitchFamily="34" charset="-122"/>
-                <a:cs typeface="Arial Black" pitchFamily="34" charset="-120"/>
-              </a:rPr>
-              <a:t>02</a:t>
-            </a:r>
-            <a:endParaRPr lang="en-US" sz="2000" dirty="0"/>
-          </a:p>
-        </p:txBody>
-      </p:sp>
-      <p:sp>
-        <p:nvSpPr>
-          <p:cNvPr id="11" name="Text 9"/>
-          <p:cNvSpPr/>
-          <p:nvPr/>
-        </p:nvSpPr>
-        <p:spPr>
-          <a:xfrm>
-            <a:off x="1371600" y="2212848"/>
-            <a:ext cx="7315200" cy="292608"/>
-          </a:xfrm>
-          <a:prstGeom prst="rect">
-            <a:avLst/>
-          </a:prstGeom>
-          <a:noFill/>
-          <a:ln/>
-        </p:spPr>
-        <p:txBody>
-          <a:bodyPr wrap="square" rtlCol="0" anchor="ctr"/>
-          <a:lstStyle/>
-          <a:p>
-            <a:pPr marL="0" indent="0">
-              <a:buNone/>
-            </a:pPr>
-            <a:r>
-              <a:rPr lang="en-US" sz="1700" b="1" dirty="0">
-                <a:solidFill>
-                  <a:srgbClr val="111111"/>
-                </a:solidFill>
-                <a:latin typeface="Arial Black" pitchFamily="34" charset="0"/>
-                <a:ea typeface="Arial Black" pitchFamily="34" charset="-122"/>
-                <a:cs typeface="Arial Black" pitchFamily="34" charset="-120"/>
-              </a:rPr>
-              <a:t>Sprint 2  —  Game engine</a:t>
-            </a:r>
-            <a:endParaRPr lang="en-US" sz="1700" dirty="0"/>
-          </a:p>
-        </p:txBody>
-      </p:sp>
-      <p:sp>
-        <p:nvSpPr>
-          <p:cNvPr id="12" name="Text 10"/>
-          <p:cNvSpPr/>
-          <p:nvPr/>
-        </p:nvSpPr>
-        <p:spPr>
-          <a:xfrm>
-            <a:off x="1371600" y="2514600"/>
-            <a:ext cx="7315200" cy="228600"/>
-          </a:xfrm>
-          <a:prstGeom prst="rect">
-            <a:avLst/>
-          </a:prstGeom>
-          <a:noFill/>
-          <a:ln/>
-        </p:spPr>
-        <p:txBody>
-          <a:bodyPr wrap="square" rtlCol="0" anchor="ctr"/>
-          <a:lstStyle/>
-          <a:p>
-            <a:pPr marL="0" indent="0">
-              <a:buNone/>
-            </a:pPr>
-            <a:r>
-              <a:rPr lang="en-US" sz="1200" dirty="0">
-                <a:solidFill>
-                  <a:srgbClr val="888888"/>
-                </a:solidFill>
-                <a:latin typeface="Arial" pitchFamily="34" charset="0"/>
-                <a:ea typeface="Arial" pitchFamily="34" charset="-122"/>
-                <a:cs typeface="Arial" pitchFamily="34" charset="-120"/>
-              </a:rPr>
-              <a:t>Core mechanics built. Daily check-ins via WhatsApp.</a:t>
-            </a:r>
-            <a:endParaRPr lang="en-US" sz="1200" dirty="0"/>
-          </a:p>
-        </p:txBody>
-      </p:sp>
-      <p:sp>
-        <p:nvSpPr>
-          <p:cNvPr id="13" name="Text 11"/>
-          <p:cNvSpPr/>
-          <p:nvPr/>
-        </p:nvSpPr>
-        <p:spPr>
-          <a:xfrm>
-            <a:off x="457200" y="2852928"/>
-            <a:ext cx="868680" cy="411480"/>
-          </a:xfrm>
-          <a:prstGeom prst="rect">
-            <a:avLst/>
-          </a:prstGeom>
-          <a:noFill/>
-          <a:ln/>
-        </p:spPr>
-        <p:txBody>
-          <a:bodyPr wrap="square" rtlCol="0" anchor="ctr">
-            <a:normAutofit/>
-          </a:bodyPr>
-          <a:lstStyle/>
-          <a:p>
-            <a:pPr marL="0" indent="0">
-              <a:buNone/>
-            </a:pPr>
-            <a:r>
-              <a:rPr lang="en-US" sz="2000" b="1" dirty="0">
-                <a:solidFill>
-                  <a:srgbClr val="FFCD00"/>
-                </a:solidFill>
-                <a:latin typeface="Arial Black" pitchFamily="34" charset="0"/>
-                <a:ea typeface="Arial Black" pitchFamily="34" charset="-122"/>
-                <a:cs typeface="Arial Black" pitchFamily="34" charset="-120"/>
-              </a:rPr>
-              <a:t>03</a:t>
-            </a:r>
-            <a:endParaRPr lang="en-US" sz="2000" dirty="0"/>
-          </a:p>
-        </p:txBody>
-      </p:sp>
-      <p:sp>
-        <p:nvSpPr>
-          <p:cNvPr id="14" name="Text 12"/>
-          <p:cNvSpPr/>
-          <p:nvPr/>
-        </p:nvSpPr>
-        <p:spPr>
-          <a:xfrm>
-            <a:off x="1371600" y="2834640"/>
-            <a:ext cx="7315200" cy="292608"/>
-          </a:xfrm>
-          <a:prstGeom prst="rect">
-            <a:avLst/>
-          </a:prstGeom>
-          <a:noFill/>
-          <a:ln/>
-        </p:spPr>
-        <p:txBody>
-          <a:bodyPr wrap="square" rtlCol="0" anchor="ctr"/>
-          <a:lstStyle/>
-          <a:p>
-            <a:pPr marL="0" indent="0">
-              <a:buNone/>
-            </a:pPr>
-            <a:r>
-              <a:rPr lang="en-US" sz="1700" b="1" dirty="0">
-                <a:solidFill>
-                  <a:srgbClr val="111111"/>
-                </a:solidFill>
-                <a:latin typeface="Arial Black" pitchFamily="34" charset="0"/>
-                <a:ea typeface="Arial Black" pitchFamily="34" charset="-122"/>
-                <a:cs typeface="Arial Black" pitchFamily="34" charset="-120"/>
-              </a:rPr>
-              <a:t>Sprint 3  —  Slicing &amp; sound</a:t>
-            </a:r>
-            <a:endParaRPr lang="en-US" sz="1700" dirty="0"/>
-          </a:p>
-        </p:txBody>
-      </p:sp>
-      <p:sp>
-        <p:nvSpPr>
-          <p:cNvPr id="15" name="Text 13"/>
-          <p:cNvSpPr/>
-          <p:nvPr/>
-        </p:nvSpPr>
-        <p:spPr>
-          <a:xfrm>
-            <a:off x="1371600" y="3136392"/>
-            <a:ext cx="7315200" cy="228600"/>
-          </a:xfrm>
-          <a:prstGeom prst="rect">
-            <a:avLst/>
-          </a:prstGeom>
-          <a:noFill/>
-          <a:ln/>
-        </p:spPr>
-        <p:txBody>
-          <a:bodyPr wrap="square" rtlCol="0" anchor="ctr"/>
-          <a:lstStyle/>
-          <a:p>
-            <a:pPr marL="0" indent="0">
-              <a:buNone/>
-            </a:pPr>
-            <a:r>
-              <a:rPr lang="en-US" sz="1200" dirty="0">
-                <a:solidFill>
-                  <a:srgbClr val="888888"/>
-                </a:solidFill>
-                <a:latin typeface="Arial" pitchFamily="34" charset="0"/>
-                <a:ea typeface="Arial" pitchFamily="34" charset="-122"/>
-                <a:cs typeface="Arial" pitchFamily="34" charset="-120"/>
-              </a:rPr>
-              <a:t>Visual integration. First merge conflicts resolved.</a:t>
-            </a:r>
-            <a:endParaRPr lang="en-US" sz="1200" dirty="0"/>
-          </a:p>
-        </p:txBody>
-      </p:sp>
-      <p:sp>
-        <p:nvSpPr>
-          <p:cNvPr id="16" name="Text 14"/>
-          <p:cNvSpPr/>
-          <p:nvPr/>
-        </p:nvSpPr>
-        <p:spPr>
-          <a:xfrm>
-            <a:off x="457200" y="3474720"/>
-            <a:ext cx="868680" cy="411480"/>
-          </a:xfrm>
-          <a:prstGeom prst="rect">
-            <a:avLst/>
-          </a:prstGeom>
-          <a:noFill/>
-          <a:ln/>
-        </p:spPr>
-        <p:txBody>
-          <a:bodyPr wrap="square" rtlCol="0" anchor="ctr">
-            <a:normAutofit/>
-          </a:bodyPr>
-          <a:lstStyle/>
-          <a:p>
-            <a:pPr marL="0" indent="0">
-              <a:buNone/>
-            </a:pPr>
-            <a:r>
-              <a:rPr lang="en-US" sz="2000" b="1" dirty="0">
-                <a:solidFill>
-                  <a:srgbClr val="FFCD00"/>
-                </a:solidFill>
-                <a:latin typeface="Arial Black" pitchFamily="34" charset="0"/>
-                <a:ea typeface="Arial Black" pitchFamily="34" charset="-122"/>
-                <a:cs typeface="Arial Black" pitchFamily="34" charset="-120"/>
-              </a:rPr>
-              <a:t>04</a:t>
-            </a:r>
-            <a:endParaRPr lang="en-US" sz="2000" dirty="0"/>
-          </a:p>
-        </p:txBody>
-      </p:sp>
-      <p:sp>
-        <p:nvSpPr>
-          <p:cNvPr id="17" name="Text 15"/>
-          <p:cNvSpPr/>
-          <p:nvPr/>
-        </p:nvSpPr>
-        <p:spPr>
-          <a:xfrm>
-            <a:off x="1371600" y="3456432"/>
-            <a:ext cx="7315200" cy="292608"/>
-          </a:xfrm>
-          <a:prstGeom prst="rect">
-            <a:avLst/>
-          </a:prstGeom>
-          <a:noFill/>
-          <a:ln/>
-        </p:spPr>
-        <p:txBody>
-          <a:bodyPr wrap="square" rtlCol="0" anchor="ctr"/>
-          <a:lstStyle/>
-          <a:p>
-            <a:pPr marL="0" indent="0">
-              <a:buNone/>
-            </a:pPr>
-            <a:r>
-              <a:rPr lang="en-US" sz="1700" b="1" dirty="0">
-                <a:solidFill>
-                  <a:srgbClr val="111111"/>
-                </a:solidFill>
-                <a:latin typeface="Arial Black" pitchFamily="34" charset="0"/>
-                <a:ea typeface="Arial Black" pitchFamily="34" charset="-122"/>
-                <a:cs typeface="Arial Black" pitchFamily="34" charset="-120"/>
-              </a:rPr>
-              <a:t>Sprint 4  —  Leaderboard</a:t>
-            </a:r>
-            <a:endParaRPr lang="en-US" sz="1700" dirty="0"/>
-          </a:p>
-        </p:txBody>
-      </p:sp>
-      <p:sp>
-        <p:nvSpPr>
-          <p:cNvPr id="18" name="Text 16"/>
-          <p:cNvSpPr/>
-          <p:nvPr/>
-        </p:nvSpPr>
-        <p:spPr>
-          <a:xfrm>
-            <a:off x="1371600" y="3758184"/>
-            <a:ext cx="7315200" cy="228600"/>
-          </a:xfrm>
-          <a:prstGeom prst="rect">
-            <a:avLst/>
-          </a:prstGeom>
-          <a:noFill/>
-          <a:ln/>
-        </p:spPr>
-        <p:txBody>
-          <a:bodyPr wrap="square" rtlCol="0" anchor="ctr"/>
-          <a:lstStyle/>
-          <a:p>
-            <a:pPr marL="0" indent="0">
-              <a:buNone/>
-            </a:pPr>
-            <a:r>
-              <a:rPr lang="en-US" sz="1200" dirty="0">
-                <a:solidFill>
-                  <a:srgbClr val="888888"/>
-                </a:solidFill>
-                <a:latin typeface="Arial" pitchFamily="34" charset="0"/>
-                <a:ea typeface="Arial" pitchFamily="34" charset="-122"/>
-                <a:cs typeface="Arial" pitchFamily="34" charset="-120"/>
-              </a:rPr>
-              <a:t>Peer testing begins. Feedback collected and logged.</a:t>
-            </a:r>
-            <a:endParaRPr lang="en-US" sz="1200" dirty="0"/>
-          </a:p>
-        </p:txBody>
-      </p:sp>
-      <p:sp>
-        <p:nvSpPr>
-          <p:cNvPr id="19" name="Text 17"/>
-          <p:cNvSpPr/>
-          <p:nvPr/>
-        </p:nvSpPr>
-        <p:spPr>
-          <a:xfrm>
-            <a:off x="457200" y="4096512"/>
-            <a:ext cx="868680" cy="411480"/>
-          </a:xfrm>
-          <a:prstGeom prst="rect">
-            <a:avLst/>
-          </a:prstGeom>
-          <a:noFill/>
-          <a:ln/>
-        </p:spPr>
-        <p:txBody>
-          <a:bodyPr wrap="square" rtlCol="0" anchor="ctr">
-            <a:normAutofit/>
-          </a:bodyPr>
-          <a:lstStyle/>
-          <a:p>
-            <a:pPr marL="0" indent="0">
-              <a:buNone/>
-            </a:pPr>
-            <a:r>
-              <a:rPr lang="en-US" sz="2000" b="1" dirty="0">
-                <a:solidFill>
-                  <a:srgbClr val="FFCD00"/>
-                </a:solidFill>
-                <a:latin typeface="Arial Black" pitchFamily="34" charset="0"/>
-                <a:ea typeface="Arial Black" pitchFamily="34" charset="-122"/>
-                <a:cs typeface="Arial Black" pitchFamily="34" charset="-120"/>
-              </a:rPr>
-              <a:t>05</a:t>
-            </a:r>
-            <a:endParaRPr lang="en-US" sz="2000" dirty="0"/>
-          </a:p>
-        </p:txBody>
-      </p:sp>
-      <p:sp>
-        <p:nvSpPr>
-          <p:cNvPr id="20" name="Text 18"/>
-          <p:cNvSpPr/>
-          <p:nvPr/>
-        </p:nvSpPr>
-        <p:spPr>
-          <a:xfrm>
-            <a:off x="1371600" y="4078224"/>
-            <a:ext cx="7315200" cy="292608"/>
-          </a:xfrm>
-          <a:prstGeom prst="rect">
-            <a:avLst/>
-          </a:prstGeom>
-          <a:noFill/>
-          <a:ln/>
-        </p:spPr>
-        <p:txBody>
-          <a:bodyPr wrap="square" rtlCol="0" anchor="ctr"/>
-          <a:lstStyle/>
-          <a:p>
-            <a:pPr marL="0" indent="0">
-              <a:buNone/>
-            </a:pPr>
-            <a:r>
-              <a:rPr lang="en-US" sz="1700" b="1" dirty="0">
-                <a:solidFill>
-                  <a:srgbClr val="111111"/>
-                </a:solidFill>
-                <a:latin typeface="Arial Black" pitchFamily="34" charset="0"/>
-                <a:ea typeface="Arial Black" pitchFamily="34" charset="-122"/>
-                <a:cs typeface="Arial Black" pitchFamily="34" charset="-120"/>
-              </a:rPr>
-              <a:t>Sprint 5  —  Testing &amp; polish</a:t>
-            </a:r>
-            <a:endParaRPr lang="en-US" sz="1700" dirty="0"/>
-          </a:p>
-        </p:txBody>
-      </p:sp>
-      <p:sp>
-        <p:nvSpPr>
-          <p:cNvPr id="21" name="Text 19"/>
-          <p:cNvSpPr/>
-          <p:nvPr/>
-        </p:nvSpPr>
-        <p:spPr>
-          <a:xfrm>
-            <a:off x="1371600" y="4379976"/>
-            <a:ext cx="7315200" cy="228600"/>
-          </a:xfrm>
-          <a:prstGeom prst="rect">
-            <a:avLst/>
-          </a:prstGeom>
-          <a:noFill/>
-          <a:ln/>
-        </p:spPr>
-        <p:txBody>
-          <a:bodyPr wrap="square" rtlCol="0" anchor="ctr"/>
-          <a:lstStyle/>
-          <a:p>
-            <a:pPr marL="0" indent="0">
-              <a:buNone/>
-            </a:pPr>
-            <a:r>
-              <a:rPr lang="en-US" sz="1200" dirty="0">
-                <a:solidFill>
-                  <a:srgbClr val="888888"/>
-                </a:solidFill>
-                <a:latin typeface="Arial" pitchFamily="34" charset="0"/>
-                <a:ea typeface="Arial" pitchFamily="34" charset="-122"/>
-                <a:cs typeface="Arial" pitchFamily="34" charset="-120"/>
-              </a:rPr>
-              <a:t>Bug hunt, final fixes, review before submission.</a:t>
-            </a:r>
-            <a:endParaRPr lang="en-US" sz="1200" dirty="0"/>
           </a:p>
         </p:txBody>
       </p:sp>

</xml_diff>

<commit_message>
Fix team slide (remove Belbin), fix collab tools slide (clean Trello image), delete agenda slide
</commit_message>
<xml_diff>
--- a/NinjaQuiz-Presentation.pptx
+++ b/NinjaQuiz-Presentation.pptx
@@ -9,7 +9,6 @@
   </p:notesMasterIdLst>
   <p:sldIdLst>
     <p:sldId id="256" r:id="rId2"/>
-    <p:sldId id="274" r:id="rId25"/>
     <p:sldId id="257" r:id="rId3"/>
     <p:sldId id="258" r:id="rId4"/>
     <p:sldId id="259" r:id="rId5"/>
@@ -8094,6 +8093,417 @@
 </file>
 
 <file path=ppt/slides/slide20.xml><?xml version="1.0" encoding="utf-8"?>
+<p:sld xmlns:a="http://schemas.openxmlformats.org/drawingml/2006/main" xmlns:p="http://schemas.openxmlformats.org/presentationml/2006/main" xmlns:r="http://schemas.openxmlformats.org/officeDocument/2006/relationships">
+  <p:cSld>
+    <p:bg>
+      <p:bgPr>
+        <a:solidFill>
+          <a:srgbClr val="0D0D0D"/>
+        </a:solidFill>
+        <a:effectLst/>
+      </p:bgPr>
+    </p:bg>
+    <p:spTree>
+      <p:nvGrpSpPr>
+        <p:cNvPr id="1" name=""/>
+        <p:cNvGrpSpPr/>
+        <p:nvPr/>
+      </p:nvGrpSpPr>
+      <p:grpSpPr/>
+      <p:sp>
+        <p:nvSpPr>
+          <p:cNvPr id="2" name="TextBox 1"/>
+          <p:cNvSpPr txBox="1"/>
+          <p:nvPr/>
+        </p:nvSpPr>
+        <p:spPr>
+          <a:xfrm>
+            <a:off x="457200" y="256032"/>
+            <a:ext cx="6858000" cy="256032"/>
+          </a:xfrm>
+          <a:prstGeom prst="rect">
+            <a:avLst/>
+          </a:prstGeom>
+          <a:noFill/>
+        </p:spPr>
+        <p:txBody>
+          <a:bodyPr wrap="square">
+            <a:spAutoFit/>
+          </a:bodyPr>
+          <a:lstStyle/>
+          <a:p>
+            <a:pPr algn="l"/>
+            <a:r>
+              <a:rPr sz="1000" b="1" i="0">
+                <a:solidFill>
+                  <a:srgbClr val="888888"/>
+                </a:solidFill>
+              </a:rPr>
+              <a:t>PROFESSIONAL DEVELOPMENT</a:t>
+            </a:r>
+          </a:p>
+        </p:txBody>
+      </p:sp>
+      <p:sp>
+        <p:nvSpPr>
+          <p:cNvPr id="3" name="TextBox 2"/>
+          <p:cNvSpPr txBox="1"/>
+          <p:nvPr/>
+        </p:nvSpPr>
+        <p:spPr>
+          <a:xfrm>
+            <a:off x="3657600" y="4919472"/>
+            <a:ext cx="5212080" cy="182880"/>
+          </a:xfrm>
+          <a:prstGeom prst="rect">
+            <a:avLst/>
+          </a:prstGeom>
+          <a:noFill/>
+        </p:spPr>
+        <p:txBody>
+          <a:bodyPr wrap="square">
+            <a:spAutoFit/>
+          </a:bodyPr>
+          <a:lstStyle/>
+          <a:p>
+            <a:pPr algn="l"/>
+            <a:r>
+              <a:rPr sz="800" b="0" i="0">
+                <a:solidFill>
+                  <a:srgbClr val="444444"/>
+                </a:solidFill>
+              </a:rPr>
+              <a:t>NINJA QUIZ  .  503IT</a:t>
+            </a:r>
+          </a:p>
+        </p:txBody>
+      </p:sp>
+      <p:sp>
+        <p:nvSpPr>
+          <p:cNvPr id="4" name="TextBox 3"/>
+          <p:cNvSpPr txBox="1"/>
+          <p:nvPr/>
+        </p:nvSpPr>
+        <p:spPr>
+          <a:xfrm>
+            <a:off x="457200" y="594360"/>
+            <a:ext cx="8229600" cy="1097280"/>
+          </a:xfrm>
+          <a:prstGeom prst="rect">
+            <a:avLst/>
+          </a:prstGeom>
+          <a:noFill/>
+        </p:spPr>
+        <p:txBody>
+          <a:bodyPr wrap="square">
+            <a:spAutoFit/>
+          </a:bodyPr>
+          <a:lstStyle/>
+          <a:p>
+            <a:pPr algn="l"/>
+            <a:r>
+              <a:rPr sz="2800" b="1" i="0">
+                <a:solidFill>
+                  <a:srgbClr val="FFFFFF"/>
+                </a:solidFill>
+              </a:rPr>
+              <a:t>This project taught us how</a:t>
+            </a:r>
+          </a:p>
+          <a:p>
+            <a:pPr algn="l"/>
+            <a:r>
+              <a:rPr sz="2800" b="1" i="0">
+                <a:solidFill>
+                  <a:srgbClr val="FFFFFF"/>
+                </a:solidFill>
+              </a:rPr>
+              <a:t>industry teams actually work.</a:t>
+            </a:r>
+          </a:p>
+        </p:txBody>
+      </p:sp>
+      <p:sp>
+        <p:nvSpPr>
+          <p:cNvPr id="5" name="TextBox 4"/>
+          <p:cNvSpPr txBox="1"/>
+          <p:nvPr/>
+        </p:nvSpPr>
+        <p:spPr>
+          <a:xfrm>
+            <a:off x="457200" y="1874519"/>
+            <a:ext cx="3840480" cy="256032"/>
+          </a:xfrm>
+          <a:prstGeom prst="rect">
+            <a:avLst/>
+          </a:prstGeom>
+          <a:noFill/>
+        </p:spPr>
+        <p:txBody>
+          <a:bodyPr wrap="square">
+            <a:spAutoFit/>
+          </a:bodyPr>
+          <a:lstStyle/>
+          <a:p>
+            <a:pPr algn="l"/>
+            <a:r>
+              <a:rPr sz="1300" b="1" i="0">
+                <a:solidFill>
+                  <a:srgbClr val="FFCD00"/>
+                </a:solidFill>
+              </a:rPr>
+              <a:t>Structured communication</a:t>
+            </a:r>
+          </a:p>
+        </p:txBody>
+      </p:sp>
+      <p:sp>
+        <p:nvSpPr>
+          <p:cNvPr id="6" name="TextBox 5"/>
+          <p:cNvSpPr txBox="1"/>
+          <p:nvPr/>
+        </p:nvSpPr>
+        <p:spPr>
+          <a:xfrm>
+            <a:off x="457200" y="2148839"/>
+            <a:ext cx="8229600" cy="411480"/>
+          </a:xfrm>
+          <a:prstGeom prst="rect">
+            <a:avLst/>
+          </a:prstGeom>
+          <a:noFill/>
+        </p:spPr>
+        <p:txBody>
+          <a:bodyPr wrap="square">
+            <a:spAutoFit/>
+          </a:bodyPr>
+          <a:lstStyle/>
+          <a:p>
+            <a:pPr algn="l"/>
+            <a:r>
+              <a:rPr sz="1100" b="0" i="0">
+                <a:solidFill>
+                  <a:srgbClr val="AAAAAA"/>
+                </a:solidFill>
+              </a:rPr>
+              <a:t>Raising issues immediately, logging decisions in Trello and meeting minutes — these are professional standards, not student habits.</a:t>
+            </a:r>
+          </a:p>
+        </p:txBody>
+      </p:sp>
+      <p:sp>
+        <p:nvSpPr>
+          <p:cNvPr id="7" name="TextBox 6"/>
+          <p:cNvSpPr txBox="1"/>
+          <p:nvPr/>
+        </p:nvSpPr>
+        <p:spPr>
+          <a:xfrm>
+            <a:off x="457200" y="2697479"/>
+            <a:ext cx="3840480" cy="256032"/>
+          </a:xfrm>
+          <a:prstGeom prst="rect">
+            <a:avLst/>
+          </a:prstGeom>
+          <a:noFill/>
+        </p:spPr>
+        <p:txBody>
+          <a:bodyPr wrap="square">
+            <a:spAutoFit/>
+          </a:bodyPr>
+          <a:lstStyle/>
+          <a:p>
+            <a:pPr algn="l"/>
+            <a:r>
+              <a:rPr sz="1300" b="1" i="0">
+                <a:solidFill>
+                  <a:srgbClr val="FFCD00"/>
+                </a:solidFill>
+              </a:rPr>
+              <a:t>Real version control</a:t>
+            </a:r>
+          </a:p>
+        </p:txBody>
+      </p:sp>
+      <p:sp>
+        <p:nvSpPr>
+          <p:cNvPr id="8" name="TextBox 7"/>
+          <p:cNvSpPr txBox="1"/>
+          <p:nvPr/>
+        </p:nvSpPr>
+        <p:spPr>
+          <a:xfrm>
+            <a:off x="457200" y="2971799"/>
+            <a:ext cx="8229600" cy="411480"/>
+          </a:xfrm>
+          <a:prstGeom prst="rect">
+            <a:avLst/>
+          </a:prstGeom>
+          <a:noFill/>
+        </p:spPr>
+        <p:txBody>
+          <a:bodyPr wrap="square">
+            <a:spAutoFit/>
+          </a:bodyPr>
+          <a:lstStyle/>
+          <a:p>
+            <a:pPr algn="l"/>
+            <a:r>
+              <a:rPr sz="1100" b="0" i="0">
+                <a:solidFill>
+                  <a:srgbClr val="AAAAAA"/>
+                </a:solidFill>
+              </a:rPr>
+              <a:t>Feature branches, no pushing to main without review. We left this project with actual Git workflow experience.</a:t>
+            </a:r>
+          </a:p>
+        </p:txBody>
+      </p:sp>
+      <p:sp>
+        <p:nvSpPr>
+          <p:cNvPr id="9" name="TextBox 8"/>
+          <p:cNvSpPr txBox="1"/>
+          <p:nvPr/>
+        </p:nvSpPr>
+        <p:spPr>
+          <a:xfrm>
+            <a:off x="457200" y="3520439"/>
+            <a:ext cx="3840480" cy="256032"/>
+          </a:xfrm>
+          <a:prstGeom prst="rect">
+            <a:avLst/>
+          </a:prstGeom>
+          <a:noFill/>
+        </p:spPr>
+        <p:txBody>
+          <a:bodyPr wrap="square">
+            <a:spAutoFit/>
+          </a:bodyPr>
+          <a:lstStyle/>
+          <a:p>
+            <a:pPr algn="l"/>
+            <a:r>
+              <a:rPr sz="1300" b="1" i="0">
+                <a:solidFill>
+                  <a:srgbClr val="FFCD00"/>
+                </a:solidFill>
+              </a:rPr>
+              <a:t>Agile delivery mindset</a:t>
+            </a:r>
+          </a:p>
+        </p:txBody>
+      </p:sp>
+      <p:sp>
+        <p:nvSpPr>
+          <p:cNvPr id="10" name="TextBox 9"/>
+          <p:cNvSpPr txBox="1"/>
+          <p:nvPr/>
+        </p:nvSpPr>
+        <p:spPr>
+          <a:xfrm>
+            <a:off x="457200" y="3794759"/>
+            <a:ext cx="8229600" cy="411480"/>
+          </a:xfrm>
+          <a:prstGeom prst="rect">
+            <a:avLst/>
+          </a:prstGeom>
+          <a:noFill/>
+        </p:spPr>
+        <p:txBody>
+          <a:bodyPr wrap="square">
+            <a:spAutoFit/>
+          </a:bodyPr>
+          <a:lstStyle/>
+          <a:p>
+            <a:pPr algn="l"/>
+            <a:r>
+              <a:rPr sz="1100" b="0" i="0">
+                <a:solidFill>
+                  <a:srgbClr val="AAAAAA"/>
+                </a:solidFill>
+              </a:rPr>
+              <a:t>Five sprints with goals, retrospectives, and user testing mirrors how software teams ship in industry.</a:t>
+            </a:r>
+          </a:p>
+        </p:txBody>
+      </p:sp>
+      <p:sp>
+        <p:nvSpPr>
+          <p:cNvPr id="11" name="TextBox 10"/>
+          <p:cNvSpPr txBox="1"/>
+          <p:nvPr/>
+        </p:nvSpPr>
+        <p:spPr>
+          <a:xfrm>
+            <a:off x="457200" y="4343400"/>
+            <a:ext cx="3840480" cy="256032"/>
+          </a:xfrm>
+          <a:prstGeom prst="rect">
+            <a:avLst/>
+          </a:prstGeom>
+          <a:noFill/>
+        </p:spPr>
+        <p:txBody>
+          <a:bodyPr wrap="square">
+            <a:spAutoFit/>
+          </a:bodyPr>
+          <a:lstStyle/>
+          <a:p>
+            <a:pPr algn="l"/>
+            <a:r>
+              <a:rPr sz="1300" b="1" i="0">
+                <a:solidFill>
+                  <a:srgbClr val="FFCD00"/>
+                </a:solidFill>
+              </a:rPr>
+              <a:t>Resilience under pressure</a:t>
+            </a:r>
+          </a:p>
+        </p:txBody>
+      </p:sp>
+      <p:sp>
+        <p:nvSpPr>
+          <p:cNvPr id="12" name="TextBox 11"/>
+          <p:cNvSpPr txBox="1"/>
+          <p:nvPr/>
+        </p:nvSpPr>
+        <p:spPr>
+          <a:xfrm>
+            <a:off x="457200" y="4617720"/>
+            <a:ext cx="8229600" cy="411480"/>
+          </a:xfrm>
+          <a:prstGeom prst="rect">
+            <a:avLst/>
+          </a:prstGeom>
+          <a:noFill/>
+        </p:spPr>
+        <p:txBody>
+          <a:bodyPr wrap="square">
+            <a:spAutoFit/>
+          </a:bodyPr>
+          <a:lstStyle/>
+          <a:p>
+            <a:pPr algn="l"/>
+            <a:r>
+              <a:rPr sz="1100" b="0" i="0">
+                <a:solidFill>
+                  <a:srgbClr val="AAAAAA"/>
+                </a:solidFill>
+              </a:rPr>
+              <a:t>When the game broke 2 weeks before submission, we diagnosed and fixed it in one day — as a team. That experience is irreplaceable.</a:t>
+            </a:r>
+          </a:p>
+        </p:txBody>
+      </p:sp>
+    </p:spTree>
+  </p:cSld>
+  <p:clrMapOvr>
+    <a:masterClrMapping/>
+  </p:clrMapOvr>
+</p:sld>
+</file>
+
+<file path=ppt/slides/slide21.xml><?xml version="1.0" encoding="utf-8"?>
 <p:sld xmlns:a="http://schemas.openxmlformats.org/drawingml/2006/main" xmlns:r="http://schemas.openxmlformats.org/officeDocument/2006/relationships" xmlns:p="http://schemas.openxmlformats.org/presentationml/2006/main">
   <p:cSld name="Slide 18">
     <p:bg>
@@ -8286,417 +8696,6 @@
               <a:t>Ninja Quiz  ·  Team The Originals  ·  503IT</a:t>
             </a:r>
             <a:endParaRPr lang="en-US" sz="1000" dirty="0"/>
-          </a:p>
-        </p:txBody>
-      </p:sp>
-    </p:spTree>
-  </p:cSld>
-  <p:clrMapOvr>
-    <a:masterClrMapping/>
-  </p:clrMapOvr>
-</p:sld>
-</file>
-
-<file path=ppt/slides/slide21.xml><?xml version="1.0" encoding="utf-8"?>
-<p:sld xmlns:a="http://schemas.openxmlformats.org/drawingml/2006/main" xmlns:p="http://schemas.openxmlformats.org/presentationml/2006/main" xmlns:r="http://schemas.openxmlformats.org/officeDocument/2006/relationships">
-  <p:cSld>
-    <p:bg>
-      <p:bgPr>
-        <a:solidFill>
-          <a:srgbClr val="0D0D0D"/>
-        </a:solidFill>
-        <a:effectLst/>
-      </p:bgPr>
-    </p:bg>
-    <p:spTree>
-      <p:nvGrpSpPr>
-        <p:cNvPr id="1" name=""/>
-        <p:cNvGrpSpPr/>
-        <p:nvPr/>
-      </p:nvGrpSpPr>
-      <p:grpSpPr/>
-      <p:sp>
-        <p:nvSpPr>
-          <p:cNvPr id="2" name="TextBox 1"/>
-          <p:cNvSpPr txBox="1"/>
-          <p:nvPr/>
-        </p:nvSpPr>
-        <p:spPr>
-          <a:xfrm>
-            <a:off x="457200" y="256032"/>
-            <a:ext cx="6858000" cy="256032"/>
-          </a:xfrm>
-          <a:prstGeom prst="rect">
-            <a:avLst/>
-          </a:prstGeom>
-          <a:noFill/>
-        </p:spPr>
-        <p:txBody>
-          <a:bodyPr wrap="square">
-            <a:spAutoFit/>
-          </a:bodyPr>
-          <a:lstStyle/>
-          <a:p>
-            <a:pPr algn="l"/>
-            <a:r>
-              <a:rPr sz="1000" b="1" i="0">
-                <a:solidFill>
-                  <a:srgbClr val="888888"/>
-                </a:solidFill>
-              </a:rPr>
-              <a:t>PROFESSIONAL DEVELOPMENT</a:t>
-            </a:r>
-          </a:p>
-        </p:txBody>
-      </p:sp>
-      <p:sp>
-        <p:nvSpPr>
-          <p:cNvPr id="3" name="TextBox 2"/>
-          <p:cNvSpPr txBox="1"/>
-          <p:nvPr/>
-        </p:nvSpPr>
-        <p:spPr>
-          <a:xfrm>
-            <a:off x="3657600" y="4919472"/>
-            <a:ext cx="5212080" cy="182880"/>
-          </a:xfrm>
-          <a:prstGeom prst="rect">
-            <a:avLst/>
-          </a:prstGeom>
-          <a:noFill/>
-        </p:spPr>
-        <p:txBody>
-          <a:bodyPr wrap="square">
-            <a:spAutoFit/>
-          </a:bodyPr>
-          <a:lstStyle/>
-          <a:p>
-            <a:pPr algn="l"/>
-            <a:r>
-              <a:rPr sz="800" b="0" i="0">
-                <a:solidFill>
-                  <a:srgbClr val="444444"/>
-                </a:solidFill>
-              </a:rPr>
-              <a:t>NINJA QUIZ  .  503IT</a:t>
-            </a:r>
-          </a:p>
-        </p:txBody>
-      </p:sp>
-      <p:sp>
-        <p:nvSpPr>
-          <p:cNvPr id="4" name="TextBox 3"/>
-          <p:cNvSpPr txBox="1"/>
-          <p:nvPr/>
-        </p:nvSpPr>
-        <p:spPr>
-          <a:xfrm>
-            <a:off x="457200" y="594360"/>
-            <a:ext cx="8229600" cy="1097280"/>
-          </a:xfrm>
-          <a:prstGeom prst="rect">
-            <a:avLst/>
-          </a:prstGeom>
-          <a:noFill/>
-        </p:spPr>
-        <p:txBody>
-          <a:bodyPr wrap="square">
-            <a:spAutoFit/>
-          </a:bodyPr>
-          <a:lstStyle/>
-          <a:p>
-            <a:pPr algn="l"/>
-            <a:r>
-              <a:rPr sz="2800" b="1" i="0">
-                <a:solidFill>
-                  <a:srgbClr val="FFFFFF"/>
-                </a:solidFill>
-              </a:rPr>
-              <a:t>This project taught us how</a:t>
-            </a:r>
-          </a:p>
-          <a:p>
-            <a:pPr algn="l"/>
-            <a:r>
-              <a:rPr sz="2800" b="1" i="0">
-                <a:solidFill>
-                  <a:srgbClr val="FFFFFF"/>
-                </a:solidFill>
-              </a:rPr>
-              <a:t>industry teams actually work.</a:t>
-            </a:r>
-          </a:p>
-        </p:txBody>
-      </p:sp>
-      <p:sp>
-        <p:nvSpPr>
-          <p:cNvPr id="5" name="TextBox 4"/>
-          <p:cNvSpPr txBox="1"/>
-          <p:nvPr/>
-        </p:nvSpPr>
-        <p:spPr>
-          <a:xfrm>
-            <a:off x="457200" y="1874519"/>
-            <a:ext cx="3840480" cy="256032"/>
-          </a:xfrm>
-          <a:prstGeom prst="rect">
-            <a:avLst/>
-          </a:prstGeom>
-          <a:noFill/>
-        </p:spPr>
-        <p:txBody>
-          <a:bodyPr wrap="square">
-            <a:spAutoFit/>
-          </a:bodyPr>
-          <a:lstStyle/>
-          <a:p>
-            <a:pPr algn="l"/>
-            <a:r>
-              <a:rPr sz="1300" b="1" i="0">
-                <a:solidFill>
-                  <a:srgbClr val="FFCD00"/>
-                </a:solidFill>
-              </a:rPr>
-              <a:t>Structured communication</a:t>
-            </a:r>
-          </a:p>
-        </p:txBody>
-      </p:sp>
-      <p:sp>
-        <p:nvSpPr>
-          <p:cNvPr id="6" name="TextBox 5"/>
-          <p:cNvSpPr txBox="1"/>
-          <p:nvPr/>
-        </p:nvSpPr>
-        <p:spPr>
-          <a:xfrm>
-            <a:off x="457200" y="2148839"/>
-            <a:ext cx="8229600" cy="411480"/>
-          </a:xfrm>
-          <a:prstGeom prst="rect">
-            <a:avLst/>
-          </a:prstGeom>
-          <a:noFill/>
-        </p:spPr>
-        <p:txBody>
-          <a:bodyPr wrap="square">
-            <a:spAutoFit/>
-          </a:bodyPr>
-          <a:lstStyle/>
-          <a:p>
-            <a:pPr algn="l"/>
-            <a:r>
-              <a:rPr sz="1100" b="0" i="0">
-                <a:solidFill>
-                  <a:srgbClr val="AAAAAA"/>
-                </a:solidFill>
-              </a:rPr>
-              <a:t>Raising issues immediately, logging decisions in Trello and meeting minutes — these are professional standards, not student habits.</a:t>
-            </a:r>
-          </a:p>
-        </p:txBody>
-      </p:sp>
-      <p:sp>
-        <p:nvSpPr>
-          <p:cNvPr id="7" name="TextBox 6"/>
-          <p:cNvSpPr txBox="1"/>
-          <p:nvPr/>
-        </p:nvSpPr>
-        <p:spPr>
-          <a:xfrm>
-            <a:off x="457200" y="2697479"/>
-            <a:ext cx="3840480" cy="256032"/>
-          </a:xfrm>
-          <a:prstGeom prst="rect">
-            <a:avLst/>
-          </a:prstGeom>
-          <a:noFill/>
-        </p:spPr>
-        <p:txBody>
-          <a:bodyPr wrap="square">
-            <a:spAutoFit/>
-          </a:bodyPr>
-          <a:lstStyle/>
-          <a:p>
-            <a:pPr algn="l"/>
-            <a:r>
-              <a:rPr sz="1300" b="1" i="0">
-                <a:solidFill>
-                  <a:srgbClr val="FFCD00"/>
-                </a:solidFill>
-              </a:rPr>
-              <a:t>Real version control</a:t>
-            </a:r>
-          </a:p>
-        </p:txBody>
-      </p:sp>
-      <p:sp>
-        <p:nvSpPr>
-          <p:cNvPr id="8" name="TextBox 7"/>
-          <p:cNvSpPr txBox="1"/>
-          <p:nvPr/>
-        </p:nvSpPr>
-        <p:spPr>
-          <a:xfrm>
-            <a:off x="457200" y="2971799"/>
-            <a:ext cx="8229600" cy="411480"/>
-          </a:xfrm>
-          <a:prstGeom prst="rect">
-            <a:avLst/>
-          </a:prstGeom>
-          <a:noFill/>
-        </p:spPr>
-        <p:txBody>
-          <a:bodyPr wrap="square">
-            <a:spAutoFit/>
-          </a:bodyPr>
-          <a:lstStyle/>
-          <a:p>
-            <a:pPr algn="l"/>
-            <a:r>
-              <a:rPr sz="1100" b="0" i="0">
-                <a:solidFill>
-                  <a:srgbClr val="AAAAAA"/>
-                </a:solidFill>
-              </a:rPr>
-              <a:t>Feature branches, no pushing to main without review. We left this project with actual Git workflow experience.</a:t>
-            </a:r>
-          </a:p>
-        </p:txBody>
-      </p:sp>
-      <p:sp>
-        <p:nvSpPr>
-          <p:cNvPr id="9" name="TextBox 8"/>
-          <p:cNvSpPr txBox="1"/>
-          <p:nvPr/>
-        </p:nvSpPr>
-        <p:spPr>
-          <a:xfrm>
-            <a:off x="457200" y="3520439"/>
-            <a:ext cx="3840480" cy="256032"/>
-          </a:xfrm>
-          <a:prstGeom prst="rect">
-            <a:avLst/>
-          </a:prstGeom>
-          <a:noFill/>
-        </p:spPr>
-        <p:txBody>
-          <a:bodyPr wrap="square">
-            <a:spAutoFit/>
-          </a:bodyPr>
-          <a:lstStyle/>
-          <a:p>
-            <a:pPr algn="l"/>
-            <a:r>
-              <a:rPr sz="1300" b="1" i="0">
-                <a:solidFill>
-                  <a:srgbClr val="FFCD00"/>
-                </a:solidFill>
-              </a:rPr>
-              <a:t>Agile delivery mindset</a:t>
-            </a:r>
-          </a:p>
-        </p:txBody>
-      </p:sp>
-      <p:sp>
-        <p:nvSpPr>
-          <p:cNvPr id="10" name="TextBox 9"/>
-          <p:cNvSpPr txBox="1"/>
-          <p:nvPr/>
-        </p:nvSpPr>
-        <p:spPr>
-          <a:xfrm>
-            <a:off x="457200" y="3794759"/>
-            <a:ext cx="8229600" cy="411480"/>
-          </a:xfrm>
-          <a:prstGeom prst="rect">
-            <a:avLst/>
-          </a:prstGeom>
-          <a:noFill/>
-        </p:spPr>
-        <p:txBody>
-          <a:bodyPr wrap="square">
-            <a:spAutoFit/>
-          </a:bodyPr>
-          <a:lstStyle/>
-          <a:p>
-            <a:pPr algn="l"/>
-            <a:r>
-              <a:rPr sz="1100" b="0" i="0">
-                <a:solidFill>
-                  <a:srgbClr val="AAAAAA"/>
-                </a:solidFill>
-              </a:rPr>
-              <a:t>Five sprints with goals, retrospectives, and user testing mirrors how software teams ship in industry.</a:t>
-            </a:r>
-          </a:p>
-        </p:txBody>
-      </p:sp>
-      <p:sp>
-        <p:nvSpPr>
-          <p:cNvPr id="11" name="TextBox 10"/>
-          <p:cNvSpPr txBox="1"/>
-          <p:nvPr/>
-        </p:nvSpPr>
-        <p:spPr>
-          <a:xfrm>
-            <a:off x="457200" y="4343400"/>
-            <a:ext cx="3840480" cy="256032"/>
-          </a:xfrm>
-          <a:prstGeom prst="rect">
-            <a:avLst/>
-          </a:prstGeom>
-          <a:noFill/>
-        </p:spPr>
-        <p:txBody>
-          <a:bodyPr wrap="square">
-            <a:spAutoFit/>
-          </a:bodyPr>
-          <a:lstStyle/>
-          <a:p>
-            <a:pPr algn="l"/>
-            <a:r>
-              <a:rPr sz="1300" b="1" i="0">
-                <a:solidFill>
-                  <a:srgbClr val="FFCD00"/>
-                </a:solidFill>
-              </a:rPr>
-              <a:t>Resilience under pressure</a:t>
-            </a:r>
-          </a:p>
-        </p:txBody>
-      </p:sp>
-      <p:sp>
-        <p:nvSpPr>
-          <p:cNvPr id="12" name="TextBox 11"/>
-          <p:cNvSpPr txBox="1"/>
-          <p:nvPr/>
-        </p:nvSpPr>
-        <p:spPr>
-          <a:xfrm>
-            <a:off x="457200" y="4617720"/>
-            <a:ext cx="8229600" cy="411480"/>
-          </a:xfrm>
-          <a:prstGeom prst="rect">
-            <a:avLst/>
-          </a:prstGeom>
-          <a:noFill/>
-        </p:spPr>
-        <p:txBody>
-          <a:bodyPr wrap="square">
-            <a:spAutoFit/>
-          </a:bodyPr>
-          <a:lstStyle/>
-          <a:p>
-            <a:pPr algn="l"/>
-            <a:r>
-              <a:rPr sz="1100" b="0" i="0">
-                <a:solidFill>
-                  <a:srgbClr val="AAAAAA"/>
-                </a:solidFill>
-              </a:rPr>
-              <a:t>When the game broke 2 weeks before submission, we diagnosed and fixed it in one day — as a team. That experience is irreplaceable.</a:t>
-            </a:r>
           </a:p>
         </p:txBody>
       </p:sp>
@@ -10198,33 +10197,6 @@
       </p:grpSpPr>
       <p:sp>
         <p:nvSpPr>
-          <p:cNvPr id="2" name="Shape 0"/>
-          <p:cNvSpPr/>
-          <p:nvPr/>
-        </p:nvSpPr>
-        <p:spPr>
-          <a:xfrm>
-            <a:off x="8458200" y="201168"/>
-            <a:ext cx="256032" cy="256032"/>
-          </a:xfrm>
-          <a:prstGeom prst="ellipse">
-            <a:avLst/>
-          </a:prstGeom>
-          <a:solidFill>
-            <a:srgbClr val="FFCD00"/>
-          </a:solidFill>
-          <a:ln/>
-        </p:spPr>
-        <p:txBody>
-          <a:bodyPr/>
-          <a:lstStyle/>
-          <a:p>
-            <a:endParaRPr lang="en-GB"/>
-          </a:p>
-        </p:txBody>
-      </p:sp>
-      <p:sp>
-        <p:nvSpPr>
           <p:cNvPr id="3" name="Text 1"/>
           <p:cNvSpPr/>
           <p:nvPr/>
@@ -11380,7 +11352,7 @@
         <p:spPr>
           <a:xfrm>
             <a:off x="457200" y="3218688"/>
-            <a:ext cx="640080" cy="502920"/>
+            <a:ext cx="4114800" cy="502920"/>
           </a:xfrm>
           <a:prstGeom prst="rect">
             <a:avLst/>
@@ -11458,7 +11430,7 @@
         <p:spPr>
           <a:xfrm>
             <a:off x="457200" y="3877056"/>
-            <a:ext cx="640080" cy="502920"/>
+            <a:ext cx="4114800" cy="502920"/>
           </a:xfrm>
           <a:prstGeom prst="rect">
             <a:avLst/>
@@ -11529,22 +11501,22 @@
       </p:sp>
       <p:pic>
         <p:nvPicPr>
-          <p:cNvPr id="13" name="Picture 12" descr="team live meeting.jpeg"/>
+          <p:cNvPr id="13" name="Picture 12" descr="image.jpg"/>
           <p:cNvPicPr>
             <a:picLocks noChangeAspect="1"/>
           </p:cNvPicPr>
           <p:nvPr/>
         </p:nvPicPr>
         <p:blipFill>
-          <a:blip r:embed="rId3"/>
+          <a:blip r:embed="rId4"/>
           <a:stretch>
             <a:fillRect/>
           </a:stretch>
         </p:blipFill>
         <p:spPr>
           <a:xfrm>
-            <a:off x="4572000" y="731520"/>
-            <a:ext cx="4389120" cy="4023360"/>
+            <a:off x="4663440" y="1417320"/>
+            <a:ext cx="4206240" cy="3291840"/>
           </a:xfrm>
           <a:prstGeom prst="rect">
             <a:avLst/>

</xml_diff>

<commit_message>
Fix team slide (Belbin fully removed) and collab tools slide (clean Trello image)
</commit_message>
<xml_diff>
--- a/NinjaQuiz-Presentation.pptx
+++ b/NinjaQuiz-Presentation.pptx
@@ -2351,805 +2351,6 @@
 </file>
 
 <file path=ppt/slides/slide10.xml><?xml version="1.0" encoding="utf-8"?>
-<p:sld xmlns:a="http://schemas.openxmlformats.org/drawingml/2006/main" xmlns:r="http://schemas.openxmlformats.org/officeDocument/2006/relationships" xmlns:p="http://schemas.openxmlformats.org/presentationml/2006/main">
-  <p:cSld name="Slide 9">
-    <p:bg>
-      <p:bgPr>
-        <a:solidFill>
-          <a:srgbClr val="FFFFFF"/>
-        </a:solidFill>
-        <a:effectLst/>
-      </p:bgPr>
-    </p:bg>
-    <p:spTree>
-      <p:nvGrpSpPr>
-        <p:cNvPr id="1" name=""/>
-        <p:cNvGrpSpPr/>
-        <p:nvPr/>
-      </p:nvGrpSpPr>
-      <p:grpSpPr>
-        <a:xfrm>
-          <a:off x="0" y="0"/>
-          <a:ext cx="0" cy="0"/>
-          <a:chOff x="0" y="0"/>
-          <a:chExt cx="0" cy="0"/>
-        </a:xfrm>
-      </p:grpSpPr>
-      <p:sp>
-        <p:nvSpPr>
-          <p:cNvPr id="2" name="Shape 0"/>
-          <p:cNvSpPr/>
-          <p:nvPr/>
-        </p:nvSpPr>
-        <p:spPr>
-          <a:xfrm>
-            <a:off x="8458200" y="201168"/>
-            <a:ext cx="256032" cy="256032"/>
-          </a:xfrm>
-          <a:prstGeom prst="ellipse">
-            <a:avLst/>
-          </a:prstGeom>
-          <a:solidFill>
-            <a:srgbClr val="DDDDDD"/>
-          </a:solidFill>
-          <a:ln/>
-        </p:spPr>
-        <p:txBody>
-          <a:bodyPr/>
-          <a:lstStyle/>
-          <a:p>
-            <a:endParaRPr lang="en-GB"/>
-          </a:p>
-        </p:txBody>
-      </p:sp>
-      <p:sp>
-        <p:nvSpPr>
-          <p:cNvPr id="3" name="Text 1"/>
-          <p:cNvSpPr/>
-          <p:nvPr/>
-        </p:nvSpPr>
-        <p:spPr>
-          <a:xfrm>
-            <a:off x="457200" y="274320"/>
-            <a:ext cx="6400800" cy="228600"/>
-          </a:xfrm>
-          <a:prstGeom prst="rect">
-            <a:avLst/>
-          </a:prstGeom>
-          <a:noFill/>
-          <a:ln/>
-        </p:spPr>
-        <p:txBody>
-          <a:bodyPr wrap="square" rtlCol="0" anchor="ctr"/>
-          <a:lstStyle/>
-          <a:p>
-            <a:pPr marL="0" indent="0">
-              <a:buNone/>
-            </a:pPr>
-            <a:r>
-              <a:rPr lang="en-US" sz="1000" b="1" kern="0" spc="200" dirty="0">
-                <a:solidFill>
-                  <a:srgbClr val="888888"/>
-                </a:solidFill>
-                <a:latin typeface="Arial" pitchFamily="34" charset="0"/>
-                <a:ea typeface="Arial" pitchFamily="34" charset="-122"/>
-                <a:cs typeface="Arial" pitchFamily="34" charset="-120"/>
-              </a:rPr>
-              <a:t>DELIVERY PROCESS</a:t>
-            </a:r>
-            <a:endParaRPr lang="en-US" sz="1000" dirty="0"/>
-          </a:p>
-        </p:txBody>
-      </p:sp>
-      <p:sp>
-        <p:nvSpPr>
-          <p:cNvPr id="4" name="Text 2"/>
-          <p:cNvSpPr/>
-          <p:nvPr/>
-        </p:nvSpPr>
-        <p:spPr>
-          <a:xfrm>
-            <a:off x="3657600" y="4919472"/>
-            <a:ext cx="5212080" cy="182880"/>
-          </a:xfrm>
-          <a:prstGeom prst="rect">
-            <a:avLst/>
-          </a:prstGeom>
-          <a:noFill/>
-          <a:ln/>
-        </p:spPr>
-        <p:txBody>
-          <a:bodyPr wrap="square" rtlCol="0" anchor="ctr"/>
-          <a:lstStyle/>
-          <a:p>
-            <a:pPr marL="0" indent="0" algn="r">
-              <a:buNone/>
-            </a:pPr>
-            <a:r>
-              <a:rPr lang="en-US" sz="900" dirty="0">
-                <a:solidFill>
-                  <a:srgbClr val="888888"/>
-                </a:solidFill>
-                <a:latin typeface="Arial" pitchFamily="34" charset="0"/>
-                <a:ea typeface="Arial" pitchFamily="34" charset="-122"/>
-                <a:cs typeface="Arial" pitchFamily="34" charset="-120"/>
-              </a:rPr>
-              <a:t>NINJA QUIZ  ·  503IT  ·  09 / 18</a:t>
-            </a:r>
-            <a:endParaRPr lang="en-US" sz="900" dirty="0"/>
-          </a:p>
-        </p:txBody>
-      </p:sp>
-      <p:sp>
-        <p:nvSpPr>
-          <p:cNvPr id="5" name="Text 3"/>
-          <p:cNvSpPr/>
-          <p:nvPr/>
-        </p:nvSpPr>
-        <p:spPr>
-          <a:xfrm>
-            <a:off x="457200" y="685800"/>
-            <a:ext cx="8229600" cy="812800"/>
-          </a:xfrm>
-          <a:prstGeom prst="rect">
-            <a:avLst/>
-          </a:prstGeom>
-          <a:noFill/>
-          <a:ln/>
-        </p:spPr>
-        <p:txBody>
-          <a:bodyPr wrap="square" rtlCol="0" anchor="ctr"/>
-          <a:lstStyle/>
-          <a:p>
-            <a:pPr marL="0" indent="0">
-              <a:buNone/>
-            </a:pPr>
-            <a:r>
-              <a:rPr lang="en-US" sz="3200" b="1" dirty="0">
-                <a:solidFill>
-                  <a:srgbClr val="111111"/>
-                </a:solidFill>
-                <a:latin typeface="Arial Black" pitchFamily="34" charset="0"/>
-                <a:ea typeface="Arial Black" pitchFamily="34" charset="-122"/>
-                <a:cs typeface="Arial Black" pitchFamily="34" charset="-120"/>
-              </a:rPr>
-              <a:t>Built in five sprints.</a:t>
-            </a:r>
-            <a:endParaRPr lang="en-US" sz="3200" dirty="0"/>
-          </a:p>
-        </p:txBody>
-      </p:sp>
-      <p:sp>
-        <p:nvSpPr>
-          <p:cNvPr id="6" name="Shape 4"/>
-          <p:cNvSpPr/>
-          <p:nvPr/>
-        </p:nvSpPr>
-        <p:spPr>
-          <a:xfrm>
-            <a:off x="457200" y="1463040"/>
-            <a:ext cx="8229600" cy="10973"/>
-          </a:xfrm>
-          <a:prstGeom prst="rect">
-            <a:avLst/>
-          </a:prstGeom>
-          <a:solidFill>
-            <a:srgbClr val="EEEEEE"/>
-          </a:solidFill>
-          <a:ln/>
-        </p:spPr>
-        <p:txBody>
-          <a:bodyPr/>
-          <a:lstStyle/>
-          <a:p>
-            <a:endParaRPr lang="en-GB"/>
-          </a:p>
-        </p:txBody>
-      </p:sp>
-      <p:sp>
-        <p:nvSpPr>
-          <p:cNvPr id="7" name="Text 5"/>
-          <p:cNvSpPr/>
-          <p:nvPr/>
-        </p:nvSpPr>
-        <p:spPr>
-          <a:xfrm>
-            <a:off x="457200" y="1609344"/>
-            <a:ext cx="868680" cy="411480"/>
-          </a:xfrm>
-          <a:prstGeom prst="rect">
-            <a:avLst/>
-          </a:prstGeom>
-          <a:noFill/>
-          <a:ln/>
-        </p:spPr>
-        <p:txBody>
-          <a:bodyPr wrap="square" rtlCol="0" anchor="ctr">
-            <a:normAutofit/>
-          </a:bodyPr>
-          <a:lstStyle/>
-          <a:p>
-            <a:pPr marL="0" indent="0">
-              <a:buNone/>
-            </a:pPr>
-            <a:r>
-              <a:rPr lang="en-US" sz="2000" b="1" dirty="0">
-                <a:solidFill>
-                  <a:srgbClr val="FFCD00"/>
-                </a:solidFill>
-                <a:latin typeface="Arial Black" pitchFamily="34" charset="0"/>
-                <a:ea typeface="Arial Black" pitchFamily="34" charset="-122"/>
-                <a:cs typeface="Arial Black" pitchFamily="34" charset="-120"/>
-              </a:rPr>
-              <a:t>01</a:t>
-            </a:r>
-            <a:endParaRPr lang="en-US" sz="2000" dirty="0"/>
-          </a:p>
-        </p:txBody>
-      </p:sp>
-      <p:sp>
-        <p:nvSpPr>
-          <p:cNvPr id="8" name="Text 6"/>
-          <p:cNvSpPr/>
-          <p:nvPr/>
-        </p:nvSpPr>
-        <p:spPr>
-          <a:xfrm>
-            <a:off x="1371600" y="1591056"/>
-            <a:ext cx="7315200" cy="292608"/>
-          </a:xfrm>
-          <a:prstGeom prst="rect">
-            <a:avLst/>
-          </a:prstGeom>
-          <a:noFill/>
-          <a:ln/>
-        </p:spPr>
-        <p:txBody>
-          <a:bodyPr wrap="square" rtlCol="0" anchor="ctr"/>
-          <a:lstStyle/>
-          <a:p>
-            <a:pPr marL="0" indent="0">
-              <a:buNone/>
-            </a:pPr>
-            <a:r>
-              <a:rPr lang="en-US" sz="1700" b="1" dirty="0">
-                <a:solidFill>
-                  <a:srgbClr val="111111"/>
-                </a:solidFill>
-                <a:latin typeface="Arial Black" pitchFamily="34" charset="0"/>
-                <a:ea typeface="Arial Black" pitchFamily="34" charset="-122"/>
-                <a:cs typeface="Arial Black" pitchFamily="34" charset="-120"/>
-              </a:rPr>
-              <a:t>Sprint 1  —  Login &amp; menu</a:t>
-            </a:r>
-            <a:endParaRPr lang="en-US" sz="1700" dirty="0"/>
-          </a:p>
-        </p:txBody>
-      </p:sp>
-      <p:sp>
-        <p:nvSpPr>
-          <p:cNvPr id="9" name="Text 7"/>
-          <p:cNvSpPr/>
-          <p:nvPr/>
-        </p:nvSpPr>
-        <p:spPr>
-          <a:xfrm>
-            <a:off x="1371600" y="1892808"/>
-            <a:ext cx="7315200" cy="228600"/>
-          </a:xfrm>
-          <a:prstGeom prst="rect">
-            <a:avLst/>
-          </a:prstGeom>
-          <a:noFill/>
-          <a:ln/>
-        </p:spPr>
-        <p:txBody>
-          <a:bodyPr wrap="square" rtlCol="0" anchor="ctr"/>
-          <a:lstStyle/>
-          <a:p>
-            <a:pPr marL="0" indent="0">
-              <a:buNone/>
-            </a:pPr>
-            <a:r>
-              <a:rPr lang="en-US" sz="1200" dirty="0">
-                <a:solidFill>
-                  <a:srgbClr val="888888"/>
-                </a:solidFill>
-                <a:latin typeface="Arial" pitchFamily="34" charset="0"/>
-                <a:ea typeface="Arial" pitchFamily="34" charset="-122"/>
-                <a:cs typeface="Arial" pitchFamily="34" charset="-120"/>
-              </a:rPr>
-              <a:t>Foundation. Every member set up. GitHub branches created.</a:t>
-            </a:r>
-            <a:endParaRPr lang="en-US" sz="1200" dirty="0"/>
-          </a:p>
-        </p:txBody>
-      </p:sp>
-      <p:sp>
-        <p:nvSpPr>
-          <p:cNvPr id="10" name="Text 8"/>
-          <p:cNvSpPr/>
-          <p:nvPr/>
-        </p:nvSpPr>
-        <p:spPr>
-          <a:xfrm>
-            <a:off x="457200" y="2231136"/>
-            <a:ext cx="868680" cy="411480"/>
-          </a:xfrm>
-          <a:prstGeom prst="rect">
-            <a:avLst/>
-          </a:prstGeom>
-          <a:noFill/>
-          <a:ln/>
-        </p:spPr>
-        <p:txBody>
-          <a:bodyPr wrap="square" rtlCol="0" anchor="ctr">
-            <a:normAutofit/>
-          </a:bodyPr>
-          <a:lstStyle/>
-          <a:p>
-            <a:pPr marL="0" indent="0">
-              <a:buNone/>
-            </a:pPr>
-            <a:r>
-              <a:rPr lang="en-US" sz="2000" b="1" dirty="0">
-                <a:solidFill>
-                  <a:srgbClr val="FFCD00"/>
-                </a:solidFill>
-                <a:latin typeface="Arial Black" pitchFamily="34" charset="0"/>
-                <a:ea typeface="Arial Black" pitchFamily="34" charset="-122"/>
-                <a:cs typeface="Arial Black" pitchFamily="34" charset="-120"/>
-              </a:rPr>
-              <a:t>02</a:t>
-            </a:r>
-            <a:endParaRPr lang="en-US" sz="2000" dirty="0"/>
-          </a:p>
-        </p:txBody>
-      </p:sp>
-      <p:sp>
-        <p:nvSpPr>
-          <p:cNvPr id="11" name="Text 9"/>
-          <p:cNvSpPr/>
-          <p:nvPr/>
-        </p:nvSpPr>
-        <p:spPr>
-          <a:xfrm>
-            <a:off x="1371600" y="2212848"/>
-            <a:ext cx="7315200" cy="292608"/>
-          </a:xfrm>
-          <a:prstGeom prst="rect">
-            <a:avLst/>
-          </a:prstGeom>
-          <a:noFill/>
-          <a:ln/>
-        </p:spPr>
-        <p:txBody>
-          <a:bodyPr wrap="square" rtlCol="0" anchor="ctr"/>
-          <a:lstStyle/>
-          <a:p>
-            <a:pPr marL="0" indent="0">
-              <a:buNone/>
-            </a:pPr>
-            <a:r>
-              <a:rPr lang="en-US" sz="1700" b="1" dirty="0">
-                <a:solidFill>
-                  <a:srgbClr val="111111"/>
-                </a:solidFill>
-                <a:latin typeface="Arial Black" pitchFamily="34" charset="0"/>
-                <a:ea typeface="Arial Black" pitchFamily="34" charset="-122"/>
-                <a:cs typeface="Arial Black" pitchFamily="34" charset="-120"/>
-              </a:rPr>
-              <a:t>Sprint 2  —  Game engine</a:t>
-            </a:r>
-            <a:endParaRPr lang="en-US" sz="1700" dirty="0"/>
-          </a:p>
-        </p:txBody>
-      </p:sp>
-      <p:sp>
-        <p:nvSpPr>
-          <p:cNvPr id="12" name="Text 10"/>
-          <p:cNvSpPr/>
-          <p:nvPr/>
-        </p:nvSpPr>
-        <p:spPr>
-          <a:xfrm>
-            <a:off x="1371600" y="2514600"/>
-            <a:ext cx="7315200" cy="228600"/>
-          </a:xfrm>
-          <a:prstGeom prst="rect">
-            <a:avLst/>
-          </a:prstGeom>
-          <a:noFill/>
-          <a:ln/>
-        </p:spPr>
-        <p:txBody>
-          <a:bodyPr wrap="square" rtlCol="0" anchor="ctr"/>
-          <a:lstStyle/>
-          <a:p>
-            <a:pPr marL="0" indent="0">
-              <a:buNone/>
-            </a:pPr>
-            <a:r>
-              <a:rPr lang="en-US" sz="1200" dirty="0">
-                <a:solidFill>
-                  <a:srgbClr val="888888"/>
-                </a:solidFill>
-                <a:latin typeface="Arial" pitchFamily="34" charset="0"/>
-                <a:ea typeface="Arial" pitchFamily="34" charset="-122"/>
-                <a:cs typeface="Arial" pitchFamily="34" charset="-120"/>
-              </a:rPr>
-              <a:t>Core mechanics built. Daily check-ins via WhatsApp.</a:t>
-            </a:r>
-            <a:endParaRPr lang="en-US" sz="1200" dirty="0"/>
-          </a:p>
-        </p:txBody>
-      </p:sp>
-      <p:sp>
-        <p:nvSpPr>
-          <p:cNvPr id="13" name="Text 11"/>
-          <p:cNvSpPr/>
-          <p:nvPr/>
-        </p:nvSpPr>
-        <p:spPr>
-          <a:xfrm>
-            <a:off x="457200" y="2852928"/>
-            <a:ext cx="868680" cy="411480"/>
-          </a:xfrm>
-          <a:prstGeom prst="rect">
-            <a:avLst/>
-          </a:prstGeom>
-          <a:noFill/>
-          <a:ln/>
-        </p:spPr>
-        <p:txBody>
-          <a:bodyPr wrap="square" rtlCol="0" anchor="ctr">
-            <a:normAutofit/>
-          </a:bodyPr>
-          <a:lstStyle/>
-          <a:p>
-            <a:pPr marL="0" indent="0">
-              <a:buNone/>
-            </a:pPr>
-            <a:r>
-              <a:rPr lang="en-US" sz="2000" b="1" dirty="0">
-                <a:solidFill>
-                  <a:srgbClr val="FFCD00"/>
-                </a:solidFill>
-                <a:latin typeface="Arial Black" pitchFamily="34" charset="0"/>
-                <a:ea typeface="Arial Black" pitchFamily="34" charset="-122"/>
-                <a:cs typeface="Arial Black" pitchFamily="34" charset="-120"/>
-              </a:rPr>
-              <a:t>03</a:t>
-            </a:r>
-            <a:endParaRPr lang="en-US" sz="2000" dirty="0"/>
-          </a:p>
-        </p:txBody>
-      </p:sp>
-      <p:sp>
-        <p:nvSpPr>
-          <p:cNvPr id="14" name="Text 12"/>
-          <p:cNvSpPr/>
-          <p:nvPr/>
-        </p:nvSpPr>
-        <p:spPr>
-          <a:xfrm>
-            <a:off x="1371600" y="2834640"/>
-            <a:ext cx="7315200" cy="292608"/>
-          </a:xfrm>
-          <a:prstGeom prst="rect">
-            <a:avLst/>
-          </a:prstGeom>
-          <a:noFill/>
-          <a:ln/>
-        </p:spPr>
-        <p:txBody>
-          <a:bodyPr wrap="square" rtlCol="0" anchor="ctr"/>
-          <a:lstStyle/>
-          <a:p>
-            <a:pPr marL="0" indent="0">
-              <a:buNone/>
-            </a:pPr>
-            <a:r>
-              <a:rPr lang="en-US" sz="1700" b="1" dirty="0">
-                <a:solidFill>
-                  <a:srgbClr val="111111"/>
-                </a:solidFill>
-                <a:latin typeface="Arial Black" pitchFamily="34" charset="0"/>
-                <a:ea typeface="Arial Black" pitchFamily="34" charset="-122"/>
-                <a:cs typeface="Arial Black" pitchFamily="34" charset="-120"/>
-              </a:rPr>
-              <a:t>Sprint 3  —  Slicing &amp; sound</a:t>
-            </a:r>
-            <a:endParaRPr lang="en-US" sz="1700" dirty="0"/>
-          </a:p>
-        </p:txBody>
-      </p:sp>
-      <p:sp>
-        <p:nvSpPr>
-          <p:cNvPr id="15" name="Text 13"/>
-          <p:cNvSpPr/>
-          <p:nvPr/>
-        </p:nvSpPr>
-        <p:spPr>
-          <a:xfrm>
-            <a:off x="1371600" y="3136392"/>
-            <a:ext cx="7315200" cy="228600"/>
-          </a:xfrm>
-          <a:prstGeom prst="rect">
-            <a:avLst/>
-          </a:prstGeom>
-          <a:noFill/>
-          <a:ln/>
-        </p:spPr>
-        <p:txBody>
-          <a:bodyPr wrap="square" rtlCol="0" anchor="ctr"/>
-          <a:lstStyle/>
-          <a:p>
-            <a:pPr marL="0" indent="0">
-              <a:buNone/>
-            </a:pPr>
-            <a:r>
-              <a:rPr lang="en-US" sz="1200" dirty="0">
-                <a:solidFill>
-                  <a:srgbClr val="888888"/>
-                </a:solidFill>
-                <a:latin typeface="Arial" pitchFamily="34" charset="0"/>
-                <a:ea typeface="Arial" pitchFamily="34" charset="-122"/>
-                <a:cs typeface="Arial" pitchFamily="34" charset="-120"/>
-              </a:rPr>
-              <a:t>Visual integration. First merge conflicts resolved.</a:t>
-            </a:r>
-            <a:endParaRPr lang="en-US" sz="1200" dirty="0"/>
-          </a:p>
-        </p:txBody>
-      </p:sp>
-      <p:sp>
-        <p:nvSpPr>
-          <p:cNvPr id="16" name="Text 14"/>
-          <p:cNvSpPr/>
-          <p:nvPr/>
-        </p:nvSpPr>
-        <p:spPr>
-          <a:xfrm>
-            <a:off x="457200" y="3474720"/>
-            <a:ext cx="868680" cy="411480"/>
-          </a:xfrm>
-          <a:prstGeom prst="rect">
-            <a:avLst/>
-          </a:prstGeom>
-          <a:noFill/>
-          <a:ln/>
-        </p:spPr>
-        <p:txBody>
-          <a:bodyPr wrap="square" rtlCol="0" anchor="ctr">
-            <a:normAutofit/>
-          </a:bodyPr>
-          <a:lstStyle/>
-          <a:p>
-            <a:pPr marL="0" indent="0">
-              <a:buNone/>
-            </a:pPr>
-            <a:r>
-              <a:rPr lang="en-US" sz="2000" b="1" dirty="0">
-                <a:solidFill>
-                  <a:srgbClr val="FFCD00"/>
-                </a:solidFill>
-                <a:latin typeface="Arial Black" pitchFamily="34" charset="0"/>
-                <a:ea typeface="Arial Black" pitchFamily="34" charset="-122"/>
-                <a:cs typeface="Arial Black" pitchFamily="34" charset="-120"/>
-              </a:rPr>
-              <a:t>04</a:t>
-            </a:r>
-            <a:endParaRPr lang="en-US" sz="2000" dirty="0"/>
-          </a:p>
-        </p:txBody>
-      </p:sp>
-      <p:sp>
-        <p:nvSpPr>
-          <p:cNvPr id="17" name="Text 15"/>
-          <p:cNvSpPr/>
-          <p:nvPr/>
-        </p:nvSpPr>
-        <p:spPr>
-          <a:xfrm>
-            <a:off x="1371600" y="3456432"/>
-            <a:ext cx="7315200" cy="292608"/>
-          </a:xfrm>
-          <a:prstGeom prst="rect">
-            <a:avLst/>
-          </a:prstGeom>
-          <a:noFill/>
-          <a:ln/>
-        </p:spPr>
-        <p:txBody>
-          <a:bodyPr wrap="square" rtlCol="0" anchor="ctr"/>
-          <a:lstStyle/>
-          <a:p>
-            <a:pPr marL="0" indent="0">
-              <a:buNone/>
-            </a:pPr>
-            <a:r>
-              <a:rPr lang="en-US" sz="1700" b="1" dirty="0">
-                <a:solidFill>
-                  <a:srgbClr val="111111"/>
-                </a:solidFill>
-                <a:latin typeface="Arial Black" pitchFamily="34" charset="0"/>
-                <a:ea typeface="Arial Black" pitchFamily="34" charset="-122"/>
-                <a:cs typeface="Arial Black" pitchFamily="34" charset="-120"/>
-              </a:rPr>
-              <a:t>Sprint 4  —  Leaderboard</a:t>
-            </a:r>
-            <a:endParaRPr lang="en-US" sz="1700" dirty="0"/>
-          </a:p>
-        </p:txBody>
-      </p:sp>
-      <p:sp>
-        <p:nvSpPr>
-          <p:cNvPr id="18" name="Text 16"/>
-          <p:cNvSpPr/>
-          <p:nvPr/>
-        </p:nvSpPr>
-        <p:spPr>
-          <a:xfrm>
-            <a:off x="1371600" y="3758184"/>
-            <a:ext cx="7315200" cy="228600"/>
-          </a:xfrm>
-          <a:prstGeom prst="rect">
-            <a:avLst/>
-          </a:prstGeom>
-          <a:noFill/>
-          <a:ln/>
-        </p:spPr>
-        <p:txBody>
-          <a:bodyPr wrap="square" rtlCol="0" anchor="ctr"/>
-          <a:lstStyle/>
-          <a:p>
-            <a:pPr marL="0" indent="0">
-              <a:buNone/>
-            </a:pPr>
-            <a:r>
-              <a:rPr lang="en-US" sz="1200" dirty="0">
-                <a:solidFill>
-                  <a:srgbClr val="888888"/>
-                </a:solidFill>
-                <a:latin typeface="Arial" pitchFamily="34" charset="0"/>
-                <a:ea typeface="Arial" pitchFamily="34" charset="-122"/>
-                <a:cs typeface="Arial" pitchFamily="34" charset="-120"/>
-              </a:rPr>
-              <a:t>Peer testing begins. Feedback collected and logged.</a:t>
-            </a:r>
-            <a:endParaRPr lang="en-US" sz="1200" dirty="0"/>
-          </a:p>
-        </p:txBody>
-      </p:sp>
-      <p:sp>
-        <p:nvSpPr>
-          <p:cNvPr id="19" name="Text 17"/>
-          <p:cNvSpPr/>
-          <p:nvPr/>
-        </p:nvSpPr>
-        <p:spPr>
-          <a:xfrm>
-            <a:off x="457200" y="4096512"/>
-            <a:ext cx="868680" cy="411480"/>
-          </a:xfrm>
-          <a:prstGeom prst="rect">
-            <a:avLst/>
-          </a:prstGeom>
-          <a:noFill/>
-          <a:ln/>
-        </p:spPr>
-        <p:txBody>
-          <a:bodyPr wrap="square" rtlCol="0" anchor="ctr">
-            <a:normAutofit/>
-          </a:bodyPr>
-          <a:lstStyle/>
-          <a:p>
-            <a:pPr marL="0" indent="0">
-              <a:buNone/>
-            </a:pPr>
-            <a:r>
-              <a:rPr lang="en-US" sz="2000" b="1" dirty="0">
-                <a:solidFill>
-                  <a:srgbClr val="FFCD00"/>
-                </a:solidFill>
-                <a:latin typeface="Arial Black" pitchFamily="34" charset="0"/>
-                <a:ea typeface="Arial Black" pitchFamily="34" charset="-122"/>
-                <a:cs typeface="Arial Black" pitchFamily="34" charset="-120"/>
-              </a:rPr>
-              <a:t>05</a:t>
-            </a:r>
-            <a:endParaRPr lang="en-US" sz="2000" dirty="0"/>
-          </a:p>
-        </p:txBody>
-      </p:sp>
-      <p:sp>
-        <p:nvSpPr>
-          <p:cNvPr id="20" name="Text 18"/>
-          <p:cNvSpPr/>
-          <p:nvPr/>
-        </p:nvSpPr>
-        <p:spPr>
-          <a:xfrm>
-            <a:off x="1371600" y="4078224"/>
-            <a:ext cx="7315200" cy="292608"/>
-          </a:xfrm>
-          <a:prstGeom prst="rect">
-            <a:avLst/>
-          </a:prstGeom>
-          <a:noFill/>
-          <a:ln/>
-        </p:spPr>
-        <p:txBody>
-          <a:bodyPr wrap="square" rtlCol="0" anchor="ctr"/>
-          <a:lstStyle/>
-          <a:p>
-            <a:pPr marL="0" indent="0">
-              <a:buNone/>
-            </a:pPr>
-            <a:r>
-              <a:rPr lang="en-US" sz="1700" b="1" dirty="0">
-                <a:solidFill>
-                  <a:srgbClr val="111111"/>
-                </a:solidFill>
-                <a:latin typeface="Arial Black" pitchFamily="34" charset="0"/>
-                <a:ea typeface="Arial Black" pitchFamily="34" charset="-122"/>
-                <a:cs typeface="Arial Black" pitchFamily="34" charset="-120"/>
-              </a:rPr>
-              <a:t>Sprint 5  —  Testing &amp; polish</a:t>
-            </a:r>
-            <a:endParaRPr lang="en-US" sz="1700" dirty="0"/>
-          </a:p>
-        </p:txBody>
-      </p:sp>
-      <p:sp>
-        <p:nvSpPr>
-          <p:cNvPr id="21" name="Text 19"/>
-          <p:cNvSpPr/>
-          <p:nvPr/>
-        </p:nvSpPr>
-        <p:spPr>
-          <a:xfrm>
-            <a:off x="1371600" y="4379976"/>
-            <a:ext cx="7315200" cy="228600"/>
-          </a:xfrm>
-          <a:prstGeom prst="rect">
-            <a:avLst/>
-          </a:prstGeom>
-          <a:noFill/>
-          <a:ln/>
-        </p:spPr>
-        <p:txBody>
-          <a:bodyPr wrap="square" rtlCol="0" anchor="ctr"/>
-          <a:lstStyle/>
-          <a:p>
-            <a:pPr marL="0" indent="0">
-              <a:buNone/>
-            </a:pPr>
-            <a:r>
-              <a:rPr lang="en-US" sz="1200" dirty="0">
-                <a:solidFill>
-                  <a:srgbClr val="888888"/>
-                </a:solidFill>
-                <a:latin typeface="Arial" pitchFamily="34" charset="0"/>
-                <a:ea typeface="Arial" pitchFamily="34" charset="-122"/>
-                <a:cs typeface="Arial" pitchFamily="34" charset="-120"/>
-              </a:rPr>
-              <a:t>Bug hunt, final fixes, review before submission.</a:t>
-            </a:r>
-            <a:endParaRPr lang="en-US" sz="1200" dirty="0"/>
-          </a:p>
-        </p:txBody>
-      </p:sp>
-    </p:spTree>
-  </p:cSld>
-  <p:clrMapOvr>
-    <a:masterClrMapping/>
-  </p:clrMapOvr>
-</p:sld>
-</file>
-
-<file path=ppt/slides/slide11.xml><?xml version="1.0" encoding="utf-8"?>
 <p:sld xmlns:a="http://schemas.openxmlformats.org/drawingml/2006/main" xmlns:p="http://schemas.openxmlformats.org/presentationml/2006/main" xmlns:r="http://schemas.openxmlformats.org/officeDocument/2006/relationships">
   <p:cSld>
     <p:bg>
@@ -3842,7 +3043,7 @@
 </p:sld>
 </file>
 
-<file path=ppt/slides/slide12.xml><?xml version="1.0" encoding="utf-8"?>
+<file path=ppt/slides/slide11.xml><?xml version="1.0" encoding="utf-8"?>
 <p:sld xmlns:a="http://schemas.openxmlformats.org/drawingml/2006/main" xmlns:r="http://schemas.openxmlformats.org/officeDocument/2006/relationships" xmlns:p="http://schemas.openxmlformats.org/presentationml/2006/main">
   <p:cSld name="Slide 10">
     <p:bg>
@@ -4047,7 +3248,7 @@
 </p:sld>
 </file>
 
-<file path=ppt/slides/slide13.xml><?xml version="1.0" encoding="utf-8"?>
+<file path=ppt/slides/slide12.xml><?xml version="1.0" encoding="utf-8"?>
 <p:sld xmlns:a="http://schemas.openxmlformats.org/drawingml/2006/main" xmlns:r="http://schemas.openxmlformats.org/officeDocument/2006/relationships" xmlns:p="http://schemas.openxmlformats.org/presentationml/2006/main">
   <p:cSld name="Slide 11">
     <p:bg>
@@ -4722,7 +3923,7 @@
 </p:sld>
 </file>
 
-<file path=ppt/slides/slide14.xml><?xml version="1.0" encoding="utf-8"?>
+<file path=ppt/slides/slide13.xml><?xml version="1.0" encoding="utf-8"?>
 <p:sld xmlns:a="http://schemas.openxmlformats.org/drawingml/2006/main" xmlns:r="http://schemas.openxmlformats.org/officeDocument/2006/relationships" xmlns:p="http://schemas.openxmlformats.org/presentationml/2006/main">
   <p:cSld name="Slide 12">
     <p:bg>
@@ -5322,7 +4523,7 @@
 </p:sld>
 </file>
 
-<file path=ppt/slides/slide15.xml><?xml version="1.0" encoding="utf-8"?>
+<file path=ppt/slides/slide14.xml><?xml version="1.0" encoding="utf-8"?>
 <p:sld xmlns:a="http://schemas.openxmlformats.org/drawingml/2006/main" xmlns:r="http://schemas.openxmlformats.org/officeDocument/2006/relationships" xmlns:p="http://schemas.openxmlformats.org/presentationml/2006/main">
   <p:cSld name="Slide 13">
     <p:bg>
@@ -5527,7 +4728,7 @@
 </p:sld>
 </file>
 
-<file path=ppt/slides/slide16.xml><?xml version="1.0" encoding="utf-8"?>
+<file path=ppt/slides/slide15.xml><?xml version="1.0" encoding="utf-8"?>
 <p:sld xmlns:a="http://schemas.openxmlformats.org/drawingml/2006/main" xmlns:r="http://schemas.openxmlformats.org/officeDocument/2006/relationships" xmlns:p="http://schemas.openxmlformats.org/presentationml/2006/main">
   <p:cSld name="Slide 14">
     <p:bg>
@@ -6391,7 +5592,7 @@
 </p:sld>
 </file>
 
-<file path=ppt/slides/slide17.xml><?xml version="1.0" encoding="utf-8"?>
+<file path=ppt/slides/slide16.xml><?xml version="1.0" encoding="utf-8"?>
 <p:sld xmlns:a="http://schemas.openxmlformats.org/drawingml/2006/main" xmlns:r="http://schemas.openxmlformats.org/officeDocument/2006/relationships" xmlns:p="http://schemas.openxmlformats.org/presentationml/2006/main">
   <p:cSld name="Slide 15">
     <p:bg>
@@ -7084,7 +6285,7 @@
 </p:sld>
 </file>
 
-<file path=ppt/slides/slide18.xml><?xml version="1.0" encoding="utf-8"?>
+<file path=ppt/slides/slide17.xml><?xml version="1.0" encoding="utf-8"?>
 <p:sld xmlns:a="http://schemas.openxmlformats.org/drawingml/2006/main" xmlns:r="http://schemas.openxmlformats.org/officeDocument/2006/relationships" xmlns:p="http://schemas.openxmlformats.org/presentationml/2006/main">
   <p:cSld name="Slide 16">
     <p:bg>
@@ -7285,7 +6486,7 @@
 </p:sld>
 </file>
 
-<file path=ppt/slides/slide19.xml><?xml version="1.0" encoding="utf-8"?>
+<file path=ppt/slides/slide18.xml><?xml version="1.0" encoding="utf-8"?>
 <p:sld xmlns:a="http://schemas.openxmlformats.org/drawingml/2006/main" xmlns:r="http://schemas.openxmlformats.org/officeDocument/2006/relationships" xmlns:p="http://schemas.openxmlformats.org/presentationml/2006/main">
   <p:cSld name="Slide 17">
     <p:bg>
@@ -7534,6 +6735,417 @@
               <a:t>Not the code. Not the tools. The way five people stayed aligned.</a:t>
             </a:r>
             <a:endParaRPr lang="en-US" sz="1400" dirty="0"/>
+          </a:p>
+        </p:txBody>
+      </p:sp>
+    </p:spTree>
+  </p:cSld>
+  <p:clrMapOvr>
+    <a:masterClrMapping/>
+  </p:clrMapOvr>
+</p:sld>
+</file>
+
+<file path=ppt/slides/slide19.xml><?xml version="1.0" encoding="utf-8"?>
+<p:sld xmlns:a="http://schemas.openxmlformats.org/drawingml/2006/main" xmlns:p="http://schemas.openxmlformats.org/presentationml/2006/main" xmlns:r="http://schemas.openxmlformats.org/officeDocument/2006/relationships">
+  <p:cSld>
+    <p:bg>
+      <p:bgPr>
+        <a:solidFill>
+          <a:srgbClr val="0D0D0D"/>
+        </a:solidFill>
+        <a:effectLst/>
+      </p:bgPr>
+    </p:bg>
+    <p:spTree>
+      <p:nvGrpSpPr>
+        <p:cNvPr id="1" name=""/>
+        <p:cNvGrpSpPr/>
+        <p:nvPr/>
+      </p:nvGrpSpPr>
+      <p:grpSpPr/>
+      <p:sp>
+        <p:nvSpPr>
+          <p:cNvPr id="2" name="TextBox 1"/>
+          <p:cNvSpPr txBox="1"/>
+          <p:nvPr/>
+        </p:nvSpPr>
+        <p:spPr>
+          <a:xfrm>
+            <a:off x="457200" y="256032"/>
+            <a:ext cx="6858000" cy="256032"/>
+          </a:xfrm>
+          <a:prstGeom prst="rect">
+            <a:avLst/>
+          </a:prstGeom>
+          <a:noFill/>
+        </p:spPr>
+        <p:txBody>
+          <a:bodyPr wrap="square">
+            <a:spAutoFit/>
+          </a:bodyPr>
+          <a:lstStyle/>
+          <a:p>
+            <a:pPr algn="l"/>
+            <a:r>
+              <a:rPr sz="1000" b="1" i="0">
+                <a:solidFill>
+                  <a:srgbClr val="888888"/>
+                </a:solidFill>
+              </a:rPr>
+              <a:t>PROFESSIONAL DEVELOPMENT</a:t>
+            </a:r>
+          </a:p>
+        </p:txBody>
+      </p:sp>
+      <p:sp>
+        <p:nvSpPr>
+          <p:cNvPr id="3" name="TextBox 2"/>
+          <p:cNvSpPr txBox="1"/>
+          <p:nvPr/>
+        </p:nvSpPr>
+        <p:spPr>
+          <a:xfrm>
+            <a:off x="3657600" y="4919472"/>
+            <a:ext cx="5212080" cy="182880"/>
+          </a:xfrm>
+          <a:prstGeom prst="rect">
+            <a:avLst/>
+          </a:prstGeom>
+          <a:noFill/>
+        </p:spPr>
+        <p:txBody>
+          <a:bodyPr wrap="square">
+            <a:spAutoFit/>
+          </a:bodyPr>
+          <a:lstStyle/>
+          <a:p>
+            <a:pPr algn="l"/>
+            <a:r>
+              <a:rPr sz="800" b="0" i="0">
+                <a:solidFill>
+                  <a:srgbClr val="444444"/>
+                </a:solidFill>
+              </a:rPr>
+              <a:t>NINJA QUIZ  .  503IT</a:t>
+            </a:r>
+          </a:p>
+        </p:txBody>
+      </p:sp>
+      <p:sp>
+        <p:nvSpPr>
+          <p:cNvPr id="4" name="TextBox 3"/>
+          <p:cNvSpPr txBox="1"/>
+          <p:nvPr/>
+        </p:nvSpPr>
+        <p:spPr>
+          <a:xfrm>
+            <a:off x="457200" y="594360"/>
+            <a:ext cx="8229600" cy="1097280"/>
+          </a:xfrm>
+          <a:prstGeom prst="rect">
+            <a:avLst/>
+          </a:prstGeom>
+          <a:noFill/>
+        </p:spPr>
+        <p:txBody>
+          <a:bodyPr wrap="square">
+            <a:spAutoFit/>
+          </a:bodyPr>
+          <a:lstStyle/>
+          <a:p>
+            <a:pPr algn="l"/>
+            <a:r>
+              <a:rPr sz="2800" b="1" i="0">
+                <a:solidFill>
+                  <a:srgbClr val="FFFFFF"/>
+                </a:solidFill>
+              </a:rPr>
+              <a:t>This project taught us how</a:t>
+            </a:r>
+          </a:p>
+          <a:p>
+            <a:pPr algn="l"/>
+            <a:r>
+              <a:rPr sz="2800" b="1" i="0">
+                <a:solidFill>
+                  <a:srgbClr val="FFFFFF"/>
+                </a:solidFill>
+              </a:rPr>
+              <a:t>industry teams actually work.</a:t>
+            </a:r>
+          </a:p>
+        </p:txBody>
+      </p:sp>
+      <p:sp>
+        <p:nvSpPr>
+          <p:cNvPr id="5" name="TextBox 4"/>
+          <p:cNvSpPr txBox="1"/>
+          <p:nvPr/>
+        </p:nvSpPr>
+        <p:spPr>
+          <a:xfrm>
+            <a:off x="457200" y="1874519"/>
+            <a:ext cx="3840480" cy="256032"/>
+          </a:xfrm>
+          <a:prstGeom prst="rect">
+            <a:avLst/>
+          </a:prstGeom>
+          <a:noFill/>
+        </p:spPr>
+        <p:txBody>
+          <a:bodyPr wrap="square">
+            <a:spAutoFit/>
+          </a:bodyPr>
+          <a:lstStyle/>
+          <a:p>
+            <a:pPr algn="l"/>
+            <a:r>
+              <a:rPr sz="1300" b="1" i="0">
+                <a:solidFill>
+                  <a:srgbClr val="FFCD00"/>
+                </a:solidFill>
+              </a:rPr>
+              <a:t>Structured communication</a:t>
+            </a:r>
+          </a:p>
+        </p:txBody>
+      </p:sp>
+      <p:sp>
+        <p:nvSpPr>
+          <p:cNvPr id="6" name="TextBox 5"/>
+          <p:cNvSpPr txBox="1"/>
+          <p:nvPr/>
+        </p:nvSpPr>
+        <p:spPr>
+          <a:xfrm>
+            <a:off x="457200" y="2148839"/>
+            <a:ext cx="8229600" cy="411480"/>
+          </a:xfrm>
+          <a:prstGeom prst="rect">
+            <a:avLst/>
+          </a:prstGeom>
+          <a:noFill/>
+        </p:spPr>
+        <p:txBody>
+          <a:bodyPr wrap="square">
+            <a:spAutoFit/>
+          </a:bodyPr>
+          <a:lstStyle/>
+          <a:p>
+            <a:pPr algn="l"/>
+            <a:r>
+              <a:rPr sz="1100" b="0" i="0">
+                <a:solidFill>
+                  <a:srgbClr val="AAAAAA"/>
+                </a:solidFill>
+              </a:rPr>
+              <a:t>Raising issues immediately, logging decisions in Trello and meeting minutes — these are professional standards, not student habits.</a:t>
+            </a:r>
+          </a:p>
+        </p:txBody>
+      </p:sp>
+      <p:sp>
+        <p:nvSpPr>
+          <p:cNvPr id="7" name="TextBox 6"/>
+          <p:cNvSpPr txBox="1"/>
+          <p:nvPr/>
+        </p:nvSpPr>
+        <p:spPr>
+          <a:xfrm>
+            <a:off x="457200" y="2697479"/>
+            <a:ext cx="3840480" cy="256032"/>
+          </a:xfrm>
+          <a:prstGeom prst="rect">
+            <a:avLst/>
+          </a:prstGeom>
+          <a:noFill/>
+        </p:spPr>
+        <p:txBody>
+          <a:bodyPr wrap="square">
+            <a:spAutoFit/>
+          </a:bodyPr>
+          <a:lstStyle/>
+          <a:p>
+            <a:pPr algn="l"/>
+            <a:r>
+              <a:rPr sz="1300" b="1" i="0">
+                <a:solidFill>
+                  <a:srgbClr val="FFCD00"/>
+                </a:solidFill>
+              </a:rPr>
+              <a:t>Real version control</a:t>
+            </a:r>
+          </a:p>
+        </p:txBody>
+      </p:sp>
+      <p:sp>
+        <p:nvSpPr>
+          <p:cNvPr id="8" name="TextBox 7"/>
+          <p:cNvSpPr txBox="1"/>
+          <p:nvPr/>
+        </p:nvSpPr>
+        <p:spPr>
+          <a:xfrm>
+            <a:off x="457200" y="2971799"/>
+            <a:ext cx="8229600" cy="411480"/>
+          </a:xfrm>
+          <a:prstGeom prst="rect">
+            <a:avLst/>
+          </a:prstGeom>
+          <a:noFill/>
+        </p:spPr>
+        <p:txBody>
+          <a:bodyPr wrap="square">
+            <a:spAutoFit/>
+          </a:bodyPr>
+          <a:lstStyle/>
+          <a:p>
+            <a:pPr algn="l"/>
+            <a:r>
+              <a:rPr sz="1100" b="0" i="0">
+                <a:solidFill>
+                  <a:srgbClr val="AAAAAA"/>
+                </a:solidFill>
+              </a:rPr>
+              <a:t>Feature branches, no pushing to main without review. We left this project with actual Git workflow experience.</a:t>
+            </a:r>
+          </a:p>
+        </p:txBody>
+      </p:sp>
+      <p:sp>
+        <p:nvSpPr>
+          <p:cNvPr id="9" name="TextBox 8"/>
+          <p:cNvSpPr txBox="1"/>
+          <p:nvPr/>
+        </p:nvSpPr>
+        <p:spPr>
+          <a:xfrm>
+            <a:off x="457200" y="3520439"/>
+            <a:ext cx="3840480" cy="256032"/>
+          </a:xfrm>
+          <a:prstGeom prst="rect">
+            <a:avLst/>
+          </a:prstGeom>
+          <a:noFill/>
+        </p:spPr>
+        <p:txBody>
+          <a:bodyPr wrap="square">
+            <a:spAutoFit/>
+          </a:bodyPr>
+          <a:lstStyle/>
+          <a:p>
+            <a:pPr algn="l"/>
+            <a:r>
+              <a:rPr sz="1300" b="1" i="0">
+                <a:solidFill>
+                  <a:srgbClr val="FFCD00"/>
+                </a:solidFill>
+              </a:rPr>
+              <a:t>Agile delivery mindset</a:t>
+            </a:r>
+          </a:p>
+        </p:txBody>
+      </p:sp>
+      <p:sp>
+        <p:nvSpPr>
+          <p:cNvPr id="10" name="TextBox 9"/>
+          <p:cNvSpPr txBox="1"/>
+          <p:nvPr/>
+        </p:nvSpPr>
+        <p:spPr>
+          <a:xfrm>
+            <a:off x="457200" y="3794759"/>
+            <a:ext cx="8229600" cy="411480"/>
+          </a:xfrm>
+          <a:prstGeom prst="rect">
+            <a:avLst/>
+          </a:prstGeom>
+          <a:noFill/>
+        </p:spPr>
+        <p:txBody>
+          <a:bodyPr wrap="square">
+            <a:spAutoFit/>
+          </a:bodyPr>
+          <a:lstStyle/>
+          <a:p>
+            <a:pPr algn="l"/>
+            <a:r>
+              <a:rPr sz="1100" b="0" i="0">
+                <a:solidFill>
+                  <a:srgbClr val="AAAAAA"/>
+                </a:solidFill>
+              </a:rPr>
+              <a:t>Five sprints with goals, retrospectives, and user testing mirrors how software teams ship in industry.</a:t>
+            </a:r>
+          </a:p>
+        </p:txBody>
+      </p:sp>
+      <p:sp>
+        <p:nvSpPr>
+          <p:cNvPr id="11" name="TextBox 10"/>
+          <p:cNvSpPr txBox="1"/>
+          <p:nvPr/>
+        </p:nvSpPr>
+        <p:spPr>
+          <a:xfrm>
+            <a:off x="457200" y="4343400"/>
+            <a:ext cx="3840480" cy="256032"/>
+          </a:xfrm>
+          <a:prstGeom prst="rect">
+            <a:avLst/>
+          </a:prstGeom>
+          <a:noFill/>
+        </p:spPr>
+        <p:txBody>
+          <a:bodyPr wrap="square">
+            <a:spAutoFit/>
+          </a:bodyPr>
+          <a:lstStyle/>
+          <a:p>
+            <a:pPr algn="l"/>
+            <a:r>
+              <a:rPr sz="1300" b="1" i="0">
+                <a:solidFill>
+                  <a:srgbClr val="FFCD00"/>
+                </a:solidFill>
+              </a:rPr>
+              <a:t>Resilience under pressure</a:t>
+            </a:r>
+          </a:p>
+        </p:txBody>
+      </p:sp>
+      <p:sp>
+        <p:nvSpPr>
+          <p:cNvPr id="12" name="TextBox 11"/>
+          <p:cNvSpPr txBox="1"/>
+          <p:nvPr/>
+        </p:nvSpPr>
+        <p:spPr>
+          <a:xfrm>
+            <a:off x="457200" y="4617720"/>
+            <a:ext cx="8229600" cy="411480"/>
+          </a:xfrm>
+          <a:prstGeom prst="rect">
+            <a:avLst/>
+          </a:prstGeom>
+          <a:noFill/>
+        </p:spPr>
+        <p:txBody>
+          <a:bodyPr wrap="square">
+            <a:spAutoFit/>
+          </a:bodyPr>
+          <a:lstStyle/>
+          <a:p>
+            <a:pPr algn="l"/>
+            <a:r>
+              <a:rPr sz="1100" b="0" i="0">
+                <a:solidFill>
+                  <a:srgbClr val="AAAAAA"/>
+                </a:solidFill>
+              </a:rPr>
+              <a:t>When the game broke 2 weeks before submission, we diagnosed and fixed it in one day — as a team. That experience is irreplaceable.</a:t>
+            </a:r>
           </a:p>
         </p:txBody>
       </p:sp>
@@ -8092,7 +7704,7 @@
 </p:sld>
 </file>
 
-<file path=ppt/slides/slide20.xml><?xml version="1.0" encoding="utf-8"?>
+<file path=ppt/slides/slide2.xml><?xml version="1.0" encoding="utf-8"?>
 <p:sld xmlns:a="http://schemas.openxmlformats.org/drawingml/2006/main" xmlns:p="http://schemas.openxmlformats.org/presentationml/2006/main" xmlns:r="http://schemas.openxmlformats.org/officeDocument/2006/relationships">
   <p:cSld>
     <p:bg>
@@ -8119,7 +7731,7 @@
         <p:spPr>
           <a:xfrm>
             <a:off x="457200" y="256032"/>
-            <a:ext cx="6858000" cy="256032"/>
+            <a:ext cx="6400800" cy="256032"/>
           </a:xfrm>
           <a:prstGeom prst="rect">
             <a:avLst/>
@@ -8139,7 +7751,7 @@
                   <a:srgbClr val="888888"/>
                 </a:solidFill>
               </a:rPr>
-              <a:t>PROFESSIONAL DEVELOPMENT</a:t>
+              <a:t>WHAT WE WILL COVER</a:t>
             </a:r>
           </a:p>
         </p:txBody>
@@ -8202,23 +7814,23 @@
           <a:p>
             <a:pPr algn="l"/>
             <a:r>
-              <a:rPr sz="2800" b="1" i="0">
+              <a:rPr sz="3400" b="1" i="0">
                 <a:solidFill>
                   <a:srgbClr val="FFFFFF"/>
                 </a:solidFill>
               </a:rPr>
-              <a:t>This project taught us how</a:t>
+              <a:t>15 minutes.</a:t>
             </a:r>
           </a:p>
           <a:p>
             <a:pPr algn="l"/>
             <a:r>
-              <a:rPr sz="2800" b="1" i="0">
+              <a:rPr sz="3400" b="1" i="0">
                 <a:solidFill>
                   <a:srgbClr val="FFFFFF"/>
                 </a:solidFill>
               </a:rPr>
-              <a:t>industry teams actually work.</a:t>
+              <a:t>One story.</a:t>
             </a:r>
           </a:p>
         </p:txBody>
@@ -8232,7 +7844,7 @@
         <p:spPr>
           <a:xfrm>
             <a:off x="457200" y="1874519"/>
-            <a:ext cx="3840480" cy="256032"/>
+            <a:ext cx="640080" cy="292608"/>
           </a:xfrm>
           <a:prstGeom prst="rect">
             <a:avLst/>
@@ -8247,12 +7859,12 @@
           <a:p>
             <a:pPr algn="l"/>
             <a:r>
-              <a:rPr sz="1300" b="1" i="0">
+              <a:rPr sz="1200" b="1" i="0">
                 <a:solidFill>
                   <a:srgbClr val="FFCD00"/>
                 </a:solidFill>
               </a:rPr>
-              <a:t>Structured communication</a:t>
+              <a:t>01</a:t>
             </a:r>
           </a:p>
         </p:txBody>
@@ -8265,8 +7877,8 @@
         </p:nvSpPr>
         <p:spPr>
           <a:xfrm>
-            <a:off x="457200" y="2148839"/>
-            <a:ext cx="8229600" cy="411480"/>
+            <a:off x="1188720" y="1874519"/>
+            <a:ext cx="7680960" cy="292608"/>
           </a:xfrm>
           <a:prstGeom prst="rect">
             <a:avLst/>
@@ -8281,12 +7893,12 @@
           <a:p>
             <a:pPr algn="l"/>
             <a:r>
-              <a:rPr sz="1100" b="0" i="0">
-                <a:solidFill>
-                  <a:srgbClr val="AAAAAA"/>
-                </a:solidFill>
-              </a:rPr>
-              <a:t>Raising issues immediately, logging decisions in Trello and meeting minutes — these are professional standards, not student habits.</a:t>
+              <a:rPr sz="1200" b="0" i="0">
+                <a:solidFill>
+                  <a:srgbClr val="DDDDDD"/>
+                </a:solidFill>
+              </a:rPr>
+              <a:t>The brief — and why we chose this audience</a:t>
             </a:r>
           </a:p>
         </p:txBody>
@@ -8299,8 +7911,8 @@
         </p:nvSpPr>
         <p:spPr>
           <a:xfrm>
-            <a:off x="457200" y="2697479"/>
-            <a:ext cx="3840480" cy="256032"/>
+            <a:off x="457200" y="2331720"/>
+            <a:ext cx="640080" cy="292608"/>
           </a:xfrm>
           <a:prstGeom prst="rect">
             <a:avLst/>
@@ -8315,12 +7927,12 @@
           <a:p>
             <a:pPr algn="l"/>
             <a:r>
-              <a:rPr sz="1300" b="1" i="0">
+              <a:rPr sz="1200" b="1" i="0">
                 <a:solidFill>
                   <a:srgbClr val="FFCD00"/>
                 </a:solidFill>
               </a:rPr>
-              <a:t>Real version control</a:t>
+              <a:t>02</a:t>
             </a:r>
           </a:p>
         </p:txBody>
@@ -8333,8 +7945,8 @@
         </p:nvSpPr>
         <p:spPr>
           <a:xfrm>
-            <a:off x="457200" y="2971799"/>
-            <a:ext cx="8229600" cy="411480"/>
+            <a:off x="1188720" y="2331720"/>
+            <a:ext cx="7680960" cy="292608"/>
           </a:xfrm>
           <a:prstGeom prst="rect">
             <a:avLst/>
@@ -8349,12 +7961,12 @@
           <a:p>
             <a:pPr algn="l"/>
             <a:r>
-              <a:rPr sz="1100" b="0" i="0">
-                <a:solidFill>
-                  <a:srgbClr val="AAAAAA"/>
-                </a:solidFill>
-              </a:rPr>
-              <a:t>Feature branches, no pushing to main without review. We left this project with actual Git workflow experience.</a:t>
+              <a:rPr sz="1200" b="0" i="0">
+                <a:solidFill>
+                  <a:srgbClr val="DDDDDD"/>
+                </a:solidFill>
+              </a:rPr>
+              <a:t>Our team — roles and Belbin framework</a:t>
             </a:r>
           </a:p>
         </p:txBody>
@@ -8367,8 +7979,8 @@
         </p:nvSpPr>
         <p:spPr>
           <a:xfrm>
-            <a:off x="457200" y="3520439"/>
-            <a:ext cx="3840480" cy="256032"/>
+            <a:off x="457200" y="2788920"/>
+            <a:ext cx="640080" cy="292608"/>
           </a:xfrm>
           <a:prstGeom prst="rect">
             <a:avLst/>
@@ -8383,12 +7995,12 @@
           <a:p>
             <a:pPr algn="l"/>
             <a:r>
-              <a:rPr sz="1300" b="1" i="0">
+              <a:rPr sz="1200" b="1" i="0">
                 <a:solidFill>
                   <a:srgbClr val="FFCD00"/>
                 </a:solidFill>
               </a:rPr>
-              <a:t>Agile delivery mindset</a:t>
+              <a:t>03</a:t>
             </a:r>
           </a:p>
         </p:txBody>
@@ -8401,8 +8013,8 @@
         </p:nvSpPr>
         <p:spPr>
           <a:xfrm>
-            <a:off x="457200" y="3794759"/>
-            <a:ext cx="8229600" cy="411480"/>
+            <a:off x="1188720" y="2788920"/>
+            <a:ext cx="7680960" cy="292608"/>
           </a:xfrm>
           <a:prstGeom prst="rect">
             <a:avLst/>
@@ -8417,12 +8029,12 @@
           <a:p>
             <a:pPr algn="l"/>
             <a:r>
-              <a:rPr sz="1100" b="0" i="0">
-                <a:solidFill>
-                  <a:srgbClr val="AAAAAA"/>
-                </a:solidFill>
-              </a:rPr>
-              <a:t>Five sprints with goals, retrospectives, and user testing mirrors how software teams ship in industry.</a:t>
+              <a:rPr sz="1200" b="0" i="0">
+                <a:solidFill>
+                  <a:srgbClr val="DDDDDD"/>
+                </a:solidFill>
+              </a:rPr>
+              <a:t>How we planned, communicated and tracked work</a:t>
             </a:r>
           </a:p>
         </p:txBody>
@@ -8435,8 +8047,8 @@
         </p:nvSpPr>
         <p:spPr>
           <a:xfrm>
-            <a:off x="457200" y="4343400"/>
-            <a:ext cx="3840480" cy="256032"/>
+            <a:off x="457200" y="3246120"/>
+            <a:ext cx="640080" cy="292608"/>
           </a:xfrm>
           <a:prstGeom prst="rect">
             <a:avLst/>
@@ -8451,12 +8063,12 @@
           <a:p>
             <a:pPr algn="l"/>
             <a:r>
-              <a:rPr sz="1300" b="1" i="0">
+              <a:rPr sz="1200" b="1" i="0">
                 <a:solidFill>
                   <a:srgbClr val="FFCD00"/>
                 </a:solidFill>
               </a:rPr>
-              <a:t>Resilience under pressure</a:t>
+              <a:t>04</a:t>
             </a:r>
           </a:p>
         </p:txBody>
@@ -8469,8 +8081,8 @@
         </p:nvSpPr>
         <p:spPr>
           <a:xfrm>
-            <a:off x="457200" y="4617720"/>
-            <a:ext cx="8229600" cy="411480"/>
+            <a:off x="1188720" y="3246120"/>
+            <a:ext cx="7680960" cy="292608"/>
           </a:xfrm>
           <a:prstGeom prst="rect">
             <a:avLst/>
@@ -8485,12 +8097,148 @@
           <a:p>
             <a:pPr algn="l"/>
             <a:r>
-              <a:rPr sz="1100" b="0" i="0">
-                <a:solidFill>
-                  <a:srgbClr val="AAAAAA"/>
-                </a:solidFill>
-              </a:rPr>
-              <a:t>When the game broke 2 weeks before submission, we diagnosed and fixed it in one day — as a team. That experience is irreplaceable.</a:t>
+              <a:rPr sz="1200" b="0" i="0">
+                <a:solidFill>
+                  <a:srgbClr val="DDDDDD"/>
+                </a:solidFill>
+              </a:rPr>
+              <a:t>Our delivery — 5 sprints and what each taught us</a:t>
+            </a:r>
+          </a:p>
+        </p:txBody>
+      </p:sp>
+      <p:sp>
+        <p:nvSpPr>
+          <p:cNvPr id="13" name="TextBox 12"/>
+          <p:cNvSpPr txBox="1"/>
+          <p:nvPr/>
+        </p:nvSpPr>
+        <p:spPr>
+          <a:xfrm>
+            <a:off x="457200" y="3703320"/>
+            <a:ext cx="640080" cy="292608"/>
+          </a:xfrm>
+          <a:prstGeom prst="rect">
+            <a:avLst/>
+          </a:prstGeom>
+          <a:noFill/>
+        </p:spPr>
+        <p:txBody>
+          <a:bodyPr wrap="square">
+            <a:spAutoFit/>
+          </a:bodyPr>
+          <a:lstStyle/>
+          <a:p>
+            <a:pPr algn="l"/>
+            <a:r>
+              <a:rPr sz="1200" b="1" i="0">
+                <a:solidFill>
+                  <a:srgbClr val="FFCD00"/>
+                </a:solidFill>
+              </a:rPr>
+              <a:t>05</a:t>
+            </a:r>
+          </a:p>
+        </p:txBody>
+      </p:sp>
+      <p:sp>
+        <p:nvSpPr>
+          <p:cNvPr id="14" name="TextBox 13"/>
+          <p:cNvSpPr txBox="1"/>
+          <p:nvPr/>
+        </p:nvSpPr>
+        <p:spPr>
+          <a:xfrm>
+            <a:off x="1188720" y="3703320"/>
+            <a:ext cx="7680960" cy="292608"/>
+          </a:xfrm>
+          <a:prstGeom prst="rect">
+            <a:avLst/>
+          </a:prstGeom>
+          <a:noFill/>
+        </p:spPr>
+        <p:txBody>
+          <a:bodyPr wrap="square">
+            <a:spAutoFit/>
+          </a:bodyPr>
+          <a:lstStyle/>
+          <a:p>
+            <a:pPr algn="l"/>
+            <a:r>
+              <a:rPr sz="1200" b="0" i="0">
+                <a:solidFill>
+                  <a:srgbClr val="DDDDDD"/>
+                </a:solidFill>
+              </a:rPr>
+              <a:t>The product — a live, playable prototype</a:t>
+            </a:r>
+          </a:p>
+        </p:txBody>
+      </p:sp>
+      <p:sp>
+        <p:nvSpPr>
+          <p:cNvPr id="15" name="TextBox 14"/>
+          <p:cNvSpPr txBox="1"/>
+          <p:nvPr/>
+        </p:nvSpPr>
+        <p:spPr>
+          <a:xfrm>
+            <a:off x="457200" y="4160520"/>
+            <a:ext cx="640080" cy="292608"/>
+          </a:xfrm>
+          <a:prstGeom prst="rect">
+            <a:avLst/>
+          </a:prstGeom>
+          <a:noFill/>
+        </p:spPr>
+        <p:txBody>
+          <a:bodyPr wrap="square">
+            <a:spAutoFit/>
+          </a:bodyPr>
+          <a:lstStyle/>
+          <a:p>
+            <a:pPr algn="l"/>
+            <a:r>
+              <a:rPr sz="1200" b="1" i="0">
+                <a:solidFill>
+                  <a:srgbClr val="FFCD00"/>
+                </a:solidFill>
+              </a:rPr>
+              <a:t>06</a:t>
+            </a:r>
+          </a:p>
+        </p:txBody>
+      </p:sp>
+      <p:sp>
+        <p:nvSpPr>
+          <p:cNvPr id="16" name="TextBox 15"/>
+          <p:cNvSpPr txBox="1"/>
+          <p:nvPr/>
+        </p:nvSpPr>
+        <p:spPr>
+          <a:xfrm>
+            <a:off x="1188720" y="4160520"/>
+            <a:ext cx="7680960" cy="292608"/>
+          </a:xfrm>
+          <a:prstGeom prst="rect">
+            <a:avLst/>
+          </a:prstGeom>
+          <a:noFill/>
+        </p:spPr>
+        <p:txBody>
+          <a:bodyPr wrap="square">
+            <a:spAutoFit/>
+          </a:bodyPr>
+          <a:lstStyle/>
+          <a:p>
+            <a:pPr algn="l"/>
+            <a:r>
+              <a:rPr sz="1200" b="0" i="0">
+                <a:solidFill>
+                  <a:srgbClr val="DDDDDD"/>
+                </a:solidFill>
+              </a:rPr>
+              <a:t>What we learned — and how it shapes our careers</a:t>
             </a:r>
           </a:p>
         </p:txBody>
@@ -8503,7 +8251,7 @@
 </p:sld>
 </file>
 
-<file path=ppt/slides/slide21.xml><?xml version="1.0" encoding="utf-8"?>
+<file path=ppt/slides/slide20.xml><?xml version="1.0" encoding="utf-8"?>
 <p:sld xmlns:a="http://schemas.openxmlformats.org/drawingml/2006/main" xmlns:r="http://schemas.openxmlformats.org/officeDocument/2006/relationships" xmlns:p="http://schemas.openxmlformats.org/presentationml/2006/main">
   <p:cSld name="Slide 18">
     <p:bg>
@@ -8709,261 +8457,6 @@
 
 <file path=ppt/slides/slide3.xml><?xml version="1.0" encoding="utf-8"?>
 <p:sld xmlns:a="http://schemas.openxmlformats.org/drawingml/2006/main" xmlns:r="http://schemas.openxmlformats.org/officeDocument/2006/relationships" xmlns:p="http://schemas.openxmlformats.org/presentationml/2006/main">
-  <p:cSld name="Slide 2">
-    <p:bg>
-      <p:bgPr>
-        <a:solidFill>
-          <a:srgbClr val="0D0D0D"/>
-        </a:solidFill>
-        <a:effectLst/>
-      </p:bgPr>
-    </p:bg>
-    <p:spTree>
-      <p:nvGrpSpPr>
-        <p:cNvPr id="1" name=""/>
-        <p:cNvGrpSpPr/>
-        <p:nvPr/>
-      </p:nvGrpSpPr>
-      <p:grpSpPr>
-        <a:xfrm>
-          <a:off x="0" y="0"/>
-          <a:ext cx="0" cy="0"/>
-          <a:chOff x="0" y="0"/>
-          <a:chExt cx="0" cy="0"/>
-        </a:xfrm>
-      </p:grpSpPr>
-      <p:sp>
-        <p:nvSpPr>
-          <p:cNvPr id="2" name="Shape 0"/>
-          <p:cNvSpPr/>
-          <p:nvPr/>
-        </p:nvSpPr>
-        <p:spPr>
-          <a:xfrm>
-            <a:off x="8458200" y="201168"/>
-            <a:ext cx="256032" cy="256032"/>
-          </a:xfrm>
-          <a:prstGeom prst="ellipse">
-            <a:avLst/>
-          </a:prstGeom>
-          <a:solidFill>
-            <a:srgbClr val="FFCD00"/>
-          </a:solidFill>
-          <a:ln/>
-        </p:spPr>
-        <p:txBody>
-          <a:bodyPr/>
-          <a:lstStyle/>
-          <a:p>
-            <a:endParaRPr lang="en-GB"/>
-          </a:p>
-        </p:txBody>
-      </p:sp>
-      <p:sp>
-        <p:nvSpPr>
-          <p:cNvPr id="3" name="Text 1"/>
-          <p:cNvSpPr/>
-          <p:nvPr/>
-        </p:nvSpPr>
-        <p:spPr>
-          <a:xfrm>
-            <a:off x="457200" y="274320"/>
-            <a:ext cx="6400800" cy="228600"/>
-          </a:xfrm>
-          <a:prstGeom prst="rect">
-            <a:avLst/>
-          </a:prstGeom>
-          <a:noFill/>
-          <a:ln/>
-        </p:spPr>
-        <p:txBody>
-          <a:bodyPr wrap="square" rtlCol="0" anchor="ctr"/>
-          <a:lstStyle/>
-          <a:p>
-            <a:pPr marL="0" indent="0">
-              <a:buNone/>
-            </a:pPr>
-            <a:r>
-              <a:rPr lang="en-US" sz="1000" b="1" kern="0" spc="200" dirty="0">
-                <a:solidFill>
-                  <a:srgbClr val="555555"/>
-                </a:solidFill>
-                <a:latin typeface="Arial" pitchFamily="34" charset="0"/>
-                <a:ea typeface="Arial" pitchFamily="34" charset="-122"/>
-                <a:cs typeface="Arial" pitchFamily="34" charset="-120"/>
-              </a:rPr>
-              <a:t>THE BRIEF</a:t>
-            </a:r>
-            <a:endParaRPr lang="en-US" sz="1000" dirty="0"/>
-          </a:p>
-        </p:txBody>
-      </p:sp>
-      <p:sp>
-        <p:nvSpPr>
-          <p:cNvPr id="4" name="Text 2"/>
-          <p:cNvSpPr/>
-          <p:nvPr/>
-        </p:nvSpPr>
-        <p:spPr>
-          <a:xfrm>
-            <a:off x="3657600" y="4919472"/>
-            <a:ext cx="5212080" cy="182880"/>
-          </a:xfrm>
-          <a:prstGeom prst="rect">
-            <a:avLst/>
-          </a:prstGeom>
-          <a:noFill/>
-          <a:ln/>
-        </p:spPr>
-        <p:txBody>
-          <a:bodyPr wrap="square" rtlCol="0" anchor="ctr"/>
-          <a:lstStyle/>
-          <a:p>
-            <a:pPr marL="0" indent="0" algn="r">
-              <a:buNone/>
-            </a:pPr>
-            <a:r>
-              <a:rPr lang="en-US" sz="900" dirty="0">
-                <a:solidFill>
-                  <a:srgbClr val="555555"/>
-                </a:solidFill>
-                <a:latin typeface="Arial" pitchFamily="34" charset="0"/>
-                <a:ea typeface="Arial" pitchFamily="34" charset="-122"/>
-                <a:cs typeface="Arial" pitchFamily="34" charset="-120"/>
-              </a:rPr>
-              <a:t>NINJA QUIZ  ·  503IT  ·  02 / 18</a:t>
-            </a:r>
-            <a:endParaRPr lang="en-US" sz="900" dirty="0"/>
-          </a:p>
-        </p:txBody>
-      </p:sp>
-      <p:sp>
-        <p:nvSpPr>
-          <p:cNvPr id="5" name="Text 3"/>
-          <p:cNvSpPr/>
-          <p:nvPr/>
-        </p:nvSpPr>
-        <p:spPr>
-          <a:xfrm>
-            <a:off x="457200" y="822960"/>
-            <a:ext cx="8229600" cy="2438400"/>
-          </a:xfrm>
-          <a:prstGeom prst="rect">
-            <a:avLst/>
-          </a:prstGeom>
-          <a:noFill/>
-          <a:ln/>
-        </p:spPr>
-        <p:txBody>
-          <a:bodyPr wrap="square" rtlCol="0" anchor="ctr"/>
-          <a:lstStyle/>
-          <a:p>
-            <a:pPr marL="0" indent="0">
-              <a:buNone/>
-            </a:pPr>
-            <a:r>
-              <a:rPr lang="en-US" sz="9600" b="1" dirty="0">
-                <a:solidFill>
-                  <a:srgbClr val="FFCD00"/>
-                </a:solidFill>
-                <a:latin typeface="Arial Black" pitchFamily="34" charset="0"/>
-                <a:ea typeface="Arial Black" pitchFamily="34" charset="-122"/>
-                <a:cs typeface="Arial Black" pitchFamily="34" charset="-120"/>
-              </a:rPr>
-              <a:t>1 in 3</a:t>
-            </a:r>
-            <a:endParaRPr lang="en-US" sz="9600" dirty="0"/>
-          </a:p>
-        </p:txBody>
-      </p:sp>
-      <p:sp>
-        <p:nvSpPr>
-          <p:cNvPr id="6" name="Text 4"/>
-          <p:cNvSpPr/>
-          <p:nvPr/>
-        </p:nvSpPr>
-        <p:spPr>
-          <a:xfrm>
-            <a:off x="457200" y="2468880"/>
-            <a:ext cx="7772400" cy="320040"/>
-          </a:xfrm>
-          <a:prstGeom prst="rect">
-            <a:avLst/>
-          </a:prstGeom>
-          <a:noFill/>
-          <a:ln/>
-        </p:spPr>
-        <p:txBody>
-          <a:bodyPr wrap="square" rtlCol="0" anchor="ctr"/>
-          <a:lstStyle/>
-          <a:p>
-            <a:pPr marL="0" indent="0">
-              <a:buNone/>
-            </a:pPr>
-            <a:r>
-              <a:rPr lang="en-US" sz="1400" dirty="0">
-                <a:solidFill>
-                  <a:srgbClr val="555555"/>
-                </a:solidFill>
-                <a:latin typeface="Arial" pitchFamily="34" charset="0"/>
-                <a:ea typeface="Arial" pitchFamily="34" charset="-122"/>
-                <a:cs typeface="Arial" pitchFamily="34" charset="-120"/>
-              </a:rPr>
-              <a:t>children have already faced an online risk.</a:t>
-            </a:r>
-            <a:endParaRPr lang="en-US" sz="1400" dirty="0"/>
-          </a:p>
-        </p:txBody>
-      </p:sp>
-      <p:sp>
-        <p:nvSpPr>
-          <p:cNvPr id="7" name="Text 5"/>
-          <p:cNvSpPr/>
-          <p:nvPr/>
-        </p:nvSpPr>
-        <p:spPr>
-          <a:xfrm>
-            <a:off x="457200" y="2926080"/>
-            <a:ext cx="7772400" cy="320040"/>
-          </a:xfrm>
-          <a:prstGeom prst="rect">
-            <a:avLst/>
-          </a:prstGeom>
-          <a:noFill/>
-          <a:ln/>
-        </p:spPr>
-        <p:txBody>
-          <a:bodyPr wrap="square" rtlCol="0" anchor="ctr"/>
-          <a:lstStyle/>
-          <a:p>
-            <a:pPr marL="0" indent="0">
-              <a:buNone/>
-            </a:pPr>
-            <a:r>
-              <a:rPr lang="en-US" sz="1400" dirty="0">
-                <a:solidFill>
-                  <a:srgbClr val="555555"/>
-                </a:solidFill>
-                <a:latin typeface="Arial" pitchFamily="34" charset="0"/>
-                <a:ea typeface="Arial" pitchFamily="34" charset="-122"/>
-                <a:cs typeface="Arial" pitchFamily="34" charset="-120"/>
-              </a:rPr>
-              <a:t>The brief: build a game that actually teaches them to stay safe.</a:t>
-            </a:r>
-            <a:endParaRPr lang="en-US" sz="1400" dirty="0"/>
-          </a:p>
-        </p:txBody>
-      </p:sp>
-    </p:spTree>
-  </p:cSld>
-  <p:clrMapOvr>
-    <a:masterClrMapping/>
-  </p:clrMapOvr>
-</p:sld>
-</file>
-
-<file path=ppt/slides/slide4.xml><?xml version="1.0" encoding="utf-8"?>
-<p:sld xmlns:a="http://schemas.openxmlformats.org/drawingml/2006/main" xmlns:r="http://schemas.openxmlformats.org/officeDocument/2006/relationships" xmlns:p="http://schemas.openxmlformats.org/presentationml/2006/main">
   <p:cSld name="Slide 3">
     <p:bg>
       <p:bgPr>
@@ -9167,7 +8660,7 @@
 </p:sld>
 </file>
 
-<file path=ppt/slides/slide5.xml><?xml version="1.0" encoding="utf-8"?>
+<file path=ppt/slides/slide4.xml><?xml version="1.0" encoding="utf-8"?>
 <p:sld xmlns:a="http://schemas.openxmlformats.org/drawingml/2006/main" xmlns:r="http://schemas.openxmlformats.org/officeDocument/2006/relationships" xmlns:p="http://schemas.openxmlformats.org/presentationml/2006/main">
   <p:cSld name="Slide 4">
     <p:bg>
@@ -9413,7 +8906,7 @@
         <p:spPr>
           <a:xfrm>
             <a:off x="1371600" y="1591056"/>
-            <a:ext cx="3474720" cy="292608"/>
+            <a:ext cx="7315200" cy="292608"/>
           </a:xfrm>
           <a:prstGeom prst="rect">
             <a:avLst/>
@@ -9452,7 +8945,7 @@
         <p:spPr>
           <a:xfrm>
             <a:off x="1371600" y="1892808"/>
-            <a:ext cx="3474720" cy="228600"/>
+            <a:ext cx="7315200" cy="228600"/>
           </a:xfrm>
           <a:prstGeom prst="rect">
             <a:avLst/>
@@ -9532,7 +9025,7 @@
         <p:spPr>
           <a:xfrm>
             <a:off x="1371600" y="2258568"/>
-            <a:ext cx="3474720" cy="292608"/>
+            <a:ext cx="7315200" cy="292608"/>
           </a:xfrm>
           <a:prstGeom prst="rect">
             <a:avLst/>
@@ -9571,7 +9064,7 @@
         <p:spPr>
           <a:xfrm>
             <a:off x="1371600" y="2560320"/>
-            <a:ext cx="3474720" cy="228600"/>
+            <a:ext cx="7315200" cy="228600"/>
           </a:xfrm>
           <a:prstGeom prst="rect">
             <a:avLst/>
@@ -9651,7 +9144,7 @@
         <p:spPr>
           <a:xfrm>
             <a:off x="1371600" y="2926080"/>
-            <a:ext cx="3474720" cy="292608"/>
+            <a:ext cx="7315200" cy="292608"/>
           </a:xfrm>
           <a:prstGeom prst="rect">
             <a:avLst/>
@@ -9690,7 +9183,7 @@
         <p:spPr>
           <a:xfrm>
             <a:off x="1371600" y="3227832"/>
-            <a:ext cx="3474720" cy="228600"/>
+            <a:ext cx="7315200" cy="228600"/>
           </a:xfrm>
           <a:prstGeom prst="rect">
             <a:avLst/>
@@ -9770,7 +9263,7 @@
         <p:spPr>
           <a:xfrm>
             <a:off x="1371600" y="3593592"/>
-            <a:ext cx="3474720" cy="292608"/>
+            <a:ext cx="7315200" cy="292608"/>
           </a:xfrm>
           <a:prstGeom prst="rect">
             <a:avLst/>
@@ -9809,7 +9302,7 @@
         <p:spPr>
           <a:xfrm>
             <a:off x="1371600" y="3895344"/>
-            <a:ext cx="3474720" cy="228600"/>
+            <a:ext cx="7315200" cy="228600"/>
           </a:xfrm>
           <a:prstGeom prst="rect">
             <a:avLst/>
@@ -9889,7 +9382,7 @@
         <p:spPr>
           <a:xfrm>
             <a:off x="1371600" y="4261104"/>
-            <a:ext cx="3474720" cy="292608"/>
+            <a:ext cx="7315200" cy="292608"/>
           </a:xfrm>
           <a:prstGeom prst="rect">
             <a:avLst/>
@@ -9928,7 +9421,7 @@
         <p:spPr>
           <a:xfrm>
             <a:off x="1371600" y="4562856"/>
-            <a:ext cx="3474720" cy="228600"/>
+            <a:ext cx="7315200" cy="228600"/>
           </a:xfrm>
           <a:prstGeom prst="rect">
             <a:avLst/>
@@ -9955,210 +9448,6 @@
               <a:t>Scoring system and results screen</a:t>
             </a:r>
             <a:endParaRPr lang="en-US" sz="1200" dirty="0"/>
-          </a:p>
-        </p:txBody>
-      </p:sp>
-      <p:sp>
-        <p:nvSpPr>
-          <p:cNvPr id="22" name="TextBox 21"/>
-          <p:cNvSpPr txBox="1"/>
-          <p:nvPr/>
-        </p:nvSpPr>
-        <p:spPr>
-          <a:xfrm>
-            <a:off x="5303520" y="1298448"/>
-            <a:ext cx="3474720" cy="256032"/>
-          </a:xfrm>
-          <a:prstGeom prst="rect">
-            <a:avLst/>
-          </a:prstGeom>
-          <a:noFill/>
-        </p:spPr>
-        <p:txBody>
-          <a:bodyPr wrap="square">
-            <a:spAutoFit/>
-          </a:bodyPr>
-          <a:lstStyle/>
-          <a:p>
-            <a:pPr algn="l"/>
-            <a:r>
-              <a:rPr sz="900" b="1" i="0">
-                <a:solidFill>
-                  <a:srgbClr val="888888"/>
-                </a:solidFill>
-              </a:rPr>
-              <a:t>BELBIN ROLE</a:t>
-            </a:r>
-          </a:p>
-        </p:txBody>
-      </p:sp>
-      <p:sp>
-        <p:nvSpPr>
-          <p:cNvPr id="23" name="TextBox 22"/>
-          <p:cNvSpPr txBox="1"/>
-          <p:nvPr/>
-        </p:nvSpPr>
-        <p:spPr>
-          <a:xfrm>
-            <a:off x="5303520" y="1591056"/>
-            <a:ext cx="3474720" cy="292608"/>
-          </a:xfrm>
-          <a:prstGeom prst="rect">
-            <a:avLst/>
-          </a:prstGeom>
-          <a:noFill/>
-        </p:spPr>
-        <p:txBody>
-          <a:bodyPr wrap="square">
-            <a:spAutoFit/>
-          </a:bodyPr>
-          <a:lstStyle/>
-          <a:p>
-            <a:pPr algn="l"/>
-            <a:r>
-              <a:rPr sz="1200" b="1" i="0">
-                <a:solidFill>
-                  <a:srgbClr val="FFCD00"/>
-                </a:solidFill>
-              </a:rPr>
-              <a:t>Coordinator</a:t>
-            </a:r>
-          </a:p>
-        </p:txBody>
-      </p:sp>
-      <p:sp>
-        <p:nvSpPr>
-          <p:cNvPr id="24" name="TextBox 23"/>
-          <p:cNvSpPr txBox="1"/>
-          <p:nvPr/>
-        </p:nvSpPr>
-        <p:spPr>
-          <a:xfrm>
-            <a:off x="5303520" y="2258568"/>
-            <a:ext cx="3474720" cy="292608"/>
-          </a:xfrm>
-          <a:prstGeom prst="rect">
-            <a:avLst/>
-          </a:prstGeom>
-          <a:noFill/>
-        </p:spPr>
-        <p:txBody>
-          <a:bodyPr wrap="square">
-            <a:spAutoFit/>
-          </a:bodyPr>
-          <a:lstStyle/>
-          <a:p>
-            <a:pPr algn="l"/>
-            <a:r>
-              <a:rPr sz="1200" b="1" i="0">
-                <a:solidFill>
-                  <a:srgbClr val="FFCD00"/>
-                </a:solidFill>
-              </a:rPr>
-              <a:t>Implementer</a:t>
-            </a:r>
-          </a:p>
-        </p:txBody>
-      </p:sp>
-      <p:sp>
-        <p:nvSpPr>
-          <p:cNvPr id="25" name="TextBox 24"/>
-          <p:cNvSpPr txBox="1"/>
-          <p:nvPr/>
-        </p:nvSpPr>
-        <p:spPr>
-          <a:xfrm>
-            <a:off x="5303520" y="2926080"/>
-            <a:ext cx="3474720" cy="292608"/>
-          </a:xfrm>
-          <a:prstGeom prst="rect">
-            <a:avLst/>
-          </a:prstGeom>
-          <a:noFill/>
-        </p:spPr>
-        <p:txBody>
-          <a:bodyPr wrap="square">
-            <a:spAutoFit/>
-          </a:bodyPr>
-          <a:lstStyle/>
-          <a:p>
-            <a:pPr algn="l"/>
-            <a:r>
-              <a:rPr sz="1200" b="1" i="0">
-                <a:solidFill>
-                  <a:srgbClr val="FFCD00"/>
-                </a:solidFill>
-              </a:rPr>
-              <a:t>Specialist</a:t>
-            </a:r>
-          </a:p>
-        </p:txBody>
-      </p:sp>
-      <p:sp>
-        <p:nvSpPr>
-          <p:cNvPr id="26" name="TextBox 25"/>
-          <p:cNvSpPr txBox="1"/>
-          <p:nvPr/>
-        </p:nvSpPr>
-        <p:spPr>
-          <a:xfrm>
-            <a:off x="5303520" y="3593592"/>
-            <a:ext cx="3474720" cy="292608"/>
-          </a:xfrm>
-          <a:prstGeom prst="rect">
-            <a:avLst/>
-          </a:prstGeom>
-          <a:noFill/>
-        </p:spPr>
-        <p:txBody>
-          <a:bodyPr wrap="square">
-            <a:spAutoFit/>
-          </a:bodyPr>
-          <a:lstStyle/>
-          <a:p>
-            <a:pPr algn="l"/>
-            <a:r>
-              <a:rPr sz="1200" b="1" i="0">
-                <a:solidFill>
-                  <a:srgbClr val="FFCD00"/>
-                </a:solidFill>
-              </a:rPr>
-              <a:t>Plant</a:t>
-            </a:r>
-          </a:p>
-        </p:txBody>
-      </p:sp>
-      <p:sp>
-        <p:nvSpPr>
-          <p:cNvPr id="27" name="TextBox 26"/>
-          <p:cNvSpPr txBox="1"/>
-          <p:nvPr/>
-        </p:nvSpPr>
-        <p:spPr>
-          <a:xfrm>
-            <a:off x="5303520" y="4261104"/>
-            <a:ext cx="3474720" cy="292608"/>
-          </a:xfrm>
-          <a:prstGeom prst="rect">
-            <a:avLst/>
-          </a:prstGeom>
-          <a:noFill/>
-        </p:spPr>
-        <p:txBody>
-          <a:bodyPr wrap="square">
-            <a:spAutoFit/>
-          </a:bodyPr>
-          <a:lstStyle/>
-          <a:p>
-            <a:pPr algn="l"/>
-            <a:r>
-              <a:rPr sz="1200" b="1" i="0">
-                <a:solidFill>
-                  <a:srgbClr val="FFCD00"/>
-                </a:solidFill>
-              </a:rPr>
-              <a:t>Completer Finisher</a:t>
-            </a:r>
           </a:p>
         </p:txBody>
       </p:sp>
@@ -10170,7 +9459,7 @@
 </p:sld>
 </file>
 
-<file path=ppt/slides/slide6.xml><?xml version="1.0" encoding="utf-8"?>
+<file path=ppt/slides/slide5.xml><?xml version="1.0" encoding="utf-8"?>
 <p:sld xmlns:a="http://schemas.openxmlformats.org/drawingml/2006/main" xmlns:r="http://schemas.openxmlformats.org/officeDocument/2006/relationships" xmlns:p="http://schemas.openxmlformats.org/presentationml/2006/main">
   <p:cSld name="Slide 5">
     <p:bg>
@@ -10370,7 +9659,7 @@
 </p:sld>
 </file>
 
-<file path=ppt/slides/slide7.xml><?xml version="1.0" encoding="utf-8"?>
+<file path=ppt/slides/slide6.xml><?xml version="1.0" encoding="utf-8"?>
 <p:sld xmlns:a="http://schemas.openxmlformats.org/drawingml/2006/main" xmlns:r="http://schemas.openxmlformats.org/officeDocument/2006/relationships" xmlns:p="http://schemas.openxmlformats.org/presentationml/2006/main">
   <p:cSld name="Slide 6">
     <p:bg>
@@ -10616,7 +9905,7 @@
         <p:spPr>
           <a:xfrm>
             <a:off x="1371600" y="1591056"/>
-            <a:ext cx="3840480" cy="292608"/>
+            <a:ext cx="4114800" cy="292608"/>
           </a:xfrm>
           <a:prstGeom prst="rect">
             <a:avLst/>
@@ -10655,7 +9944,7 @@
         <p:spPr>
           <a:xfrm>
             <a:off x="1371600" y="1892808"/>
-            <a:ext cx="3840480" cy="228600"/>
+            <a:ext cx="4114800" cy="228600"/>
           </a:xfrm>
           <a:prstGeom prst="rect">
             <a:avLst/>
@@ -10735,7 +10024,7 @@
         <p:spPr>
           <a:xfrm>
             <a:off x="1371600" y="2414016"/>
-            <a:ext cx="3840480" cy="292608"/>
+            <a:ext cx="4114800" cy="292608"/>
           </a:xfrm>
           <a:prstGeom prst="rect">
             <a:avLst/>
@@ -10774,7 +10063,7 @@
         <p:spPr>
           <a:xfrm>
             <a:off x="1371600" y="2715768"/>
-            <a:ext cx="3840480" cy="228600"/>
+            <a:ext cx="4114800" cy="228600"/>
           </a:xfrm>
           <a:prstGeom prst="rect">
             <a:avLst/>
@@ -10854,7 +10143,7 @@
         <p:spPr>
           <a:xfrm>
             <a:off x="1371600" y="3236976"/>
-            <a:ext cx="3840480" cy="292608"/>
+            <a:ext cx="4114800" cy="292608"/>
           </a:xfrm>
           <a:prstGeom prst="rect">
             <a:avLst/>
@@ -10893,7 +10182,7 @@
         <p:spPr>
           <a:xfrm>
             <a:off x="1371600" y="3538728"/>
-            <a:ext cx="3840480" cy="228600"/>
+            <a:ext cx="4114800" cy="228600"/>
           </a:xfrm>
           <a:prstGeom prst="rect">
             <a:avLst/>
@@ -10932,7 +10221,7 @@
         <p:spPr>
           <a:xfrm>
             <a:off x="457200" y="4160520"/>
-            <a:ext cx="3840480" cy="320040"/>
+            <a:ext cx="4114800" cy="320040"/>
           </a:xfrm>
           <a:prstGeom prst="rect">
             <a:avLst/>
@@ -10964,7 +10253,7 @@
       </p:sp>
       <p:pic>
         <p:nvPicPr>
-          <p:cNvPr id="17" name="Picture 16" descr="Trello.png"/>
+          <p:cNvPr id="17" name="Picture 16" descr="image.jpg"/>
           <p:cNvPicPr>
             <a:picLocks noChangeAspect="1"/>
           </p:cNvPicPr>
@@ -10978,72 +10267,14 @@
         </p:blipFill>
         <p:spPr>
           <a:xfrm>
-            <a:off x="4572000" y="1417320"/>
-            <a:ext cx="4297680" cy="2514600"/>
+            <a:off x="4663440" y="1417320"/>
+            <a:ext cx="4206240" cy="3291840"/>
           </a:xfrm>
           <a:prstGeom prst="rect">
             <a:avLst/>
           </a:prstGeom>
         </p:spPr>
       </p:pic>
-      <p:pic>
-        <p:nvPicPr>
-          <p:cNvPr id="18" name="Picture 17" descr="Call in whatsapp.jpeg"/>
-          <p:cNvPicPr>
-            <a:picLocks noChangeAspect="1"/>
-          </p:cNvPicPr>
-          <p:nvPr/>
-        </p:nvPicPr>
-        <p:blipFill>
-          <a:blip r:embed="rId4"/>
-          <a:stretch>
-            <a:fillRect/>
-          </a:stretch>
-        </p:blipFill>
-        <p:spPr>
-          <a:xfrm>
-            <a:off x="4572000" y="4023360"/>
-            <a:ext cx="960120" cy="914400"/>
-          </a:xfrm>
-          <a:prstGeom prst="rect">
-            <a:avLst/>
-          </a:prstGeom>
-        </p:spPr>
-      </p:pic>
-      <p:sp>
-        <p:nvSpPr>
-          <p:cNvPr id="19" name="TextBox 18"/>
-          <p:cNvSpPr txBox="1"/>
-          <p:nvPr/>
-        </p:nvSpPr>
-        <p:spPr>
-          <a:xfrm>
-            <a:off x="5577840" y="4160520"/>
-            <a:ext cx="3291840" cy="274320"/>
-          </a:xfrm>
-          <a:prstGeom prst="rect">
-            <a:avLst/>
-          </a:prstGeom>
-          <a:noFill/>
-        </p:spPr>
-        <p:txBody>
-          <a:bodyPr wrap="square">
-            <a:spAutoFit/>
-          </a:bodyPr>
-          <a:lstStyle/>
-          <a:p>
-            <a:pPr algn="l"/>
-            <a:r>
-              <a:rPr sz="900" b="0" i="1">
-                <a:solidFill>
-                  <a:srgbClr val="888888"/>
-                </a:solidFill>
-              </a:rPr>
-              <a:t>WhatsApp team call — 4 of 5 members</a:t>
-            </a:r>
-          </a:p>
-        </p:txBody>
-      </p:sp>
     </p:spTree>
   </p:cSld>
   <p:clrMapOvr>
@@ -11052,7 +10283,7 @@
 </p:sld>
 </file>
 
-<file path=ppt/slides/slide8.xml><?xml version="1.0" encoding="utf-8"?>
+<file path=ppt/slides/slide7.xml><?xml version="1.0" encoding="utf-8"?>
 <p:sld xmlns:a="http://schemas.openxmlformats.org/drawingml/2006/main" xmlns:r="http://schemas.openxmlformats.org/officeDocument/2006/relationships" xmlns:p="http://schemas.openxmlformats.org/presentationml/2006/main">
   <p:cSld name="Slide 7">
     <p:bg>
@@ -11531,7 +10762,7 @@
 </p:sld>
 </file>
 
-<file path=ppt/slides/slide9.xml><?xml version="1.0" encoding="utf-8"?>
+<file path=ppt/slides/slide8.xml><?xml version="1.0" encoding="utf-8"?>
 <p:sld xmlns:a="http://schemas.openxmlformats.org/drawingml/2006/main" xmlns:r="http://schemas.openxmlformats.org/officeDocument/2006/relationships" xmlns:p="http://schemas.openxmlformats.org/presentationml/2006/main">
   <p:cSld name="Slide 8">
     <p:bg>
@@ -12279,6 +11510,805 @@
               <a:t>Everyone had a vote</a:t>
             </a:r>
             <a:endParaRPr lang="en-US" sz="1400" dirty="0"/>
+          </a:p>
+        </p:txBody>
+      </p:sp>
+    </p:spTree>
+  </p:cSld>
+  <p:clrMapOvr>
+    <a:masterClrMapping/>
+  </p:clrMapOvr>
+</p:sld>
+</file>
+
+<file path=ppt/slides/slide9.xml><?xml version="1.0" encoding="utf-8"?>
+<p:sld xmlns:a="http://schemas.openxmlformats.org/drawingml/2006/main" xmlns:r="http://schemas.openxmlformats.org/officeDocument/2006/relationships" xmlns:p="http://schemas.openxmlformats.org/presentationml/2006/main">
+  <p:cSld name="Slide 9">
+    <p:bg>
+      <p:bgPr>
+        <a:solidFill>
+          <a:srgbClr val="FFFFFF"/>
+        </a:solidFill>
+        <a:effectLst/>
+      </p:bgPr>
+    </p:bg>
+    <p:spTree>
+      <p:nvGrpSpPr>
+        <p:cNvPr id="1" name=""/>
+        <p:cNvGrpSpPr/>
+        <p:nvPr/>
+      </p:nvGrpSpPr>
+      <p:grpSpPr>
+        <a:xfrm>
+          <a:off x="0" y="0"/>
+          <a:ext cx="0" cy="0"/>
+          <a:chOff x="0" y="0"/>
+          <a:chExt cx="0" cy="0"/>
+        </a:xfrm>
+      </p:grpSpPr>
+      <p:sp>
+        <p:nvSpPr>
+          <p:cNvPr id="2" name="Shape 0"/>
+          <p:cNvSpPr/>
+          <p:nvPr/>
+        </p:nvSpPr>
+        <p:spPr>
+          <a:xfrm>
+            <a:off x="8458200" y="201168"/>
+            <a:ext cx="256032" cy="256032"/>
+          </a:xfrm>
+          <a:prstGeom prst="ellipse">
+            <a:avLst/>
+          </a:prstGeom>
+          <a:solidFill>
+            <a:srgbClr val="DDDDDD"/>
+          </a:solidFill>
+          <a:ln/>
+        </p:spPr>
+        <p:txBody>
+          <a:bodyPr/>
+          <a:lstStyle/>
+          <a:p>
+            <a:endParaRPr lang="en-GB"/>
+          </a:p>
+        </p:txBody>
+      </p:sp>
+      <p:sp>
+        <p:nvSpPr>
+          <p:cNvPr id="3" name="Text 1"/>
+          <p:cNvSpPr/>
+          <p:nvPr/>
+        </p:nvSpPr>
+        <p:spPr>
+          <a:xfrm>
+            <a:off x="457200" y="274320"/>
+            <a:ext cx="6400800" cy="228600"/>
+          </a:xfrm>
+          <a:prstGeom prst="rect">
+            <a:avLst/>
+          </a:prstGeom>
+          <a:noFill/>
+          <a:ln/>
+        </p:spPr>
+        <p:txBody>
+          <a:bodyPr wrap="square" rtlCol="0" anchor="ctr"/>
+          <a:lstStyle/>
+          <a:p>
+            <a:pPr marL="0" indent="0">
+              <a:buNone/>
+            </a:pPr>
+            <a:r>
+              <a:rPr lang="en-US" sz="1000" b="1" kern="0" spc="200" dirty="0">
+                <a:solidFill>
+                  <a:srgbClr val="888888"/>
+                </a:solidFill>
+                <a:latin typeface="Arial" pitchFamily="34" charset="0"/>
+                <a:ea typeface="Arial" pitchFamily="34" charset="-122"/>
+                <a:cs typeface="Arial" pitchFamily="34" charset="-120"/>
+              </a:rPr>
+              <a:t>DELIVERY PROCESS</a:t>
+            </a:r>
+            <a:endParaRPr lang="en-US" sz="1000" dirty="0"/>
+          </a:p>
+        </p:txBody>
+      </p:sp>
+      <p:sp>
+        <p:nvSpPr>
+          <p:cNvPr id="4" name="Text 2"/>
+          <p:cNvSpPr/>
+          <p:nvPr/>
+        </p:nvSpPr>
+        <p:spPr>
+          <a:xfrm>
+            <a:off x="3657600" y="4919472"/>
+            <a:ext cx="5212080" cy="182880"/>
+          </a:xfrm>
+          <a:prstGeom prst="rect">
+            <a:avLst/>
+          </a:prstGeom>
+          <a:noFill/>
+          <a:ln/>
+        </p:spPr>
+        <p:txBody>
+          <a:bodyPr wrap="square" rtlCol="0" anchor="ctr"/>
+          <a:lstStyle/>
+          <a:p>
+            <a:pPr marL="0" indent="0" algn="r">
+              <a:buNone/>
+            </a:pPr>
+            <a:r>
+              <a:rPr lang="en-US" sz="900" dirty="0">
+                <a:solidFill>
+                  <a:srgbClr val="888888"/>
+                </a:solidFill>
+                <a:latin typeface="Arial" pitchFamily="34" charset="0"/>
+                <a:ea typeface="Arial" pitchFamily="34" charset="-122"/>
+                <a:cs typeface="Arial" pitchFamily="34" charset="-120"/>
+              </a:rPr>
+              <a:t>NINJA QUIZ  ·  503IT  ·  09 / 18</a:t>
+            </a:r>
+            <a:endParaRPr lang="en-US" sz="900" dirty="0"/>
+          </a:p>
+        </p:txBody>
+      </p:sp>
+      <p:sp>
+        <p:nvSpPr>
+          <p:cNvPr id="5" name="Text 3"/>
+          <p:cNvSpPr/>
+          <p:nvPr/>
+        </p:nvSpPr>
+        <p:spPr>
+          <a:xfrm>
+            <a:off x="457200" y="685800"/>
+            <a:ext cx="8229600" cy="812800"/>
+          </a:xfrm>
+          <a:prstGeom prst="rect">
+            <a:avLst/>
+          </a:prstGeom>
+          <a:noFill/>
+          <a:ln/>
+        </p:spPr>
+        <p:txBody>
+          <a:bodyPr wrap="square" rtlCol="0" anchor="ctr"/>
+          <a:lstStyle/>
+          <a:p>
+            <a:pPr marL="0" indent="0">
+              <a:buNone/>
+            </a:pPr>
+            <a:r>
+              <a:rPr lang="en-US" sz="3200" b="1" dirty="0">
+                <a:solidFill>
+                  <a:srgbClr val="111111"/>
+                </a:solidFill>
+                <a:latin typeface="Arial Black" pitchFamily="34" charset="0"/>
+                <a:ea typeface="Arial Black" pitchFamily="34" charset="-122"/>
+                <a:cs typeface="Arial Black" pitchFamily="34" charset="-120"/>
+              </a:rPr>
+              <a:t>Built in five sprints.</a:t>
+            </a:r>
+            <a:endParaRPr lang="en-US" sz="3200" dirty="0"/>
+          </a:p>
+        </p:txBody>
+      </p:sp>
+      <p:sp>
+        <p:nvSpPr>
+          <p:cNvPr id="6" name="Shape 4"/>
+          <p:cNvSpPr/>
+          <p:nvPr/>
+        </p:nvSpPr>
+        <p:spPr>
+          <a:xfrm>
+            <a:off x="457200" y="1463040"/>
+            <a:ext cx="8229600" cy="10973"/>
+          </a:xfrm>
+          <a:prstGeom prst="rect">
+            <a:avLst/>
+          </a:prstGeom>
+          <a:solidFill>
+            <a:srgbClr val="EEEEEE"/>
+          </a:solidFill>
+          <a:ln/>
+        </p:spPr>
+        <p:txBody>
+          <a:bodyPr/>
+          <a:lstStyle/>
+          <a:p>
+            <a:endParaRPr lang="en-GB"/>
+          </a:p>
+        </p:txBody>
+      </p:sp>
+      <p:sp>
+        <p:nvSpPr>
+          <p:cNvPr id="7" name="Text 5"/>
+          <p:cNvSpPr/>
+          <p:nvPr/>
+        </p:nvSpPr>
+        <p:spPr>
+          <a:xfrm>
+            <a:off x="457200" y="1609344"/>
+            <a:ext cx="868680" cy="411480"/>
+          </a:xfrm>
+          <a:prstGeom prst="rect">
+            <a:avLst/>
+          </a:prstGeom>
+          <a:noFill/>
+          <a:ln/>
+        </p:spPr>
+        <p:txBody>
+          <a:bodyPr wrap="square" rtlCol="0" anchor="ctr">
+            <a:normAutofit/>
+          </a:bodyPr>
+          <a:lstStyle/>
+          <a:p>
+            <a:pPr marL="0" indent="0">
+              <a:buNone/>
+            </a:pPr>
+            <a:r>
+              <a:rPr lang="en-US" sz="2000" b="1" dirty="0">
+                <a:solidFill>
+                  <a:srgbClr val="FFCD00"/>
+                </a:solidFill>
+                <a:latin typeface="Arial Black" pitchFamily="34" charset="0"/>
+                <a:ea typeface="Arial Black" pitchFamily="34" charset="-122"/>
+                <a:cs typeface="Arial Black" pitchFamily="34" charset="-120"/>
+              </a:rPr>
+              <a:t>01</a:t>
+            </a:r>
+            <a:endParaRPr lang="en-US" sz="2000" dirty="0"/>
+          </a:p>
+        </p:txBody>
+      </p:sp>
+      <p:sp>
+        <p:nvSpPr>
+          <p:cNvPr id="8" name="Text 6"/>
+          <p:cNvSpPr/>
+          <p:nvPr/>
+        </p:nvSpPr>
+        <p:spPr>
+          <a:xfrm>
+            <a:off x="1371600" y="1591056"/>
+            <a:ext cx="7315200" cy="292608"/>
+          </a:xfrm>
+          <a:prstGeom prst="rect">
+            <a:avLst/>
+          </a:prstGeom>
+          <a:noFill/>
+          <a:ln/>
+        </p:spPr>
+        <p:txBody>
+          <a:bodyPr wrap="square" rtlCol="0" anchor="ctr"/>
+          <a:lstStyle/>
+          <a:p>
+            <a:pPr marL="0" indent="0">
+              <a:buNone/>
+            </a:pPr>
+            <a:r>
+              <a:rPr lang="en-US" sz="1700" b="1" dirty="0">
+                <a:solidFill>
+                  <a:srgbClr val="111111"/>
+                </a:solidFill>
+                <a:latin typeface="Arial Black" pitchFamily="34" charset="0"/>
+                <a:ea typeface="Arial Black" pitchFamily="34" charset="-122"/>
+                <a:cs typeface="Arial Black" pitchFamily="34" charset="-120"/>
+              </a:rPr>
+              <a:t>Sprint 1  —  Login &amp; menu</a:t>
+            </a:r>
+            <a:endParaRPr lang="en-US" sz="1700" dirty="0"/>
+          </a:p>
+        </p:txBody>
+      </p:sp>
+      <p:sp>
+        <p:nvSpPr>
+          <p:cNvPr id="9" name="Text 7"/>
+          <p:cNvSpPr/>
+          <p:nvPr/>
+        </p:nvSpPr>
+        <p:spPr>
+          <a:xfrm>
+            <a:off x="1371600" y="1892808"/>
+            <a:ext cx="7315200" cy="228600"/>
+          </a:xfrm>
+          <a:prstGeom prst="rect">
+            <a:avLst/>
+          </a:prstGeom>
+          <a:noFill/>
+          <a:ln/>
+        </p:spPr>
+        <p:txBody>
+          <a:bodyPr wrap="square" rtlCol="0" anchor="ctr"/>
+          <a:lstStyle/>
+          <a:p>
+            <a:pPr marL="0" indent="0">
+              <a:buNone/>
+            </a:pPr>
+            <a:r>
+              <a:rPr lang="en-US" sz="1200" dirty="0">
+                <a:solidFill>
+                  <a:srgbClr val="888888"/>
+                </a:solidFill>
+                <a:latin typeface="Arial" pitchFamily="34" charset="0"/>
+                <a:ea typeface="Arial" pitchFamily="34" charset="-122"/>
+                <a:cs typeface="Arial" pitchFamily="34" charset="-120"/>
+              </a:rPr>
+              <a:t>Foundation. Every member set up. GitHub branches created.</a:t>
+            </a:r>
+            <a:endParaRPr lang="en-US" sz="1200" dirty="0"/>
+          </a:p>
+        </p:txBody>
+      </p:sp>
+      <p:sp>
+        <p:nvSpPr>
+          <p:cNvPr id="10" name="Text 8"/>
+          <p:cNvSpPr/>
+          <p:nvPr/>
+        </p:nvSpPr>
+        <p:spPr>
+          <a:xfrm>
+            <a:off x="457200" y="2231136"/>
+            <a:ext cx="868680" cy="411480"/>
+          </a:xfrm>
+          <a:prstGeom prst="rect">
+            <a:avLst/>
+          </a:prstGeom>
+          <a:noFill/>
+          <a:ln/>
+        </p:spPr>
+        <p:txBody>
+          <a:bodyPr wrap="square" rtlCol="0" anchor="ctr">
+            <a:normAutofit/>
+          </a:bodyPr>
+          <a:lstStyle/>
+          <a:p>
+            <a:pPr marL="0" indent="0">
+              <a:buNone/>
+            </a:pPr>
+            <a:r>
+              <a:rPr lang="en-US" sz="2000" b="1" dirty="0">
+                <a:solidFill>
+                  <a:srgbClr val="FFCD00"/>
+                </a:solidFill>
+                <a:latin typeface="Arial Black" pitchFamily="34" charset="0"/>
+                <a:ea typeface="Arial Black" pitchFamily="34" charset="-122"/>
+                <a:cs typeface="Arial Black" pitchFamily="34" charset="-120"/>
+              </a:rPr>
+              <a:t>02</a:t>
+            </a:r>
+            <a:endParaRPr lang="en-US" sz="2000" dirty="0"/>
+          </a:p>
+        </p:txBody>
+      </p:sp>
+      <p:sp>
+        <p:nvSpPr>
+          <p:cNvPr id="11" name="Text 9"/>
+          <p:cNvSpPr/>
+          <p:nvPr/>
+        </p:nvSpPr>
+        <p:spPr>
+          <a:xfrm>
+            <a:off x="1371600" y="2212848"/>
+            <a:ext cx="7315200" cy="292608"/>
+          </a:xfrm>
+          <a:prstGeom prst="rect">
+            <a:avLst/>
+          </a:prstGeom>
+          <a:noFill/>
+          <a:ln/>
+        </p:spPr>
+        <p:txBody>
+          <a:bodyPr wrap="square" rtlCol="0" anchor="ctr"/>
+          <a:lstStyle/>
+          <a:p>
+            <a:pPr marL="0" indent="0">
+              <a:buNone/>
+            </a:pPr>
+            <a:r>
+              <a:rPr lang="en-US" sz="1700" b="1" dirty="0">
+                <a:solidFill>
+                  <a:srgbClr val="111111"/>
+                </a:solidFill>
+                <a:latin typeface="Arial Black" pitchFamily="34" charset="0"/>
+                <a:ea typeface="Arial Black" pitchFamily="34" charset="-122"/>
+                <a:cs typeface="Arial Black" pitchFamily="34" charset="-120"/>
+              </a:rPr>
+              <a:t>Sprint 2  —  Game engine</a:t>
+            </a:r>
+            <a:endParaRPr lang="en-US" sz="1700" dirty="0"/>
+          </a:p>
+        </p:txBody>
+      </p:sp>
+      <p:sp>
+        <p:nvSpPr>
+          <p:cNvPr id="12" name="Text 10"/>
+          <p:cNvSpPr/>
+          <p:nvPr/>
+        </p:nvSpPr>
+        <p:spPr>
+          <a:xfrm>
+            <a:off x="1371600" y="2514600"/>
+            <a:ext cx="7315200" cy="228600"/>
+          </a:xfrm>
+          <a:prstGeom prst="rect">
+            <a:avLst/>
+          </a:prstGeom>
+          <a:noFill/>
+          <a:ln/>
+        </p:spPr>
+        <p:txBody>
+          <a:bodyPr wrap="square" rtlCol="0" anchor="ctr"/>
+          <a:lstStyle/>
+          <a:p>
+            <a:pPr marL="0" indent="0">
+              <a:buNone/>
+            </a:pPr>
+            <a:r>
+              <a:rPr lang="en-US" sz="1200" dirty="0">
+                <a:solidFill>
+                  <a:srgbClr val="888888"/>
+                </a:solidFill>
+                <a:latin typeface="Arial" pitchFamily="34" charset="0"/>
+                <a:ea typeface="Arial" pitchFamily="34" charset="-122"/>
+                <a:cs typeface="Arial" pitchFamily="34" charset="-120"/>
+              </a:rPr>
+              <a:t>Core mechanics built. Daily check-ins via WhatsApp.</a:t>
+            </a:r>
+            <a:endParaRPr lang="en-US" sz="1200" dirty="0"/>
+          </a:p>
+        </p:txBody>
+      </p:sp>
+      <p:sp>
+        <p:nvSpPr>
+          <p:cNvPr id="13" name="Text 11"/>
+          <p:cNvSpPr/>
+          <p:nvPr/>
+        </p:nvSpPr>
+        <p:spPr>
+          <a:xfrm>
+            <a:off x="457200" y="2852928"/>
+            <a:ext cx="868680" cy="411480"/>
+          </a:xfrm>
+          <a:prstGeom prst="rect">
+            <a:avLst/>
+          </a:prstGeom>
+          <a:noFill/>
+          <a:ln/>
+        </p:spPr>
+        <p:txBody>
+          <a:bodyPr wrap="square" rtlCol="0" anchor="ctr">
+            <a:normAutofit/>
+          </a:bodyPr>
+          <a:lstStyle/>
+          <a:p>
+            <a:pPr marL="0" indent="0">
+              <a:buNone/>
+            </a:pPr>
+            <a:r>
+              <a:rPr lang="en-US" sz="2000" b="1" dirty="0">
+                <a:solidFill>
+                  <a:srgbClr val="FFCD00"/>
+                </a:solidFill>
+                <a:latin typeface="Arial Black" pitchFamily="34" charset="0"/>
+                <a:ea typeface="Arial Black" pitchFamily="34" charset="-122"/>
+                <a:cs typeface="Arial Black" pitchFamily="34" charset="-120"/>
+              </a:rPr>
+              <a:t>03</a:t>
+            </a:r>
+            <a:endParaRPr lang="en-US" sz="2000" dirty="0"/>
+          </a:p>
+        </p:txBody>
+      </p:sp>
+      <p:sp>
+        <p:nvSpPr>
+          <p:cNvPr id="14" name="Text 12"/>
+          <p:cNvSpPr/>
+          <p:nvPr/>
+        </p:nvSpPr>
+        <p:spPr>
+          <a:xfrm>
+            <a:off x="1371600" y="2834640"/>
+            <a:ext cx="7315200" cy="292608"/>
+          </a:xfrm>
+          <a:prstGeom prst="rect">
+            <a:avLst/>
+          </a:prstGeom>
+          <a:noFill/>
+          <a:ln/>
+        </p:spPr>
+        <p:txBody>
+          <a:bodyPr wrap="square" rtlCol="0" anchor="ctr"/>
+          <a:lstStyle/>
+          <a:p>
+            <a:pPr marL="0" indent="0">
+              <a:buNone/>
+            </a:pPr>
+            <a:r>
+              <a:rPr lang="en-US" sz="1700" b="1" dirty="0">
+                <a:solidFill>
+                  <a:srgbClr val="111111"/>
+                </a:solidFill>
+                <a:latin typeface="Arial Black" pitchFamily="34" charset="0"/>
+                <a:ea typeface="Arial Black" pitchFamily="34" charset="-122"/>
+                <a:cs typeface="Arial Black" pitchFamily="34" charset="-120"/>
+              </a:rPr>
+              <a:t>Sprint 3  —  Slicing &amp; sound</a:t>
+            </a:r>
+            <a:endParaRPr lang="en-US" sz="1700" dirty="0"/>
+          </a:p>
+        </p:txBody>
+      </p:sp>
+      <p:sp>
+        <p:nvSpPr>
+          <p:cNvPr id="15" name="Text 13"/>
+          <p:cNvSpPr/>
+          <p:nvPr/>
+        </p:nvSpPr>
+        <p:spPr>
+          <a:xfrm>
+            <a:off x="1371600" y="3136392"/>
+            <a:ext cx="7315200" cy="228600"/>
+          </a:xfrm>
+          <a:prstGeom prst="rect">
+            <a:avLst/>
+          </a:prstGeom>
+          <a:noFill/>
+          <a:ln/>
+        </p:spPr>
+        <p:txBody>
+          <a:bodyPr wrap="square" rtlCol="0" anchor="ctr"/>
+          <a:lstStyle/>
+          <a:p>
+            <a:pPr marL="0" indent="0">
+              <a:buNone/>
+            </a:pPr>
+            <a:r>
+              <a:rPr lang="en-US" sz="1200" dirty="0">
+                <a:solidFill>
+                  <a:srgbClr val="888888"/>
+                </a:solidFill>
+                <a:latin typeface="Arial" pitchFamily="34" charset="0"/>
+                <a:ea typeface="Arial" pitchFamily="34" charset="-122"/>
+                <a:cs typeface="Arial" pitchFamily="34" charset="-120"/>
+              </a:rPr>
+              <a:t>Visual integration. First merge conflicts resolved.</a:t>
+            </a:r>
+            <a:endParaRPr lang="en-US" sz="1200" dirty="0"/>
+          </a:p>
+        </p:txBody>
+      </p:sp>
+      <p:sp>
+        <p:nvSpPr>
+          <p:cNvPr id="16" name="Text 14"/>
+          <p:cNvSpPr/>
+          <p:nvPr/>
+        </p:nvSpPr>
+        <p:spPr>
+          <a:xfrm>
+            <a:off x="457200" y="3474720"/>
+            <a:ext cx="868680" cy="411480"/>
+          </a:xfrm>
+          <a:prstGeom prst="rect">
+            <a:avLst/>
+          </a:prstGeom>
+          <a:noFill/>
+          <a:ln/>
+        </p:spPr>
+        <p:txBody>
+          <a:bodyPr wrap="square" rtlCol="0" anchor="ctr">
+            <a:normAutofit/>
+          </a:bodyPr>
+          <a:lstStyle/>
+          <a:p>
+            <a:pPr marL="0" indent="0">
+              <a:buNone/>
+            </a:pPr>
+            <a:r>
+              <a:rPr lang="en-US" sz="2000" b="1" dirty="0">
+                <a:solidFill>
+                  <a:srgbClr val="FFCD00"/>
+                </a:solidFill>
+                <a:latin typeface="Arial Black" pitchFamily="34" charset="0"/>
+                <a:ea typeface="Arial Black" pitchFamily="34" charset="-122"/>
+                <a:cs typeface="Arial Black" pitchFamily="34" charset="-120"/>
+              </a:rPr>
+              <a:t>04</a:t>
+            </a:r>
+            <a:endParaRPr lang="en-US" sz="2000" dirty="0"/>
+          </a:p>
+        </p:txBody>
+      </p:sp>
+      <p:sp>
+        <p:nvSpPr>
+          <p:cNvPr id="17" name="Text 15"/>
+          <p:cNvSpPr/>
+          <p:nvPr/>
+        </p:nvSpPr>
+        <p:spPr>
+          <a:xfrm>
+            <a:off x="1371600" y="3456432"/>
+            <a:ext cx="7315200" cy="292608"/>
+          </a:xfrm>
+          <a:prstGeom prst="rect">
+            <a:avLst/>
+          </a:prstGeom>
+          <a:noFill/>
+          <a:ln/>
+        </p:spPr>
+        <p:txBody>
+          <a:bodyPr wrap="square" rtlCol="0" anchor="ctr"/>
+          <a:lstStyle/>
+          <a:p>
+            <a:pPr marL="0" indent="0">
+              <a:buNone/>
+            </a:pPr>
+            <a:r>
+              <a:rPr lang="en-US" sz="1700" b="1" dirty="0">
+                <a:solidFill>
+                  <a:srgbClr val="111111"/>
+                </a:solidFill>
+                <a:latin typeface="Arial Black" pitchFamily="34" charset="0"/>
+                <a:ea typeface="Arial Black" pitchFamily="34" charset="-122"/>
+                <a:cs typeface="Arial Black" pitchFamily="34" charset="-120"/>
+              </a:rPr>
+              <a:t>Sprint 4  —  Leaderboard</a:t>
+            </a:r>
+            <a:endParaRPr lang="en-US" sz="1700" dirty="0"/>
+          </a:p>
+        </p:txBody>
+      </p:sp>
+      <p:sp>
+        <p:nvSpPr>
+          <p:cNvPr id="18" name="Text 16"/>
+          <p:cNvSpPr/>
+          <p:nvPr/>
+        </p:nvSpPr>
+        <p:spPr>
+          <a:xfrm>
+            <a:off x="1371600" y="3758184"/>
+            <a:ext cx="7315200" cy="228600"/>
+          </a:xfrm>
+          <a:prstGeom prst="rect">
+            <a:avLst/>
+          </a:prstGeom>
+          <a:noFill/>
+          <a:ln/>
+        </p:spPr>
+        <p:txBody>
+          <a:bodyPr wrap="square" rtlCol="0" anchor="ctr"/>
+          <a:lstStyle/>
+          <a:p>
+            <a:pPr marL="0" indent="0">
+              <a:buNone/>
+            </a:pPr>
+            <a:r>
+              <a:rPr lang="en-US" sz="1200" dirty="0">
+                <a:solidFill>
+                  <a:srgbClr val="888888"/>
+                </a:solidFill>
+                <a:latin typeface="Arial" pitchFamily="34" charset="0"/>
+                <a:ea typeface="Arial" pitchFamily="34" charset="-122"/>
+                <a:cs typeface="Arial" pitchFamily="34" charset="-120"/>
+              </a:rPr>
+              <a:t>Peer testing begins. Feedback collected and logged.</a:t>
+            </a:r>
+            <a:endParaRPr lang="en-US" sz="1200" dirty="0"/>
+          </a:p>
+        </p:txBody>
+      </p:sp>
+      <p:sp>
+        <p:nvSpPr>
+          <p:cNvPr id="19" name="Text 17"/>
+          <p:cNvSpPr/>
+          <p:nvPr/>
+        </p:nvSpPr>
+        <p:spPr>
+          <a:xfrm>
+            <a:off x="457200" y="4096512"/>
+            <a:ext cx="868680" cy="411480"/>
+          </a:xfrm>
+          <a:prstGeom prst="rect">
+            <a:avLst/>
+          </a:prstGeom>
+          <a:noFill/>
+          <a:ln/>
+        </p:spPr>
+        <p:txBody>
+          <a:bodyPr wrap="square" rtlCol="0" anchor="ctr">
+            <a:normAutofit/>
+          </a:bodyPr>
+          <a:lstStyle/>
+          <a:p>
+            <a:pPr marL="0" indent="0">
+              <a:buNone/>
+            </a:pPr>
+            <a:r>
+              <a:rPr lang="en-US" sz="2000" b="1" dirty="0">
+                <a:solidFill>
+                  <a:srgbClr val="FFCD00"/>
+                </a:solidFill>
+                <a:latin typeface="Arial Black" pitchFamily="34" charset="0"/>
+                <a:ea typeface="Arial Black" pitchFamily="34" charset="-122"/>
+                <a:cs typeface="Arial Black" pitchFamily="34" charset="-120"/>
+              </a:rPr>
+              <a:t>05</a:t>
+            </a:r>
+            <a:endParaRPr lang="en-US" sz="2000" dirty="0"/>
+          </a:p>
+        </p:txBody>
+      </p:sp>
+      <p:sp>
+        <p:nvSpPr>
+          <p:cNvPr id="20" name="Text 18"/>
+          <p:cNvSpPr/>
+          <p:nvPr/>
+        </p:nvSpPr>
+        <p:spPr>
+          <a:xfrm>
+            <a:off x="1371600" y="4078224"/>
+            <a:ext cx="7315200" cy="292608"/>
+          </a:xfrm>
+          <a:prstGeom prst="rect">
+            <a:avLst/>
+          </a:prstGeom>
+          <a:noFill/>
+          <a:ln/>
+        </p:spPr>
+        <p:txBody>
+          <a:bodyPr wrap="square" rtlCol="0" anchor="ctr"/>
+          <a:lstStyle/>
+          <a:p>
+            <a:pPr marL="0" indent="0">
+              <a:buNone/>
+            </a:pPr>
+            <a:r>
+              <a:rPr lang="en-US" sz="1700" b="1" dirty="0">
+                <a:solidFill>
+                  <a:srgbClr val="111111"/>
+                </a:solidFill>
+                <a:latin typeface="Arial Black" pitchFamily="34" charset="0"/>
+                <a:ea typeface="Arial Black" pitchFamily="34" charset="-122"/>
+                <a:cs typeface="Arial Black" pitchFamily="34" charset="-120"/>
+              </a:rPr>
+              <a:t>Sprint 5  —  Testing &amp; polish</a:t>
+            </a:r>
+            <a:endParaRPr lang="en-US" sz="1700" dirty="0"/>
+          </a:p>
+        </p:txBody>
+      </p:sp>
+      <p:sp>
+        <p:nvSpPr>
+          <p:cNvPr id="21" name="Text 19"/>
+          <p:cNvSpPr/>
+          <p:nvPr/>
+        </p:nvSpPr>
+        <p:spPr>
+          <a:xfrm>
+            <a:off x="1371600" y="4379976"/>
+            <a:ext cx="7315200" cy="228600"/>
+          </a:xfrm>
+          <a:prstGeom prst="rect">
+            <a:avLst/>
+          </a:prstGeom>
+          <a:noFill/>
+          <a:ln/>
+        </p:spPr>
+        <p:txBody>
+          <a:bodyPr wrap="square" rtlCol="0" anchor="ctr"/>
+          <a:lstStyle/>
+          <a:p>
+            <a:pPr marL="0" indent="0">
+              <a:buNone/>
+            </a:pPr>
+            <a:r>
+              <a:rPr lang="en-US" sz="1200" dirty="0">
+                <a:solidFill>
+                  <a:srgbClr val="888888"/>
+                </a:solidFill>
+                <a:latin typeface="Arial" pitchFamily="34" charset="0"/>
+                <a:ea typeface="Arial" pitchFamily="34" charset="-122"/>
+                <a:cs typeface="Arial" pitchFamily="34" charset="-120"/>
+              </a:rPr>
+              <a:t>Bug hunt, final fixes, review before submission.</a:t>
+            </a:r>
+            <a:endParaRPr lang="en-US" sz="1200" dirty="0"/>
           </a:p>
         </p:txBody>
       </p:sp>

</xml_diff>

<commit_message>
Restore clean pptx: remove Belbin, fix collab tools image, delete agenda
</commit_message>
<xml_diff>
--- a/NinjaQuiz-Presentation.pptx
+++ b/NinjaQuiz-Presentation.pptx
@@ -2351,6 +2351,805 @@
 </file>
 
 <file path=ppt/slides/slide10.xml><?xml version="1.0" encoding="utf-8"?>
+<p:sld xmlns:a="http://schemas.openxmlformats.org/drawingml/2006/main" xmlns:r="http://schemas.openxmlformats.org/officeDocument/2006/relationships" xmlns:p="http://schemas.openxmlformats.org/presentationml/2006/main">
+  <p:cSld name="Slide 9">
+    <p:bg>
+      <p:bgPr>
+        <a:solidFill>
+          <a:srgbClr val="FFFFFF"/>
+        </a:solidFill>
+        <a:effectLst/>
+      </p:bgPr>
+    </p:bg>
+    <p:spTree>
+      <p:nvGrpSpPr>
+        <p:cNvPr id="1" name=""/>
+        <p:cNvGrpSpPr/>
+        <p:nvPr/>
+      </p:nvGrpSpPr>
+      <p:grpSpPr>
+        <a:xfrm>
+          <a:off x="0" y="0"/>
+          <a:ext cx="0" cy="0"/>
+          <a:chOff x="0" y="0"/>
+          <a:chExt cx="0" cy="0"/>
+        </a:xfrm>
+      </p:grpSpPr>
+      <p:sp>
+        <p:nvSpPr>
+          <p:cNvPr id="2" name="Shape 0"/>
+          <p:cNvSpPr/>
+          <p:nvPr/>
+        </p:nvSpPr>
+        <p:spPr>
+          <a:xfrm>
+            <a:off x="8458200" y="201168"/>
+            <a:ext cx="256032" cy="256032"/>
+          </a:xfrm>
+          <a:prstGeom prst="ellipse">
+            <a:avLst/>
+          </a:prstGeom>
+          <a:solidFill>
+            <a:srgbClr val="DDDDDD"/>
+          </a:solidFill>
+          <a:ln/>
+        </p:spPr>
+        <p:txBody>
+          <a:bodyPr/>
+          <a:lstStyle/>
+          <a:p>
+            <a:endParaRPr lang="en-GB"/>
+          </a:p>
+        </p:txBody>
+      </p:sp>
+      <p:sp>
+        <p:nvSpPr>
+          <p:cNvPr id="3" name="Text 1"/>
+          <p:cNvSpPr/>
+          <p:nvPr/>
+        </p:nvSpPr>
+        <p:spPr>
+          <a:xfrm>
+            <a:off x="457200" y="274320"/>
+            <a:ext cx="6400800" cy="228600"/>
+          </a:xfrm>
+          <a:prstGeom prst="rect">
+            <a:avLst/>
+          </a:prstGeom>
+          <a:noFill/>
+          <a:ln/>
+        </p:spPr>
+        <p:txBody>
+          <a:bodyPr wrap="square" rtlCol="0" anchor="ctr"/>
+          <a:lstStyle/>
+          <a:p>
+            <a:pPr marL="0" indent="0">
+              <a:buNone/>
+            </a:pPr>
+            <a:r>
+              <a:rPr lang="en-US" sz="1000" b="1" kern="0" spc="200" dirty="0">
+                <a:solidFill>
+                  <a:srgbClr val="888888"/>
+                </a:solidFill>
+                <a:latin typeface="Arial" pitchFamily="34" charset="0"/>
+                <a:ea typeface="Arial" pitchFamily="34" charset="-122"/>
+                <a:cs typeface="Arial" pitchFamily="34" charset="-120"/>
+              </a:rPr>
+              <a:t>DELIVERY PROCESS</a:t>
+            </a:r>
+            <a:endParaRPr lang="en-US" sz="1000" dirty="0"/>
+          </a:p>
+        </p:txBody>
+      </p:sp>
+      <p:sp>
+        <p:nvSpPr>
+          <p:cNvPr id="4" name="Text 2"/>
+          <p:cNvSpPr/>
+          <p:nvPr/>
+        </p:nvSpPr>
+        <p:spPr>
+          <a:xfrm>
+            <a:off x="3657600" y="4919472"/>
+            <a:ext cx="5212080" cy="182880"/>
+          </a:xfrm>
+          <a:prstGeom prst="rect">
+            <a:avLst/>
+          </a:prstGeom>
+          <a:noFill/>
+          <a:ln/>
+        </p:spPr>
+        <p:txBody>
+          <a:bodyPr wrap="square" rtlCol="0" anchor="ctr"/>
+          <a:lstStyle/>
+          <a:p>
+            <a:pPr marL="0" indent="0" algn="r">
+              <a:buNone/>
+            </a:pPr>
+            <a:r>
+              <a:rPr lang="en-US" sz="900" dirty="0">
+                <a:solidFill>
+                  <a:srgbClr val="888888"/>
+                </a:solidFill>
+                <a:latin typeface="Arial" pitchFamily="34" charset="0"/>
+                <a:ea typeface="Arial" pitchFamily="34" charset="-122"/>
+                <a:cs typeface="Arial" pitchFamily="34" charset="-120"/>
+              </a:rPr>
+              <a:t>NINJA QUIZ  ·  503IT  ·  09 / 18</a:t>
+            </a:r>
+            <a:endParaRPr lang="en-US" sz="900" dirty="0"/>
+          </a:p>
+        </p:txBody>
+      </p:sp>
+      <p:sp>
+        <p:nvSpPr>
+          <p:cNvPr id="5" name="Text 3"/>
+          <p:cNvSpPr/>
+          <p:nvPr/>
+        </p:nvSpPr>
+        <p:spPr>
+          <a:xfrm>
+            <a:off x="457200" y="685800"/>
+            <a:ext cx="8229600" cy="812800"/>
+          </a:xfrm>
+          <a:prstGeom prst="rect">
+            <a:avLst/>
+          </a:prstGeom>
+          <a:noFill/>
+          <a:ln/>
+        </p:spPr>
+        <p:txBody>
+          <a:bodyPr wrap="square" rtlCol="0" anchor="ctr"/>
+          <a:lstStyle/>
+          <a:p>
+            <a:pPr marL="0" indent="0">
+              <a:buNone/>
+            </a:pPr>
+            <a:r>
+              <a:rPr lang="en-US" sz="3200" b="1" dirty="0">
+                <a:solidFill>
+                  <a:srgbClr val="111111"/>
+                </a:solidFill>
+                <a:latin typeface="Arial Black" pitchFamily="34" charset="0"/>
+                <a:ea typeface="Arial Black" pitchFamily="34" charset="-122"/>
+                <a:cs typeface="Arial Black" pitchFamily="34" charset="-120"/>
+              </a:rPr>
+              <a:t>Built in five sprints.</a:t>
+            </a:r>
+            <a:endParaRPr lang="en-US" sz="3200" dirty="0"/>
+          </a:p>
+        </p:txBody>
+      </p:sp>
+      <p:sp>
+        <p:nvSpPr>
+          <p:cNvPr id="6" name="Shape 4"/>
+          <p:cNvSpPr/>
+          <p:nvPr/>
+        </p:nvSpPr>
+        <p:spPr>
+          <a:xfrm>
+            <a:off x="457200" y="1463040"/>
+            <a:ext cx="8229600" cy="10973"/>
+          </a:xfrm>
+          <a:prstGeom prst="rect">
+            <a:avLst/>
+          </a:prstGeom>
+          <a:solidFill>
+            <a:srgbClr val="EEEEEE"/>
+          </a:solidFill>
+          <a:ln/>
+        </p:spPr>
+        <p:txBody>
+          <a:bodyPr/>
+          <a:lstStyle/>
+          <a:p>
+            <a:endParaRPr lang="en-GB"/>
+          </a:p>
+        </p:txBody>
+      </p:sp>
+      <p:sp>
+        <p:nvSpPr>
+          <p:cNvPr id="7" name="Text 5"/>
+          <p:cNvSpPr/>
+          <p:nvPr/>
+        </p:nvSpPr>
+        <p:spPr>
+          <a:xfrm>
+            <a:off x="457200" y="1609344"/>
+            <a:ext cx="868680" cy="411480"/>
+          </a:xfrm>
+          <a:prstGeom prst="rect">
+            <a:avLst/>
+          </a:prstGeom>
+          <a:noFill/>
+          <a:ln/>
+        </p:spPr>
+        <p:txBody>
+          <a:bodyPr wrap="square" rtlCol="0" anchor="ctr">
+            <a:normAutofit/>
+          </a:bodyPr>
+          <a:lstStyle/>
+          <a:p>
+            <a:pPr marL="0" indent="0">
+              <a:buNone/>
+            </a:pPr>
+            <a:r>
+              <a:rPr lang="en-US" sz="2000" b="1" dirty="0">
+                <a:solidFill>
+                  <a:srgbClr val="FFCD00"/>
+                </a:solidFill>
+                <a:latin typeface="Arial Black" pitchFamily="34" charset="0"/>
+                <a:ea typeface="Arial Black" pitchFamily="34" charset="-122"/>
+                <a:cs typeface="Arial Black" pitchFamily="34" charset="-120"/>
+              </a:rPr>
+              <a:t>01</a:t>
+            </a:r>
+            <a:endParaRPr lang="en-US" sz="2000" dirty="0"/>
+          </a:p>
+        </p:txBody>
+      </p:sp>
+      <p:sp>
+        <p:nvSpPr>
+          <p:cNvPr id="8" name="Text 6"/>
+          <p:cNvSpPr/>
+          <p:nvPr/>
+        </p:nvSpPr>
+        <p:spPr>
+          <a:xfrm>
+            <a:off x="1371600" y="1591056"/>
+            <a:ext cx="7315200" cy="292608"/>
+          </a:xfrm>
+          <a:prstGeom prst="rect">
+            <a:avLst/>
+          </a:prstGeom>
+          <a:noFill/>
+          <a:ln/>
+        </p:spPr>
+        <p:txBody>
+          <a:bodyPr wrap="square" rtlCol="0" anchor="ctr"/>
+          <a:lstStyle/>
+          <a:p>
+            <a:pPr marL="0" indent="0">
+              <a:buNone/>
+            </a:pPr>
+            <a:r>
+              <a:rPr lang="en-US" sz="1700" b="1" dirty="0">
+                <a:solidFill>
+                  <a:srgbClr val="111111"/>
+                </a:solidFill>
+                <a:latin typeface="Arial Black" pitchFamily="34" charset="0"/>
+                <a:ea typeface="Arial Black" pitchFamily="34" charset="-122"/>
+                <a:cs typeface="Arial Black" pitchFamily="34" charset="-120"/>
+              </a:rPr>
+              <a:t>Sprint 1  —  Login &amp; menu</a:t>
+            </a:r>
+            <a:endParaRPr lang="en-US" sz="1700" dirty="0"/>
+          </a:p>
+        </p:txBody>
+      </p:sp>
+      <p:sp>
+        <p:nvSpPr>
+          <p:cNvPr id="9" name="Text 7"/>
+          <p:cNvSpPr/>
+          <p:nvPr/>
+        </p:nvSpPr>
+        <p:spPr>
+          <a:xfrm>
+            <a:off x="1371600" y="1892808"/>
+            <a:ext cx="7315200" cy="228600"/>
+          </a:xfrm>
+          <a:prstGeom prst="rect">
+            <a:avLst/>
+          </a:prstGeom>
+          <a:noFill/>
+          <a:ln/>
+        </p:spPr>
+        <p:txBody>
+          <a:bodyPr wrap="square" rtlCol="0" anchor="ctr"/>
+          <a:lstStyle/>
+          <a:p>
+            <a:pPr marL="0" indent="0">
+              <a:buNone/>
+            </a:pPr>
+            <a:r>
+              <a:rPr lang="en-US" sz="1200" dirty="0">
+                <a:solidFill>
+                  <a:srgbClr val="888888"/>
+                </a:solidFill>
+                <a:latin typeface="Arial" pitchFamily="34" charset="0"/>
+                <a:ea typeface="Arial" pitchFamily="34" charset="-122"/>
+                <a:cs typeface="Arial" pitchFamily="34" charset="-120"/>
+              </a:rPr>
+              <a:t>Foundation. Every member set up. GitHub branches created.</a:t>
+            </a:r>
+            <a:endParaRPr lang="en-US" sz="1200" dirty="0"/>
+          </a:p>
+        </p:txBody>
+      </p:sp>
+      <p:sp>
+        <p:nvSpPr>
+          <p:cNvPr id="10" name="Text 8"/>
+          <p:cNvSpPr/>
+          <p:nvPr/>
+        </p:nvSpPr>
+        <p:spPr>
+          <a:xfrm>
+            <a:off x="457200" y="2231136"/>
+            <a:ext cx="868680" cy="411480"/>
+          </a:xfrm>
+          <a:prstGeom prst="rect">
+            <a:avLst/>
+          </a:prstGeom>
+          <a:noFill/>
+          <a:ln/>
+        </p:spPr>
+        <p:txBody>
+          <a:bodyPr wrap="square" rtlCol="0" anchor="ctr">
+            <a:normAutofit/>
+          </a:bodyPr>
+          <a:lstStyle/>
+          <a:p>
+            <a:pPr marL="0" indent="0">
+              <a:buNone/>
+            </a:pPr>
+            <a:r>
+              <a:rPr lang="en-US" sz="2000" b="1" dirty="0">
+                <a:solidFill>
+                  <a:srgbClr val="FFCD00"/>
+                </a:solidFill>
+                <a:latin typeface="Arial Black" pitchFamily="34" charset="0"/>
+                <a:ea typeface="Arial Black" pitchFamily="34" charset="-122"/>
+                <a:cs typeface="Arial Black" pitchFamily="34" charset="-120"/>
+              </a:rPr>
+              <a:t>02</a:t>
+            </a:r>
+            <a:endParaRPr lang="en-US" sz="2000" dirty="0"/>
+          </a:p>
+        </p:txBody>
+      </p:sp>
+      <p:sp>
+        <p:nvSpPr>
+          <p:cNvPr id="11" name="Text 9"/>
+          <p:cNvSpPr/>
+          <p:nvPr/>
+        </p:nvSpPr>
+        <p:spPr>
+          <a:xfrm>
+            <a:off x="1371600" y="2212848"/>
+            <a:ext cx="7315200" cy="292608"/>
+          </a:xfrm>
+          <a:prstGeom prst="rect">
+            <a:avLst/>
+          </a:prstGeom>
+          <a:noFill/>
+          <a:ln/>
+        </p:spPr>
+        <p:txBody>
+          <a:bodyPr wrap="square" rtlCol="0" anchor="ctr"/>
+          <a:lstStyle/>
+          <a:p>
+            <a:pPr marL="0" indent="0">
+              <a:buNone/>
+            </a:pPr>
+            <a:r>
+              <a:rPr lang="en-US" sz="1700" b="1" dirty="0">
+                <a:solidFill>
+                  <a:srgbClr val="111111"/>
+                </a:solidFill>
+                <a:latin typeface="Arial Black" pitchFamily="34" charset="0"/>
+                <a:ea typeface="Arial Black" pitchFamily="34" charset="-122"/>
+                <a:cs typeface="Arial Black" pitchFamily="34" charset="-120"/>
+              </a:rPr>
+              <a:t>Sprint 2  —  Game engine</a:t>
+            </a:r>
+            <a:endParaRPr lang="en-US" sz="1700" dirty="0"/>
+          </a:p>
+        </p:txBody>
+      </p:sp>
+      <p:sp>
+        <p:nvSpPr>
+          <p:cNvPr id="12" name="Text 10"/>
+          <p:cNvSpPr/>
+          <p:nvPr/>
+        </p:nvSpPr>
+        <p:spPr>
+          <a:xfrm>
+            <a:off x="1371600" y="2514600"/>
+            <a:ext cx="7315200" cy="228600"/>
+          </a:xfrm>
+          <a:prstGeom prst="rect">
+            <a:avLst/>
+          </a:prstGeom>
+          <a:noFill/>
+          <a:ln/>
+        </p:spPr>
+        <p:txBody>
+          <a:bodyPr wrap="square" rtlCol="0" anchor="ctr"/>
+          <a:lstStyle/>
+          <a:p>
+            <a:pPr marL="0" indent="0">
+              <a:buNone/>
+            </a:pPr>
+            <a:r>
+              <a:rPr lang="en-US" sz="1200" dirty="0">
+                <a:solidFill>
+                  <a:srgbClr val="888888"/>
+                </a:solidFill>
+                <a:latin typeface="Arial" pitchFamily="34" charset="0"/>
+                <a:ea typeface="Arial" pitchFamily="34" charset="-122"/>
+                <a:cs typeface="Arial" pitchFamily="34" charset="-120"/>
+              </a:rPr>
+              <a:t>Core mechanics built. Daily check-ins via WhatsApp.</a:t>
+            </a:r>
+            <a:endParaRPr lang="en-US" sz="1200" dirty="0"/>
+          </a:p>
+        </p:txBody>
+      </p:sp>
+      <p:sp>
+        <p:nvSpPr>
+          <p:cNvPr id="13" name="Text 11"/>
+          <p:cNvSpPr/>
+          <p:nvPr/>
+        </p:nvSpPr>
+        <p:spPr>
+          <a:xfrm>
+            <a:off x="457200" y="2852928"/>
+            <a:ext cx="868680" cy="411480"/>
+          </a:xfrm>
+          <a:prstGeom prst="rect">
+            <a:avLst/>
+          </a:prstGeom>
+          <a:noFill/>
+          <a:ln/>
+        </p:spPr>
+        <p:txBody>
+          <a:bodyPr wrap="square" rtlCol="0" anchor="ctr">
+            <a:normAutofit/>
+          </a:bodyPr>
+          <a:lstStyle/>
+          <a:p>
+            <a:pPr marL="0" indent="0">
+              <a:buNone/>
+            </a:pPr>
+            <a:r>
+              <a:rPr lang="en-US" sz="2000" b="1" dirty="0">
+                <a:solidFill>
+                  <a:srgbClr val="FFCD00"/>
+                </a:solidFill>
+                <a:latin typeface="Arial Black" pitchFamily="34" charset="0"/>
+                <a:ea typeface="Arial Black" pitchFamily="34" charset="-122"/>
+                <a:cs typeface="Arial Black" pitchFamily="34" charset="-120"/>
+              </a:rPr>
+              <a:t>03</a:t>
+            </a:r>
+            <a:endParaRPr lang="en-US" sz="2000" dirty="0"/>
+          </a:p>
+        </p:txBody>
+      </p:sp>
+      <p:sp>
+        <p:nvSpPr>
+          <p:cNvPr id="14" name="Text 12"/>
+          <p:cNvSpPr/>
+          <p:nvPr/>
+        </p:nvSpPr>
+        <p:spPr>
+          <a:xfrm>
+            <a:off x="1371600" y="2834640"/>
+            <a:ext cx="7315200" cy="292608"/>
+          </a:xfrm>
+          <a:prstGeom prst="rect">
+            <a:avLst/>
+          </a:prstGeom>
+          <a:noFill/>
+          <a:ln/>
+        </p:spPr>
+        <p:txBody>
+          <a:bodyPr wrap="square" rtlCol="0" anchor="ctr"/>
+          <a:lstStyle/>
+          <a:p>
+            <a:pPr marL="0" indent="0">
+              <a:buNone/>
+            </a:pPr>
+            <a:r>
+              <a:rPr lang="en-US" sz="1700" b="1" dirty="0">
+                <a:solidFill>
+                  <a:srgbClr val="111111"/>
+                </a:solidFill>
+                <a:latin typeface="Arial Black" pitchFamily="34" charset="0"/>
+                <a:ea typeface="Arial Black" pitchFamily="34" charset="-122"/>
+                <a:cs typeface="Arial Black" pitchFamily="34" charset="-120"/>
+              </a:rPr>
+              <a:t>Sprint 3  —  Slicing &amp; sound</a:t>
+            </a:r>
+            <a:endParaRPr lang="en-US" sz="1700" dirty="0"/>
+          </a:p>
+        </p:txBody>
+      </p:sp>
+      <p:sp>
+        <p:nvSpPr>
+          <p:cNvPr id="15" name="Text 13"/>
+          <p:cNvSpPr/>
+          <p:nvPr/>
+        </p:nvSpPr>
+        <p:spPr>
+          <a:xfrm>
+            <a:off x="1371600" y="3136392"/>
+            <a:ext cx="7315200" cy="228600"/>
+          </a:xfrm>
+          <a:prstGeom prst="rect">
+            <a:avLst/>
+          </a:prstGeom>
+          <a:noFill/>
+          <a:ln/>
+        </p:spPr>
+        <p:txBody>
+          <a:bodyPr wrap="square" rtlCol="0" anchor="ctr"/>
+          <a:lstStyle/>
+          <a:p>
+            <a:pPr marL="0" indent="0">
+              <a:buNone/>
+            </a:pPr>
+            <a:r>
+              <a:rPr lang="en-US" sz="1200" dirty="0">
+                <a:solidFill>
+                  <a:srgbClr val="888888"/>
+                </a:solidFill>
+                <a:latin typeface="Arial" pitchFamily="34" charset="0"/>
+                <a:ea typeface="Arial" pitchFamily="34" charset="-122"/>
+                <a:cs typeface="Arial" pitchFamily="34" charset="-120"/>
+              </a:rPr>
+              <a:t>Visual integration. First merge conflicts resolved.</a:t>
+            </a:r>
+            <a:endParaRPr lang="en-US" sz="1200" dirty="0"/>
+          </a:p>
+        </p:txBody>
+      </p:sp>
+      <p:sp>
+        <p:nvSpPr>
+          <p:cNvPr id="16" name="Text 14"/>
+          <p:cNvSpPr/>
+          <p:nvPr/>
+        </p:nvSpPr>
+        <p:spPr>
+          <a:xfrm>
+            <a:off x="457200" y="3474720"/>
+            <a:ext cx="868680" cy="411480"/>
+          </a:xfrm>
+          <a:prstGeom prst="rect">
+            <a:avLst/>
+          </a:prstGeom>
+          <a:noFill/>
+          <a:ln/>
+        </p:spPr>
+        <p:txBody>
+          <a:bodyPr wrap="square" rtlCol="0" anchor="ctr">
+            <a:normAutofit/>
+          </a:bodyPr>
+          <a:lstStyle/>
+          <a:p>
+            <a:pPr marL="0" indent="0">
+              <a:buNone/>
+            </a:pPr>
+            <a:r>
+              <a:rPr lang="en-US" sz="2000" b="1" dirty="0">
+                <a:solidFill>
+                  <a:srgbClr val="FFCD00"/>
+                </a:solidFill>
+                <a:latin typeface="Arial Black" pitchFamily="34" charset="0"/>
+                <a:ea typeface="Arial Black" pitchFamily="34" charset="-122"/>
+                <a:cs typeface="Arial Black" pitchFamily="34" charset="-120"/>
+              </a:rPr>
+              <a:t>04</a:t>
+            </a:r>
+            <a:endParaRPr lang="en-US" sz="2000" dirty="0"/>
+          </a:p>
+        </p:txBody>
+      </p:sp>
+      <p:sp>
+        <p:nvSpPr>
+          <p:cNvPr id="17" name="Text 15"/>
+          <p:cNvSpPr/>
+          <p:nvPr/>
+        </p:nvSpPr>
+        <p:spPr>
+          <a:xfrm>
+            <a:off x="1371600" y="3456432"/>
+            <a:ext cx="7315200" cy="292608"/>
+          </a:xfrm>
+          <a:prstGeom prst="rect">
+            <a:avLst/>
+          </a:prstGeom>
+          <a:noFill/>
+          <a:ln/>
+        </p:spPr>
+        <p:txBody>
+          <a:bodyPr wrap="square" rtlCol="0" anchor="ctr"/>
+          <a:lstStyle/>
+          <a:p>
+            <a:pPr marL="0" indent="0">
+              <a:buNone/>
+            </a:pPr>
+            <a:r>
+              <a:rPr lang="en-US" sz="1700" b="1" dirty="0">
+                <a:solidFill>
+                  <a:srgbClr val="111111"/>
+                </a:solidFill>
+                <a:latin typeface="Arial Black" pitchFamily="34" charset="0"/>
+                <a:ea typeface="Arial Black" pitchFamily="34" charset="-122"/>
+                <a:cs typeface="Arial Black" pitchFamily="34" charset="-120"/>
+              </a:rPr>
+              <a:t>Sprint 4  —  Leaderboard</a:t>
+            </a:r>
+            <a:endParaRPr lang="en-US" sz="1700" dirty="0"/>
+          </a:p>
+        </p:txBody>
+      </p:sp>
+      <p:sp>
+        <p:nvSpPr>
+          <p:cNvPr id="18" name="Text 16"/>
+          <p:cNvSpPr/>
+          <p:nvPr/>
+        </p:nvSpPr>
+        <p:spPr>
+          <a:xfrm>
+            <a:off x="1371600" y="3758184"/>
+            <a:ext cx="7315200" cy="228600"/>
+          </a:xfrm>
+          <a:prstGeom prst="rect">
+            <a:avLst/>
+          </a:prstGeom>
+          <a:noFill/>
+          <a:ln/>
+        </p:spPr>
+        <p:txBody>
+          <a:bodyPr wrap="square" rtlCol="0" anchor="ctr"/>
+          <a:lstStyle/>
+          <a:p>
+            <a:pPr marL="0" indent="0">
+              <a:buNone/>
+            </a:pPr>
+            <a:r>
+              <a:rPr lang="en-US" sz="1200" dirty="0">
+                <a:solidFill>
+                  <a:srgbClr val="888888"/>
+                </a:solidFill>
+                <a:latin typeface="Arial" pitchFamily="34" charset="0"/>
+                <a:ea typeface="Arial" pitchFamily="34" charset="-122"/>
+                <a:cs typeface="Arial" pitchFamily="34" charset="-120"/>
+              </a:rPr>
+              <a:t>Peer testing begins. Feedback collected and logged.</a:t>
+            </a:r>
+            <a:endParaRPr lang="en-US" sz="1200" dirty="0"/>
+          </a:p>
+        </p:txBody>
+      </p:sp>
+      <p:sp>
+        <p:nvSpPr>
+          <p:cNvPr id="19" name="Text 17"/>
+          <p:cNvSpPr/>
+          <p:nvPr/>
+        </p:nvSpPr>
+        <p:spPr>
+          <a:xfrm>
+            <a:off x="457200" y="4096512"/>
+            <a:ext cx="868680" cy="411480"/>
+          </a:xfrm>
+          <a:prstGeom prst="rect">
+            <a:avLst/>
+          </a:prstGeom>
+          <a:noFill/>
+          <a:ln/>
+        </p:spPr>
+        <p:txBody>
+          <a:bodyPr wrap="square" rtlCol="0" anchor="ctr">
+            <a:normAutofit/>
+          </a:bodyPr>
+          <a:lstStyle/>
+          <a:p>
+            <a:pPr marL="0" indent="0">
+              <a:buNone/>
+            </a:pPr>
+            <a:r>
+              <a:rPr lang="en-US" sz="2000" b="1" dirty="0">
+                <a:solidFill>
+                  <a:srgbClr val="FFCD00"/>
+                </a:solidFill>
+                <a:latin typeface="Arial Black" pitchFamily="34" charset="0"/>
+                <a:ea typeface="Arial Black" pitchFamily="34" charset="-122"/>
+                <a:cs typeface="Arial Black" pitchFamily="34" charset="-120"/>
+              </a:rPr>
+              <a:t>05</a:t>
+            </a:r>
+            <a:endParaRPr lang="en-US" sz="2000" dirty="0"/>
+          </a:p>
+        </p:txBody>
+      </p:sp>
+      <p:sp>
+        <p:nvSpPr>
+          <p:cNvPr id="20" name="Text 18"/>
+          <p:cNvSpPr/>
+          <p:nvPr/>
+        </p:nvSpPr>
+        <p:spPr>
+          <a:xfrm>
+            <a:off x="1371600" y="4078224"/>
+            <a:ext cx="7315200" cy="292608"/>
+          </a:xfrm>
+          <a:prstGeom prst="rect">
+            <a:avLst/>
+          </a:prstGeom>
+          <a:noFill/>
+          <a:ln/>
+        </p:spPr>
+        <p:txBody>
+          <a:bodyPr wrap="square" rtlCol="0" anchor="ctr"/>
+          <a:lstStyle/>
+          <a:p>
+            <a:pPr marL="0" indent="0">
+              <a:buNone/>
+            </a:pPr>
+            <a:r>
+              <a:rPr lang="en-US" sz="1700" b="1" dirty="0">
+                <a:solidFill>
+                  <a:srgbClr val="111111"/>
+                </a:solidFill>
+                <a:latin typeface="Arial Black" pitchFamily="34" charset="0"/>
+                <a:ea typeface="Arial Black" pitchFamily="34" charset="-122"/>
+                <a:cs typeface="Arial Black" pitchFamily="34" charset="-120"/>
+              </a:rPr>
+              <a:t>Sprint 5  —  Testing &amp; polish</a:t>
+            </a:r>
+            <a:endParaRPr lang="en-US" sz="1700" dirty="0"/>
+          </a:p>
+        </p:txBody>
+      </p:sp>
+      <p:sp>
+        <p:nvSpPr>
+          <p:cNvPr id="21" name="Text 19"/>
+          <p:cNvSpPr/>
+          <p:nvPr/>
+        </p:nvSpPr>
+        <p:spPr>
+          <a:xfrm>
+            <a:off x="1371600" y="4379976"/>
+            <a:ext cx="7315200" cy="228600"/>
+          </a:xfrm>
+          <a:prstGeom prst="rect">
+            <a:avLst/>
+          </a:prstGeom>
+          <a:noFill/>
+          <a:ln/>
+        </p:spPr>
+        <p:txBody>
+          <a:bodyPr wrap="square" rtlCol="0" anchor="ctr"/>
+          <a:lstStyle/>
+          <a:p>
+            <a:pPr marL="0" indent="0">
+              <a:buNone/>
+            </a:pPr>
+            <a:r>
+              <a:rPr lang="en-US" sz="1200" dirty="0">
+                <a:solidFill>
+                  <a:srgbClr val="888888"/>
+                </a:solidFill>
+                <a:latin typeface="Arial" pitchFamily="34" charset="0"/>
+                <a:ea typeface="Arial" pitchFamily="34" charset="-122"/>
+                <a:cs typeface="Arial" pitchFamily="34" charset="-120"/>
+              </a:rPr>
+              <a:t>Bug hunt, final fixes, review before submission.</a:t>
+            </a:r>
+            <a:endParaRPr lang="en-US" sz="1200" dirty="0"/>
+          </a:p>
+        </p:txBody>
+      </p:sp>
+    </p:spTree>
+  </p:cSld>
+  <p:clrMapOvr>
+    <a:masterClrMapping/>
+  </p:clrMapOvr>
+</p:sld>
+</file>
+
+<file path=ppt/slides/slide11.xml><?xml version="1.0" encoding="utf-8"?>
 <p:sld xmlns:a="http://schemas.openxmlformats.org/drawingml/2006/main" xmlns:p="http://schemas.openxmlformats.org/presentationml/2006/main" xmlns:r="http://schemas.openxmlformats.org/officeDocument/2006/relationships">
   <p:cSld>
     <p:bg>
@@ -3043,7 +3842,7 @@
 </p:sld>
 </file>
 
-<file path=ppt/slides/slide11.xml><?xml version="1.0" encoding="utf-8"?>
+<file path=ppt/slides/slide12.xml><?xml version="1.0" encoding="utf-8"?>
 <p:sld xmlns:a="http://schemas.openxmlformats.org/drawingml/2006/main" xmlns:r="http://schemas.openxmlformats.org/officeDocument/2006/relationships" xmlns:p="http://schemas.openxmlformats.org/presentationml/2006/main">
   <p:cSld name="Slide 10">
     <p:bg>
@@ -3248,7 +4047,7 @@
 </p:sld>
 </file>
 
-<file path=ppt/slides/slide12.xml><?xml version="1.0" encoding="utf-8"?>
+<file path=ppt/slides/slide13.xml><?xml version="1.0" encoding="utf-8"?>
 <p:sld xmlns:a="http://schemas.openxmlformats.org/drawingml/2006/main" xmlns:r="http://schemas.openxmlformats.org/officeDocument/2006/relationships" xmlns:p="http://schemas.openxmlformats.org/presentationml/2006/main">
   <p:cSld name="Slide 11">
     <p:bg>
@@ -3923,7 +4722,7 @@
 </p:sld>
 </file>
 
-<file path=ppt/slides/slide13.xml><?xml version="1.0" encoding="utf-8"?>
+<file path=ppt/slides/slide14.xml><?xml version="1.0" encoding="utf-8"?>
 <p:sld xmlns:a="http://schemas.openxmlformats.org/drawingml/2006/main" xmlns:r="http://schemas.openxmlformats.org/officeDocument/2006/relationships" xmlns:p="http://schemas.openxmlformats.org/presentationml/2006/main">
   <p:cSld name="Slide 12">
     <p:bg>
@@ -4523,7 +5322,7 @@
 </p:sld>
 </file>
 
-<file path=ppt/slides/slide14.xml><?xml version="1.0" encoding="utf-8"?>
+<file path=ppt/slides/slide15.xml><?xml version="1.0" encoding="utf-8"?>
 <p:sld xmlns:a="http://schemas.openxmlformats.org/drawingml/2006/main" xmlns:r="http://schemas.openxmlformats.org/officeDocument/2006/relationships" xmlns:p="http://schemas.openxmlformats.org/presentationml/2006/main">
   <p:cSld name="Slide 13">
     <p:bg>
@@ -4728,7 +5527,7 @@
 </p:sld>
 </file>
 
-<file path=ppt/slides/slide15.xml><?xml version="1.0" encoding="utf-8"?>
+<file path=ppt/slides/slide16.xml><?xml version="1.0" encoding="utf-8"?>
 <p:sld xmlns:a="http://schemas.openxmlformats.org/drawingml/2006/main" xmlns:r="http://schemas.openxmlformats.org/officeDocument/2006/relationships" xmlns:p="http://schemas.openxmlformats.org/presentationml/2006/main">
   <p:cSld name="Slide 14">
     <p:bg>
@@ -5592,7 +6391,7 @@
 </p:sld>
 </file>
 
-<file path=ppt/slides/slide16.xml><?xml version="1.0" encoding="utf-8"?>
+<file path=ppt/slides/slide17.xml><?xml version="1.0" encoding="utf-8"?>
 <p:sld xmlns:a="http://schemas.openxmlformats.org/drawingml/2006/main" xmlns:r="http://schemas.openxmlformats.org/officeDocument/2006/relationships" xmlns:p="http://schemas.openxmlformats.org/presentationml/2006/main">
   <p:cSld name="Slide 15">
     <p:bg>
@@ -6285,7 +7084,7 @@
 </p:sld>
 </file>
 
-<file path=ppt/slides/slide17.xml><?xml version="1.0" encoding="utf-8"?>
+<file path=ppt/slides/slide18.xml><?xml version="1.0" encoding="utf-8"?>
 <p:sld xmlns:a="http://schemas.openxmlformats.org/drawingml/2006/main" xmlns:r="http://schemas.openxmlformats.org/officeDocument/2006/relationships" xmlns:p="http://schemas.openxmlformats.org/presentationml/2006/main">
   <p:cSld name="Slide 16">
     <p:bg>
@@ -6486,7 +7285,7 @@
 </p:sld>
 </file>
 
-<file path=ppt/slides/slide18.xml><?xml version="1.0" encoding="utf-8"?>
+<file path=ppt/slides/slide19.xml><?xml version="1.0" encoding="utf-8"?>
 <p:sld xmlns:a="http://schemas.openxmlformats.org/drawingml/2006/main" xmlns:r="http://schemas.openxmlformats.org/officeDocument/2006/relationships" xmlns:p="http://schemas.openxmlformats.org/presentationml/2006/main">
   <p:cSld name="Slide 17">
     <p:bg>
@@ -6735,417 +7534,6 @@
               <a:t>Not the code. Not the tools. The way five people stayed aligned.</a:t>
             </a:r>
             <a:endParaRPr lang="en-US" sz="1400" dirty="0"/>
-          </a:p>
-        </p:txBody>
-      </p:sp>
-    </p:spTree>
-  </p:cSld>
-  <p:clrMapOvr>
-    <a:masterClrMapping/>
-  </p:clrMapOvr>
-</p:sld>
-</file>
-
-<file path=ppt/slides/slide19.xml><?xml version="1.0" encoding="utf-8"?>
-<p:sld xmlns:a="http://schemas.openxmlformats.org/drawingml/2006/main" xmlns:p="http://schemas.openxmlformats.org/presentationml/2006/main" xmlns:r="http://schemas.openxmlformats.org/officeDocument/2006/relationships">
-  <p:cSld>
-    <p:bg>
-      <p:bgPr>
-        <a:solidFill>
-          <a:srgbClr val="0D0D0D"/>
-        </a:solidFill>
-        <a:effectLst/>
-      </p:bgPr>
-    </p:bg>
-    <p:spTree>
-      <p:nvGrpSpPr>
-        <p:cNvPr id="1" name=""/>
-        <p:cNvGrpSpPr/>
-        <p:nvPr/>
-      </p:nvGrpSpPr>
-      <p:grpSpPr/>
-      <p:sp>
-        <p:nvSpPr>
-          <p:cNvPr id="2" name="TextBox 1"/>
-          <p:cNvSpPr txBox="1"/>
-          <p:nvPr/>
-        </p:nvSpPr>
-        <p:spPr>
-          <a:xfrm>
-            <a:off x="457200" y="256032"/>
-            <a:ext cx="6858000" cy="256032"/>
-          </a:xfrm>
-          <a:prstGeom prst="rect">
-            <a:avLst/>
-          </a:prstGeom>
-          <a:noFill/>
-        </p:spPr>
-        <p:txBody>
-          <a:bodyPr wrap="square">
-            <a:spAutoFit/>
-          </a:bodyPr>
-          <a:lstStyle/>
-          <a:p>
-            <a:pPr algn="l"/>
-            <a:r>
-              <a:rPr sz="1000" b="1" i="0">
-                <a:solidFill>
-                  <a:srgbClr val="888888"/>
-                </a:solidFill>
-              </a:rPr>
-              <a:t>PROFESSIONAL DEVELOPMENT</a:t>
-            </a:r>
-          </a:p>
-        </p:txBody>
-      </p:sp>
-      <p:sp>
-        <p:nvSpPr>
-          <p:cNvPr id="3" name="TextBox 2"/>
-          <p:cNvSpPr txBox="1"/>
-          <p:nvPr/>
-        </p:nvSpPr>
-        <p:spPr>
-          <a:xfrm>
-            <a:off x="3657600" y="4919472"/>
-            <a:ext cx="5212080" cy="182880"/>
-          </a:xfrm>
-          <a:prstGeom prst="rect">
-            <a:avLst/>
-          </a:prstGeom>
-          <a:noFill/>
-        </p:spPr>
-        <p:txBody>
-          <a:bodyPr wrap="square">
-            <a:spAutoFit/>
-          </a:bodyPr>
-          <a:lstStyle/>
-          <a:p>
-            <a:pPr algn="l"/>
-            <a:r>
-              <a:rPr sz="800" b="0" i="0">
-                <a:solidFill>
-                  <a:srgbClr val="444444"/>
-                </a:solidFill>
-              </a:rPr>
-              <a:t>NINJA QUIZ  .  503IT</a:t>
-            </a:r>
-          </a:p>
-        </p:txBody>
-      </p:sp>
-      <p:sp>
-        <p:nvSpPr>
-          <p:cNvPr id="4" name="TextBox 3"/>
-          <p:cNvSpPr txBox="1"/>
-          <p:nvPr/>
-        </p:nvSpPr>
-        <p:spPr>
-          <a:xfrm>
-            <a:off x="457200" y="594360"/>
-            <a:ext cx="8229600" cy="1097280"/>
-          </a:xfrm>
-          <a:prstGeom prst="rect">
-            <a:avLst/>
-          </a:prstGeom>
-          <a:noFill/>
-        </p:spPr>
-        <p:txBody>
-          <a:bodyPr wrap="square">
-            <a:spAutoFit/>
-          </a:bodyPr>
-          <a:lstStyle/>
-          <a:p>
-            <a:pPr algn="l"/>
-            <a:r>
-              <a:rPr sz="2800" b="1" i="0">
-                <a:solidFill>
-                  <a:srgbClr val="FFFFFF"/>
-                </a:solidFill>
-              </a:rPr>
-              <a:t>This project taught us how</a:t>
-            </a:r>
-          </a:p>
-          <a:p>
-            <a:pPr algn="l"/>
-            <a:r>
-              <a:rPr sz="2800" b="1" i="0">
-                <a:solidFill>
-                  <a:srgbClr val="FFFFFF"/>
-                </a:solidFill>
-              </a:rPr>
-              <a:t>industry teams actually work.</a:t>
-            </a:r>
-          </a:p>
-        </p:txBody>
-      </p:sp>
-      <p:sp>
-        <p:nvSpPr>
-          <p:cNvPr id="5" name="TextBox 4"/>
-          <p:cNvSpPr txBox="1"/>
-          <p:nvPr/>
-        </p:nvSpPr>
-        <p:spPr>
-          <a:xfrm>
-            <a:off x="457200" y="1874519"/>
-            <a:ext cx="3840480" cy="256032"/>
-          </a:xfrm>
-          <a:prstGeom prst="rect">
-            <a:avLst/>
-          </a:prstGeom>
-          <a:noFill/>
-        </p:spPr>
-        <p:txBody>
-          <a:bodyPr wrap="square">
-            <a:spAutoFit/>
-          </a:bodyPr>
-          <a:lstStyle/>
-          <a:p>
-            <a:pPr algn="l"/>
-            <a:r>
-              <a:rPr sz="1300" b="1" i="0">
-                <a:solidFill>
-                  <a:srgbClr val="FFCD00"/>
-                </a:solidFill>
-              </a:rPr>
-              <a:t>Structured communication</a:t>
-            </a:r>
-          </a:p>
-        </p:txBody>
-      </p:sp>
-      <p:sp>
-        <p:nvSpPr>
-          <p:cNvPr id="6" name="TextBox 5"/>
-          <p:cNvSpPr txBox="1"/>
-          <p:nvPr/>
-        </p:nvSpPr>
-        <p:spPr>
-          <a:xfrm>
-            <a:off x="457200" y="2148839"/>
-            <a:ext cx="8229600" cy="411480"/>
-          </a:xfrm>
-          <a:prstGeom prst="rect">
-            <a:avLst/>
-          </a:prstGeom>
-          <a:noFill/>
-        </p:spPr>
-        <p:txBody>
-          <a:bodyPr wrap="square">
-            <a:spAutoFit/>
-          </a:bodyPr>
-          <a:lstStyle/>
-          <a:p>
-            <a:pPr algn="l"/>
-            <a:r>
-              <a:rPr sz="1100" b="0" i="0">
-                <a:solidFill>
-                  <a:srgbClr val="AAAAAA"/>
-                </a:solidFill>
-              </a:rPr>
-              <a:t>Raising issues immediately, logging decisions in Trello and meeting minutes — these are professional standards, not student habits.</a:t>
-            </a:r>
-          </a:p>
-        </p:txBody>
-      </p:sp>
-      <p:sp>
-        <p:nvSpPr>
-          <p:cNvPr id="7" name="TextBox 6"/>
-          <p:cNvSpPr txBox="1"/>
-          <p:nvPr/>
-        </p:nvSpPr>
-        <p:spPr>
-          <a:xfrm>
-            <a:off x="457200" y="2697479"/>
-            <a:ext cx="3840480" cy="256032"/>
-          </a:xfrm>
-          <a:prstGeom prst="rect">
-            <a:avLst/>
-          </a:prstGeom>
-          <a:noFill/>
-        </p:spPr>
-        <p:txBody>
-          <a:bodyPr wrap="square">
-            <a:spAutoFit/>
-          </a:bodyPr>
-          <a:lstStyle/>
-          <a:p>
-            <a:pPr algn="l"/>
-            <a:r>
-              <a:rPr sz="1300" b="1" i="0">
-                <a:solidFill>
-                  <a:srgbClr val="FFCD00"/>
-                </a:solidFill>
-              </a:rPr>
-              <a:t>Real version control</a:t>
-            </a:r>
-          </a:p>
-        </p:txBody>
-      </p:sp>
-      <p:sp>
-        <p:nvSpPr>
-          <p:cNvPr id="8" name="TextBox 7"/>
-          <p:cNvSpPr txBox="1"/>
-          <p:nvPr/>
-        </p:nvSpPr>
-        <p:spPr>
-          <a:xfrm>
-            <a:off x="457200" y="2971799"/>
-            <a:ext cx="8229600" cy="411480"/>
-          </a:xfrm>
-          <a:prstGeom prst="rect">
-            <a:avLst/>
-          </a:prstGeom>
-          <a:noFill/>
-        </p:spPr>
-        <p:txBody>
-          <a:bodyPr wrap="square">
-            <a:spAutoFit/>
-          </a:bodyPr>
-          <a:lstStyle/>
-          <a:p>
-            <a:pPr algn="l"/>
-            <a:r>
-              <a:rPr sz="1100" b="0" i="0">
-                <a:solidFill>
-                  <a:srgbClr val="AAAAAA"/>
-                </a:solidFill>
-              </a:rPr>
-              <a:t>Feature branches, no pushing to main without review. We left this project with actual Git workflow experience.</a:t>
-            </a:r>
-          </a:p>
-        </p:txBody>
-      </p:sp>
-      <p:sp>
-        <p:nvSpPr>
-          <p:cNvPr id="9" name="TextBox 8"/>
-          <p:cNvSpPr txBox="1"/>
-          <p:nvPr/>
-        </p:nvSpPr>
-        <p:spPr>
-          <a:xfrm>
-            <a:off x="457200" y="3520439"/>
-            <a:ext cx="3840480" cy="256032"/>
-          </a:xfrm>
-          <a:prstGeom prst="rect">
-            <a:avLst/>
-          </a:prstGeom>
-          <a:noFill/>
-        </p:spPr>
-        <p:txBody>
-          <a:bodyPr wrap="square">
-            <a:spAutoFit/>
-          </a:bodyPr>
-          <a:lstStyle/>
-          <a:p>
-            <a:pPr algn="l"/>
-            <a:r>
-              <a:rPr sz="1300" b="1" i="0">
-                <a:solidFill>
-                  <a:srgbClr val="FFCD00"/>
-                </a:solidFill>
-              </a:rPr>
-              <a:t>Agile delivery mindset</a:t>
-            </a:r>
-          </a:p>
-        </p:txBody>
-      </p:sp>
-      <p:sp>
-        <p:nvSpPr>
-          <p:cNvPr id="10" name="TextBox 9"/>
-          <p:cNvSpPr txBox="1"/>
-          <p:nvPr/>
-        </p:nvSpPr>
-        <p:spPr>
-          <a:xfrm>
-            <a:off x="457200" y="3794759"/>
-            <a:ext cx="8229600" cy="411480"/>
-          </a:xfrm>
-          <a:prstGeom prst="rect">
-            <a:avLst/>
-          </a:prstGeom>
-          <a:noFill/>
-        </p:spPr>
-        <p:txBody>
-          <a:bodyPr wrap="square">
-            <a:spAutoFit/>
-          </a:bodyPr>
-          <a:lstStyle/>
-          <a:p>
-            <a:pPr algn="l"/>
-            <a:r>
-              <a:rPr sz="1100" b="0" i="0">
-                <a:solidFill>
-                  <a:srgbClr val="AAAAAA"/>
-                </a:solidFill>
-              </a:rPr>
-              <a:t>Five sprints with goals, retrospectives, and user testing mirrors how software teams ship in industry.</a:t>
-            </a:r>
-          </a:p>
-        </p:txBody>
-      </p:sp>
-      <p:sp>
-        <p:nvSpPr>
-          <p:cNvPr id="11" name="TextBox 10"/>
-          <p:cNvSpPr txBox="1"/>
-          <p:nvPr/>
-        </p:nvSpPr>
-        <p:spPr>
-          <a:xfrm>
-            <a:off x="457200" y="4343400"/>
-            <a:ext cx="3840480" cy="256032"/>
-          </a:xfrm>
-          <a:prstGeom prst="rect">
-            <a:avLst/>
-          </a:prstGeom>
-          <a:noFill/>
-        </p:spPr>
-        <p:txBody>
-          <a:bodyPr wrap="square">
-            <a:spAutoFit/>
-          </a:bodyPr>
-          <a:lstStyle/>
-          <a:p>
-            <a:pPr algn="l"/>
-            <a:r>
-              <a:rPr sz="1300" b="1" i="0">
-                <a:solidFill>
-                  <a:srgbClr val="FFCD00"/>
-                </a:solidFill>
-              </a:rPr>
-              <a:t>Resilience under pressure</a:t>
-            </a:r>
-          </a:p>
-        </p:txBody>
-      </p:sp>
-      <p:sp>
-        <p:nvSpPr>
-          <p:cNvPr id="12" name="TextBox 11"/>
-          <p:cNvSpPr txBox="1"/>
-          <p:nvPr/>
-        </p:nvSpPr>
-        <p:spPr>
-          <a:xfrm>
-            <a:off x="457200" y="4617720"/>
-            <a:ext cx="8229600" cy="411480"/>
-          </a:xfrm>
-          <a:prstGeom prst="rect">
-            <a:avLst/>
-          </a:prstGeom>
-          <a:noFill/>
-        </p:spPr>
-        <p:txBody>
-          <a:bodyPr wrap="square">
-            <a:spAutoFit/>
-          </a:bodyPr>
-          <a:lstStyle/>
-          <a:p>
-            <a:pPr algn="l"/>
-            <a:r>
-              <a:rPr sz="1100" b="0" i="0">
-                <a:solidFill>
-                  <a:srgbClr val="AAAAAA"/>
-                </a:solidFill>
-              </a:rPr>
-              <a:t>When the game broke 2 weeks before submission, we diagnosed and fixed it in one day — as a team. That experience is irreplaceable.</a:t>
-            </a:r>
           </a:p>
         </p:txBody>
       </p:sp>
@@ -7704,7 +8092,7 @@
 </p:sld>
 </file>
 
-<file path=ppt/slides/slide2.xml><?xml version="1.0" encoding="utf-8"?>
+<file path=ppt/slides/slide20.xml><?xml version="1.0" encoding="utf-8"?>
 <p:sld xmlns:a="http://schemas.openxmlformats.org/drawingml/2006/main" xmlns:p="http://schemas.openxmlformats.org/presentationml/2006/main" xmlns:r="http://schemas.openxmlformats.org/officeDocument/2006/relationships">
   <p:cSld>
     <p:bg>
@@ -7731,7 +8119,7 @@
         <p:spPr>
           <a:xfrm>
             <a:off x="457200" y="256032"/>
-            <a:ext cx="6400800" cy="256032"/>
+            <a:ext cx="6858000" cy="256032"/>
           </a:xfrm>
           <a:prstGeom prst="rect">
             <a:avLst/>
@@ -7751,7 +8139,7 @@
                   <a:srgbClr val="888888"/>
                 </a:solidFill>
               </a:rPr>
-              <a:t>WHAT WE WILL COVER</a:t>
+              <a:t>PROFESSIONAL DEVELOPMENT</a:t>
             </a:r>
           </a:p>
         </p:txBody>
@@ -7814,23 +8202,23 @@
           <a:p>
             <a:pPr algn="l"/>
             <a:r>
-              <a:rPr sz="3400" b="1" i="0">
+              <a:rPr sz="2800" b="1" i="0">
                 <a:solidFill>
                   <a:srgbClr val="FFFFFF"/>
                 </a:solidFill>
               </a:rPr>
-              <a:t>15 minutes.</a:t>
+              <a:t>This project taught us how</a:t>
             </a:r>
           </a:p>
           <a:p>
             <a:pPr algn="l"/>
             <a:r>
-              <a:rPr sz="3400" b="1" i="0">
+              <a:rPr sz="2800" b="1" i="0">
                 <a:solidFill>
                   <a:srgbClr val="FFFFFF"/>
                 </a:solidFill>
               </a:rPr>
-              <a:t>One story.</a:t>
+              <a:t>industry teams actually work.</a:t>
             </a:r>
           </a:p>
         </p:txBody>
@@ -7844,7 +8232,7 @@
         <p:spPr>
           <a:xfrm>
             <a:off x="457200" y="1874519"/>
-            <a:ext cx="640080" cy="292608"/>
+            <a:ext cx="3840480" cy="256032"/>
           </a:xfrm>
           <a:prstGeom prst="rect">
             <a:avLst/>
@@ -7859,12 +8247,12 @@
           <a:p>
             <a:pPr algn="l"/>
             <a:r>
-              <a:rPr sz="1200" b="1" i="0">
+              <a:rPr sz="1300" b="1" i="0">
                 <a:solidFill>
                   <a:srgbClr val="FFCD00"/>
                 </a:solidFill>
               </a:rPr>
-              <a:t>01</a:t>
+              <a:t>Structured communication</a:t>
             </a:r>
           </a:p>
         </p:txBody>
@@ -7877,8 +8265,8 @@
         </p:nvSpPr>
         <p:spPr>
           <a:xfrm>
-            <a:off x="1188720" y="1874519"/>
-            <a:ext cx="7680960" cy="292608"/>
+            <a:off x="457200" y="2148839"/>
+            <a:ext cx="8229600" cy="411480"/>
           </a:xfrm>
           <a:prstGeom prst="rect">
             <a:avLst/>
@@ -7893,12 +8281,12 @@
           <a:p>
             <a:pPr algn="l"/>
             <a:r>
-              <a:rPr sz="1200" b="0" i="0">
-                <a:solidFill>
-                  <a:srgbClr val="DDDDDD"/>
-                </a:solidFill>
-              </a:rPr>
-              <a:t>The brief — and why we chose this audience</a:t>
+              <a:rPr sz="1100" b="0" i="0">
+                <a:solidFill>
+                  <a:srgbClr val="AAAAAA"/>
+                </a:solidFill>
+              </a:rPr>
+              <a:t>Raising issues immediately, logging decisions in Trello and meeting minutes — these are professional standards, not student habits.</a:t>
             </a:r>
           </a:p>
         </p:txBody>
@@ -7911,8 +8299,8 @@
         </p:nvSpPr>
         <p:spPr>
           <a:xfrm>
-            <a:off x="457200" y="2331720"/>
-            <a:ext cx="640080" cy="292608"/>
+            <a:off x="457200" y="2697479"/>
+            <a:ext cx="3840480" cy="256032"/>
           </a:xfrm>
           <a:prstGeom prst="rect">
             <a:avLst/>
@@ -7927,12 +8315,12 @@
           <a:p>
             <a:pPr algn="l"/>
             <a:r>
-              <a:rPr sz="1200" b="1" i="0">
+              <a:rPr sz="1300" b="1" i="0">
                 <a:solidFill>
                   <a:srgbClr val="FFCD00"/>
                 </a:solidFill>
               </a:rPr>
-              <a:t>02</a:t>
+              <a:t>Real version control</a:t>
             </a:r>
           </a:p>
         </p:txBody>
@@ -7945,8 +8333,8 @@
         </p:nvSpPr>
         <p:spPr>
           <a:xfrm>
-            <a:off x="1188720" y="2331720"/>
-            <a:ext cx="7680960" cy="292608"/>
+            <a:off x="457200" y="2971799"/>
+            <a:ext cx="8229600" cy="411480"/>
           </a:xfrm>
           <a:prstGeom prst="rect">
             <a:avLst/>
@@ -7961,12 +8349,12 @@
           <a:p>
             <a:pPr algn="l"/>
             <a:r>
-              <a:rPr sz="1200" b="0" i="0">
-                <a:solidFill>
-                  <a:srgbClr val="DDDDDD"/>
-                </a:solidFill>
-              </a:rPr>
-              <a:t>Our team — roles and Belbin framework</a:t>
+              <a:rPr sz="1100" b="0" i="0">
+                <a:solidFill>
+                  <a:srgbClr val="AAAAAA"/>
+                </a:solidFill>
+              </a:rPr>
+              <a:t>Feature branches, no pushing to main without review. We left this project with actual Git workflow experience.</a:t>
             </a:r>
           </a:p>
         </p:txBody>
@@ -7979,8 +8367,8 @@
         </p:nvSpPr>
         <p:spPr>
           <a:xfrm>
-            <a:off x="457200" y="2788920"/>
-            <a:ext cx="640080" cy="292608"/>
+            <a:off x="457200" y="3520439"/>
+            <a:ext cx="3840480" cy="256032"/>
           </a:xfrm>
           <a:prstGeom prst="rect">
             <a:avLst/>
@@ -7995,12 +8383,12 @@
           <a:p>
             <a:pPr algn="l"/>
             <a:r>
-              <a:rPr sz="1200" b="1" i="0">
+              <a:rPr sz="1300" b="1" i="0">
                 <a:solidFill>
                   <a:srgbClr val="FFCD00"/>
                 </a:solidFill>
               </a:rPr>
-              <a:t>03</a:t>
+              <a:t>Agile delivery mindset</a:t>
             </a:r>
           </a:p>
         </p:txBody>
@@ -8013,8 +8401,8 @@
         </p:nvSpPr>
         <p:spPr>
           <a:xfrm>
-            <a:off x="1188720" y="2788920"/>
-            <a:ext cx="7680960" cy="292608"/>
+            <a:off x="457200" y="3794759"/>
+            <a:ext cx="8229600" cy="411480"/>
           </a:xfrm>
           <a:prstGeom prst="rect">
             <a:avLst/>
@@ -8029,12 +8417,12 @@
           <a:p>
             <a:pPr algn="l"/>
             <a:r>
-              <a:rPr sz="1200" b="0" i="0">
-                <a:solidFill>
-                  <a:srgbClr val="DDDDDD"/>
-                </a:solidFill>
-              </a:rPr>
-              <a:t>How we planned, communicated and tracked work</a:t>
+              <a:rPr sz="1100" b="0" i="0">
+                <a:solidFill>
+                  <a:srgbClr val="AAAAAA"/>
+                </a:solidFill>
+              </a:rPr>
+              <a:t>Five sprints with goals, retrospectives, and user testing mirrors how software teams ship in industry.</a:t>
             </a:r>
           </a:p>
         </p:txBody>
@@ -8047,8 +8435,8 @@
         </p:nvSpPr>
         <p:spPr>
           <a:xfrm>
-            <a:off x="457200" y="3246120"/>
-            <a:ext cx="640080" cy="292608"/>
+            <a:off x="457200" y="4343400"/>
+            <a:ext cx="3840480" cy="256032"/>
           </a:xfrm>
           <a:prstGeom prst="rect">
             <a:avLst/>
@@ -8063,12 +8451,12 @@
           <a:p>
             <a:pPr algn="l"/>
             <a:r>
-              <a:rPr sz="1200" b="1" i="0">
+              <a:rPr sz="1300" b="1" i="0">
                 <a:solidFill>
                   <a:srgbClr val="FFCD00"/>
                 </a:solidFill>
               </a:rPr>
-              <a:t>04</a:t>
+              <a:t>Resilience under pressure</a:t>
             </a:r>
           </a:p>
         </p:txBody>
@@ -8081,8 +8469,8 @@
         </p:nvSpPr>
         <p:spPr>
           <a:xfrm>
-            <a:off x="1188720" y="3246120"/>
-            <a:ext cx="7680960" cy="292608"/>
+            <a:off x="457200" y="4617720"/>
+            <a:ext cx="8229600" cy="411480"/>
           </a:xfrm>
           <a:prstGeom prst="rect">
             <a:avLst/>
@@ -8097,148 +8485,12 @@
           <a:p>
             <a:pPr algn="l"/>
             <a:r>
-              <a:rPr sz="1200" b="0" i="0">
-                <a:solidFill>
-                  <a:srgbClr val="DDDDDD"/>
-                </a:solidFill>
-              </a:rPr>
-              <a:t>Our delivery — 5 sprints and what each taught us</a:t>
-            </a:r>
-          </a:p>
-        </p:txBody>
-      </p:sp>
-      <p:sp>
-        <p:nvSpPr>
-          <p:cNvPr id="13" name="TextBox 12"/>
-          <p:cNvSpPr txBox="1"/>
-          <p:nvPr/>
-        </p:nvSpPr>
-        <p:spPr>
-          <a:xfrm>
-            <a:off x="457200" y="3703320"/>
-            <a:ext cx="640080" cy="292608"/>
-          </a:xfrm>
-          <a:prstGeom prst="rect">
-            <a:avLst/>
-          </a:prstGeom>
-          <a:noFill/>
-        </p:spPr>
-        <p:txBody>
-          <a:bodyPr wrap="square">
-            <a:spAutoFit/>
-          </a:bodyPr>
-          <a:lstStyle/>
-          <a:p>
-            <a:pPr algn="l"/>
-            <a:r>
-              <a:rPr sz="1200" b="1" i="0">
-                <a:solidFill>
-                  <a:srgbClr val="FFCD00"/>
-                </a:solidFill>
-              </a:rPr>
-              <a:t>05</a:t>
-            </a:r>
-          </a:p>
-        </p:txBody>
-      </p:sp>
-      <p:sp>
-        <p:nvSpPr>
-          <p:cNvPr id="14" name="TextBox 13"/>
-          <p:cNvSpPr txBox="1"/>
-          <p:nvPr/>
-        </p:nvSpPr>
-        <p:spPr>
-          <a:xfrm>
-            <a:off x="1188720" y="3703320"/>
-            <a:ext cx="7680960" cy="292608"/>
-          </a:xfrm>
-          <a:prstGeom prst="rect">
-            <a:avLst/>
-          </a:prstGeom>
-          <a:noFill/>
-        </p:spPr>
-        <p:txBody>
-          <a:bodyPr wrap="square">
-            <a:spAutoFit/>
-          </a:bodyPr>
-          <a:lstStyle/>
-          <a:p>
-            <a:pPr algn="l"/>
-            <a:r>
-              <a:rPr sz="1200" b="0" i="0">
-                <a:solidFill>
-                  <a:srgbClr val="DDDDDD"/>
-                </a:solidFill>
-              </a:rPr>
-              <a:t>The product — a live, playable prototype</a:t>
-            </a:r>
-          </a:p>
-        </p:txBody>
-      </p:sp>
-      <p:sp>
-        <p:nvSpPr>
-          <p:cNvPr id="15" name="TextBox 14"/>
-          <p:cNvSpPr txBox="1"/>
-          <p:nvPr/>
-        </p:nvSpPr>
-        <p:spPr>
-          <a:xfrm>
-            <a:off x="457200" y="4160520"/>
-            <a:ext cx="640080" cy="292608"/>
-          </a:xfrm>
-          <a:prstGeom prst="rect">
-            <a:avLst/>
-          </a:prstGeom>
-          <a:noFill/>
-        </p:spPr>
-        <p:txBody>
-          <a:bodyPr wrap="square">
-            <a:spAutoFit/>
-          </a:bodyPr>
-          <a:lstStyle/>
-          <a:p>
-            <a:pPr algn="l"/>
-            <a:r>
-              <a:rPr sz="1200" b="1" i="0">
-                <a:solidFill>
-                  <a:srgbClr val="FFCD00"/>
-                </a:solidFill>
-              </a:rPr>
-              <a:t>06</a:t>
-            </a:r>
-          </a:p>
-        </p:txBody>
-      </p:sp>
-      <p:sp>
-        <p:nvSpPr>
-          <p:cNvPr id="16" name="TextBox 15"/>
-          <p:cNvSpPr txBox="1"/>
-          <p:nvPr/>
-        </p:nvSpPr>
-        <p:spPr>
-          <a:xfrm>
-            <a:off x="1188720" y="4160520"/>
-            <a:ext cx="7680960" cy="292608"/>
-          </a:xfrm>
-          <a:prstGeom prst="rect">
-            <a:avLst/>
-          </a:prstGeom>
-          <a:noFill/>
-        </p:spPr>
-        <p:txBody>
-          <a:bodyPr wrap="square">
-            <a:spAutoFit/>
-          </a:bodyPr>
-          <a:lstStyle/>
-          <a:p>
-            <a:pPr algn="l"/>
-            <a:r>
-              <a:rPr sz="1200" b="0" i="0">
-                <a:solidFill>
-                  <a:srgbClr val="DDDDDD"/>
-                </a:solidFill>
-              </a:rPr>
-              <a:t>What we learned — and how it shapes our careers</a:t>
+              <a:rPr sz="1100" b="0" i="0">
+                <a:solidFill>
+                  <a:srgbClr val="AAAAAA"/>
+                </a:solidFill>
+              </a:rPr>
+              <a:t>When the game broke 2 weeks before submission, we diagnosed and fixed it in one day — as a team. That experience is irreplaceable.</a:t>
             </a:r>
           </a:p>
         </p:txBody>
@@ -8251,7 +8503,7 @@
 </p:sld>
 </file>
 
-<file path=ppt/slides/slide20.xml><?xml version="1.0" encoding="utf-8"?>
+<file path=ppt/slides/slide21.xml><?xml version="1.0" encoding="utf-8"?>
 <p:sld xmlns:a="http://schemas.openxmlformats.org/drawingml/2006/main" xmlns:r="http://schemas.openxmlformats.org/officeDocument/2006/relationships" xmlns:p="http://schemas.openxmlformats.org/presentationml/2006/main">
   <p:cSld name="Slide 18">
     <p:bg>
@@ -8457,6 +8709,261 @@
 
 <file path=ppt/slides/slide3.xml><?xml version="1.0" encoding="utf-8"?>
 <p:sld xmlns:a="http://schemas.openxmlformats.org/drawingml/2006/main" xmlns:r="http://schemas.openxmlformats.org/officeDocument/2006/relationships" xmlns:p="http://schemas.openxmlformats.org/presentationml/2006/main">
+  <p:cSld name="Slide 2">
+    <p:bg>
+      <p:bgPr>
+        <a:solidFill>
+          <a:srgbClr val="0D0D0D"/>
+        </a:solidFill>
+        <a:effectLst/>
+      </p:bgPr>
+    </p:bg>
+    <p:spTree>
+      <p:nvGrpSpPr>
+        <p:cNvPr id="1" name=""/>
+        <p:cNvGrpSpPr/>
+        <p:nvPr/>
+      </p:nvGrpSpPr>
+      <p:grpSpPr>
+        <a:xfrm>
+          <a:off x="0" y="0"/>
+          <a:ext cx="0" cy="0"/>
+          <a:chOff x="0" y="0"/>
+          <a:chExt cx="0" cy="0"/>
+        </a:xfrm>
+      </p:grpSpPr>
+      <p:sp>
+        <p:nvSpPr>
+          <p:cNvPr id="2" name="Shape 0"/>
+          <p:cNvSpPr/>
+          <p:nvPr/>
+        </p:nvSpPr>
+        <p:spPr>
+          <a:xfrm>
+            <a:off x="8458200" y="201168"/>
+            <a:ext cx="256032" cy="256032"/>
+          </a:xfrm>
+          <a:prstGeom prst="ellipse">
+            <a:avLst/>
+          </a:prstGeom>
+          <a:solidFill>
+            <a:srgbClr val="FFCD00"/>
+          </a:solidFill>
+          <a:ln/>
+        </p:spPr>
+        <p:txBody>
+          <a:bodyPr/>
+          <a:lstStyle/>
+          <a:p>
+            <a:endParaRPr lang="en-GB"/>
+          </a:p>
+        </p:txBody>
+      </p:sp>
+      <p:sp>
+        <p:nvSpPr>
+          <p:cNvPr id="3" name="Text 1"/>
+          <p:cNvSpPr/>
+          <p:nvPr/>
+        </p:nvSpPr>
+        <p:spPr>
+          <a:xfrm>
+            <a:off x="457200" y="274320"/>
+            <a:ext cx="6400800" cy="228600"/>
+          </a:xfrm>
+          <a:prstGeom prst="rect">
+            <a:avLst/>
+          </a:prstGeom>
+          <a:noFill/>
+          <a:ln/>
+        </p:spPr>
+        <p:txBody>
+          <a:bodyPr wrap="square" rtlCol="0" anchor="ctr"/>
+          <a:lstStyle/>
+          <a:p>
+            <a:pPr marL="0" indent="0">
+              <a:buNone/>
+            </a:pPr>
+            <a:r>
+              <a:rPr lang="en-US" sz="1000" b="1" kern="0" spc="200" dirty="0">
+                <a:solidFill>
+                  <a:srgbClr val="555555"/>
+                </a:solidFill>
+                <a:latin typeface="Arial" pitchFamily="34" charset="0"/>
+                <a:ea typeface="Arial" pitchFamily="34" charset="-122"/>
+                <a:cs typeface="Arial" pitchFamily="34" charset="-120"/>
+              </a:rPr>
+              <a:t>THE BRIEF</a:t>
+            </a:r>
+            <a:endParaRPr lang="en-US" sz="1000" dirty="0"/>
+          </a:p>
+        </p:txBody>
+      </p:sp>
+      <p:sp>
+        <p:nvSpPr>
+          <p:cNvPr id="4" name="Text 2"/>
+          <p:cNvSpPr/>
+          <p:nvPr/>
+        </p:nvSpPr>
+        <p:spPr>
+          <a:xfrm>
+            <a:off x="3657600" y="4919472"/>
+            <a:ext cx="5212080" cy="182880"/>
+          </a:xfrm>
+          <a:prstGeom prst="rect">
+            <a:avLst/>
+          </a:prstGeom>
+          <a:noFill/>
+          <a:ln/>
+        </p:spPr>
+        <p:txBody>
+          <a:bodyPr wrap="square" rtlCol="0" anchor="ctr"/>
+          <a:lstStyle/>
+          <a:p>
+            <a:pPr marL="0" indent="0" algn="r">
+              <a:buNone/>
+            </a:pPr>
+            <a:r>
+              <a:rPr lang="en-US" sz="900" dirty="0">
+                <a:solidFill>
+                  <a:srgbClr val="555555"/>
+                </a:solidFill>
+                <a:latin typeface="Arial" pitchFamily="34" charset="0"/>
+                <a:ea typeface="Arial" pitchFamily="34" charset="-122"/>
+                <a:cs typeface="Arial" pitchFamily="34" charset="-120"/>
+              </a:rPr>
+              <a:t>NINJA QUIZ  ·  503IT  ·  02 / 18</a:t>
+            </a:r>
+            <a:endParaRPr lang="en-US" sz="900" dirty="0"/>
+          </a:p>
+        </p:txBody>
+      </p:sp>
+      <p:sp>
+        <p:nvSpPr>
+          <p:cNvPr id="5" name="Text 3"/>
+          <p:cNvSpPr/>
+          <p:nvPr/>
+        </p:nvSpPr>
+        <p:spPr>
+          <a:xfrm>
+            <a:off x="457200" y="822960"/>
+            <a:ext cx="8229600" cy="2438400"/>
+          </a:xfrm>
+          <a:prstGeom prst="rect">
+            <a:avLst/>
+          </a:prstGeom>
+          <a:noFill/>
+          <a:ln/>
+        </p:spPr>
+        <p:txBody>
+          <a:bodyPr wrap="square" rtlCol="0" anchor="ctr"/>
+          <a:lstStyle/>
+          <a:p>
+            <a:pPr marL="0" indent="0">
+              <a:buNone/>
+            </a:pPr>
+            <a:r>
+              <a:rPr lang="en-US" sz="9600" b="1" dirty="0">
+                <a:solidFill>
+                  <a:srgbClr val="FFCD00"/>
+                </a:solidFill>
+                <a:latin typeface="Arial Black" pitchFamily="34" charset="0"/>
+                <a:ea typeface="Arial Black" pitchFamily="34" charset="-122"/>
+                <a:cs typeface="Arial Black" pitchFamily="34" charset="-120"/>
+              </a:rPr>
+              <a:t>1 in 3</a:t>
+            </a:r>
+            <a:endParaRPr lang="en-US" sz="9600" dirty="0"/>
+          </a:p>
+        </p:txBody>
+      </p:sp>
+      <p:sp>
+        <p:nvSpPr>
+          <p:cNvPr id="6" name="Text 4"/>
+          <p:cNvSpPr/>
+          <p:nvPr/>
+        </p:nvSpPr>
+        <p:spPr>
+          <a:xfrm>
+            <a:off x="457200" y="2468880"/>
+            <a:ext cx="7772400" cy="320040"/>
+          </a:xfrm>
+          <a:prstGeom prst="rect">
+            <a:avLst/>
+          </a:prstGeom>
+          <a:noFill/>
+          <a:ln/>
+        </p:spPr>
+        <p:txBody>
+          <a:bodyPr wrap="square" rtlCol="0" anchor="ctr"/>
+          <a:lstStyle/>
+          <a:p>
+            <a:pPr marL="0" indent="0">
+              <a:buNone/>
+            </a:pPr>
+            <a:r>
+              <a:rPr lang="en-US" sz="1400" dirty="0">
+                <a:solidFill>
+                  <a:srgbClr val="555555"/>
+                </a:solidFill>
+                <a:latin typeface="Arial" pitchFamily="34" charset="0"/>
+                <a:ea typeface="Arial" pitchFamily="34" charset="-122"/>
+                <a:cs typeface="Arial" pitchFamily="34" charset="-120"/>
+              </a:rPr>
+              <a:t>children have already faced an online risk.</a:t>
+            </a:r>
+            <a:endParaRPr lang="en-US" sz="1400" dirty="0"/>
+          </a:p>
+        </p:txBody>
+      </p:sp>
+      <p:sp>
+        <p:nvSpPr>
+          <p:cNvPr id="7" name="Text 5"/>
+          <p:cNvSpPr/>
+          <p:nvPr/>
+        </p:nvSpPr>
+        <p:spPr>
+          <a:xfrm>
+            <a:off x="457200" y="2926080"/>
+            <a:ext cx="7772400" cy="320040"/>
+          </a:xfrm>
+          <a:prstGeom prst="rect">
+            <a:avLst/>
+          </a:prstGeom>
+          <a:noFill/>
+          <a:ln/>
+        </p:spPr>
+        <p:txBody>
+          <a:bodyPr wrap="square" rtlCol="0" anchor="ctr"/>
+          <a:lstStyle/>
+          <a:p>
+            <a:pPr marL="0" indent="0">
+              <a:buNone/>
+            </a:pPr>
+            <a:r>
+              <a:rPr lang="en-US" sz="1400" dirty="0">
+                <a:solidFill>
+                  <a:srgbClr val="555555"/>
+                </a:solidFill>
+                <a:latin typeface="Arial" pitchFamily="34" charset="0"/>
+                <a:ea typeface="Arial" pitchFamily="34" charset="-122"/>
+                <a:cs typeface="Arial" pitchFamily="34" charset="-120"/>
+              </a:rPr>
+              <a:t>The brief: build a game that actually teaches them to stay safe.</a:t>
+            </a:r>
+            <a:endParaRPr lang="en-US" sz="1400" dirty="0"/>
+          </a:p>
+        </p:txBody>
+      </p:sp>
+    </p:spTree>
+  </p:cSld>
+  <p:clrMapOvr>
+    <a:masterClrMapping/>
+  </p:clrMapOvr>
+</p:sld>
+</file>
+
+<file path=ppt/slides/slide4.xml><?xml version="1.0" encoding="utf-8"?>
+<p:sld xmlns:a="http://schemas.openxmlformats.org/drawingml/2006/main" xmlns:r="http://schemas.openxmlformats.org/officeDocument/2006/relationships" xmlns:p="http://schemas.openxmlformats.org/presentationml/2006/main">
   <p:cSld name="Slide 3">
     <p:bg>
       <p:bgPr>
@@ -8660,7 +9167,7 @@
 </p:sld>
 </file>
 
-<file path=ppt/slides/slide4.xml><?xml version="1.0" encoding="utf-8"?>
+<file path=ppt/slides/slide5.xml><?xml version="1.0" encoding="utf-8"?>
 <p:sld xmlns:a="http://schemas.openxmlformats.org/drawingml/2006/main" xmlns:r="http://schemas.openxmlformats.org/officeDocument/2006/relationships" xmlns:p="http://schemas.openxmlformats.org/presentationml/2006/main">
   <p:cSld name="Slide 4">
     <p:bg>
@@ -9459,7 +9966,7 @@
 </p:sld>
 </file>
 
-<file path=ppt/slides/slide5.xml><?xml version="1.0" encoding="utf-8"?>
+<file path=ppt/slides/slide6.xml><?xml version="1.0" encoding="utf-8"?>
 <p:sld xmlns:a="http://schemas.openxmlformats.org/drawingml/2006/main" xmlns:r="http://schemas.openxmlformats.org/officeDocument/2006/relationships" xmlns:p="http://schemas.openxmlformats.org/presentationml/2006/main">
   <p:cSld name="Slide 5">
     <p:bg>
@@ -9486,6 +9993,33 @@
       </p:grpSpPr>
       <p:sp>
         <p:nvSpPr>
+          <p:cNvPr id="2" name="Shape 0"/>
+          <p:cNvSpPr/>
+          <p:nvPr/>
+        </p:nvSpPr>
+        <p:spPr>
+          <a:xfrm>
+            <a:off x="8458200" y="201168"/>
+            <a:ext cx="256032" cy="256032"/>
+          </a:xfrm>
+          <a:prstGeom prst="ellipse">
+            <a:avLst/>
+          </a:prstGeom>
+          <a:solidFill>
+            <a:srgbClr val="FFCD00"/>
+          </a:solidFill>
+          <a:ln/>
+        </p:spPr>
+        <p:txBody>
+          <a:bodyPr/>
+          <a:lstStyle/>
+          <a:p>
+            <a:endParaRPr lang="en-GB"/>
+          </a:p>
+        </p:txBody>
+      </p:sp>
+      <p:sp>
+        <p:nvSpPr>
           <p:cNvPr id="3" name="Text 1"/>
           <p:cNvSpPr/>
           <p:nvPr/>
@@ -9659,7 +10193,7 @@
 </p:sld>
 </file>
 
-<file path=ppt/slides/slide6.xml><?xml version="1.0" encoding="utf-8"?>
+<file path=ppt/slides/slide7.xml><?xml version="1.0" encoding="utf-8"?>
 <p:sld xmlns:a="http://schemas.openxmlformats.org/drawingml/2006/main" xmlns:r="http://schemas.openxmlformats.org/officeDocument/2006/relationships" xmlns:p="http://schemas.openxmlformats.org/presentationml/2006/main">
   <p:cSld name="Slide 6">
     <p:bg>
@@ -10283,7 +10817,7 @@
 </p:sld>
 </file>
 
-<file path=ppt/slides/slide7.xml><?xml version="1.0" encoding="utf-8"?>
+<file path=ppt/slides/slide8.xml><?xml version="1.0" encoding="utf-8"?>
 <p:sld xmlns:a="http://schemas.openxmlformats.org/drawingml/2006/main" xmlns:r="http://schemas.openxmlformats.org/officeDocument/2006/relationships" xmlns:p="http://schemas.openxmlformats.org/presentationml/2006/main">
   <p:cSld name="Slide 7">
     <p:bg>
@@ -10583,7 +11117,7 @@
         <p:spPr>
           <a:xfrm>
             <a:off x="457200" y="3218688"/>
-            <a:ext cx="4114800" cy="502920"/>
+            <a:ext cx="640080" cy="502920"/>
           </a:xfrm>
           <a:prstGeom prst="rect">
             <a:avLst/>
@@ -10661,7 +11195,7 @@
         <p:spPr>
           <a:xfrm>
             <a:off x="457200" y="3877056"/>
-            <a:ext cx="4114800" cy="502920"/>
+            <a:ext cx="640080" cy="502920"/>
           </a:xfrm>
           <a:prstGeom prst="rect">
             <a:avLst/>
@@ -10732,22 +11266,22 @@
       </p:sp>
       <p:pic>
         <p:nvPicPr>
-          <p:cNvPr id="13" name="Picture 12" descr="image.jpg"/>
+          <p:cNvPr id="13" name="Picture 12" descr="team live meeting.jpeg"/>
           <p:cNvPicPr>
             <a:picLocks noChangeAspect="1"/>
           </p:cNvPicPr>
           <p:nvPr/>
         </p:nvPicPr>
         <p:blipFill>
-          <a:blip r:embed="rId4"/>
+          <a:blip r:embed="rId3"/>
           <a:stretch>
             <a:fillRect/>
           </a:stretch>
         </p:blipFill>
         <p:spPr>
           <a:xfrm>
-            <a:off x="4663440" y="1417320"/>
-            <a:ext cx="4206240" cy="3291840"/>
+            <a:off x="4572000" y="731520"/>
+            <a:ext cx="4389120" cy="4023360"/>
           </a:xfrm>
           <a:prstGeom prst="rect">
             <a:avLst/>
@@ -10762,7 +11296,7 @@
 </p:sld>
 </file>
 
-<file path=ppt/slides/slide8.xml><?xml version="1.0" encoding="utf-8"?>
+<file path=ppt/slides/slide9.xml><?xml version="1.0" encoding="utf-8"?>
 <p:sld xmlns:a="http://schemas.openxmlformats.org/drawingml/2006/main" xmlns:r="http://schemas.openxmlformats.org/officeDocument/2006/relationships" xmlns:p="http://schemas.openxmlformats.org/presentationml/2006/main">
   <p:cSld name="Slide 8">
     <p:bg>
@@ -11510,805 +12044,6 @@
               <a:t>Everyone had a vote</a:t>
             </a:r>
             <a:endParaRPr lang="en-US" sz="1400" dirty="0"/>
-          </a:p>
-        </p:txBody>
-      </p:sp>
-    </p:spTree>
-  </p:cSld>
-  <p:clrMapOvr>
-    <a:masterClrMapping/>
-  </p:clrMapOvr>
-</p:sld>
-</file>
-
-<file path=ppt/slides/slide9.xml><?xml version="1.0" encoding="utf-8"?>
-<p:sld xmlns:a="http://schemas.openxmlformats.org/drawingml/2006/main" xmlns:r="http://schemas.openxmlformats.org/officeDocument/2006/relationships" xmlns:p="http://schemas.openxmlformats.org/presentationml/2006/main">
-  <p:cSld name="Slide 9">
-    <p:bg>
-      <p:bgPr>
-        <a:solidFill>
-          <a:srgbClr val="FFFFFF"/>
-        </a:solidFill>
-        <a:effectLst/>
-      </p:bgPr>
-    </p:bg>
-    <p:spTree>
-      <p:nvGrpSpPr>
-        <p:cNvPr id="1" name=""/>
-        <p:cNvGrpSpPr/>
-        <p:nvPr/>
-      </p:nvGrpSpPr>
-      <p:grpSpPr>
-        <a:xfrm>
-          <a:off x="0" y="0"/>
-          <a:ext cx="0" cy="0"/>
-          <a:chOff x="0" y="0"/>
-          <a:chExt cx="0" cy="0"/>
-        </a:xfrm>
-      </p:grpSpPr>
-      <p:sp>
-        <p:nvSpPr>
-          <p:cNvPr id="2" name="Shape 0"/>
-          <p:cNvSpPr/>
-          <p:nvPr/>
-        </p:nvSpPr>
-        <p:spPr>
-          <a:xfrm>
-            <a:off x="8458200" y="201168"/>
-            <a:ext cx="256032" cy="256032"/>
-          </a:xfrm>
-          <a:prstGeom prst="ellipse">
-            <a:avLst/>
-          </a:prstGeom>
-          <a:solidFill>
-            <a:srgbClr val="DDDDDD"/>
-          </a:solidFill>
-          <a:ln/>
-        </p:spPr>
-        <p:txBody>
-          <a:bodyPr/>
-          <a:lstStyle/>
-          <a:p>
-            <a:endParaRPr lang="en-GB"/>
-          </a:p>
-        </p:txBody>
-      </p:sp>
-      <p:sp>
-        <p:nvSpPr>
-          <p:cNvPr id="3" name="Text 1"/>
-          <p:cNvSpPr/>
-          <p:nvPr/>
-        </p:nvSpPr>
-        <p:spPr>
-          <a:xfrm>
-            <a:off x="457200" y="274320"/>
-            <a:ext cx="6400800" cy="228600"/>
-          </a:xfrm>
-          <a:prstGeom prst="rect">
-            <a:avLst/>
-          </a:prstGeom>
-          <a:noFill/>
-          <a:ln/>
-        </p:spPr>
-        <p:txBody>
-          <a:bodyPr wrap="square" rtlCol="0" anchor="ctr"/>
-          <a:lstStyle/>
-          <a:p>
-            <a:pPr marL="0" indent="0">
-              <a:buNone/>
-            </a:pPr>
-            <a:r>
-              <a:rPr lang="en-US" sz="1000" b="1" kern="0" spc="200" dirty="0">
-                <a:solidFill>
-                  <a:srgbClr val="888888"/>
-                </a:solidFill>
-                <a:latin typeface="Arial" pitchFamily="34" charset="0"/>
-                <a:ea typeface="Arial" pitchFamily="34" charset="-122"/>
-                <a:cs typeface="Arial" pitchFamily="34" charset="-120"/>
-              </a:rPr>
-              <a:t>DELIVERY PROCESS</a:t>
-            </a:r>
-            <a:endParaRPr lang="en-US" sz="1000" dirty="0"/>
-          </a:p>
-        </p:txBody>
-      </p:sp>
-      <p:sp>
-        <p:nvSpPr>
-          <p:cNvPr id="4" name="Text 2"/>
-          <p:cNvSpPr/>
-          <p:nvPr/>
-        </p:nvSpPr>
-        <p:spPr>
-          <a:xfrm>
-            <a:off x="3657600" y="4919472"/>
-            <a:ext cx="5212080" cy="182880"/>
-          </a:xfrm>
-          <a:prstGeom prst="rect">
-            <a:avLst/>
-          </a:prstGeom>
-          <a:noFill/>
-          <a:ln/>
-        </p:spPr>
-        <p:txBody>
-          <a:bodyPr wrap="square" rtlCol="0" anchor="ctr"/>
-          <a:lstStyle/>
-          <a:p>
-            <a:pPr marL="0" indent="0" algn="r">
-              <a:buNone/>
-            </a:pPr>
-            <a:r>
-              <a:rPr lang="en-US" sz="900" dirty="0">
-                <a:solidFill>
-                  <a:srgbClr val="888888"/>
-                </a:solidFill>
-                <a:latin typeface="Arial" pitchFamily="34" charset="0"/>
-                <a:ea typeface="Arial" pitchFamily="34" charset="-122"/>
-                <a:cs typeface="Arial" pitchFamily="34" charset="-120"/>
-              </a:rPr>
-              <a:t>NINJA QUIZ  ·  503IT  ·  09 / 18</a:t>
-            </a:r>
-            <a:endParaRPr lang="en-US" sz="900" dirty="0"/>
-          </a:p>
-        </p:txBody>
-      </p:sp>
-      <p:sp>
-        <p:nvSpPr>
-          <p:cNvPr id="5" name="Text 3"/>
-          <p:cNvSpPr/>
-          <p:nvPr/>
-        </p:nvSpPr>
-        <p:spPr>
-          <a:xfrm>
-            <a:off x="457200" y="685800"/>
-            <a:ext cx="8229600" cy="812800"/>
-          </a:xfrm>
-          <a:prstGeom prst="rect">
-            <a:avLst/>
-          </a:prstGeom>
-          <a:noFill/>
-          <a:ln/>
-        </p:spPr>
-        <p:txBody>
-          <a:bodyPr wrap="square" rtlCol="0" anchor="ctr"/>
-          <a:lstStyle/>
-          <a:p>
-            <a:pPr marL="0" indent="0">
-              <a:buNone/>
-            </a:pPr>
-            <a:r>
-              <a:rPr lang="en-US" sz="3200" b="1" dirty="0">
-                <a:solidFill>
-                  <a:srgbClr val="111111"/>
-                </a:solidFill>
-                <a:latin typeface="Arial Black" pitchFamily="34" charset="0"/>
-                <a:ea typeface="Arial Black" pitchFamily="34" charset="-122"/>
-                <a:cs typeface="Arial Black" pitchFamily="34" charset="-120"/>
-              </a:rPr>
-              <a:t>Built in five sprints.</a:t>
-            </a:r>
-            <a:endParaRPr lang="en-US" sz="3200" dirty="0"/>
-          </a:p>
-        </p:txBody>
-      </p:sp>
-      <p:sp>
-        <p:nvSpPr>
-          <p:cNvPr id="6" name="Shape 4"/>
-          <p:cNvSpPr/>
-          <p:nvPr/>
-        </p:nvSpPr>
-        <p:spPr>
-          <a:xfrm>
-            <a:off x="457200" y="1463040"/>
-            <a:ext cx="8229600" cy="10973"/>
-          </a:xfrm>
-          <a:prstGeom prst="rect">
-            <a:avLst/>
-          </a:prstGeom>
-          <a:solidFill>
-            <a:srgbClr val="EEEEEE"/>
-          </a:solidFill>
-          <a:ln/>
-        </p:spPr>
-        <p:txBody>
-          <a:bodyPr/>
-          <a:lstStyle/>
-          <a:p>
-            <a:endParaRPr lang="en-GB"/>
-          </a:p>
-        </p:txBody>
-      </p:sp>
-      <p:sp>
-        <p:nvSpPr>
-          <p:cNvPr id="7" name="Text 5"/>
-          <p:cNvSpPr/>
-          <p:nvPr/>
-        </p:nvSpPr>
-        <p:spPr>
-          <a:xfrm>
-            <a:off x="457200" y="1609344"/>
-            <a:ext cx="868680" cy="411480"/>
-          </a:xfrm>
-          <a:prstGeom prst="rect">
-            <a:avLst/>
-          </a:prstGeom>
-          <a:noFill/>
-          <a:ln/>
-        </p:spPr>
-        <p:txBody>
-          <a:bodyPr wrap="square" rtlCol="0" anchor="ctr">
-            <a:normAutofit/>
-          </a:bodyPr>
-          <a:lstStyle/>
-          <a:p>
-            <a:pPr marL="0" indent="0">
-              <a:buNone/>
-            </a:pPr>
-            <a:r>
-              <a:rPr lang="en-US" sz="2000" b="1" dirty="0">
-                <a:solidFill>
-                  <a:srgbClr val="FFCD00"/>
-                </a:solidFill>
-                <a:latin typeface="Arial Black" pitchFamily="34" charset="0"/>
-                <a:ea typeface="Arial Black" pitchFamily="34" charset="-122"/>
-                <a:cs typeface="Arial Black" pitchFamily="34" charset="-120"/>
-              </a:rPr>
-              <a:t>01</a:t>
-            </a:r>
-            <a:endParaRPr lang="en-US" sz="2000" dirty="0"/>
-          </a:p>
-        </p:txBody>
-      </p:sp>
-      <p:sp>
-        <p:nvSpPr>
-          <p:cNvPr id="8" name="Text 6"/>
-          <p:cNvSpPr/>
-          <p:nvPr/>
-        </p:nvSpPr>
-        <p:spPr>
-          <a:xfrm>
-            <a:off x="1371600" y="1591056"/>
-            <a:ext cx="7315200" cy="292608"/>
-          </a:xfrm>
-          <a:prstGeom prst="rect">
-            <a:avLst/>
-          </a:prstGeom>
-          <a:noFill/>
-          <a:ln/>
-        </p:spPr>
-        <p:txBody>
-          <a:bodyPr wrap="square" rtlCol="0" anchor="ctr"/>
-          <a:lstStyle/>
-          <a:p>
-            <a:pPr marL="0" indent="0">
-              <a:buNone/>
-            </a:pPr>
-            <a:r>
-              <a:rPr lang="en-US" sz="1700" b="1" dirty="0">
-                <a:solidFill>
-                  <a:srgbClr val="111111"/>
-                </a:solidFill>
-                <a:latin typeface="Arial Black" pitchFamily="34" charset="0"/>
-                <a:ea typeface="Arial Black" pitchFamily="34" charset="-122"/>
-                <a:cs typeface="Arial Black" pitchFamily="34" charset="-120"/>
-              </a:rPr>
-              <a:t>Sprint 1  —  Login &amp; menu</a:t>
-            </a:r>
-            <a:endParaRPr lang="en-US" sz="1700" dirty="0"/>
-          </a:p>
-        </p:txBody>
-      </p:sp>
-      <p:sp>
-        <p:nvSpPr>
-          <p:cNvPr id="9" name="Text 7"/>
-          <p:cNvSpPr/>
-          <p:nvPr/>
-        </p:nvSpPr>
-        <p:spPr>
-          <a:xfrm>
-            <a:off x="1371600" y="1892808"/>
-            <a:ext cx="7315200" cy="228600"/>
-          </a:xfrm>
-          <a:prstGeom prst="rect">
-            <a:avLst/>
-          </a:prstGeom>
-          <a:noFill/>
-          <a:ln/>
-        </p:spPr>
-        <p:txBody>
-          <a:bodyPr wrap="square" rtlCol="0" anchor="ctr"/>
-          <a:lstStyle/>
-          <a:p>
-            <a:pPr marL="0" indent="0">
-              <a:buNone/>
-            </a:pPr>
-            <a:r>
-              <a:rPr lang="en-US" sz="1200" dirty="0">
-                <a:solidFill>
-                  <a:srgbClr val="888888"/>
-                </a:solidFill>
-                <a:latin typeface="Arial" pitchFamily="34" charset="0"/>
-                <a:ea typeface="Arial" pitchFamily="34" charset="-122"/>
-                <a:cs typeface="Arial" pitchFamily="34" charset="-120"/>
-              </a:rPr>
-              <a:t>Foundation. Every member set up. GitHub branches created.</a:t>
-            </a:r>
-            <a:endParaRPr lang="en-US" sz="1200" dirty="0"/>
-          </a:p>
-        </p:txBody>
-      </p:sp>
-      <p:sp>
-        <p:nvSpPr>
-          <p:cNvPr id="10" name="Text 8"/>
-          <p:cNvSpPr/>
-          <p:nvPr/>
-        </p:nvSpPr>
-        <p:spPr>
-          <a:xfrm>
-            <a:off x="457200" y="2231136"/>
-            <a:ext cx="868680" cy="411480"/>
-          </a:xfrm>
-          <a:prstGeom prst="rect">
-            <a:avLst/>
-          </a:prstGeom>
-          <a:noFill/>
-          <a:ln/>
-        </p:spPr>
-        <p:txBody>
-          <a:bodyPr wrap="square" rtlCol="0" anchor="ctr">
-            <a:normAutofit/>
-          </a:bodyPr>
-          <a:lstStyle/>
-          <a:p>
-            <a:pPr marL="0" indent="0">
-              <a:buNone/>
-            </a:pPr>
-            <a:r>
-              <a:rPr lang="en-US" sz="2000" b="1" dirty="0">
-                <a:solidFill>
-                  <a:srgbClr val="FFCD00"/>
-                </a:solidFill>
-                <a:latin typeface="Arial Black" pitchFamily="34" charset="0"/>
-                <a:ea typeface="Arial Black" pitchFamily="34" charset="-122"/>
-                <a:cs typeface="Arial Black" pitchFamily="34" charset="-120"/>
-              </a:rPr>
-              <a:t>02</a:t>
-            </a:r>
-            <a:endParaRPr lang="en-US" sz="2000" dirty="0"/>
-          </a:p>
-        </p:txBody>
-      </p:sp>
-      <p:sp>
-        <p:nvSpPr>
-          <p:cNvPr id="11" name="Text 9"/>
-          <p:cNvSpPr/>
-          <p:nvPr/>
-        </p:nvSpPr>
-        <p:spPr>
-          <a:xfrm>
-            <a:off x="1371600" y="2212848"/>
-            <a:ext cx="7315200" cy="292608"/>
-          </a:xfrm>
-          <a:prstGeom prst="rect">
-            <a:avLst/>
-          </a:prstGeom>
-          <a:noFill/>
-          <a:ln/>
-        </p:spPr>
-        <p:txBody>
-          <a:bodyPr wrap="square" rtlCol="0" anchor="ctr"/>
-          <a:lstStyle/>
-          <a:p>
-            <a:pPr marL="0" indent="0">
-              <a:buNone/>
-            </a:pPr>
-            <a:r>
-              <a:rPr lang="en-US" sz="1700" b="1" dirty="0">
-                <a:solidFill>
-                  <a:srgbClr val="111111"/>
-                </a:solidFill>
-                <a:latin typeface="Arial Black" pitchFamily="34" charset="0"/>
-                <a:ea typeface="Arial Black" pitchFamily="34" charset="-122"/>
-                <a:cs typeface="Arial Black" pitchFamily="34" charset="-120"/>
-              </a:rPr>
-              <a:t>Sprint 2  —  Game engine</a:t>
-            </a:r>
-            <a:endParaRPr lang="en-US" sz="1700" dirty="0"/>
-          </a:p>
-        </p:txBody>
-      </p:sp>
-      <p:sp>
-        <p:nvSpPr>
-          <p:cNvPr id="12" name="Text 10"/>
-          <p:cNvSpPr/>
-          <p:nvPr/>
-        </p:nvSpPr>
-        <p:spPr>
-          <a:xfrm>
-            <a:off x="1371600" y="2514600"/>
-            <a:ext cx="7315200" cy="228600"/>
-          </a:xfrm>
-          <a:prstGeom prst="rect">
-            <a:avLst/>
-          </a:prstGeom>
-          <a:noFill/>
-          <a:ln/>
-        </p:spPr>
-        <p:txBody>
-          <a:bodyPr wrap="square" rtlCol="0" anchor="ctr"/>
-          <a:lstStyle/>
-          <a:p>
-            <a:pPr marL="0" indent="0">
-              <a:buNone/>
-            </a:pPr>
-            <a:r>
-              <a:rPr lang="en-US" sz="1200" dirty="0">
-                <a:solidFill>
-                  <a:srgbClr val="888888"/>
-                </a:solidFill>
-                <a:latin typeface="Arial" pitchFamily="34" charset="0"/>
-                <a:ea typeface="Arial" pitchFamily="34" charset="-122"/>
-                <a:cs typeface="Arial" pitchFamily="34" charset="-120"/>
-              </a:rPr>
-              <a:t>Core mechanics built. Daily check-ins via WhatsApp.</a:t>
-            </a:r>
-            <a:endParaRPr lang="en-US" sz="1200" dirty="0"/>
-          </a:p>
-        </p:txBody>
-      </p:sp>
-      <p:sp>
-        <p:nvSpPr>
-          <p:cNvPr id="13" name="Text 11"/>
-          <p:cNvSpPr/>
-          <p:nvPr/>
-        </p:nvSpPr>
-        <p:spPr>
-          <a:xfrm>
-            <a:off x="457200" y="2852928"/>
-            <a:ext cx="868680" cy="411480"/>
-          </a:xfrm>
-          <a:prstGeom prst="rect">
-            <a:avLst/>
-          </a:prstGeom>
-          <a:noFill/>
-          <a:ln/>
-        </p:spPr>
-        <p:txBody>
-          <a:bodyPr wrap="square" rtlCol="0" anchor="ctr">
-            <a:normAutofit/>
-          </a:bodyPr>
-          <a:lstStyle/>
-          <a:p>
-            <a:pPr marL="0" indent="0">
-              <a:buNone/>
-            </a:pPr>
-            <a:r>
-              <a:rPr lang="en-US" sz="2000" b="1" dirty="0">
-                <a:solidFill>
-                  <a:srgbClr val="FFCD00"/>
-                </a:solidFill>
-                <a:latin typeface="Arial Black" pitchFamily="34" charset="0"/>
-                <a:ea typeface="Arial Black" pitchFamily="34" charset="-122"/>
-                <a:cs typeface="Arial Black" pitchFamily="34" charset="-120"/>
-              </a:rPr>
-              <a:t>03</a:t>
-            </a:r>
-            <a:endParaRPr lang="en-US" sz="2000" dirty="0"/>
-          </a:p>
-        </p:txBody>
-      </p:sp>
-      <p:sp>
-        <p:nvSpPr>
-          <p:cNvPr id="14" name="Text 12"/>
-          <p:cNvSpPr/>
-          <p:nvPr/>
-        </p:nvSpPr>
-        <p:spPr>
-          <a:xfrm>
-            <a:off x="1371600" y="2834640"/>
-            <a:ext cx="7315200" cy="292608"/>
-          </a:xfrm>
-          <a:prstGeom prst="rect">
-            <a:avLst/>
-          </a:prstGeom>
-          <a:noFill/>
-          <a:ln/>
-        </p:spPr>
-        <p:txBody>
-          <a:bodyPr wrap="square" rtlCol="0" anchor="ctr"/>
-          <a:lstStyle/>
-          <a:p>
-            <a:pPr marL="0" indent="0">
-              <a:buNone/>
-            </a:pPr>
-            <a:r>
-              <a:rPr lang="en-US" sz="1700" b="1" dirty="0">
-                <a:solidFill>
-                  <a:srgbClr val="111111"/>
-                </a:solidFill>
-                <a:latin typeface="Arial Black" pitchFamily="34" charset="0"/>
-                <a:ea typeface="Arial Black" pitchFamily="34" charset="-122"/>
-                <a:cs typeface="Arial Black" pitchFamily="34" charset="-120"/>
-              </a:rPr>
-              <a:t>Sprint 3  —  Slicing &amp; sound</a:t>
-            </a:r>
-            <a:endParaRPr lang="en-US" sz="1700" dirty="0"/>
-          </a:p>
-        </p:txBody>
-      </p:sp>
-      <p:sp>
-        <p:nvSpPr>
-          <p:cNvPr id="15" name="Text 13"/>
-          <p:cNvSpPr/>
-          <p:nvPr/>
-        </p:nvSpPr>
-        <p:spPr>
-          <a:xfrm>
-            <a:off x="1371600" y="3136392"/>
-            <a:ext cx="7315200" cy="228600"/>
-          </a:xfrm>
-          <a:prstGeom prst="rect">
-            <a:avLst/>
-          </a:prstGeom>
-          <a:noFill/>
-          <a:ln/>
-        </p:spPr>
-        <p:txBody>
-          <a:bodyPr wrap="square" rtlCol="0" anchor="ctr"/>
-          <a:lstStyle/>
-          <a:p>
-            <a:pPr marL="0" indent="0">
-              <a:buNone/>
-            </a:pPr>
-            <a:r>
-              <a:rPr lang="en-US" sz="1200" dirty="0">
-                <a:solidFill>
-                  <a:srgbClr val="888888"/>
-                </a:solidFill>
-                <a:latin typeface="Arial" pitchFamily="34" charset="0"/>
-                <a:ea typeface="Arial" pitchFamily="34" charset="-122"/>
-                <a:cs typeface="Arial" pitchFamily="34" charset="-120"/>
-              </a:rPr>
-              <a:t>Visual integration. First merge conflicts resolved.</a:t>
-            </a:r>
-            <a:endParaRPr lang="en-US" sz="1200" dirty="0"/>
-          </a:p>
-        </p:txBody>
-      </p:sp>
-      <p:sp>
-        <p:nvSpPr>
-          <p:cNvPr id="16" name="Text 14"/>
-          <p:cNvSpPr/>
-          <p:nvPr/>
-        </p:nvSpPr>
-        <p:spPr>
-          <a:xfrm>
-            <a:off x="457200" y="3474720"/>
-            <a:ext cx="868680" cy="411480"/>
-          </a:xfrm>
-          <a:prstGeom prst="rect">
-            <a:avLst/>
-          </a:prstGeom>
-          <a:noFill/>
-          <a:ln/>
-        </p:spPr>
-        <p:txBody>
-          <a:bodyPr wrap="square" rtlCol="0" anchor="ctr">
-            <a:normAutofit/>
-          </a:bodyPr>
-          <a:lstStyle/>
-          <a:p>
-            <a:pPr marL="0" indent="0">
-              <a:buNone/>
-            </a:pPr>
-            <a:r>
-              <a:rPr lang="en-US" sz="2000" b="1" dirty="0">
-                <a:solidFill>
-                  <a:srgbClr val="FFCD00"/>
-                </a:solidFill>
-                <a:latin typeface="Arial Black" pitchFamily="34" charset="0"/>
-                <a:ea typeface="Arial Black" pitchFamily="34" charset="-122"/>
-                <a:cs typeface="Arial Black" pitchFamily="34" charset="-120"/>
-              </a:rPr>
-              <a:t>04</a:t>
-            </a:r>
-            <a:endParaRPr lang="en-US" sz="2000" dirty="0"/>
-          </a:p>
-        </p:txBody>
-      </p:sp>
-      <p:sp>
-        <p:nvSpPr>
-          <p:cNvPr id="17" name="Text 15"/>
-          <p:cNvSpPr/>
-          <p:nvPr/>
-        </p:nvSpPr>
-        <p:spPr>
-          <a:xfrm>
-            <a:off x="1371600" y="3456432"/>
-            <a:ext cx="7315200" cy="292608"/>
-          </a:xfrm>
-          <a:prstGeom prst="rect">
-            <a:avLst/>
-          </a:prstGeom>
-          <a:noFill/>
-          <a:ln/>
-        </p:spPr>
-        <p:txBody>
-          <a:bodyPr wrap="square" rtlCol="0" anchor="ctr"/>
-          <a:lstStyle/>
-          <a:p>
-            <a:pPr marL="0" indent="0">
-              <a:buNone/>
-            </a:pPr>
-            <a:r>
-              <a:rPr lang="en-US" sz="1700" b="1" dirty="0">
-                <a:solidFill>
-                  <a:srgbClr val="111111"/>
-                </a:solidFill>
-                <a:latin typeface="Arial Black" pitchFamily="34" charset="0"/>
-                <a:ea typeface="Arial Black" pitchFamily="34" charset="-122"/>
-                <a:cs typeface="Arial Black" pitchFamily="34" charset="-120"/>
-              </a:rPr>
-              <a:t>Sprint 4  —  Leaderboard</a:t>
-            </a:r>
-            <a:endParaRPr lang="en-US" sz="1700" dirty="0"/>
-          </a:p>
-        </p:txBody>
-      </p:sp>
-      <p:sp>
-        <p:nvSpPr>
-          <p:cNvPr id="18" name="Text 16"/>
-          <p:cNvSpPr/>
-          <p:nvPr/>
-        </p:nvSpPr>
-        <p:spPr>
-          <a:xfrm>
-            <a:off x="1371600" y="3758184"/>
-            <a:ext cx="7315200" cy="228600"/>
-          </a:xfrm>
-          <a:prstGeom prst="rect">
-            <a:avLst/>
-          </a:prstGeom>
-          <a:noFill/>
-          <a:ln/>
-        </p:spPr>
-        <p:txBody>
-          <a:bodyPr wrap="square" rtlCol="0" anchor="ctr"/>
-          <a:lstStyle/>
-          <a:p>
-            <a:pPr marL="0" indent="0">
-              <a:buNone/>
-            </a:pPr>
-            <a:r>
-              <a:rPr lang="en-US" sz="1200" dirty="0">
-                <a:solidFill>
-                  <a:srgbClr val="888888"/>
-                </a:solidFill>
-                <a:latin typeface="Arial" pitchFamily="34" charset="0"/>
-                <a:ea typeface="Arial" pitchFamily="34" charset="-122"/>
-                <a:cs typeface="Arial" pitchFamily="34" charset="-120"/>
-              </a:rPr>
-              <a:t>Peer testing begins. Feedback collected and logged.</a:t>
-            </a:r>
-            <a:endParaRPr lang="en-US" sz="1200" dirty="0"/>
-          </a:p>
-        </p:txBody>
-      </p:sp>
-      <p:sp>
-        <p:nvSpPr>
-          <p:cNvPr id="19" name="Text 17"/>
-          <p:cNvSpPr/>
-          <p:nvPr/>
-        </p:nvSpPr>
-        <p:spPr>
-          <a:xfrm>
-            <a:off x="457200" y="4096512"/>
-            <a:ext cx="868680" cy="411480"/>
-          </a:xfrm>
-          <a:prstGeom prst="rect">
-            <a:avLst/>
-          </a:prstGeom>
-          <a:noFill/>
-          <a:ln/>
-        </p:spPr>
-        <p:txBody>
-          <a:bodyPr wrap="square" rtlCol="0" anchor="ctr">
-            <a:normAutofit/>
-          </a:bodyPr>
-          <a:lstStyle/>
-          <a:p>
-            <a:pPr marL="0" indent="0">
-              <a:buNone/>
-            </a:pPr>
-            <a:r>
-              <a:rPr lang="en-US" sz="2000" b="1" dirty="0">
-                <a:solidFill>
-                  <a:srgbClr val="FFCD00"/>
-                </a:solidFill>
-                <a:latin typeface="Arial Black" pitchFamily="34" charset="0"/>
-                <a:ea typeface="Arial Black" pitchFamily="34" charset="-122"/>
-                <a:cs typeface="Arial Black" pitchFamily="34" charset="-120"/>
-              </a:rPr>
-              <a:t>05</a:t>
-            </a:r>
-            <a:endParaRPr lang="en-US" sz="2000" dirty="0"/>
-          </a:p>
-        </p:txBody>
-      </p:sp>
-      <p:sp>
-        <p:nvSpPr>
-          <p:cNvPr id="20" name="Text 18"/>
-          <p:cNvSpPr/>
-          <p:nvPr/>
-        </p:nvSpPr>
-        <p:spPr>
-          <a:xfrm>
-            <a:off x="1371600" y="4078224"/>
-            <a:ext cx="7315200" cy="292608"/>
-          </a:xfrm>
-          <a:prstGeom prst="rect">
-            <a:avLst/>
-          </a:prstGeom>
-          <a:noFill/>
-          <a:ln/>
-        </p:spPr>
-        <p:txBody>
-          <a:bodyPr wrap="square" rtlCol="0" anchor="ctr"/>
-          <a:lstStyle/>
-          <a:p>
-            <a:pPr marL="0" indent="0">
-              <a:buNone/>
-            </a:pPr>
-            <a:r>
-              <a:rPr lang="en-US" sz="1700" b="1" dirty="0">
-                <a:solidFill>
-                  <a:srgbClr val="111111"/>
-                </a:solidFill>
-                <a:latin typeface="Arial Black" pitchFamily="34" charset="0"/>
-                <a:ea typeface="Arial Black" pitchFamily="34" charset="-122"/>
-                <a:cs typeface="Arial Black" pitchFamily="34" charset="-120"/>
-              </a:rPr>
-              <a:t>Sprint 5  —  Testing &amp; polish</a:t>
-            </a:r>
-            <a:endParaRPr lang="en-US" sz="1700" dirty="0"/>
-          </a:p>
-        </p:txBody>
-      </p:sp>
-      <p:sp>
-        <p:nvSpPr>
-          <p:cNvPr id="21" name="Text 19"/>
-          <p:cNvSpPr/>
-          <p:nvPr/>
-        </p:nvSpPr>
-        <p:spPr>
-          <a:xfrm>
-            <a:off x="1371600" y="4379976"/>
-            <a:ext cx="7315200" cy="228600"/>
-          </a:xfrm>
-          <a:prstGeom prst="rect">
-            <a:avLst/>
-          </a:prstGeom>
-          <a:noFill/>
-          <a:ln/>
-        </p:spPr>
-        <p:txBody>
-          <a:bodyPr wrap="square" rtlCol="0" anchor="ctr"/>
-          <a:lstStyle/>
-          <a:p>
-            <a:pPr marL="0" indent="0">
-              <a:buNone/>
-            </a:pPr>
-            <a:r>
-              <a:rPr lang="en-US" sz="1200" dirty="0">
-                <a:solidFill>
-                  <a:srgbClr val="888888"/>
-                </a:solidFill>
-                <a:latin typeface="Arial" pitchFamily="34" charset="0"/>
-                <a:ea typeface="Arial" pitchFamily="34" charset="-122"/>
-                <a:cs typeface="Arial" pitchFamily="34" charset="-120"/>
-              </a:rPr>
-              <a:t>Bug hunt, final fixes, review before submission.</a:t>
-            </a:r>
-            <a:endParaRPr lang="en-US" sz="1200" dirty="0"/>
           </a:p>
         </p:txBody>
       </p:sp>

</xml_diff>

<commit_message>
Add evidence images and updated presentation
</commit_message>
<xml_diff>
--- a/NinjaQuiz-Presentation.pptx
+++ b/NinjaQuiz-Presentation.pptx
@@ -5,19 +5,18 @@
     <p:sldMasterId id="2147483648" r:id="rId1"/>
   </p:sldMasterIdLst>
   <p:notesMasterIdLst>
-    <p:notesMasterId r:id="rId20"/>
+    <p:notesMasterId r:id="rId21"/>
   </p:notesMasterIdLst>
   <p:sldIdLst>
     <p:sldId id="256" r:id="rId2"/>
-    <p:sldId id="257" r:id="rId3"/>
-    <p:sldId id="258" r:id="rId4"/>
-    <p:sldId id="259" r:id="rId5"/>
-    <p:sldId id="260" r:id="rId6"/>
-    <p:sldId id="261" r:id="rId7"/>
-    <p:sldId id="262" r:id="rId8"/>
-    <p:sldId id="263" r:id="rId9"/>
-    <p:sldId id="264" r:id="rId10"/>
-    <p:sldId id="275" r:id="rId26"/>
+    <p:sldId id="258" r:id="rId3"/>
+    <p:sldId id="259" r:id="rId4"/>
+    <p:sldId id="260" r:id="rId5"/>
+    <p:sldId id="261" r:id="rId6"/>
+    <p:sldId id="262" r:id="rId7"/>
+    <p:sldId id="263" r:id="rId8"/>
+    <p:sldId id="264" r:id="rId9"/>
+    <p:sldId id="275" r:id="rId10"/>
     <p:sldId id="265" r:id="rId11"/>
     <p:sldId id="266" r:id="rId12"/>
     <p:sldId id="267" r:id="rId13"/>
@@ -26,8 +25,8 @@
     <p:sldId id="270" r:id="rId16"/>
     <p:sldId id="271" r:id="rId17"/>
     <p:sldId id="272" r:id="rId18"/>
-    <p:sldId id="276" r:id="rId27"/>
-    <p:sldId id="273" r:id="rId19"/>
+    <p:sldId id="276" r:id="rId19"/>
+    <p:sldId id="273" r:id="rId20"/>
   </p:sldIdLst>
   <p:sldSz cx="9144000" cy="5143500" type="screen16x9"/>
   <p:notesSz cx="5143500" cy="9144000"/>
@@ -389,7 +388,7 @@
           <a:p>
             <a:r>
               <a:rPr lang="en-US" dirty="0"/>
-              <a:t>Halfway through the project, we hit our biggest challenge. This is where the team's communication structure was actually tested.</a:t>
+              <a:t>This was our make-or-break moment. The game ran but answer targets never appeared — the entire gameplay depended on them. The reason it was resolved in one day: the team communicated immediately. Everyone looked at the error log together. Root cause identified, component rebuilt. Not one person could have done that alone.</a:t>
             </a:r>
           </a:p>
         </p:txBody>
@@ -411,7 +410,7 @@
           <a:p>
             <a:fld id="{F7021451-1387-4CA6-816F-3879F97B5CBC}" type="slidenum">
               <a:rPr lang="en-US"/>
-              <a:t>10</a:t>
+              <a:t>11</a:t>
             </a:fld>
             <a:endParaRPr lang="en-US"/>
           </a:p>
@@ -476,7 +475,7 @@
           <a:p>
             <a:r>
               <a:rPr lang="en-US" dirty="0"/>
-              <a:t>This was our make-or-break moment. The game ran but answer targets never appeared — the entire gameplay depended on them. The reason it was resolved in one day: the team communicated immediately. Everyone looked at the error log together. Root cause identified, component rebuilt. Not one person could have done that alone.</a:t>
+              <a:t>The bug was not just a technical problem — it was a test of our process. And our process worked. Because every person knew their role, issues were raised immediately, and the team reviewed code collaboratively, we resolved it without delaying the sprint.</a:t>
             </a:r>
           </a:p>
         </p:txBody>
@@ -498,7 +497,7 @@
           <a:p>
             <a:fld id="{F7021451-1387-4CA6-816F-3879F97B5CBC}" type="slidenum">
               <a:rPr lang="en-US"/>
-              <a:t>11</a:t>
+              <a:t>12</a:t>
             </a:fld>
             <a:endParaRPr lang="en-US"/>
           </a:p>
@@ -563,7 +562,7 @@
           <a:p>
             <a:r>
               <a:rPr lang="en-US" dirty="0"/>
-              <a:t>The bug was not just a technical problem — it was a test of our process. And our process worked. Because every person knew their role, issues were raised immediately, and the team reviewed code collaboratively, we resolved it without delaying the sprint.</a:t>
+              <a:t>With the process covered — let's show what it produced.</a:t>
             </a:r>
           </a:p>
         </p:txBody>
@@ -585,7 +584,7 @@
           <a:p>
             <a:fld id="{F7021451-1387-4CA6-816F-3879F97B5CBC}" type="slidenum">
               <a:rPr lang="en-US"/>
-              <a:t>12</a:t>
+              <a:t>13</a:t>
             </a:fld>
             <a:endParaRPr lang="en-US"/>
           </a:p>
@@ -650,7 +649,7 @@
           <a:p>
             <a:r>
               <a:rPr lang="en-US" dirty="0"/>
-              <a:t>With the process covered — let's show what it produced.</a:t>
+              <a:t>The team delivered every client requirement. This was possible because of the structured process — clear roles, sprint planning, and documented decisions meant nothing was missed.</a:t>
             </a:r>
           </a:p>
         </p:txBody>
@@ -672,7 +671,7 @@
           <a:p>
             <a:fld id="{F7021451-1387-4CA6-816F-3879F97B5CBC}" type="slidenum">
               <a:rPr lang="en-US"/>
-              <a:t>13</a:t>
+              <a:t>14</a:t>
             </a:fld>
             <a:endParaRPr lang="en-US"/>
           </a:p>
@@ -737,7 +736,7 @@
           <a:p>
             <a:r>
               <a:rPr lang="en-US" dirty="0"/>
-              <a:t>The team delivered every client requirement. This was possible because of the structured process — clear roles, sprint planning, and documented decisions meant nothing was missed.</a:t>
+              <a:t>User testing was part of Sprint 4 and 5. We gathered feedback from peers who had not seen the game before. Their responses validated that the game teaches while entertaining — and the desire to replay confirms educational retention.</a:t>
             </a:r>
           </a:p>
         </p:txBody>
@@ -759,7 +758,7 @@
           <a:p>
             <a:fld id="{F7021451-1387-4CA6-816F-3879F97B5CBC}" type="slidenum">
               <a:rPr lang="en-US"/>
-              <a:t>14</a:t>
+              <a:t>15</a:t>
             </a:fld>
             <a:endParaRPr lang="en-US"/>
           </a:p>
@@ -824,7 +823,7 @@
           <a:p>
             <a:r>
               <a:rPr lang="en-US" dirty="0"/>
-              <a:t>User testing was part of Sprint 4 and 5. We gathered feedback from peers who had not seen the game before. Their responses validated that the game teaches while entertaining — and the desire to replay confirms educational retention.</a:t>
+              <a:t>This is Ninja Quiz in play. A cyber-safety question appears, four answer targets fly across the screen, and the player slices the correct one. The product is fully working and available for a live demo right now.</a:t>
             </a:r>
           </a:p>
         </p:txBody>
@@ -846,7 +845,7 @@
           <a:p>
             <a:fld id="{F7021451-1387-4CA6-816F-3879F97B5CBC}" type="slidenum">
               <a:rPr lang="en-US"/>
-              <a:t>15</a:t>
+              <a:t>16</a:t>
             </a:fld>
             <a:endParaRPr lang="en-US"/>
           </a:p>
@@ -911,7 +910,7 @@
           <a:p>
             <a:r>
               <a:rPr lang="en-US" dirty="0"/>
-              <a:t>This is Ninja Quiz in play. A cyber-safety question appears, four answer targets fly across the screen, and the player slices the correct one. The product is fully working and available for a live demo right now.</a:t>
+              <a:t>Our biggest takeaway from this project: the game existed because of how we communicated — not just how we coded. Structured stand-ups, documented decisions, and fast escalation of issues made the difference between a broken prototype and a working product.</a:t>
             </a:r>
           </a:p>
         </p:txBody>
@@ -933,7 +932,7 @@
           <a:p>
             <a:fld id="{F7021451-1387-4CA6-816F-3879F97B5CBC}" type="slidenum">
               <a:rPr lang="en-US"/>
-              <a:t>16</a:t>
+              <a:t>17</a:t>
             </a:fld>
             <a:endParaRPr lang="en-US"/>
           </a:p>
@@ -998,7 +997,7 @@
           <a:p>
             <a:r>
               <a:rPr lang="en-US" dirty="0"/>
-              <a:t>Our biggest takeaway from this project: the game existed because of how we communicated — not just how we coded. Structured stand-ups, documented decisions, and fast escalation of issues made the difference between a broken prototype and a working product.</a:t>
+              <a:t>Thank you. We are happy to take questions and run a live demo of the game. We are also happy to walk through any part of the team process in more detail.</a:t>
             </a:r>
           </a:p>
         </p:txBody>
@@ -1020,94 +1019,7 @@
           <a:p>
             <a:fld id="{F7021451-1387-4CA6-816F-3879F97B5CBC}" type="slidenum">
               <a:rPr lang="en-US"/>
-              <a:t>17</a:t>
-            </a:fld>
-            <a:endParaRPr lang="en-US"/>
-          </a:p>
-        </p:txBody>
-      </p:sp>
-    </p:spTree>
-    <p:extLst>
-      <p:ext uri="{BB962C8B-B14F-4D97-AF65-F5344CB8AC3E}">
-        <p14:creationId xmlns:p14="http://schemas.microsoft.com/office/powerpoint/2010/main" val="1024086991"/>
-      </p:ext>
-    </p:extLst>
-  </p:cSld>
-  <p:clrMapOvr>
-    <a:masterClrMapping/>
-  </p:clrMapOvr>
-</p:notes>
-</file>
-
-<file path=ppt/notesSlides/notesSlide18.xml><?xml version="1.0" encoding="utf-8"?>
-<p:notes xmlns:a="http://schemas.openxmlformats.org/drawingml/2006/main" xmlns:r="http://schemas.openxmlformats.org/officeDocument/2006/relationships" xmlns:p="http://schemas.openxmlformats.org/presentationml/2006/main">
-  <p:cSld>
-    <p:spTree>
-      <p:nvGrpSpPr>
-        <p:cNvPr id="1" name=""/>
-        <p:cNvGrpSpPr/>
-        <p:nvPr/>
-      </p:nvGrpSpPr>
-      <p:grpSpPr>
-        <a:xfrm>
-          <a:off x="0" y="0"/>
-          <a:ext cx="0" cy="0"/>
-          <a:chOff x="0" y="0"/>
-          <a:chExt cx="0" cy="0"/>
-        </a:xfrm>
-      </p:grpSpPr>
-      <p:sp>
-        <p:nvSpPr>
-          <p:cNvPr id="2" name="Slide Image Placeholder 1"/>
-          <p:cNvSpPr>
-            <a:spLocks noGrp="1" noRot="1" noChangeAspect="1"/>
-          </p:cNvSpPr>
-          <p:nvPr>
-            <p:ph type="sldImg"/>
-          </p:nvPr>
-        </p:nvSpPr>
-        <p:spPr/>
-      </p:sp>
-      <p:sp>
-        <p:nvSpPr>
-          <p:cNvPr id="3" name="Notes Placeholder 2"/>
-          <p:cNvSpPr>
-            <a:spLocks noGrp="1"/>
-          </p:cNvSpPr>
-          <p:nvPr>
-            <p:ph type="body" idx="1"/>
-          </p:nvPr>
-        </p:nvSpPr>
-        <p:spPr/>
-        <p:txBody>
-          <a:bodyPr/>
-          <a:lstStyle/>
-          <a:p>
-            <a:r>
-              <a:rPr lang="en-US" dirty="0"/>
-              <a:t>Thank you. We are happy to take questions and run a live demo of the game. We are also happy to walk through any part of the team process in more detail.</a:t>
-            </a:r>
-          </a:p>
-        </p:txBody>
-      </p:sp>
-      <p:sp>
-        <p:nvSpPr>
-          <p:cNvPr id="4" name="Slide Number Placeholder 3"/>
-          <p:cNvSpPr>
-            <a:spLocks noGrp="1"/>
-          </p:cNvSpPr>
-          <p:nvPr>
-            <p:ph type="sldNum" sz="quarter" idx="10"/>
-          </p:nvPr>
-        </p:nvSpPr>
-        <p:spPr/>
-        <p:txBody>
-          <a:bodyPr/>
-          <a:lstStyle/>
-          <a:p>
-            <a:fld id="{F7021451-1387-4CA6-816F-3879F97B5CBC}" type="slidenum">
-              <a:rPr lang="en-US"/>
-              <a:t>18</a:t>
+              <a:t>19</a:t>
             </a:fld>
             <a:endParaRPr lang="en-US"/>
           </a:p>
@@ -1172,7 +1084,7 @@
           <a:p>
             <a:r>
               <a:rPr lang="en-US" dirty="0"/>
-              <a:t>This is why the brief existed. One in three children has already encountered an online risk — but passive teaching does not stick. The client needed something young people would actually engage with. That was our starting point.</a:t>
+              <a:t>Before we talk about what we built — let's establish who we are and how we divided the work.</a:t>
             </a:r>
           </a:p>
         </p:txBody>
@@ -1259,7 +1171,7 @@
           <a:p>
             <a:r>
               <a:rPr lang="en-US" dirty="0"/>
-              <a:t>Before we talk about what we built — let's establish who we are and how we divided the work.</a:t>
+              <a:t>Work was divided so every person owned one module end-to-end. No overlap meant clear accountability — when something needed fixing, we knew exactly who to speak to. This was a deliberate decision made in our first meeting.</a:t>
             </a:r>
           </a:p>
         </p:txBody>
@@ -1346,7 +1258,7 @@
           <a:p>
             <a:r>
               <a:rPr lang="en-US" dirty="0"/>
-              <a:t>Work was divided so every person owned one module end-to-end. No overlap meant clear accountability — when something needed fixing, we knew exactly who to speak to. This was a deliberate decision made in our first meeting.</a:t>
+              <a:t>Now let's talk about process — how we actually organised, communicated and made decisions as a team.</a:t>
             </a:r>
           </a:p>
         </p:txBody>
@@ -1433,7 +1345,7 @@
           <a:p>
             <a:r>
               <a:rPr lang="en-US" dirty="0"/>
-              <a:t>Now let's talk about process — how we actually organised, communicated and made decisions as a team.</a:t>
+              <a:t>We chose three tools deliberately. Trello kept tasks visible to everyone — no one had to ask 'what are you working on?' GitHub meant five people could write code at the same time without conflicts. WhatsApp was our daily pulse — stand-ups every week.</a:t>
             </a:r>
           </a:p>
         </p:txBody>
@@ -1520,7 +1432,7 @@
           <a:p>
             <a:r>
               <a:rPr lang="en-US" dirty="0"/>
-              <a:t>We chose three tools deliberately. Trello kept tasks visible to everyone — no one had to ask 'what are you working on?' GitHub meant five people could write code at the same time without conflicts. WhatsApp was our daily pulse — stand-ups every week.</a:t>
+              <a:t>We ran eight stand-ups over eight weeks. Same three questions every time. This kept every team member focused on progress and surfaced blockers early — before they became emergencies. The stand-up format came from Agile methodology.</a:t>
             </a:r>
           </a:p>
         </p:txBody>
@@ -1607,7 +1519,7 @@
           <a:p>
             <a:r>
               <a:rPr lang="en-US" dirty="0"/>
-              <a:t>We ran eight stand-ups over eight weeks. Same three questions every time. This kept every team member focused on progress and surfaced blockers early — before they became emergencies. The stand-up format came from Agile methodology.</a:t>
+              <a:t>Early in the project we recognised that undocumented decisions were causing confusion. We moved to a structured approach — minutes for every meeting, a Trello card for every decision. If someone was absent, they could catch up. Nothing was lost.</a:t>
             </a:r>
           </a:p>
         </p:txBody>
@@ -1694,7 +1606,7 @@
           <a:p>
             <a:r>
               <a:rPr lang="en-US" dirty="0"/>
-              <a:t>Early in the project we recognised that undocumented decisions were causing confusion. We moved to a structured approach — minutes for every meeting, a Trello card for every decision. If someone was absent, they could catch up. Nothing was lost.</a:t>
+              <a:t>We used Agile methodology — five two-week sprints. Each sprint closed with a working demo and a team retrospective. This meant we were always building on something that worked, and the team reviewed its own process at the end of every cycle.</a:t>
             </a:r>
           </a:p>
         </p:txBody>
@@ -1781,7 +1693,7 @@
           <a:p>
             <a:r>
               <a:rPr lang="en-US" dirty="0"/>
-              <a:t>We used Agile methodology — five two-week sprints. Each sprint closed with a working demo and a team retrospective. This meant we were always building on something that worked, and the team reviewed its own process at the end of every cycle.</a:t>
+              <a:t>Halfway through the project, we hit our biggest challenge. This is where the team's communication structure was actually tested.</a:t>
             </a:r>
           </a:p>
         </p:txBody>
@@ -1803,7 +1715,7 @@
           <a:p>
             <a:fld id="{F7021451-1387-4CA6-816F-3879F97B5CBC}" type="slidenum">
               <a:rPr lang="en-US"/>
-              <a:t>9</a:t>
+              <a:t>10</a:t>
             </a:fld>
             <a:endParaRPr lang="en-US"/>
           </a:p>
@@ -2352,1498 +2264,6 @@
 
 <file path=ppt/slides/slide10.xml><?xml version="1.0" encoding="utf-8"?>
 <p:sld xmlns:a="http://schemas.openxmlformats.org/drawingml/2006/main" xmlns:r="http://schemas.openxmlformats.org/officeDocument/2006/relationships" xmlns:p="http://schemas.openxmlformats.org/presentationml/2006/main">
-  <p:cSld name="Slide 9">
-    <p:bg>
-      <p:bgPr>
-        <a:solidFill>
-          <a:srgbClr val="FFFFFF"/>
-        </a:solidFill>
-        <a:effectLst/>
-      </p:bgPr>
-    </p:bg>
-    <p:spTree>
-      <p:nvGrpSpPr>
-        <p:cNvPr id="1" name=""/>
-        <p:cNvGrpSpPr/>
-        <p:nvPr/>
-      </p:nvGrpSpPr>
-      <p:grpSpPr>
-        <a:xfrm>
-          <a:off x="0" y="0"/>
-          <a:ext cx="0" cy="0"/>
-          <a:chOff x="0" y="0"/>
-          <a:chExt cx="0" cy="0"/>
-        </a:xfrm>
-      </p:grpSpPr>
-      <p:sp>
-        <p:nvSpPr>
-          <p:cNvPr id="2" name="Shape 0"/>
-          <p:cNvSpPr/>
-          <p:nvPr/>
-        </p:nvSpPr>
-        <p:spPr>
-          <a:xfrm>
-            <a:off x="8458200" y="201168"/>
-            <a:ext cx="256032" cy="256032"/>
-          </a:xfrm>
-          <a:prstGeom prst="ellipse">
-            <a:avLst/>
-          </a:prstGeom>
-          <a:solidFill>
-            <a:srgbClr val="DDDDDD"/>
-          </a:solidFill>
-          <a:ln/>
-        </p:spPr>
-        <p:txBody>
-          <a:bodyPr/>
-          <a:lstStyle/>
-          <a:p>
-            <a:endParaRPr lang="en-GB"/>
-          </a:p>
-        </p:txBody>
-      </p:sp>
-      <p:sp>
-        <p:nvSpPr>
-          <p:cNvPr id="3" name="Text 1"/>
-          <p:cNvSpPr/>
-          <p:nvPr/>
-        </p:nvSpPr>
-        <p:spPr>
-          <a:xfrm>
-            <a:off x="457200" y="274320"/>
-            <a:ext cx="6400800" cy="228600"/>
-          </a:xfrm>
-          <a:prstGeom prst="rect">
-            <a:avLst/>
-          </a:prstGeom>
-          <a:noFill/>
-          <a:ln/>
-        </p:spPr>
-        <p:txBody>
-          <a:bodyPr wrap="square" rtlCol="0" anchor="ctr"/>
-          <a:lstStyle/>
-          <a:p>
-            <a:pPr marL="0" indent="0">
-              <a:buNone/>
-            </a:pPr>
-            <a:r>
-              <a:rPr lang="en-US" sz="1000" b="1" kern="0" spc="200" dirty="0">
-                <a:solidFill>
-                  <a:srgbClr val="888888"/>
-                </a:solidFill>
-                <a:latin typeface="Arial" pitchFamily="34" charset="0"/>
-                <a:ea typeface="Arial" pitchFamily="34" charset="-122"/>
-                <a:cs typeface="Arial" pitchFamily="34" charset="-120"/>
-              </a:rPr>
-              <a:t>DELIVERY PROCESS</a:t>
-            </a:r>
-            <a:endParaRPr lang="en-US" sz="1000" dirty="0"/>
-          </a:p>
-        </p:txBody>
-      </p:sp>
-      <p:sp>
-        <p:nvSpPr>
-          <p:cNvPr id="4" name="Text 2"/>
-          <p:cNvSpPr/>
-          <p:nvPr/>
-        </p:nvSpPr>
-        <p:spPr>
-          <a:xfrm>
-            <a:off x="3657600" y="4919472"/>
-            <a:ext cx="5212080" cy="182880"/>
-          </a:xfrm>
-          <a:prstGeom prst="rect">
-            <a:avLst/>
-          </a:prstGeom>
-          <a:noFill/>
-          <a:ln/>
-        </p:spPr>
-        <p:txBody>
-          <a:bodyPr wrap="square" rtlCol="0" anchor="ctr"/>
-          <a:lstStyle/>
-          <a:p>
-            <a:pPr marL="0" indent="0" algn="r">
-              <a:buNone/>
-            </a:pPr>
-            <a:r>
-              <a:rPr lang="en-US" sz="900" dirty="0">
-                <a:solidFill>
-                  <a:srgbClr val="888888"/>
-                </a:solidFill>
-                <a:latin typeface="Arial" pitchFamily="34" charset="0"/>
-                <a:ea typeface="Arial" pitchFamily="34" charset="-122"/>
-                <a:cs typeface="Arial" pitchFamily="34" charset="-120"/>
-              </a:rPr>
-              <a:t>NINJA QUIZ  ·  503IT  ·  09 / 18</a:t>
-            </a:r>
-            <a:endParaRPr lang="en-US" sz="900" dirty="0"/>
-          </a:p>
-        </p:txBody>
-      </p:sp>
-      <p:sp>
-        <p:nvSpPr>
-          <p:cNvPr id="5" name="Text 3"/>
-          <p:cNvSpPr/>
-          <p:nvPr/>
-        </p:nvSpPr>
-        <p:spPr>
-          <a:xfrm>
-            <a:off x="457200" y="685800"/>
-            <a:ext cx="8229600" cy="812800"/>
-          </a:xfrm>
-          <a:prstGeom prst="rect">
-            <a:avLst/>
-          </a:prstGeom>
-          <a:noFill/>
-          <a:ln/>
-        </p:spPr>
-        <p:txBody>
-          <a:bodyPr wrap="square" rtlCol="0" anchor="ctr"/>
-          <a:lstStyle/>
-          <a:p>
-            <a:pPr marL="0" indent="0">
-              <a:buNone/>
-            </a:pPr>
-            <a:r>
-              <a:rPr lang="en-US" sz="3200" b="1" dirty="0">
-                <a:solidFill>
-                  <a:srgbClr val="111111"/>
-                </a:solidFill>
-                <a:latin typeface="Arial Black" pitchFamily="34" charset="0"/>
-                <a:ea typeface="Arial Black" pitchFamily="34" charset="-122"/>
-                <a:cs typeface="Arial Black" pitchFamily="34" charset="-120"/>
-              </a:rPr>
-              <a:t>Built in five sprints.</a:t>
-            </a:r>
-            <a:endParaRPr lang="en-US" sz="3200" dirty="0"/>
-          </a:p>
-        </p:txBody>
-      </p:sp>
-      <p:sp>
-        <p:nvSpPr>
-          <p:cNvPr id="6" name="Shape 4"/>
-          <p:cNvSpPr/>
-          <p:nvPr/>
-        </p:nvSpPr>
-        <p:spPr>
-          <a:xfrm>
-            <a:off x="457200" y="1463040"/>
-            <a:ext cx="8229600" cy="10973"/>
-          </a:xfrm>
-          <a:prstGeom prst="rect">
-            <a:avLst/>
-          </a:prstGeom>
-          <a:solidFill>
-            <a:srgbClr val="EEEEEE"/>
-          </a:solidFill>
-          <a:ln/>
-        </p:spPr>
-        <p:txBody>
-          <a:bodyPr/>
-          <a:lstStyle/>
-          <a:p>
-            <a:endParaRPr lang="en-GB"/>
-          </a:p>
-        </p:txBody>
-      </p:sp>
-      <p:sp>
-        <p:nvSpPr>
-          <p:cNvPr id="7" name="Text 5"/>
-          <p:cNvSpPr/>
-          <p:nvPr/>
-        </p:nvSpPr>
-        <p:spPr>
-          <a:xfrm>
-            <a:off x="457200" y="1609344"/>
-            <a:ext cx="868680" cy="411480"/>
-          </a:xfrm>
-          <a:prstGeom prst="rect">
-            <a:avLst/>
-          </a:prstGeom>
-          <a:noFill/>
-          <a:ln/>
-        </p:spPr>
-        <p:txBody>
-          <a:bodyPr wrap="square" rtlCol="0" anchor="ctr">
-            <a:normAutofit/>
-          </a:bodyPr>
-          <a:lstStyle/>
-          <a:p>
-            <a:pPr marL="0" indent="0">
-              <a:buNone/>
-            </a:pPr>
-            <a:r>
-              <a:rPr lang="en-US" sz="2000" b="1" dirty="0">
-                <a:solidFill>
-                  <a:srgbClr val="FFCD00"/>
-                </a:solidFill>
-                <a:latin typeface="Arial Black" pitchFamily="34" charset="0"/>
-                <a:ea typeface="Arial Black" pitchFamily="34" charset="-122"/>
-                <a:cs typeface="Arial Black" pitchFamily="34" charset="-120"/>
-              </a:rPr>
-              <a:t>01</a:t>
-            </a:r>
-            <a:endParaRPr lang="en-US" sz="2000" dirty="0"/>
-          </a:p>
-        </p:txBody>
-      </p:sp>
-      <p:sp>
-        <p:nvSpPr>
-          <p:cNvPr id="8" name="Text 6"/>
-          <p:cNvSpPr/>
-          <p:nvPr/>
-        </p:nvSpPr>
-        <p:spPr>
-          <a:xfrm>
-            <a:off x="1371600" y="1591056"/>
-            <a:ext cx="7315200" cy="292608"/>
-          </a:xfrm>
-          <a:prstGeom prst="rect">
-            <a:avLst/>
-          </a:prstGeom>
-          <a:noFill/>
-          <a:ln/>
-        </p:spPr>
-        <p:txBody>
-          <a:bodyPr wrap="square" rtlCol="0" anchor="ctr"/>
-          <a:lstStyle/>
-          <a:p>
-            <a:pPr marL="0" indent="0">
-              <a:buNone/>
-            </a:pPr>
-            <a:r>
-              <a:rPr lang="en-US" sz="1700" b="1" dirty="0">
-                <a:solidFill>
-                  <a:srgbClr val="111111"/>
-                </a:solidFill>
-                <a:latin typeface="Arial Black" pitchFamily="34" charset="0"/>
-                <a:ea typeface="Arial Black" pitchFamily="34" charset="-122"/>
-                <a:cs typeface="Arial Black" pitchFamily="34" charset="-120"/>
-              </a:rPr>
-              <a:t>Sprint 1  —  Login &amp; menu</a:t>
-            </a:r>
-            <a:endParaRPr lang="en-US" sz="1700" dirty="0"/>
-          </a:p>
-        </p:txBody>
-      </p:sp>
-      <p:sp>
-        <p:nvSpPr>
-          <p:cNvPr id="9" name="Text 7"/>
-          <p:cNvSpPr/>
-          <p:nvPr/>
-        </p:nvSpPr>
-        <p:spPr>
-          <a:xfrm>
-            <a:off x="1371600" y="1892808"/>
-            <a:ext cx="7315200" cy="228600"/>
-          </a:xfrm>
-          <a:prstGeom prst="rect">
-            <a:avLst/>
-          </a:prstGeom>
-          <a:noFill/>
-          <a:ln/>
-        </p:spPr>
-        <p:txBody>
-          <a:bodyPr wrap="square" rtlCol="0" anchor="ctr"/>
-          <a:lstStyle/>
-          <a:p>
-            <a:pPr marL="0" indent="0">
-              <a:buNone/>
-            </a:pPr>
-            <a:r>
-              <a:rPr lang="en-US" sz="1200" dirty="0">
-                <a:solidFill>
-                  <a:srgbClr val="888888"/>
-                </a:solidFill>
-                <a:latin typeface="Arial" pitchFamily="34" charset="0"/>
-                <a:ea typeface="Arial" pitchFamily="34" charset="-122"/>
-                <a:cs typeface="Arial" pitchFamily="34" charset="-120"/>
-              </a:rPr>
-              <a:t>Foundation. Every member set up. GitHub branches created.</a:t>
-            </a:r>
-            <a:endParaRPr lang="en-US" sz="1200" dirty="0"/>
-          </a:p>
-        </p:txBody>
-      </p:sp>
-      <p:sp>
-        <p:nvSpPr>
-          <p:cNvPr id="10" name="Text 8"/>
-          <p:cNvSpPr/>
-          <p:nvPr/>
-        </p:nvSpPr>
-        <p:spPr>
-          <a:xfrm>
-            <a:off x="457200" y="2231136"/>
-            <a:ext cx="868680" cy="411480"/>
-          </a:xfrm>
-          <a:prstGeom prst="rect">
-            <a:avLst/>
-          </a:prstGeom>
-          <a:noFill/>
-          <a:ln/>
-        </p:spPr>
-        <p:txBody>
-          <a:bodyPr wrap="square" rtlCol="0" anchor="ctr">
-            <a:normAutofit/>
-          </a:bodyPr>
-          <a:lstStyle/>
-          <a:p>
-            <a:pPr marL="0" indent="0">
-              <a:buNone/>
-            </a:pPr>
-            <a:r>
-              <a:rPr lang="en-US" sz="2000" b="1" dirty="0">
-                <a:solidFill>
-                  <a:srgbClr val="FFCD00"/>
-                </a:solidFill>
-                <a:latin typeface="Arial Black" pitchFamily="34" charset="0"/>
-                <a:ea typeface="Arial Black" pitchFamily="34" charset="-122"/>
-                <a:cs typeface="Arial Black" pitchFamily="34" charset="-120"/>
-              </a:rPr>
-              <a:t>02</a:t>
-            </a:r>
-            <a:endParaRPr lang="en-US" sz="2000" dirty="0"/>
-          </a:p>
-        </p:txBody>
-      </p:sp>
-      <p:sp>
-        <p:nvSpPr>
-          <p:cNvPr id="11" name="Text 9"/>
-          <p:cNvSpPr/>
-          <p:nvPr/>
-        </p:nvSpPr>
-        <p:spPr>
-          <a:xfrm>
-            <a:off x="1371600" y="2212848"/>
-            <a:ext cx="7315200" cy="292608"/>
-          </a:xfrm>
-          <a:prstGeom prst="rect">
-            <a:avLst/>
-          </a:prstGeom>
-          <a:noFill/>
-          <a:ln/>
-        </p:spPr>
-        <p:txBody>
-          <a:bodyPr wrap="square" rtlCol="0" anchor="ctr"/>
-          <a:lstStyle/>
-          <a:p>
-            <a:pPr marL="0" indent="0">
-              <a:buNone/>
-            </a:pPr>
-            <a:r>
-              <a:rPr lang="en-US" sz="1700" b="1" dirty="0">
-                <a:solidFill>
-                  <a:srgbClr val="111111"/>
-                </a:solidFill>
-                <a:latin typeface="Arial Black" pitchFamily="34" charset="0"/>
-                <a:ea typeface="Arial Black" pitchFamily="34" charset="-122"/>
-                <a:cs typeface="Arial Black" pitchFamily="34" charset="-120"/>
-              </a:rPr>
-              <a:t>Sprint 2  —  Game engine</a:t>
-            </a:r>
-            <a:endParaRPr lang="en-US" sz="1700" dirty="0"/>
-          </a:p>
-        </p:txBody>
-      </p:sp>
-      <p:sp>
-        <p:nvSpPr>
-          <p:cNvPr id="12" name="Text 10"/>
-          <p:cNvSpPr/>
-          <p:nvPr/>
-        </p:nvSpPr>
-        <p:spPr>
-          <a:xfrm>
-            <a:off x="1371600" y="2514600"/>
-            <a:ext cx="7315200" cy="228600"/>
-          </a:xfrm>
-          <a:prstGeom prst="rect">
-            <a:avLst/>
-          </a:prstGeom>
-          <a:noFill/>
-          <a:ln/>
-        </p:spPr>
-        <p:txBody>
-          <a:bodyPr wrap="square" rtlCol="0" anchor="ctr"/>
-          <a:lstStyle/>
-          <a:p>
-            <a:pPr marL="0" indent="0">
-              <a:buNone/>
-            </a:pPr>
-            <a:r>
-              <a:rPr lang="en-US" sz="1200" dirty="0">
-                <a:solidFill>
-                  <a:srgbClr val="888888"/>
-                </a:solidFill>
-                <a:latin typeface="Arial" pitchFamily="34" charset="0"/>
-                <a:ea typeface="Arial" pitchFamily="34" charset="-122"/>
-                <a:cs typeface="Arial" pitchFamily="34" charset="-120"/>
-              </a:rPr>
-              <a:t>Core mechanics built. Daily check-ins via WhatsApp.</a:t>
-            </a:r>
-            <a:endParaRPr lang="en-US" sz="1200" dirty="0"/>
-          </a:p>
-        </p:txBody>
-      </p:sp>
-      <p:sp>
-        <p:nvSpPr>
-          <p:cNvPr id="13" name="Text 11"/>
-          <p:cNvSpPr/>
-          <p:nvPr/>
-        </p:nvSpPr>
-        <p:spPr>
-          <a:xfrm>
-            <a:off x="457200" y="2852928"/>
-            <a:ext cx="868680" cy="411480"/>
-          </a:xfrm>
-          <a:prstGeom prst="rect">
-            <a:avLst/>
-          </a:prstGeom>
-          <a:noFill/>
-          <a:ln/>
-        </p:spPr>
-        <p:txBody>
-          <a:bodyPr wrap="square" rtlCol="0" anchor="ctr">
-            <a:normAutofit/>
-          </a:bodyPr>
-          <a:lstStyle/>
-          <a:p>
-            <a:pPr marL="0" indent="0">
-              <a:buNone/>
-            </a:pPr>
-            <a:r>
-              <a:rPr lang="en-US" sz="2000" b="1" dirty="0">
-                <a:solidFill>
-                  <a:srgbClr val="FFCD00"/>
-                </a:solidFill>
-                <a:latin typeface="Arial Black" pitchFamily="34" charset="0"/>
-                <a:ea typeface="Arial Black" pitchFamily="34" charset="-122"/>
-                <a:cs typeface="Arial Black" pitchFamily="34" charset="-120"/>
-              </a:rPr>
-              <a:t>03</a:t>
-            </a:r>
-            <a:endParaRPr lang="en-US" sz="2000" dirty="0"/>
-          </a:p>
-        </p:txBody>
-      </p:sp>
-      <p:sp>
-        <p:nvSpPr>
-          <p:cNvPr id="14" name="Text 12"/>
-          <p:cNvSpPr/>
-          <p:nvPr/>
-        </p:nvSpPr>
-        <p:spPr>
-          <a:xfrm>
-            <a:off x="1371600" y="2834640"/>
-            <a:ext cx="7315200" cy="292608"/>
-          </a:xfrm>
-          <a:prstGeom prst="rect">
-            <a:avLst/>
-          </a:prstGeom>
-          <a:noFill/>
-          <a:ln/>
-        </p:spPr>
-        <p:txBody>
-          <a:bodyPr wrap="square" rtlCol="0" anchor="ctr"/>
-          <a:lstStyle/>
-          <a:p>
-            <a:pPr marL="0" indent="0">
-              <a:buNone/>
-            </a:pPr>
-            <a:r>
-              <a:rPr lang="en-US" sz="1700" b="1" dirty="0">
-                <a:solidFill>
-                  <a:srgbClr val="111111"/>
-                </a:solidFill>
-                <a:latin typeface="Arial Black" pitchFamily="34" charset="0"/>
-                <a:ea typeface="Arial Black" pitchFamily="34" charset="-122"/>
-                <a:cs typeface="Arial Black" pitchFamily="34" charset="-120"/>
-              </a:rPr>
-              <a:t>Sprint 3  —  Slicing &amp; sound</a:t>
-            </a:r>
-            <a:endParaRPr lang="en-US" sz="1700" dirty="0"/>
-          </a:p>
-        </p:txBody>
-      </p:sp>
-      <p:sp>
-        <p:nvSpPr>
-          <p:cNvPr id="15" name="Text 13"/>
-          <p:cNvSpPr/>
-          <p:nvPr/>
-        </p:nvSpPr>
-        <p:spPr>
-          <a:xfrm>
-            <a:off x="1371600" y="3136392"/>
-            <a:ext cx="7315200" cy="228600"/>
-          </a:xfrm>
-          <a:prstGeom prst="rect">
-            <a:avLst/>
-          </a:prstGeom>
-          <a:noFill/>
-          <a:ln/>
-        </p:spPr>
-        <p:txBody>
-          <a:bodyPr wrap="square" rtlCol="0" anchor="ctr"/>
-          <a:lstStyle/>
-          <a:p>
-            <a:pPr marL="0" indent="0">
-              <a:buNone/>
-            </a:pPr>
-            <a:r>
-              <a:rPr lang="en-US" sz="1200" dirty="0">
-                <a:solidFill>
-                  <a:srgbClr val="888888"/>
-                </a:solidFill>
-                <a:latin typeface="Arial" pitchFamily="34" charset="0"/>
-                <a:ea typeface="Arial" pitchFamily="34" charset="-122"/>
-                <a:cs typeface="Arial" pitchFamily="34" charset="-120"/>
-              </a:rPr>
-              <a:t>Visual integration. First merge conflicts resolved.</a:t>
-            </a:r>
-            <a:endParaRPr lang="en-US" sz="1200" dirty="0"/>
-          </a:p>
-        </p:txBody>
-      </p:sp>
-      <p:sp>
-        <p:nvSpPr>
-          <p:cNvPr id="16" name="Text 14"/>
-          <p:cNvSpPr/>
-          <p:nvPr/>
-        </p:nvSpPr>
-        <p:spPr>
-          <a:xfrm>
-            <a:off x="457200" y="3474720"/>
-            <a:ext cx="868680" cy="411480"/>
-          </a:xfrm>
-          <a:prstGeom prst="rect">
-            <a:avLst/>
-          </a:prstGeom>
-          <a:noFill/>
-          <a:ln/>
-        </p:spPr>
-        <p:txBody>
-          <a:bodyPr wrap="square" rtlCol="0" anchor="ctr">
-            <a:normAutofit/>
-          </a:bodyPr>
-          <a:lstStyle/>
-          <a:p>
-            <a:pPr marL="0" indent="0">
-              <a:buNone/>
-            </a:pPr>
-            <a:r>
-              <a:rPr lang="en-US" sz="2000" b="1" dirty="0">
-                <a:solidFill>
-                  <a:srgbClr val="FFCD00"/>
-                </a:solidFill>
-                <a:latin typeface="Arial Black" pitchFamily="34" charset="0"/>
-                <a:ea typeface="Arial Black" pitchFamily="34" charset="-122"/>
-                <a:cs typeface="Arial Black" pitchFamily="34" charset="-120"/>
-              </a:rPr>
-              <a:t>04</a:t>
-            </a:r>
-            <a:endParaRPr lang="en-US" sz="2000" dirty="0"/>
-          </a:p>
-        </p:txBody>
-      </p:sp>
-      <p:sp>
-        <p:nvSpPr>
-          <p:cNvPr id="17" name="Text 15"/>
-          <p:cNvSpPr/>
-          <p:nvPr/>
-        </p:nvSpPr>
-        <p:spPr>
-          <a:xfrm>
-            <a:off x="1371600" y="3456432"/>
-            <a:ext cx="7315200" cy="292608"/>
-          </a:xfrm>
-          <a:prstGeom prst="rect">
-            <a:avLst/>
-          </a:prstGeom>
-          <a:noFill/>
-          <a:ln/>
-        </p:spPr>
-        <p:txBody>
-          <a:bodyPr wrap="square" rtlCol="0" anchor="ctr"/>
-          <a:lstStyle/>
-          <a:p>
-            <a:pPr marL="0" indent="0">
-              <a:buNone/>
-            </a:pPr>
-            <a:r>
-              <a:rPr lang="en-US" sz="1700" b="1" dirty="0">
-                <a:solidFill>
-                  <a:srgbClr val="111111"/>
-                </a:solidFill>
-                <a:latin typeface="Arial Black" pitchFamily="34" charset="0"/>
-                <a:ea typeface="Arial Black" pitchFamily="34" charset="-122"/>
-                <a:cs typeface="Arial Black" pitchFamily="34" charset="-120"/>
-              </a:rPr>
-              <a:t>Sprint 4  —  Leaderboard</a:t>
-            </a:r>
-            <a:endParaRPr lang="en-US" sz="1700" dirty="0"/>
-          </a:p>
-        </p:txBody>
-      </p:sp>
-      <p:sp>
-        <p:nvSpPr>
-          <p:cNvPr id="18" name="Text 16"/>
-          <p:cNvSpPr/>
-          <p:nvPr/>
-        </p:nvSpPr>
-        <p:spPr>
-          <a:xfrm>
-            <a:off x="1371600" y="3758184"/>
-            <a:ext cx="7315200" cy="228600"/>
-          </a:xfrm>
-          <a:prstGeom prst="rect">
-            <a:avLst/>
-          </a:prstGeom>
-          <a:noFill/>
-          <a:ln/>
-        </p:spPr>
-        <p:txBody>
-          <a:bodyPr wrap="square" rtlCol="0" anchor="ctr"/>
-          <a:lstStyle/>
-          <a:p>
-            <a:pPr marL="0" indent="0">
-              <a:buNone/>
-            </a:pPr>
-            <a:r>
-              <a:rPr lang="en-US" sz="1200" dirty="0">
-                <a:solidFill>
-                  <a:srgbClr val="888888"/>
-                </a:solidFill>
-                <a:latin typeface="Arial" pitchFamily="34" charset="0"/>
-                <a:ea typeface="Arial" pitchFamily="34" charset="-122"/>
-                <a:cs typeface="Arial" pitchFamily="34" charset="-120"/>
-              </a:rPr>
-              <a:t>Peer testing begins. Feedback collected and logged.</a:t>
-            </a:r>
-            <a:endParaRPr lang="en-US" sz="1200" dirty="0"/>
-          </a:p>
-        </p:txBody>
-      </p:sp>
-      <p:sp>
-        <p:nvSpPr>
-          <p:cNvPr id="19" name="Text 17"/>
-          <p:cNvSpPr/>
-          <p:nvPr/>
-        </p:nvSpPr>
-        <p:spPr>
-          <a:xfrm>
-            <a:off x="457200" y="4096512"/>
-            <a:ext cx="868680" cy="411480"/>
-          </a:xfrm>
-          <a:prstGeom prst="rect">
-            <a:avLst/>
-          </a:prstGeom>
-          <a:noFill/>
-          <a:ln/>
-        </p:spPr>
-        <p:txBody>
-          <a:bodyPr wrap="square" rtlCol="0" anchor="ctr">
-            <a:normAutofit/>
-          </a:bodyPr>
-          <a:lstStyle/>
-          <a:p>
-            <a:pPr marL="0" indent="0">
-              <a:buNone/>
-            </a:pPr>
-            <a:r>
-              <a:rPr lang="en-US" sz="2000" b="1" dirty="0">
-                <a:solidFill>
-                  <a:srgbClr val="FFCD00"/>
-                </a:solidFill>
-                <a:latin typeface="Arial Black" pitchFamily="34" charset="0"/>
-                <a:ea typeface="Arial Black" pitchFamily="34" charset="-122"/>
-                <a:cs typeface="Arial Black" pitchFamily="34" charset="-120"/>
-              </a:rPr>
-              <a:t>05</a:t>
-            </a:r>
-            <a:endParaRPr lang="en-US" sz="2000" dirty="0"/>
-          </a:p>
-        </p:txBody>
-      </p:sp>
-      <p:sp>
-        <p:nvSpPr>
-          <p:cNvPr id="20" name="Text 18"/>
-          <p:cNvSpPr/>
-          <p:nvPr/>
-        </p:nvSpPr>
-        <p:spPr>
-          <a:xfrm>
-            <a:off x="1371600" y="4078224"/>
-            <a:ext cx="7315200" cy="292608"/>
-          </a:xfrm>
-          <a:prstGeom prst="rect">
-            <a:avLst/>
-          </a:prstGeom>
-          <a:noFill/>
-          <a:ln/>
-        </p:spPr>
-        <p:txBody>
-          <a:bodyPr wrap="square" rtlCol="0" anchor="ctr"/>
-          <a:lstStyle/>
-          <a:p>
-            <a:pPr marL="0" indent="0">
-              <a:buNone/>
-            </a:pPr>
-            <a:r>
-              <a:rPr lang="en-US" sz="1700" b="1" dirty="0">
-                <a:solidFill>
-                  <a:srgbClr val="111111"/>
-                </a:solidFill>
-                <a:latin typeface="Arial Black" pitchFamily="34" charset="0"/>
-                <a:ea typeface="Arial Black" pitchFamily="34" charset="-122"/>
-                <a:cs typeface="Arial Black" pitchFamily="34" charset="-120"/>
-              </a:rPr>
-              <a:t>Sprint 5  —  Testing &amp; polish</a:t>
-            </a:r>
-            <a:endParaRPr lang="en-US" sz="1700" dirty="0"/>
-          </a:p>
-        </p:txBody>
-      </p:sp>
-      <p:sp>
-        <p:nvSpPr>
-          <p:cNvPr id="21" name="Text 19"/>
-          <p:cNvSpPr/>
-          <p:nvPr/>
-        </p:nvSpPr>
-        <p:spPr>
-          <a:xfrm>
-            <a:off x="1371600" y="4379976"/>
-            <a:ext cx="7315200" cy="228600"/>
-          </a:xfrm>
-          <a:prstGeom prst="rect">
-            <a:avLst/>
-          </a:prstGeom>
-          <a:noFill/>
-          <a:ln/>
-        </p:spPr>
-        <p:txBody>
-          <a:bodyPr wrap="square" rtlCol="0" anchor="ctr"/>
-          <a:lstStyle/>
-          <a:p>
-            <a:pPr marL="0" indent="0">
-              <a:buNone/>
-            </a:pPr>
-            <a:r>
-              <a:rPr lang="en-US" sz="1200" dirty="0">
-                <a:solidFill>
-                  <a:srgbClr val="888888"/>
-                </a:solidFill>
-                <a:latin typeface="Arial" pitchFamily="34" charset="0"/>
-                <a:ea typeface="Arial" pitchFamily="34" charset="-122"/>
-                <a:cs typeface="Arial" pitchFamily="34" charset="-120"/>
-              </a:rPr>
-              <a:t>Bug hunt, final fixes, review before submission.</a:t>
-            </a:r>
-            <a:endParaRPr lang="en-US" sz="1200" dirty="0"/>
-          </a:p>
-        </p:txBody>
-      </p:sp>
-    </p:spTree>
-  </p:cSld>
-  <p:clrMapOvr>
-    <a:masterClrMapping/>
-  </p:clrMapOvr>
-</p:sld>
-</file>
-
-<file path=ppt/slides/slide11.xml><?xml version="1.0" encoding="utf-8"?>
-<p:sld xmlns:a="http://schemas.openxmlformats.org/drawingml/2006/main" xmlns:p="http://schemas.openxmlformats.org/presentationml/2006/main" xmlns:r="http://schemas.openxmlformats.org/officeDocument/2006/relationships">
-  <p:cSld>
-    <p:bg>
-      <p:bgPr>
-        <a:solidFill>
-          <a:srgbClr val="FFFFFF"/>
-        </a:solidFill>
-        <a:effectLst/>
-      </p:bgPr>
-    </p:bg>
-    <p:spTree>
-      <p:nvGrpSpPr>
-        <p:cNvPr id="1" name=""/>
-        <p:cNvGrpSpPr/>
-        <p:nvPr/>
-      </p:nvGrpSpPr>
-      <p:grpSpPr/>
-      <p:sp>
-        <p:nvSpPr>
-          <p:cNvPr id="2" name="TextBox 1"/>
-          <p:cNvSpPr txBox="1"/>
-          <p:nvPr/>
-        </p:nvSpPr>
-        <p:spPr>
-          <a:xfrm>
-            <a:off x="457200" y="256032"/>
-            <a:ext cx="6400800" cy="256032"/>
-          </a:xfrm>
-          <a:prstGeom prst="rect">
-            <a:avLst/>
-          </a:prstGeom>
-          <a:noFill/>
-        </p:spPr>
-        <p:txBody>
-          <a:bodyPr wrap="square">
-            <a:spAutoFit/>
-          </a:bodyPr>
-          <a:lstStyle/>
-          <a:p>
-            <a:pPr algn="l"/>
-            <a:r>
-              <a:rPr sz="1000" b="1" i="0">
-                <a:solidFill>
-                  <a:srgbClr val="888888"/>
-                </a:solidFill>
-              </a:rPr>
-              <a:t>SPRINT OUTCOMES</a:t>
-            </a:r>
-          </a:p>
-        </p:txBody>
-      </p:sp>
-      <p:sp>
-        <p:nvSpPr>
-          <p:cNvPr id="3" name="TextBox 2"/>
-          <p:cNvSpPr txBox="1"/>
-          <p:nvPr/>
-        </p:nvSpPr>
-        <p:spPr>
-          <a:xfrm>
-            <a:off x="3657600" y="4919472"/>
-            <a:ext cx="5212080" cy="182880"/>
-          </a:xfrm>
-          <a:prstGeom prst="rect">
-            <a:avLst/>
-          </a:prstGeom>
-          <a:noFill/>
-        </p:spPr>
-        <p:txBody>
-          <a:bodyPr wrap="square">
-            <a:spAutoFit/>
-          </a:bodyPr>
-          <a:lstStyle/>
-          <a:p>
-            <a:pPr algn="l"/>
-            <a:r>
-              <a:rPr sz="800" b="0" i="0">
-                <a:solidFill>
-                  <a:srgbClr val="888888"/>
-                </a:solidFill>
-              </a:rPr>
-              <a:t>NINJA QUIZ  .  503IT</a:t>
-            </a:r>
-          </a:p>
-        </p:txBody>
-      </p:sp>
-      <p:sp>
-        <p:nvSpPr>
-          <p:cNvPr id="4" name="TextBox 3"/>
-          <p:cNvSpPr txBox="1"/>
-          <p:nvPr/>
-        </p:nvSpPr>
-        <p:spPr>
-          <a:xfrm>
-            <a:off x="457200" y="658368"/>
-            <a:ext cx="8229600" cy="365760"/>
-          </a:xfrm>
-          <a:prstGeom prst="rect">
-            <a:avLst/>
-          </a:prstGeom>
-          <a:noFill/>
-        </p:spPr>
-        <p:txBody>
-          <a:bodyPr wrap="square">
-            <a:spAutoFit/>
-          </a:bodyPr>
-          <a:lstStyle/>
-          <a:p>
-            <a:pPr algn="l"/>
-            <a:r>
-              <a:rPr sz="1500" b="1" i="0">
-                <a:solidFill>
-                  <a:srgbClr val="111111"/>
-                </a:solidFill>
-              </a:rPr>
-              <a:t>What each sprint delivered — and what it taught the team.</a:t>
-            </a:r>
-          </a:p>
-        </p:txBody>
-      </p:sp>
-      <p:sp>
-        <p:nvSpPr>
-          <p:cNvPr id="5" name="TextBox 4"/>
-          <p:cNvSpPr txBox="1"/>
-          <p:nvPr/>
-        </p:nvSpPr>
-        <p:spPr>
-          <a:xfrm>
-            <a:off x="457200" y="1188720"/>
-            <a:ext cx="640080" cy="274320"/>
-          </a:xfrm>
-          <a:prstGeom prst="rect">
-            <a:avLst/>
-          </a:prstGeom>
-          <a:noFill/>
-        </p:spPr>
-        <p:txBody>
-          <a:bodyPr wrap="square">
-            <a:spAutoFit/>
-          </a:bodyPr>
-          <a:lstStyle/>
-          <a:p>
-            <a:pPr algn="l"/>
-            <a:r>
-              <a:rPr sz="1200" b="1" i="0">
-                <a:solidFill>
-                  <a:srgbClr val="FFCD00"/>
-                </a:solidFill>
-              </a:rPr>
-              <a:t>01</a:t>
-            </a:r>
-          </a:p>
-        </p:txBody>
-      </p:sp>
-      <p:sp>
-        <p:nvSpPr>
-          <p:cNvPr id="6" name="TextBox 5"/>
-          <p:cNvSpPr txBox="1"/>
-          <p:nvPr/>
-        </p:nvSpPr>
-        <p:spPr>
-          <a:xfrm>
-            <a:off x="1188720" y="1188720"/>
-            <a:ext cx="3657600" cy="256032"/>
-          </a:xfrm>
-          <a:prstGeom prst="rect">
-            <a:avLst/>
-          </a:prstGeom>
-          <a:noFill/>
-        </p:spPr>
-        <p:txBody>
-          <a:bodyPr wrap="square">
-            <a:spAutoFit/>
-          </a:bodyPr>
-          <a:lstStyle/>
-          <a:p>
-            <a:pPr algn="l"/>
-            <a:r>
-              <a:rPr sz="1200" b="1" i="0">
-                <a:solidFill>
-                  <a:srgbClr val="111111"/>
-                </a:solidFill>
-              </a:rPr>
-              <a:t>Sprint 1 — Setup &amp; Login</a:t>
-            </a:r>
-          </a:p>
-        </p:txBody>
-      </p:sp>
-      <p:sp>
-        <p:nvSpPr>
-          <p:cNvPr id="7" name="TextBox 6"/>
-          <p:cNvSpPr txBox="1"/>
-          <p:nvPr/>
-        </p:nvSpPr>
-        <p:spPr>
-          <a:xfrm>
-            <a:off x="1188720" y="1463040"/>
-            <a:ext cx="7680960" cy="457200"/>
-          </a:xfrm>
-          <a:prstGeom prst="rect">
-            <a:avLst/>
-          </a:prstGeom>
-          <a:noFill/>
-        </p:spPr>
-        <p:txBody>
-          <a:bodyPr wrap="square">
-            <a:spAutoFit/>
-          </a:bodyPr>
-          <a:lstStyle/>
-          <a:p>
-            <a:pPr algn="l"/>
-            <a:r>
-              <a:rPr sz="900" b="0" i="0">
-                <a:solidFill>
-                  <a:srgbClr val="555555"/>
-                </a:solidFill>
-              </a:rPr>
-              <a:t>Built: auth system, GitHub branches, role structure.</a:t>
-            </a:r>
-          </a:p>
-          <a:p>
-            <a:pPr algn="l"/>
-            <a:r>
-              <a:rPr sz="900" b="0" i="0">
-                <a:solidFill>
-                  <a:srgbClr val="555555"/>
-                </a:solidFill>
-              </a:rPr>
-              <a:t>Learned: agreeing roles before coding prevented overlap and blame.</a:t>
-            </a:r>
-          </a:p>
-        </p:txBody>
-      </p:sp>
-      <p:sp>
-        <p:nvSpPr>
-          <p:cNvPr id="8" name="TextBox 7"/>
-          <p:cNvSpPr txBox="1"/>
-          <p:nvPr/>
-        </p:nvSpPr>
-        <p:spPr>
-          <a:xfrm>
-            <a:off x="457200" y="1938528"/>
-            <a:ext cx="640080" cy="274320"/>
-          </a:xfrm>
-          <a:prstGeom prst="rect">
-            <a:avLst/>
-          </a:prstGeom>
-          <a:noFill/>
-        </p:spPr>
-        <p:txBody>
-          <a:bodyPr wrap="square">
-            <a:spAutoFit/>
-          </a:bodyPr>
-          <a:lstStyle/>
-          <a:p>
-            <a:pPr algn="l"/>
-            <a:r>
-              <a:rPr sz="1200" b="1" i="0">
-                <a:solidFill>
-                  <a:srgbClr val="FFCD00"/>
-                </a:solidFill>
-              </a:rPr>
-              <a:t>02</a:t>
-            </a:r>
-          </a:p>
-        </p:txBody>
-      </p:sp>
-      <p:sp>
-        <p:nvSpPr>
-          <p:cNvPr id="9" name="TextBox 8"/>
-          <p:cNvSpPr txBox="1"/>
-          <p:nvPr/>
-        </p:nvSpPr>
-        <p:spPr>
-          <a:xfrm>
-            <a:off x="1188720" y="1938528"/>
-            <a:ext cx="3657600" cy="256032"/>
-          </a:xfrm>
-          <a:prstGeom prst="rect">
-            <a:avLst/>
-          </a:prstGeom>
-          <a:noFill/>
-        </p:spPr>
-        <p:txBody>
-          <a:bodyPr wrap="square">
-            <a:spAutoFit/>
-          </a:bodyPr>
-          <a:lstStyle/>
-          <a:p>
-            <a:pPr algn="l"/>
-            <a:r>
-              <a:rPr sz="1200" b="1" i="0">
-                <a:solidFill>
-                  <a:srgbClr val="111111"/>
-                </a:solidFill>
-              </a:rPr>
-              <a:t>Sprint 2 — Game Engine</a:t>
-            </a:r>
-          </a:p>
-        </p:txBody>
-      </p:sp>
-      <p:sp>
-        <p:nvSpPr>
-          <p:cNvPr id="10" name="TextBox 9"/>
-          <p:cNvSpPr txBox="1"/>
-          <p:nvPr/>
-        </p:nvSpPr>
-        <p:spPr>
-          <a:xfrm>
-            <a:off x="1188720" y="2212848"/>
-            <a:ext cx="7680960" cy="457200"/>
-          </a:xfrm>
-          <a:prstGeom prst="rect">
-            <a:avLst/>
-          </a:prstGeom>
-          <a:noFill/>
-        </p:spPr>
-        <p:txBody>
-          <a:bodyPr wrap="square">
-            <a:spAutoFit/>
-          </a:bodyPr>
-          <a:lstStyle/>
-          <a:p>
-            <a:pPr algn="l"/>
-            <a:r>
-              <a:rPr sz="900" b="0" i="0">
-                <a:solidFill>
-                  <a:srgbClr val="555555"/>
-                </a:solidFill>
-              </a:rPr>
-              <a:t>Built: core quiz loop, slash mechanic.</a:t>
-            </a:r>
-          </a:p>
-          <a:p>
-            <a:pPr algn="l"/>
-            <a:r>
-              <a:rPr sz="900" b="0" i="0">
-                <a:solidFill>
-                  <a:srgbClr val="555555"/>
-                </a:solidFill>
-              </a:rPr>
-              <a:t>Learned: daily WhatsApp check-ins replaced long weekly catch-ups and kept everyone unblocked.</a:t>
-            </a:r>
-          </a:p>
-        </p:txBody>
-      </p:sp>
-      <p:sp>
-        <p:nvSpPr>
-          <p:cNvPr id="11" name="TextBox 10"/>
-          <p:cNvSpPr txBox="1"/>
-          <p:nvPr/>
-        </p:nvSpPr>
-        <p:spPr>
-          <a:xfrm>
-            <a:off x="457200" y="2688336"/>
-            <a:ext cx="640080" cy="274320"/>
-          </a:xfrm>
-          <a:prstGeom prst="rect">
-            <a:avLst/>
-          </a:prstGeom>
-          <a:noFill/>
-        </p:spPr>
-        <p:txBody>
-          <a:bodyPr wrap="square">
-            <a:spAutoFit/>
-          </a:bodyPr>
-          <a:lstStyle/>
-          <a:p>
-            <a:pPr algn="l"/>
-            <a:r>
-              <a:rPr sz="1200" b="1" i="0">
-                <a:solidFill>
-                  <a:srgbClr val="FFCD00"/>
-                </a:solidFill>
-              </a:rPr>
-              <a:t>03</a:t>
-            </a:r>
-          </a:p>
-        </p:txBody>
-      </p:sp>
-      <p:sp>
-        <p:nvSpPr>
-          <p:cNvPr id="12" name="TextBox 11"/>
-          <p:cNvSpPr txBox="1"/>
-          <p:nvPr/>
-        </p:nvSpPr>
-        <p:spPr>
-          <a:xfrm>
-            <a:off x="1188720" y="2688336"/>
-            <a:ext cx="3657600" cy="256032"/>
-          </a:xfrm>
-          <a:prstGeom prst="rect">
-            <a:avLst/>
-          </a:prstGeom>
-          <a:noFill/>
-        </p:spPr>
-        <p:txBody>
-          <a:bodyPr wrap="square">
-            <a:spAutoFit/>
-          </a:bodyPr>
-          <a:lstStyle/>
-          <a:p>
-            <a:pPr algn="l"/>
-            <a:r>
-              <a:rPr sz="1200" b="1" i="0">
-                <a:solidFill>
-                  <a:srgbClr val="111111"/>
-                </a:solidFill>
-              </a:rPr>
-              <a:t>Sprint 3 — Slicing &amp; Sound</a:t>
-            </a:r>
-          </a:p>
-        </p:txBody>
-      </p:sp>
-      <p:sp>
-        <p:nvSpPr>
-          <p:cNvPr id="13" name="TextBox 12"/>
-          <p:cNvSpPr txBox="1"/>
-          <p:nvPr/>
-        </p:nvSpPr>
-        <p:spPr>
-          <a:xfrm>
-            <a:off x="1188720" y="2962656"/>
-            <a:ext cx="7680960" cy="457200"/>
-          </a:xfrm>
-          <a:prstGeom prst="rect">
-            <a:avLst/>
-          </a:prstGeom>
-          <a:noFill/>
-        </p:spPr>
-        <p:txBody>
-          <a:bodyPr wrap="square">
-            <a:spAutoFit/>
-          </a:bodyPr>
-          <a:lstStyle/>
-          <a:p>
-            <a:pPr algn="l"/>
-            <a:r>
-              <a:rPr sz="900" b="0" i="0">
-                <a:solidFill>
-                  <a:srgbClr val="555555"/>
-                </a:solidFill>
-              </a:rPr>
-              <a:t>Built: animations, visual effects, audio.</a:t>
-            </a:r>
-          </a:p>
-          <a:p>
-            <a:pPr algn="l"/>
-            <a:r>
-              <a:rPr sz="900" b="0" i="0">
-                <a:solidFill>
-                  <a:srgbClr val="555555"/>
-                </a:solidFill>
-              </a:rPr>
-              <a:t>Learned: first merge conflicts taught us to always pull before push — a discipline we kept.</a:t>
-            </a:r>
-          </a:p>
-        </p:txBody>
-      </p:sp>
-      <p:sp>
-        <p:nvSpPr>
-          <p:cNvPr id="14" name="TextBox 13"/>
-          <p:cNvSpPr txBox="1"/>
-          <p:nvPr/>
-        </p:nvSpPr>
-        <p:spPr>
-          <a:xfrm>
-            <a:off x="457200" y="3438144"/>
-            <a:ext cx="640080" cy="274320"/>
-          </a:xfrm>
-          <a:prstGeom prst="rect">
-            <a:avLst/>
-          </a:prstGeom>
-          <a:noFill/>
-        </p:spPr>
-        <p:txBody>
-          <a:bodyPr wrap="square">
-            <a:spAutoFit/>
-          </a:bodyPr>
-          <a:lstStyle/>
-          <a:p>
-            <a:pPr algn="l"/>
-            <a:r>
-              <a:rPr sz="1200" b="1" i="0">
-                <a:solidFill>
-                  <a:srgbClr val="FFCD00"/>
-                </a:solidFill>
-              </a:rPr>
-              <a:t>04</a:t>
-            </a:r>
-          </a:p>
-        </p:txBody>
-      </p:sp>
-      <p:sp>
-        <p:nvSpPr>
-          <p:cNvPr id="15" name="TextBox 14"/>
-          <p:cNvSpPr txBox="1"/>
-          <p:nvPr/>
-        </p:nvSpPr>
-        <p:spPr>
-          <a:xfrm>
-            <a:off x="1188720" y="3438144"/>
-            <a:ext cx="3657600" cy="256032"/>
-          </a:xfrm>
-          <a:prstGeom prst="rect">
-            <a:avLst/>
-          </a:prstGeom>
-          <a:noFill/>
-        </p:spPr>
-        <p:txBody>
-          <a:bodyPr wrap="square">
-            <a:spAutoFit/>
-          </a:bodyPr>
-          <a:lstStyle/>
-          <a:p>
-            <a:pPr algn="l"/>
-            <a:r>
-              <a:rPr sz="1200" b="1" i="0">
-                <a:solidFill>
-                  <a:srgbClr val="111111"/>
-                </a:solidFill>
-              </a:rPr>
-              <a:t>Sprint 4 — Leaderboard &amp; Test</a:t>
-            </a:r>
-          </a:p>
-        </p:txBody>
-      </p:sp>
-      <p:sp>
-        <p:nvSpPr>
-          <p:cNvPr id="16" name="TextBox 15"/>
-          <p:cNvSpPr txBox="1"/>
-          <p:nvPr/>
-        </p:nvSpPr>
-        <p:spPr>
-          <a:xfrm>
-            <a:off x="1188720" y="3712463"/>
-            <a:ext cx="7680960" cy="457200"/>
-          </a:xfrm>
-          <a:prstGeom prst="rect">
-            <a:avLst/>
-          </a:prstGeom>
-          <a:noFill/>
-        </p:spPr>
-        <p:txBody>
-          <a:bodyPr wrap="square">
-            <a:spAutoFit/>
-          </a:bodyPr>
-          <a:lstStyle/>
-          <a:p>
-            <a:pPr algn="l"/>
-            <a:r>
-              <a:rPr sz="900" b="0" i="0">
-                <a:solidFill>
-                  <a:srgbClr val="555555"/>
-                </a:solidFill>
-              </a:rPr>
-              <a:t>Built: scoring, peer testing sessions.</a:t>
-            </a:r>
-          </a:p>
-          <a:p>
-            <a:pPr algn="l"/>
-            <a:r>
-              <a:rPr sz="900" b="0" i="0">
-                <a:solidFill>
-                  <a:srgbClr val="555555"/>
-                </a:solidFill>
-              </a:rPr>
-              <a:t>Learned: external testers found issues we missed — peer testing is essential, not optional.</a:t>
-            </a:r>
-          </a:p>
-        </p:txBody>
-      </p:sp>
-      <p:sp>
-        <p:nvSpPr>
-          <p:cNvPr id="17" name="TextBox 16"/>
-          <p:cNvSpPr txBox="1"/>
-          <p:nvPr/>
-        </p:nvSpPr>
-        <p:spPr>
-          <a:xfrm>
-            <a:off x="457200" y="4187952"/>
-            <a:ext cx="640080" cy="274320"/>
-          </a:xfrm>
-          <a:prstGeom prst="rect">
-            <a:avLst/>
-          </a:prstGeom>
-          <a:noFill/>
-        </p:spPr>
-        <p:txBody>
-          <a:bodyPr wrap="square">
-            <a:spAutoFit/>
-          </a:bodyPr>
-          <a:lstStyle/>
-          <a:p>
-            <a:pPr algn="l"/>
-            <a:r>
-              <a:rPr sz="1200" b="1" i="0">
-                <a:solidFill>
-                  <a:srgbClr val="FFCD00"/>
-                </a:solidFill>
-              </a:rPr>
-              <a:t>05</a:t>
-            </a:r>
-          </a:p>
-        </p:txBody>
-      </p:sp>
-      <p:sp>
-        <p:nvSpPr>
-          <p:cNvPr id="18" name="TextBox 17"/>
-          <p:cNvSpPr txBox="1"/>
-          <p:nvPr/>
-        </p:nvSpPr>
-        <p:spPr>
-          <a:xfrm>
-            <a:off x="1188720" y="4187952"/>
-            <a:ext cx="3657600" cy="256032"/>
-          </a:xfrm>
-          <a:prstGeom prst="rect">
-            <a:avLst/>
-          </a:prstGeom>
-          <a:noFill/>
-        </p:spPr>
-        <p:txBody>
-          <a:bodyPr wrap="square">
-            <a:spAutoFit/>
-          </a:bodyPr>
-          <a:lstStyle/>
-          <a:p>
-            <a:pPr algn="l"/>
-            <a:r>
-              <a:rPr sz="1200" b="1" i="0">
-                <a:solidFill>
-                  <a:srgbClr val="111111"/>
-                </a:solidFill>
-              </a:rPr>
-              <a:t>Sprint 5 — Polish &amp; Submit</a:t>
-            </a:r>
-          </a:p>
-        </p:txBody>
-      </p:sp>
-      <p:sp>
-        <p:nvSpPr>
-          <p:cNvPr id="19" name="TextBox 18"/>
-          <p:cNvSpPr txBox="1"/>
-          <p:nvPr/>
-        </p:nvSpPr>
-        <p:spPr>
-          <a:xfrm>
-            <a:off x="1188720" y="4462272"/>
-            <a:ext cx="7680960" cy="457200"/>
-          </a:xfrm>
-          <a:prstGeom prst="rect">
-            <a:avLst/>
-          </a:prstGeom>
-          <a:noFill/>
-        </p:spPr>
-        <p:txBody>
-          <a:bodyPr wrap="square">
-            <a:spAutoFit/>
-          </a:bodyPr>
-          <a:lstStyle/>
-          <a:p>
-            <a:pPr algn="l"/>
-            <a:r>
-              <a:rPr sz="900" b="0" i="0">
-                <a:solidFill>
-                  <a:srgbClr val="555555"/>
-                </a:solidFill>
-              </a:rPr>
-              <a:t>Built: final bug fixes, documentation.</a:t>
-            </a:r>
-          </a:p>
-          <a:p>
-            <a:pPr algn="l"/>
-            <a:r>
-              <a:rPr sz="900" b="0" i="0">
-                <a:solidFill>
-                  <a:srgbClr val="555555"/>
-                </a:solidFill>
-              </a:rPr>
-              <a:t>Learned: a team that communicates daily ships on time. We did.</a:t>
-            </a:r>
-          </a:p>
-        </p:txBody>
-      </p:sp>
-    </p:spTree>
-  </p:cSld>
-  <p:clrMapOvr>
-    <a:masterClrMapping/>
-  </p:clrMapOvr>
-</p:sld>
-</file>
-
-<file path=ppt/slides/slide12.xml><?xml version="1.0" encoding="utf-8"?>
-<p:sld xmlns:a="http://schemas.openxmlformats.org/drawingml/2006/main" xmlns:r="http://schemas.openxmlformats.org/officeDocument/2006/relationships" xmlns:p="http://schemas.openxmlformats.org/presentationml/2006/main">
   <p:cSld name="Slide 10">
     <p:bg>
       <p:bgPr>
@@ -4047,7 +2467,7 @@
 </p:sld>
 </file>
 
-<file path=ppt/slides/slide13.xml><?xml version="1.0" encoding="utf-8"?>
+<file path=ppt/slides/slide11.xml><?xml version="1.0" encoding="utf-8"?>
 <p:sld xmlns:a="http://schemas.openxmlformats.org/drawingml/2006/main" xmlns:r="http://schemas.openxmlformats.org/officeDocument/2006/relationships" xmlns:p="http://schemas.openxmlformats.org/presentationml/2006/main">
   <p:cSld name="Slide 11">
     <p:bg>
@@ -4722,7 +3142,7 @@
 </p:sld>
 </file>
 
-<file path=ppt/slides/slide14.xml><?xml version="1.0" encoding="utf-8"?>
+<file path=ppt/slides/slide12.xml><?xml version="1.0" encoding="utf-8"?>
 <p:sld xmlns:a="http://schemas.openxmlformats.org/drawingml/2006/main" xmlns:r="http://schemas.openxmlformats.org/officeDocument/2006/relationships" xmlns:p="http://schemas.openxmlformats.org/presentationml/2006/main">
   <p:cSld name="Slide 12">
     <p:bg>
@@ -5322,7 +3742,7 @@
 </p:sld>
 </file>
 
-<file path=ppt/slides/slide15.xml><?xml version="1.0" encoding="utf-8"?>
+<file path=ppt/slides/slide13.xml><?xml version="1.0" encoding="utf-8"?>
 <p:sld xmlns:a="http://schemas.openxmlformats.org/drawingml/2006/main" xmlns:r="http://schemas.openxmlformats.org/officeDocument/2006/relationships" xmlns:p="http://schemas.openxmlformats.org/presentationml/2006/main">
   <p:cSld name="Slide 13">
     <p:bg>
@@ -5527,7 +3947,7 @@
 </p:sld>
 </file>
 
-<file path=ppt/slides/slide16.xml><?xml version="1.0" encoding="utf-8"?>
+<file path=ppt/slides/slide14.xml><?xml version="1.0" encoding="utf-8"?>
 <p:sld xmlns:a="http://schemas.openxmlformats.org/drawingml/2006/main" xmlns:r="http://schemas.openxmlformats.org/officeDocument/2006/relationships" xmlns:p="http://schemas.openxmlformats.org/presentationml/2006/main">
   <p:cSld name="Slide 14">
     <p:bg>
@@ -6391,7 +4811,7 @@
 </p:sld>
 </file>
 
-<file path=ppt/slides/slide17.xml><?xml version="1.0" encoding="utf-8"?>
+<file path=ppt/slides/slide15.xml><?xml version="1.0" encoding="utf-8"?>
 <p:sld xmlns:a="http://schemas.openxmlformats.org/drawingml/2006/main" xmlns:r="http://schemas.openxmlformats.org/officeDocument/2006/relationships" xmlns:p="http://schemas.openxmlformats.org/presentationml/2006/main">
   <p:cSld name="Slide 15">
     <p:bg>
@@ -7084,7 +5504,7 @@
 </p:sld>
 </file>
 
-<file path=ppt/slides/slide18.xml><?xml version="1.0" encoding="utf-8"?>
+<file path=ppt/slides/slide16.xml><?xml version="1.0" encoding="utf-8"?>
 <p:sld xmlns:a="http://schemas.openxmlformats.org/drawingml/2006/main" xmlns:r="http://schemas.openxmlformats.org/officeDocument/2006/relationships" xmlns:p="http://schemas.openxmlformats.org/presentationml/2006/main">
   <p:cSld name="Slide 16">
     <p:bg>
@@ -7262,7 +5682,7 @@
           <p:nvPr/>
         </p:nvPicPr>
         <p:blipFill>
-          <a:blip r:embed="rId4"/>
+          <a:blip r:embed="rId3"/>
           <a:stretch>
             <a:fillRect/>
           </a:stretch>
@@ -7285,7 +5705,7 @@
 </p:sld>
 </file>
 
-<file path=ppt/slides/slide19.xml><?xml version="1.0" encoding="utf-8"?>
+<file path=ppt/slides/slide17.xml><?xml version="1.0" encoding="utf-8"?>
 <p:sld xmlns:a="http://schemas.openxmlformats.org/drawingml/2006/main" xmlns:r="http://schemas.openxmlformats.org/officeDocument/2006/relationships" xmlns:p="http://schemas.openxmlformats.org/presentationml/2006/main">
   <p:cSld name="Slide 17">
     <p:bg>
@@ -7545,8 +5965,8 @@
 </p:sld>
 </file>
 
-<file path=ppt/slides/slide2.xml><?xml version="1.0" encoding="utf-8"?>
-<p:sld xmlns:a="http://schemas.openxmlformats.org/drawingml/2006/main" xmlns:p="http://schemas.openxmlformats.org/presentationml/2006/main" xmlns:r="http://schemas.openxmlformats.org/officeDocument/2006/relationships">
+<file path=ppt/slides/slide18.xml><?xml version="1.0" encoding="utf-8"?>
+<p:sld xmlns:a="http://schemas.openxmlformats.org/drawingml/2006/main" xmlns:r="http://schemas.openxmlformats.org/officeDocument/2006/relationships" xmlns:p="http://schemas.openxmlformats.org/presentationml/2006/main">
   <p:cSld>
     <p:bg>
       <p:bgPr>
@@ -7562,7 +5982,14 @@
         <p:cNvGrpSpPr/>
         <p:nvPr/>
       </p:nvGrpSpPr>
-      <p:grpSpPr/>
+      <p:grpSpPr>
+        <a:xfrm>
+          <a:off x="0" y="0"/>
+          <a:ext cx="0" cy="0"/>
+          <a:chOff x="0" y="0"/>
+          <a:chExt cx="0" cy="0"/>
+        </a:xfrm>
+      </p:grpSpPr>
       <p:sp>
         <p:nvSpPr>
           <p:cNvPr id="2" name="TextBox 1"/>
@@ -7572,7 +5999,7 @@
         <p:spPr>
           <a:xfrm>
             <a:off x="457200" y="256032"/>
-            <a:ext cx="6400800" cy="256032"/>
+            <a:ext cx="6858000" cy="256032"/>
           </a:xfrm>
           <a:prstGeom prst="rect">
             <a:avLst/>
@@ -7592,7 +6019,7 @@
                   <a:srgbClr val="888888"/>
                 </a:solidFill>
               </a:rPr>
-              <a:t>WHAT WE WILL COVER</a:t>
+              <a:t>PROFESSIONAL DEVELOPMENT</a:t>
             </a:r>
           </a:p>
         </p:txBody>
@@ -7655,23 +6082,23 @@
           <a:p>
             <a:pPr algn="l"/>
             <a:r>
-              <a:rPr sz="3400" b="1" i="0">
+              <a:rPr sz="2800" b="1" i="0">
                 <a:solidFill>
                   <a:srgbClr val="FFFFFF"/>
                 </a:solidFill>
               </a:rPr>
-              <a:t>15 minutes.</a:t>
+              <a:t>This project taught us how</a:t>
             </a:r>
           </a:p>
           <a:p>
             <a:pPr algn="l"/>
             <a:r>
-              <a:rPr sz="3400" b="1" i="0">
+              <a:rPr sz="2800" b="1" i="0">
                 <a:solidFill>
                   <a:srgbClr val="FFFFFF"/>
                 </a:solidFill>
               </a:rPr>
-              <a:t>One story.</a:t>
+              <a:t>industry teams actually work.</a:t>
             </a:r>
           </a:p>
         </p:txBody>
@@ -7685,7 +6112,7 @@
         <p:spPr>
           <a:xfrm>
             <a:off x="457200" y="1874519"/>
-            <a:ext cx="640080" cy="292608"/>
+            <a:ext cx="3840480" cy="256032"/>
           </a:xfrm>
           <a:prstGeom prst="rect">
             <a:avLst/>
@@ -7700,12 +6127,12 @@
           <a:p>
             <a:pPr algn="l"/>
             <a:r>
-              <a:rPr sz="1200" b="1" i="0">
+              <a:rPr sz="1300" b="1" i="0">
                 <a:solidFill>
                   <a:srgbClr val="FFCD00"/>
                 </a:solidFill>
               </a:rPr>
-              <a:t>01</a:t>
+              <a:t>Structured communication</a:t>
             </a:r>
           </a:p>
         </p:txBody>
@@ -7718,8 +6145,8 @@
         </p:nvSpPr>
         <p:spPr>
           <a:xfrm>
-            <a:off x="1188720" y="1874519"/>
-            <a:ext cx="7680960" cy="292608"/>
+            <a:off x="457200" y="2148839"/>
+            <a:ext cx="8229600" cy="411480"/>
           </a:xfrm>
           <a:prstGeom prst="rect">
             <a:avLst/>
@@ -7734,12 +6161,12 @@
           <a:p>
             <a:pPr algn="l"/>
             <a:r>
-              <a:rPr sz="1200" b="0" i="0">
-                <a:solidFill>
-                  <a:srgbClr val="DDDDDD"/>
-                </a:solidFill>
-              </a:rPr>
-              <a:t>The brief — and why we chose this audience</a:t>
+              <a:rPr sz="1100" b="0" i="0">
+                <a:solidFill>
+                  <a:srgbClr val="AAAAAA"/>
+                </a:solidFill>
+              </a:rPr>
+              <a:t>Raising issues immediately, logging decisions in Trello and meeting minutes — these are professional standards, not student habits.</a:t>
             </a:r>
           </a:p>
         </p:txBody>
@@ -7752,8 +6179,8 @@
         </p:nvSpPr>
         <p:spPr>
           <a:xfrm>
-            <a:off x="457200" y="2331720"/>
-            <a:ext cx="640080" cy="292608"/>
+            <a:off x="457200" y="2697479"/>
+            <a:ext cx="3840480" cy="256032"/>
           </a:xfrm>
           <a:prstGeom prst="rect">
             <a:avLst/>
@@ -7768,12 +6195,12 @@
           <a:p>
             <a:pPr algn="l"/>
             <a:r>
-              <a:rPr sz="1200" b="1" i="0">
+              <a:rPr sz="1300" b="1" i="0">
                 <a:solidFill>
                   <a:srgbClr val="FFCD00"/>
                 </a:solidFill>
               </a:rPr>
-              <a:t>02</a:t>
+              <a:t>Real version control</a:t>
             </a:r>
           </a:p>
         </p:txBody>
@@ -7786,8 +6213,8 @@
         </p:nvSpPr>
         <p:spPr>
           <a:xfrm>
-            <a:off x="1188720" y="2331720"/>
-            <a:ext cx="7680960" cy="292608"/>
+            <a:off x="457200" y="2971799"/>
+            <a:ext cx="8229600" cy="411480"/>
           </a:xfrm>
           <a:prstGeom prst="rect">
             <a:avLst/>
@@ -7802,12 +6229,12 @@
           <a:p>
             <a:pPr algn="l"/>
             <a:r>
-              <a:rPr sz="1200" b="0" i="0">
-                <a:solidFill>
-                  <a:srgbClr val="DDDDDD"/>
-                </a:solidFill>
-              </a:rPr>
-              <a:t>Our team — roles and Belbin framework</a:t>
+              <a:rPr sz="1100" b="0" i="0">
+                <a:solidFill>
+                  <a:srgbClr val="AAAAAA"/>
+                </a:solidFill>
+              </a:rPr>
+              <a:t>Feature branches, no pushing to main without review. We left this project with actual Git workflow experience.</a:t>
             </a:r>
           </a:p>
         </p:txBody>
@@ -7820,8 +6247,8 @@
         </p:nvSpPr>
         <p:spPr>
           <a:xfrm>
-            <a:off x="457200" y="2788920"/>
-            <a:ext cx="640080" cy="292608"/>
+            <a:off x="457200" y="3520439"/>
+            <a:ext cx="3840480" cy="256032"/>
           </a:xfrm>
           <a:prstGeom prst="rect">
             <a:avLst/>
@@ -7836,12 +6263,12 @@
           <a:p>
             <a:pPr algn="l"/>
             <a:r>
-              <a:rPr sz="1200" b="1" i="0">
+              <a:rPr sz="1300" b="1" i="0">
                 <a:solidFill>
                   <a:srgbClr val="FFCD00"/>
                 </a:solidFill>
               </a:rPr>
-              <a:t>03</a:t>
+              <a:t>Agile delivery mindset</a:t>
             </a:r>
           </a:p>
         </p:txBody>
@@ -7854,8 +6281,8 @@
         </p:nvSpPr>
         <p:spPr>
           <a:xfrm>
-            <a:off x="1188720" y="2788920"/>
-            <a:ext cx="7680960" cy="292608"/>
+            <a:off x="457200" y="3794759"/>
+            <a:ext cx="8229600" cy="411480"/>
           </a:xfrm>
           <a:prstGeom prst="rect">
             <a:avLst/>
@@ -7870,12 +6297,12 @@
           <a:p>
             <a:pPr algn="l"/>
             <a:r>
-              <a:rPr sz="1200" b="0" i="0">
-                <a:solidFill>
-                  <a:srgbClr val="DDDDDD"/>
-                </a:solidFill>
-              </a:rPr>
-              <a:t>How we planned, communicated and tracked work</a:t>
+              <a:rPr sz="1100" b="0" i="0">
+                <a:solidFill>
+                  <a:srgbClr val="AAAAAA"/>
+                </a:solidFill>
+              </a:rPr>
+              <a:t>Five sprints with goals, retrospectives, and user testing mirrors how software teams ship in industry.</a:t>
             </a:r>
           </a:p>
         </p:txBody>
@@ -7888,8 +6315,8 @@
         </p:nvSpPr>
         <p:spPr>
           <a:xfrm>
-            <a:off x="457200" y="3246120"/>
-            <a:ext cx="640080" cy="292608"/>
+            <a:off x="457200" y="4343400"/>
+            <a:ext cx="3840480" cy="256032"/>
           </a:xfrm>
           <a:prstGeom prst="rect">
             <a:avLst/>
@@ -7904,12 +6331,12 @@
           <a:p>
             <a:pPr algn="l"/>
             <a:r>
-              <a:rPr sz="1200" b="1" i="0">
+              <a:rPr sz="1300" b="1" i="0">
                 <a:solidFill>
                   <a:srgbClr val="FFCD00"/>
                 </a:solidFill>
               </a:rPr>
-              <a:t>04</a:t>
+              <a:t>Resilience under pressure</a:t>
             </a:r>
           </a:p>
         </p:txBody>
@@ -7922,8 +6349,8 @@
         </p:nvSpPr>
         <p:spPr>
           <a:xfrm>
-            <a:off x="1188720" y="3246120"/>
-            <a:ext cx="7680960" cy="292608"/>
+            <a:off x="457200" y="4617720"/>
+            <a:ext cx="8229600" cy="411480"/>
           </a:xfrm>
           <a:prstGeom prst="rect">
             <a:avLst/>
@@ -7938,148 +6365,12 @@
           <a:p>
             <a:pPr algn="l"/>
             <a:r>
-              <a:rPr sz="1200" b="0" i="0">
-                <a:solidFill>
-                  <a:srgbClr val="DDDDDD"/>
-                </a:solidFill>
-              </a:rPr>
-              <a:t>Our delivery — 5 sprints and what each taught us</a:t>
-            </a:r>
-          </a:p>
-        </p:txBody>
-      </p:sp>
-      <p:sp>
-        <p:nvSpPr>
-          <p:cNvPr id="13" name="TextBox 12"/>
-          <p:cNvSpPr txBox="1"/>
-          <p:nvPr/>
-        </p:nvSpPr>
-        <p:spPr>
-          <a:xfrm>
-            <a:off x="457200" y="3703320"/>
-            <a:ext cx="640080" cy="292608"/>
-          </a:xfrm>
-          <a:prstGeom prst="rect">
-            <a:avLst/>
-          </a:prstGeom>
-          <a:noFill/>
-        </p:spPr>
-        <p:txBody>
-          <a:bodyPr wrap="square">
-            <a:spAutoFit/>
-          </a:bodyPr>
-          <a:lstStyle/>
-          <a:p>
-            <a:pPr algn="l"/>
-            <a:r>
-              <a:rPr sz="1200" b="1" i="0">
-                <a:solidFill>
-                  <a:srgbClr val="FFCD00"/>
-                </a:solidFill>
-              </a:rPr>
-              <a:t>05</a:t>
-            </a:r>
-          </a:p>
-        </p:txBody>
-      </p:sp>
-      <p:sp>
-        <p:nvSpPr>
-          <p:cNvPr id="14" name="TextBox 13"/>
-          <p:cNvSpPr txBox="1"/>
-          <p:nvPr/>
-        </p:nvSpPr>
-        <p:spPr>
-          <a:xfrm>
-            <a:off x="1188720" y="3703320"/>
-            <a:ext cx="7680960" cy="292608"/>
-          </a:xfrm>
-          <a:prstGeom prst="rect">
-            <a:avLst/>
-          </a:prstGeom>
-          <a:noFill/>
-        </p:spPr>
-        <p:txBody>
-          <a:bodyPr wrap="square">
-            <a:spAutoFit/>
-          </a:bodyPr>
-          <a:lstStyle/>
-          <a:p>
-            <a:pPr algn="l"/>
-            <a:r>
-              <a:rPr sz="1200" b="0" i="0">
-                <a:solidFill>
-                  <a:srgbClr val="DDDDDD"/>
-                </a:solidFill>
-              </a:rPr>
-              <a:t>The product — a live, playable prototype</a:t>
-            </a:r>
-          </a:p>
-        </p:txBody>
-      </p:sp>
-      <p:sp>
-        <p:nvSpPr>
-          <p:cNvPr id="15" name="TextBox 14"/>
-          <p:cNvSpPr txBox="1"/>
-          <p:nvPr/>
-        </p:nvSpPr>
-        <p:spPr>
-          <a:xfrm>
-            <a:off x="457200" y="4160520"/>
-            <a:ext cx="640080" cy="292608"/>
-          </a:xfrm>
-          <a:prstGeom prst="rect">
-            <a:avLst/>
-          </a:prstGeom>
-          <a:noFill/>
-        </p:spPr>
-        <p:txBody>
-          <a:bodyPr wrap="square">
-            <a:spAutoFit/>
-          </a:bodyPr>
-          <a:lstStyle/>
-          <a:p>
-            <a:pPr algn="l"/>
-            <a:r>
-              <a:rPr sz="1200" b="1" i="0">
-                <a:solidFill>
-                  <a:srgbClr val="FFCD00"/>
-                </a:solidFill>
-              </a:rPr>
-              <a:t>06</a:t>
-            </a:r>
-          </a:p>
-        </p:txBody>
-      </p:sp>
-      <p:sp>
-        <p:nvSpPr>
-          <p:cNvPr id="16" name="TextBox 15"/>
-          <p:cNvSpPr txBox="1"/>
-          <p:nvPr/>
-        </p:nvSpPr>
-        <p:spPr>
-          <a:xfrm>
-            <a:off x="1188720" y="4160520"/>
-            <a:ext cx="7680960" cy="292608"/>
-          </a:xfrm>
-          <a:prstGeom prst="rect">
-            <a:avLst/>
-          </a:prstGeom>
-          <a:noFill/>
-        </p:spPr>
-        <p:txBody>
-          <a:bodyPr wrap="square">
-            <a:spAutoFit/>
-          </a:bodyPr>
-          <a:lstStyle/>
-          <a:p>
-            <a:pPr algn="l"/>
-            <a:r>
-              <a:rPr sz="1200" b="0" i="0">
-                <a:solidFill>
-                  <a:srgbClr val="DDDDDD"/>
-                </a:solidFill>
-              </a:rPr>
-              <a:t>What we learned — and how it shapes our careers</a:t>
+              <a:rPr sz="1100" b="0" i="0">
+                <a:solidFill>
+                  <a:srgbClr val="AAAAAA"/>
+                </a:solidFill>
+              </a:rPr>
+              <a:t>When the game broke 2 weeks before submission, we diagnosed and fixed it in one day — as a team. That experience is irreplaceable.</a:t>
             </a:r>
           </a:p>
         </p:txBody>
@@ -8092,418 +6383,7 @@
 </p:sld>
 </file>
 
-<file path=ppt/slides/slide20.xml><?xml version="1.0" encoding="utf-8"?>
-<p:sld xmlns:a="http://schemas.openxmlformats.org/drawingml/2006/main" xmlns:p="http://schemas.openxmlformats.org/presentationml/2006/main" xmlns:r="http://schemas.openxmlformats.org/officeDocument/2006/relationships">
-  <p:cSld>
-    <p:bg>
-      <p:bgPr>
-        <a:solidFill>
-          <a:srgbClr val="0D0D0D"/>
-        </a:solidFill>
-        <a:effectLst/>
-      </p:bgPr>
-    </p:bg>
-    <p:spTree>
-      <p:nvGrpSpPr>
-        <p:cNvPr id="1" name=""/>
-        <p:cNvGrpSpPr/>
-        <p:nvPr/>
-      </p:nvGrpSpPr>
-      <p:grpSpPr/>
-      <p:sp>
-        <p:nvSpPr>
-          <p:cNvPr id="2" name="TextBox 1"/>
-          <p:cNvSpPr txBox="1"/>
-          <p:nvPr/>
-        </p:nvSpPr>
-        <p:spPr>
-          <a:xfrm>
-            <a:off x="457200" y="256032"/>
-            <a:ext cx="6858000" cy="256032"/>
-          </a:xfrm>
-          <a:prstGeom prst="rect">
-            <a:avLst/>
-          </a:prstGeom>
-          <a:noFill/>
-        </p:spPr>
-        <p:txBody>
-          <a:bodyPr wrap="square">
-            <a:spAutoFit/>
-          </a:bodyPr>
-          <a:lstStyle/>
-          <a:p>
-            <a:pPr algn="l"/>
-            <a:r>
-              <a:rPr sz="1000" b="1" i="0">
-                <a:solidFill>
-                  <a:srgbClr val="888888"/>
-                </a:solidFill>
-              </a:rPr>
-              <a:t>PROFESSIONAL DEVELOPMENT</a:t>
-            </a:r>
-          </a:p>
-        </p:txBody>
-      </p:sp>
-      <p:sp>
-        <p:nvSpPr>
-          <p:cNvPr id="3" name="TextBox 2"/>
-          <p:cNvSpPr txBox="1"/>
-          <p:nvPr/>
-        </p:nvSpPr>
-        <p:spPr>
-          <a:xfrm>
-            <a:off x="3657600" y="4919472"/>
-            <a:ext cx="5212080" cy="182880"/>
-          </a:xfrm>
-          <a:prstGeom prst="rect">
-            <a:avLst/>
-          </a:prstGeom>
-          <a:noFill/>
-        </p:spPr>
-        <p:txBody>
-          <a:bodyPr wrap="square">
-            <a:spAutoFit/>
-          </a:bodyPr>
-          <a:lstStyle/>
-          <a:p>
-            <a:pPr algn="l"/>
-            <a:r>
-              <a:rPr sz="800" b="0" i="0">
-                <a:solidFill>
-                  <a:srgbClr val="444444"/>
-                </a:solidFill>
-              </a:rPr>
-              <a:t>NINJA QUIZ  .  503IT</a:t>
-            </a:r>
-          </a:p>
-        </p:txBody>
-      </p:sp>
-      <p:sp>
-        <p:nvSpPr>
-          <p:cNvPr id="4" name="TextBox 3"/>
-          <p:cNvSpPr txBox="1"/>
-          <p:nvPr/>
-        </p:nvSpPr>
-        <p:spPr>
-          <a:xfrm>
-            <a:off x="457200" y="594360"/>
-            <a:ext cx="8229600" cy="1097280"/>
-          </a:xfrm>
-          <a:prstGeom prst="rect">
-            <a:avLst/>
-          </a:prstGeom>
-          <a:noFill/>
-        </p:spPr>
-        <p:txBody>
-          <a:bodyPr wrap="square">
-            <a:spAutoFit/>
-          </a:bodyPr>
-          <a:lstStyle/>
-          <a:p>
-            <a:pPr algn="l"/>
-            <a:r>
-              <a:rPr sz="2800" b="1" i="0">
-                <a:solidFill>
-                  <a:srgbClr val="FFFFFF"/>
-                </a:solidFill>
-              </a:rPr>
-              <a:t>This project taught us how</a:t>
-            </a:r>
-          </a:p>
-          <a:p>
-            <a:pPr algn="l"/>
-            <a:r>
-              <a:rPr sz="2800" b="1" i="0">
-                <a:solidFill>
-                  <a:srgbClr val="FFFFFF"/>
-                </a:solidFill>
-              </a:rPr>
-              <a:t>industry teams actually work.</a:t>
-            </a:r>
-          </a:p>
-        </p:txBody>
-      </p:sp>
-      <p:sp>
-        <p:nvSpPr>
-          <p:cNvPr id="5" name="TextBox 4"/>
-          <p:cNvSpPr txBox="1"/>
-          <p:nvPr/>
-        </p:nvSpPr>
-        <p:spPr>
-          <a:xfrm>
-            <a:off x="457200" y="1874519"/>
-            <a:ext cx="3840480" cy="256032"/>
-          </a:xfrm>
-          <a:prstGeom prst="rect">
-            <a:avLst/>
-          </a:prstGeom>
-          <a:noFill/>
-        </p:spPr>
-        <p:txBody>
-          <a:bodyPr wrap="square">
-            <a:spAutoFit/>
-          </a:bodyPr>
-          <a:lstStyle/>
-          <a:p>
-            <a:pPr algn="l"/>
-            <a:r>
-              <a:rPr sz="1300" b="1" i="0">
-                <a:solidFill>
-                  <a:srgbClr val="FFCD00"/>
-                </a:solidFill>
-              </a:rPr>
-              <a:t>Structured communication</a:t>
-            </a:r>
-          </a:p>
-        </p:txBody>
-      </p:sp>
-      <p:sp>
-        <p:nvSpPr>
-          <p:cNvPr id="6" name="TextBox 5"/>
-          <p:cNvSpPr txBox="1"/>
-          <p:nvPr/>
-        </p:nvSpPr>
-        <p:spPr>
-          <a:xfrm>
-            <a:off x="457200" y="2148839"/>
-            <a:ext cx="8229600" cy="411480"/>
-          </a:xfrm>
-          <a:prstGeom prst="rect">
-            <a:avLst/>
-          </a:prstGeom>
-          <a:noFill/>
-        </p:spPr>
-        <p:txBody>
-          <a:bodyPr wrap="square">
-            <a:spAutoFit/>
-          </a:bodyPr>
-          <a:lstStyle/>
-          <a:p>
-            <a:pPr algn="l"/>
-            <a:r>
-              <a:rPr sz="1100" b="0" i="0">
-                <a:solidFill>
-                  <a:srgbClr val="AAAAAA"/>
-                </a:solidFill>
-              </a:rPr>
-              <a:t>Raising issues immediately, logging decisions in Trello and meeting minutes — these are professional standards, not student habits.</a:t>
-            </a:r>
-          </a:p>
-        </p:txBody>
-      </p:sp>
-      <p:sp>
-        <p:nvSpPr>
-          <p:cNvPr id="7" name="TextBox 6"/>
-          <p:cNvSpPr txBox="1"/>
-          <p:nvPr/>
-        </p:nvSpPr>
-        <p:spPr>
-          <a:xfrm>
-            <a:off x="457200" y="2697479"/>
-            <a:ext cx="3840480" cy="256032"/>
-          </a:xfrm>
-          <a:prstGeom prst="rect">
-            <a:avLst/>
-          </a:prstGeom>
-          <a:noFill/>
-        </p:spPr>
-        <p:txBody>
-          <a:bodyPr wrap="square">
-            <a:spAutoFit/>
-          </a:bodyPr>
-          <a:lstStyle/>
-          <a:p>
-            <a:pPr algn="l"/>
-            <a:r>
-              <a:rPr sz="1300" b="1" i="0">
-                <a:solidFill>
-                  <a:srgbClr val="FFCD00"/>
-                </a:solidFill>
-              </a:rPr>
-              <a:t>Real version control</a:t>
-            </a:r>
-          </a:p>
-        </p:txBody>
-      </p:sp>
-      <p:sp>
-        <p:nvSpPr>
-          <p:cNvPr id="8" name="TextBox 7"/>
-          <p:cNvSpPr txBox="1"/>
-          <p:nvPr/>
-        </p:nvSpPr>
-        <p:spPr>
-          <a:xfrm>
-            <a:off x="457200" y="2971799"/>
-            <a:ext cx="8229600" cy="411480"/>
-          </a:xfrm>
-          <a:prstGeom prst="rect">
-            <a:avLst/>
-          </a:prstGeom>
-          <a:noFill/>
-        </p:spPr>
-        <p:txBody>
-          <a:bodyPr wrap="square">
-            <a:spAutoFit/>
-          </a:bodyPr>
-          <a:lstStyle/>
-          <a:p>
-            <a:pPr algn="l"/>
-            <a:r>
-              <a:rPr sz="1100" b="0" i="0">
-                <a:solidFill>
-                  <a:srgbClr val="AAAAAA"/>
-                </a:solidFill>
-              </a:rPr>
-              <a:t>Feature branches, no pushing to main without review. We left this project with actual Git workflow experience.</a:t>
-            </a:r>
-          </a:p>
-        </p:txBody>
-      </p:sp>
-      <p:sp>
-        <p:nvSpPr>
-          <p:cNvPr id="9" name="TextBox 8"/>
-          <p:cNvSpPr txBox="1"/>
-          <p:nvPr/>
-        </p:nvSpPr>
-        <p:spPr>
-          <a:xfrm>
-            <a:off x="457200" y="3520439"/>
-            <a:ext cx="3840480" cy="256032"/>
-          </a:xfrm>
-          <a:prstGeom prst="rect">
-            <a:avLst/>
-          </a:prstGeom>
-          <a:noFill/>
-        </p:spPr>
-        <p:txBody>
-          <a:bodyPr wrap="square">
-            <a:spAutoFit/>
-          </a:bodyPr>
-          <a:lstStyle/>
-          <a:p>
-            <a:pPr algn="l"/>
-            <a:r>
-              <a:rPr sz="1300" b="1" i="0">
-                <a:solidFill>
-                  <a:srgbClr val="FFCD00"/>
-                </a:solidFill>
-              </a:rPr>
-              <a:t>Agile delivery mindset</a:t>
-            </a:r>
-          </a:p>
-        </p:txBody>
-      </p:sp>
-      <p:sp>
-        <p:nvSpPr>
-          <p:cNvPr id="10" name="TextBox 9"/>
-          <p:cNvSpPr txBox="1"/>
-          <p:nvPr/>
-        </p:nvSpPr>
-        <p:spPr>
-          <a:xfrm>
-            <a:off x="457200" y="3794759"/>
-            <a:ext cx="8229600" cy="411480"/>
-          </a:xfrm>
-          <a:prstGeom prst="rect">
-            <a:avLst/>
-          </a:prstGeom>
-          <a:noFill/>
-        </p:spPr>
-        <p:txBody>
-          <a:bodyPr wrap="square">
-            <a:spAutoFit/>
-          </a:bodyPr>
-          <a:lstStyle/>
-          <a:p>
-            <a:pPr algn="l"/>
-            <a:r>
-              <a:rPr sz="1100" b="0" i="0">
-                <a:solidFill>
-                  <a:srgbClr val="AAAAAA"/>
-                </a:solidFill>
-              </a:rPr>
-              <a:t>Five sprints with goals, retrospectives, and user testing mirrors how software teams ship in industry.</a:t>
-            </a:r>
-          </a:p>
-        </p:txBody>
-      </p:sp>
-      <p:sp>
-        <p:nvSpPr>
-          <p:cNvPr id="11" name="TextBox 10"/>
-          <p:cNvSpPr txBox="1"/>
-          <p:nvPr/>
-        </p:nvSpPr>
-        <p:spPr>
-          <a:xfrm>
-            <a:off x="457200" y="4343400"/>
-            <a:ext cx="3840480" cy="256032"/>
-          </a:xfrm>
-          <a:prstGeom prst="rect">
-            <a:avLst/>
-          </a:prstGeom>
-          <a:noFill/>
-        </p:spPr>
-        <p:txBody>
-          <a:bodyPr wrap="square">
-            <a:spAutoFit/>
-          </a:bodyPr>
-          <a:lstStyle/>
-          <a:p>
-            <a:pPr algn="l"/>
-            <a:r>
-              <a:rPr sz="1300" b="1" i="0">
-                <a:solidFill>
-                  <a:srgbClr val="FFCD00"/>
-                </a:solidFill>
-              </a:rPr>
-              <a:t>Resilience under pressure</a:t>
-            </a:r>
-          </a:p>
-        </p:txBody>
-      </p:sp>
-      <p:sp>
-        <p:nvSpPr>
-          <p:cNvPr id="12" name="TextBox 11"/>
-          <p:cNvSpPr txBox="1"/>
-          <p:nvPr/>
-        </p:nvSpPr>
-        <p:spPr>
-          <a:xfrm>
-            <a:off x="457200" y="4617720"/>
-            <a:ext cx="8229600" cy="411480"/>
-          </a:xfrm>
-          <a:prstGeom prst="rect">
-            <a:avLst/>
-          </a:prstGeom>
-          <a:noFill/>
-        </p:spPr>
-        <p:txBody>
-          <a:bodyPr wrap="square">
-            <a:spAutoFit/>
-          </a:bodyPr>
-          <a:lstStyle/>
-          <a:p>
-            <a:pPr algn="l"/>
-            <a:r>
-              <a:rPr sz="1100" b="0" i="0">
-                <a:solidFill>
-                  <a:srgbClr val="AAAAAA"/>
-                </a:solidFill>
-              </a:rPr>
-              <a:t>When the game broke 2 weeks before submission, we diagnosed and fixed it in one day — as a team. That experience is irreplaceable.</a:t>
-            </a:r>
-          </a:p>
-        </p:txBody>
-      </p:sp>
-    </p:spTree>
-  </p:cSld>
-  <p:clrMapOvr>
-    <a:masterClrMapping/>
-  </p:clrMapOvr>
-</p:sld>
-</file>
-
-<file path=ppt/slides/slide21.xml><?xml version="1.0" encoding="utf-8"?>
+<file path=ppt/slides/slide19.xml><?xml version="1.0" encoding="utf-8"?>
 <p:sld xmlns:a="http://schemas.openxmlformats.org/drawingml/2006/main" xmlns:r="http://schemas.openxmlformats.org/officeDocument/2006/relationships" xmlns:p="http://schemas.openxmlformats.org/presentationml/2006/main">
   <p:cSld name="Slide 18">
     <p:bg>
@@ -8707,262 +6587,7 @@
 </p:sld>
 </file>
 
-<file path=ppt/slides/slide3.xml><?xml version="1.0" encoding="utf-8"?>
-<p:sld xmlns:a="http://schemas.openxmlformats.org/drawingml/2006/main" xmlns:r="http://schemas.openxmlformats.org/officeDocument/2006/relationships" xmlns:p="http://schemas.openxmlformats.org/presentationml/2006/main">
-  <p:cSld name="Slide 2">
-    <p:bg>
-      <p:bgPr>
-        <a:solidFill>
-          <a:srgbClr val="0D0D0D"/>
-        </a:solidFill>
-        <a:effectLst/>
-      </p:bgPr>
-    </p:bg>
-    <p:spTree>
-      <p:nvGrpSpPr>
-        <p:cNvPr id="1" name=""/>
-        <p:cNvGrpSpPr/>
-        <p:nvPr/>
-      </p:nvGrpSpPr>
-      <p:grpSpPr>
-        <a:xfrm>
-          <a:off x="0" y="0"/>
-          <a:ext cx="0" cy="0"/>
-          <a:chOff x="0" y="0"/>
-          <a:chExt cx="0" cy="0"/>
-        </a:xfrm>
-      </p:grpSpPr>
-      <p:sp>
-        <p:nvSpPr>
-          <p:cNvPr id="2" name="Shape 0"/>
-          <p:cNvSpPr/>
-          <p:nvPr/>
-        </p:nvSpPr>
-        <p:spPr>
-          <a:xfrm>
-            <a:off x="8458200" y="201168"/>
-            <a:ext cx="256032" cy="256032"/>
-          </a:xfrm>
-          <a:prstGeom prst="ellipse">
-            <a:avLst/>
-          </a:prstGeom>
-          <a:solidFill>
-            <a:srgbClr val="FFCD00"/>
-          </a:solidFill>
-          <a:ln/>
-        </p:spPr>
-        <p:txBody>
-          <a:bodyPr/>
-          <a:lstStyle/>
-          <a:p>
-            <a:endParaRPr lang="en-GB"/>
-          </a:p>
-        </p:txBody>
-      </p:sp>
-      <p:sp>
-        <p:nvSpPr>
-          <p:cNvPr id="3" name="Text 1"/>
-          <p:cNvSpPr/>
-          <p:nvPr/>
-        </p:nvSpPr>
-        <p:spPr>
-          <a:xfrm>
-            <a:off x="457200" y="274320"/>
-            <a:ext cx="6400800" cy="228600"/>
-          </a:xfrm>
-          <a:prstGeom prst="rect">
-            <a:avLst/>
-          </a:prstGeom>
-          <a:noFill/>
-          <a:ln/>
-        </p:spPr>
-        <p:txBody>
-          <a:bodyPr wrap="square" rtlCol="0" anchor="ctr"/>
-          <a:lstStyle/>
-          <a:p>
-            <a:pPr marL="0" indent="0">
-              <a:buNone/>
-            </a:pPr>
-            <a:r>
-              <a:rPr lang="en-US" sz="1000" b="1" kern="0" spc="200" dirty="0">
-                <a:solidFill>
-                  <a:srgbClr val="555555"/>
-                </a:solidFill>
-                <a:latin typeface="Arial" pitchFamily="34" charset="0"/>
-                <a:ea typeface="Arial" pitchFamily="34" charset="-122"/>
-                <a:cs typeface="Arial" pitchFamily="34" charset="-120"/>
-              </a:rPr>
-              <a:t>THE BRIEF</a:t>
-            </a:r>
-            <a:endParaRPr lang="en-US" sz="1000" dirty="0"/>
-          </a:p>
-        </p:txBody>
-      </p:sp>
-      <p:sp>
-        <p:nvSpPr>
-          <p:cNvPr id="4" name="Text 2"/>
-          <p:cNvSpPr/>
-          <p:nvPr/>
-        </p:nvSpPr>
-        <p:spPr>
-          <a:xfrm>
-            <a:off x="3657600" y="4919472"/>
-            <a:ext cx="5212080" cy="182880"/>
-          </a:xfrm>
-          <a:prstGeom prst="rect">
-            <a:avLst/>
-          </a:prstGeom>
-          <a:noFill/>
-          <a:ln/>
-        </p:spPr>
-        <p:txBody>
-          <a:bodyPr wrap="square" rtlCol="0" anchor="ctr"/>
-          <a:lstStyle/>
-          <a:p>
-            <a:pPr marL="0" indent="0" algn="r">
-              <a:buNone/>
-            </a:pPr>
-            <a:r>
-              <a:rPr lang="en-US" sz="900" dirty="0">
-                <a:solidFill>
-                  <a:srgbClr val="555555"/>
-                </a:solidFill>
-                <a:latin typeface="Arial" pitchFamily="34" charset="0"/>
-                <a:ea typeface="Arial" pitchFamily="34" charset="-122"/>
-                <a:cs typeface="Arial" pitchFamily="34" charset="-120"/>
-              </a:rPr>
-              <a:t>NINJA QUIZ  ·  503IT  ·  02 / 18</a:t>
-            </a:r>
-            <a:endParaRPr lang="en-US" sz="900" dirty="0"/>
-          </a:p>
-        </p:txBody>
-      </p:sp>
-      <p:sp>
-        <p:nvSpPr>
-          <p:cNvPr id="5" name="Text 3"/>
-          <p:cNvSpPr/>
-          <p:nvPr/>
-        </p:nvSpPr>
-        <p:spPr>
-          <a:xfrm>
-            <a:off x="457200" y="822960"/>
-            <a:ext cx="8229600" cy="2438400"/>
-          </a:xfrm>
-          <a:prstGeom prst="rect">
-            <a:avLst/>
-          </a:prstGeom>
-          <a:noFill/>
-          <a:ln/>
-        </p:spPr>
-        <p:txBody>
-          <a:bodyPr wrap="square" rtlCol="0" anchor="ctr"/>
-          <a:lstStyle/>
-          <a:p>
-            <a:pPr marL="0" indent="0">
-              <a:buNone/>
-            </a:pPr>
-            <a:r>
-              <a:rPr lang="en-US" sz="9600" b="1" dirty="0">
-                <a:solidFill>
-                  <a:srgbClr val="FFCD00"/>
-                </a:solidFill>
-                <a:latin typeface="Arial Black" pitchFamily="34" charset="0"/>
-                <a:ea typeface="Arial Black" pitchFamily="34" charset="-122"/>
-                <a:cs typeface="Arial Black" pitchFamily="34" charset="-120"/>
-              </a:rPr>
-              <a:t>1 in 3</a:t>
-            </a:r>
-            <a:endParaRPr lang="en-US" sz="9600" dirty="0"/>
-          </a:p>
-        </p:txBody>
-      </p:sp>
-      <p:sp>
-        <p:nvSpPr>
-          <p:cNvPr id="6" name="Text 4"/>
-          <p:cNvSpPr/>
-          <p:nvPr/>
-        </p:nvSpPr>
-        <p:spPr>
-          <a:xfrm>
-            <a:off x="457200" y="2468880"/>
-            <a:ext cx="7772400" cy="320040"/>
-          </a:xfrm>
-          <a:prstGeom prst="rect">
-            <a:avLst/>
-          </a:prstGeom>
-          <a:noFill/>
-          <a:ln/>
-        </p:spPr>
-        <p:txBody>
-          <a:bodyPr wrap="square" rtlCol="0" anchor="ctr"/>
-          <a:lstStyle/>
-          <a:p>
-            <a:pPr marL="0" indent="0">
-              <a:buNone/>
-            </a:pPr>
-            <a:r>
-              <a:rPr lang="en-US" sz="1400" dirty="0">
-                <a:solidFill>
-                  <a:srgbClr val="555555"/>
-                </a:solidFill>
-                <a:latin typeface="Arial" pitchFamily="34" charset="0"/>
-                <a:ea typeface="Arial" pitchFamily="34" charset="-122"/>
-                <a:cs typeface="Arial" pitchFamily="34" charset="-120"/>
-              </a:rPr>
-              <a:t>children have already faced an online risk.</a:t>
-            </a:r>
-            <a:endParaRPr lang="en-US" sz="1400" dirty="0"/>
-          </a:p>
-        </p:txBody>
-      </p:sp>
-      <p:sp>
-        <p:nvSpPr>
-          <p:cNvPr id="7" name="Text 5"/>
-          <p:cNvSpPr/>
-          <p:nvPr/>
-        </p:nvSpPr>
-        <p:spPr>
-          <a:xfrm>
-            <a:off x="457200" y="2926080"/>
-            <a:ext cx="7772400" cy="320040"/>
-          </a:xfrm>
-          <a:prstGeom prst="rect">
-            <a:avLst/>
-          </a:prstGeom>
-          <a:noFill/>
-          <a:ln/>
-        </p:spPr>
-        <p:txBody>
-          <a:bodyPr wrap="square" rtlCol="0" anchor="ctr"/>
-          <a:lstStyle/>
-          <a:p>
-            <a:pPr marL="0" indent="0">
-              <a:buNone/>
-            </a:pPr>
-            <a:r>
-              <a:rPr lang="en-US" sz="1400" dirty="0">
-                <a:solidFill>
-                  <a:srgbClr val="555555"/>
-                </a:solidFill>
-                <a:latin typeface="Arial" pitchFamily="34" charset="0"/>
-                <a:ea typeface="Arial" pitchFamily="34" charset="-122"/>
-                <a:cs typeface="Arial" pitchFamily="34" charset="-120"/>
-              </a:rPr>
-              <a:t>The brief: build a game that actually teaches them to stay safe.</a:t>
-            </a:r>
-            <a:endParaRPr lang="en-US" sz="1400" dirty="0"/>
-          </a:p>
-        </p:txBody>
-      </p:sp>
-    </p:spTree>
-  </p:cSld>
-  <p:clrMapOvr>
-    <a:masterClrMapping/>
-  </p:clrMapOvr>
-</p:sld>
-</file>
-
-<file path=ppt/slides/slide4.xml><?xml version="1.0" encoding="utf-8"?>
+<file path=ppt/slides/slide2.xml><?xml version="1.0" encoding="utf-8"?>
 <p:sld xmlns:a="http://schemas.openxmlformats.org/drawingml/2006/main" xmlns:r="http://schemas.openxmlformats.org/officeDocument/2006/relationships" xmlns:p="http://schemas.openxmlformats.org/presentationml/2006/main">
   <p:cSld name="Slide 3">
     <p:bg>
@@ -9167,7 +6792,7 @@
 </p:sld>
 </file>
 
-<file path=ppt/slides/slide5.xml><?xml version="1.0" encoding="utf-8"?>
+<file path=ppt/slides/slide3.xml><?xml version="1.0" encoding="utf-8"?>
 <p:sld xmlns:a="http://schemas.openxmlformats.org/drawingml/2006/main" xmlns:r="http://schemas.openxmlformats.org/officeDocument/2006/relationships" xmlns:p="http://schemas.openxmlformats.org/presentationml/2006/main">
   <p:cSld name="Slide 4">
     <p:bg>
@@ -9966,7 +7591,7 @@
 </p:sld>
 </file>
 
-<file path=ppt/slides/slide6.xml><?xml version="1.0" encoding="utf-8"?>
+<file path=ppt/slides/slide4.xml><?xml version="1.0" encoding="utf-8"?>
 <p:sld xmlns:a="http://schemas.openxmlformats.org/drawingml/2006/main" xmlns:r="http://schemas.openxmlformats.org/officeDocument/2006/relationships" xmlns:p="http://schemas.openxmlformats.org/presentationml/2006/main">
   <p:cSld name="Slide 5">
     <p:bg>
@@ -10193,7 +7818,7 @@
 </p:sld>
 </file>
 
-<file path=ppt/slides/slide7.xml><?xml version="1.0" encoding="utf-8"?>
+<file path=ppt/slides/slide5.xml><?xml version="1.0" encoding="utf-8"?>
 <p:sld xmlns:a="http://schemas.openxmlformats.org/drawingml/2006/main" xmlns:r="http://schemas.openxmlformats.org/officeDocument/2006/relationships" xmlns:p="http://schemas.openxmlformats.org/presentationml/2006/main">
   <p:cSld name="Slide 6">
     <p:bg>
@@ -10331,7 +7956,7 @@
         </p:nvSpPr>
         <p:spPr>
           <a:xfrm>
-            <a:off x="457200" y="685800"/>
+            <a:off x="-21981" y="743352"/>
             <a:ext cx="8229600" cy="812800"/>
           </a:xfrm>
           <a:prstGeom prst="rect">
@@ -10801,8 +8426,38 @@
         </p:blipFill>
         <p:spPr>
           <a:xfrm>
-            <a:off x="4663440" y="1417320"/>
-            <a:ext cx="4206240" cy="3291840"/>
+            <a:off x="6146551" y="1348326"/>
+            <a:ext cx="2930969" cy="1421637"/>
+          </a:xfrm>
+          <a:prstGeom prst="rect">
+            <a:avLst/>
+          </a:prstGeom>
+        </p:spPr>
+      </p:pic>
+      <p:pic>
+        <p:nvPicPr>
+          <p:cNvPr id="19" name="Picture 18">
+            <a:extLst>
+              <a:ext uri="{FF2B5EF4-FFF2-40B4-BE49-F238E27FC236}">
+                <a16:creationId xmlns:a16="http://schemas.microsoft.com/office/drawing/2014/main" id="{9BA7A73D-0397-1BAE-5DED-7C16FF5F0991}"/>
+              </a:ext>
+            </a:extLst>
+          </p:cNvPr>
+          <p:cNvPicPr>
+            <a:picLocks noChangeAspect="1"/>
+          </p:cNvPicPr>
+          <p:nvPr/>
+        </p:nvPicPr>
+        <p:blipFill>
+          <a:blip r:embed="rId4"/>
+          <a:stretch>
+            <a:fillRect/>
+          </a:stretch>
+        </p:blipFill>
+        <p:spPr>
+          <a:xfrm>
+            <a:off x="6146551" y="2787256"/>
+            <a:ext cx="2355459" cy="2081924"/>
           </a:xfrm>
           <a:prstGeom prst="rect">
             <a:avLst/>
@@ -10817,7 +8472,7 @@
 </p:sld>
 </file>
 
-<file path=ppt/slides/slide8.xml><?xml version="1.0" encoding="utf-8"?>
+<file path=ppt/slides/slide6.xml><?xml version="1.0" encoding="utf-8"?>
 <p:sld xmlns:a="http://schemas.openxmlformats.org/drawingml/2006/main" xmlns:r="http://schemas.openxmlformats.org/officeDocument/2006/relationships" xmlns:p="http://schemas.openxmlformats.org/presentationml/2006/main">
   <p:cSld name="Slide 7">
     <p:bg>
@@ -10877,7 +8532,7 @@
         </p:nvSpPr>
         <p:spPr>
           <a:xfrm>
-            <a:off x="457200" y="274320"/>
+            <a:off x="294542" y="160020"/>
             <a:ext cx="6400800" cy="228600"/>
           </a:xfrm>
           <a:prstGeom prst="rect">
@@ -10955,8 +8610,8 @@
         </p:nvSpPr>
         <p:spPr>
           <a:xfrm>
-            <a:off x="457200" y="777240"/>
-            <a:ext cx="4114800" cy="1117600"/>
+            <a:off x="496765" y="938034"/>
+            <a:ext cx="4114800" cy="1060704"/>
           </a:xfrm>
           <a:prstGeom prst="rect">
             <a:avLst/>
@@ -11280,8 +8935,8 @@
         </p:blipFill>
         <p:spPr>
           <a:xfrm>
-            <a:off x="4572000" y="731520"/>
-            <a:ext cx="4389120" cy="4023360"/>
+            <a:off x="5376496" y="731520"/>
+            <a:ext cx="3584624" cy="3285905"/>
           </a:xfrm>
           <a:prstGeom prst="rect">
             <a:avLst/>
@@ -11296,7 +8951,7 @@
 </p:sld>
 </file>
 
-<file path=ppt/slides/slide9.xml><?xml version="1.0" encoding="utf-8"?>
+<file path=ppt/slides/slide7.xml><?xml version="1.0" encoding="utf-8"?>
 <p:sld xmlns:a="http://schemas.openxmlformats.org/drawingml/2006/main" xmlns:r="http://schemas.openxmlformats.org/officeDocument/2006/relationships" xmlns:p="http://schemas.openxmlformats.org/presentationml/2006/main">
   <p:cSld name="Slide 8">
     <p:bg>
@@ -12044,6 +9699,1505 @@
               <a:t>Everyone had a vote</a:t>
             </a:r>
             <a:endParaRPr lang="en-US" sz="1400" dirty="0"/>
+          </a:p>
+        </p:txBody>
+      </p:sp>
+    </p:spTree>
+  </p:cSld>
+  <p:clrMapOvr>
+    <a:masterClrMapping/>
+  </p:clrMapOvr>
+</p:sld>
+</file>
+
+<file path=ppt/slides/slide8.xml><?xml version="1.0" encoding="utf-8"?>
+<p:sld xmlns:a="http://schemas.openxmlformats.org/drawingml/2006/main" xmlns:r="http://schemas.openxmlformats.org/officeDocument/2006/relationships" xmlns:p="http://schemas.openxmlformats.org/presentationml/2006/main">
+  <p:cSld name="Slide 9">
+    <p:bg>
+      <p:bgPr>
+        <a:solidFill>
+          <a:srgbClr val="FFFFFF"/>
+        </a:solidFill>
+        <a:effectLst/>
+      </p:bgPr>
+    </p:bg>
+    <p:spTree>
+      <p:nvGrpSpPr>
+        <p:cNvPr id="1" name=""/>
+        <p:cNvGrpSpPr/>
+        <p:nvPr/>
+      </p:nvGrpSpPr>
+      <p:grpSpPr>
+        <a:xfrm>
+          <a:off x="0" y="0"/>
+          <a:ext cx="0" cy="0"/>
+          <a:chOff x="0" y="0"/>
+          <a:chExt cx="0" cy="0"/>
+        </a:xfrm>
+      </p:grpSpPr>
+      <p:sp>
+        <p:nvSpPr>
+          <p:cNvPr id="2" name="Shape 0"/>
+          <p:cNvSpPr/>
+          <p:nvPr/>
+        </p:nvSpPr>
+        <p:spPr>
+          <a:xfrm>
+            <a:off x="8458200" y="201168"/>
+            <a:ext cx="256032" cy="256032"/>
+          </a:xfrm>
+          <a:prstGeom prst="ellipse">
+            <a:avLst/>
+          </a:prstGeom>
+          <a:solidFill>
+            <a:srgbClr val="DDDDDD"/>
+          </a:solidFill>
+          <a:ln/>
+        </p:spPr>
+        <p:txBody>
+          <a:bodyPr/>
+          <a:lstStyle/>
+          <a:p>
+            <a:endParaRPr lang="en-GB"/>
+          </a:p>
+        </p:txBody>
+      </p:sp>
+      <p:sp>
+        <p:nvSpPr>
+          <p:cNvPr id="3" name="Text 1"/>
+          <p:cNvSpPr/>
+          <p:nvPr/>
+        </p:nvSpPr>
+        <p:spPr>
+          <a:xfrm>
+            <a:off x="457200" y="274320"/>
+            <a:ext cx="6400800" cy="228600"/>
+          </a:xfrm>
+          <a:prstGeom prst="rect">
+            <a:avLst/>
+          </a:prstGeom>
+          <a:noFill/>
+          <a:ln/>
+        </p:spPr>
+        <p:txBody>
+          <a:bodyPr wrap="square" rtlCol="0" anchor="ctr"/>
+          <a:lstStyle/>
+          <a:p>
+            <a:pPr marL="0" indent="0">
+              <a:buNone/>
+            </a:pPr>
+            <a:r>
+              <a:rPr lang="en-US" sz="1000" b="1" kern="0" spc="200" dirty="0">
+                <a:solidFill>
+                  <a:srgbClr val="888888"/>
+                </a:solidFill>
+                <a:latin typeface="Arial" pitchFamily="34" charset="0"/>
+                <a:ea typeface="Arial" pitchFamily="34" charset="-122"/>
+                <a:cs typeface="Arial" pitchFamily="34" charset="-120"/>
+              </a:rPr>
+              <a:t>DELIVERY PROCESS</a:t>
+            </a:r>
+            <a:endParaRPr lang="en-US" sz="1000" dirty="0"/>
+          </a:p>
+        </p:txBody>
+      </p:sp>
+      <p:sp>
+        <p:nvSpPr>
+          <p:cNvPr id="4" name="Text 2"/>
+          <p:cNvSpPr/>
+          <p:nvPr/>
+        </p:nvSpPr>
+        <p:spPr>
+          <a:xfrm>
+            <a:off x="3657600" y="4919472"/>
+            <a:ext cx="5212080" cy="182880"/>
+          </a:xfrm>
+          <a:prstGeom prst="rect">
+            <a:avLst/>
+          </a:prstGeom>
+          <a:noFill/>
+          <a:ln/>
+        </p:spPr>
+        <p:txBody>
+          <a:bodyPr wrap="square" rtlCol="0" anchor="ctr"/>
+          <a:lstStyle/>
+          <a:p>
+            <a:pPr marL="0" indent="0" algn="r">
+              <a:buNone/>
+            </a:pPr>
+            <a:r>
+              <a:rPr lang="en-US" sz="900" dirty="0">
+                <a:solidFill>
+                  <a:srgbClr val="888888"/>
+                </a:solidFill>
+                <a:latin typeface="Arial" pitchFamily="34" charset="0"/>
+                <a:ea typeface="Arial" pitchFamily="34" charset="-122"/>
+                <a:cs typeface="Arial" pitchFamily="34" charset="-120"/>
+              </a:rPr>
+              <a:t>NINJA QUIZ  ·  503IT  ·  09 / 18</a:t>
+            </a:r>
+            <a:endParaRPr lang="en-US" sz="900" dirty="0"/>
+          </a:p>
+        </p:txBody>
+      </p:sp>
+      <p:sp>
+        <p:nvSpPr>
+          <p:cNvPr id="5" name="Text 3"/>
+          <p:cNvSpPr/>
+          <p:nvPr/>
+        </p:nvSpPr>
+        <p:spPr>
+          <a:xfrm>
+            <a:off x="457200" y="685800"/>
+            <a:ext cx="8229600" cy="812800"/>
+          </a:xfrm>
+          <a:prstGeom prst="rect">
+            <a:avLst/>
+          </a:prstGeom>
+          <a:noFill/>
+          <a:ln/>
+        </p:spPr>
+        <p:txBody>
+          <a:bodyPr wrap="square" rtlCol="0" anchor="ctr"/>
+          <a:lstStyle/>
+          <a:p>
+            <a:pPr marL="0" indent="0">
+              <a:buNone/>
+            </a:pPr>
+            <a:r>
+              <a:rPr lang="en-US" sz="3200" b="1" dirty="0">
+                <a:solidFill>
+                  <a:srgbClr val="111111"/>
+                </a:solidFill>
+                <a:latin typeface="Arial Black" pitchFamily="34" charset="0"/>
+                <a:ea typeface="Arial Black" pitchFamily="34" charset="-122"/>
+                <a:cs typeface="Arial Black" pitchFamily="34" charset="-120"/>
+              </a:rPr>
+              <a:t>Built in five sprints.</a:t>
+            </a:r>
+            <a:endParaRPr lang="en-US" sz="3200" dirty="0"/>
+          </a:p>
+        </p:txBody>
+      </p:sp>
+      <p:sp>
+        <p:nvSpPr>
+          <p:cNvPr id="6" name="Shape 4"/>
+          <p:cNvSpPr/>
+          <p:nvPr/>
+        </p:nvSpPr>
+        <p:spPr>
+          <a:xfrm>
+            <a:off x="457200" y="1463040"/>
+            <a:ext cx="8229600" cy="10973"/>
+          </a:xfrm>
+          <a:prstGeom prst="rect">
+            <a:avLst/>
+          </a:prstGeom>
+          <a:solidFill>
+            <a:srgbClr val="EEEEEE"/>
+          </a:solidFill>
+          <a:ln/>
+        </p:spPr>
+        <p:txBody>
+          <a:bodyPr/>
+          <a:lstStyle/>
+          <a:p>
+            <a:endParaRPr lang="en-GB"/>
+          </a:p>
+        </p:txBody>
+      </p:sp>
+      <p:sp>
+        <p:nvSpPr>
+          <p:cNvPr id="7" name="Text 5"/>
+          <p:cNvSpPr/>
+          <p:nvPr/>
+        </p:nvSpPr>
+        <p:spPr>
+          <a:xfrm>
+            <a:off x="457200" y="1609344"/>
+            <a:ext cx="868680" cy="411480"/>
+          </a:xfrm>
+          <a:prstGeom prst="rect">
+            <a:avLst/>
+          </a:prstGeom>
+          <a:noFill/>
+          <a:ln/>
+        </p:spPr>
+        <p:txBody>
+          <a:bodyPr wrap="square" rtlCol="0" anchor="ctr">
+            <a:normAutofit/>
+          </a:bodyPr>
+          <a:lstStyle/>
+          <a:p>
+            <a:pPr marL="0" indent="0">
+              <a:buNone/>
+            </a:pPr>
+            <a:r>
+              <a:rPr lang="en-US" sz="2000" b="1" dirty="0">
+                <a:solidFill>
+                  <a:srgbClr val="FFCD00"/>
+                </a:solidFill>
+                <a:latin typeface="Arial Black" pitchFamily="34" charset="0"/>
+                <a:ea typeface="Arial Black" pitchFamily="34" charset="-122"/>
+                <a:cs typeface="Arial Black" pitchFamily="34" charset="-120"/>
+              </a:rPr>
+              <a:t>01</a:t>
+            </a:r>
+            <a:endParaRPr lang="en-US" sz="2000" dirty="0"/>
+          </a:p>
+        </p:txBody>
+      </p:sp>
+      <p:sp>
+        <p:nvSpPr>
+          <p:cNvPr id="8" name="Text 6"/>
+          <p:cNvSpPr/>
+          <p:nvPr/>
+        </p:nvSpPr>
+        <p:spPr>
+          <a:xfrm>
+            <a:off x="1371600" y="1591056"/>
+            <a:ext cx="7315200" cy="292608"/>
+          </a:xfrm>
+          <a:prstGeom prst="rect">
+            <a:avLst/>
+          </a:prstGeom>
+          <a:noFill/>
+          <a:ln/>
+        </p:spPr>
+        <p:txBody>
+          <a:bodyPr wrap="square" rtlCol="0" anchor="ctr"/>
+          <a:lstStyle/>
+          <a:p>
+            <a:pPr marL="0" indent="0">
+              <a:buNone/>
+            </a:pPr>
+            <a:r>
+              <a:rPr lang="en-US" sz="1700" b="1" dirty="0">
+                <a:solidFill>
+                  <a:srgbClr val="111111"/>
+                </a:solidFill>
+                <a:latin typeface="Arial Black" pitchFamily="34" charset="0"/>
+                <a:ea typeface="Arial Black" pitchFamily="34" charset="-122"/>
+                <a:cs typeface="Arial Black" pitchFamily="34" charset="-120"/>
+              </a:rPr>
+              <a:t>Sprint 1  —  Login &amp; menu</a:t>
+            </a:r>
+            <a:endParaRPr lang="en-US" sz="1700" dirty="0"/>
+          </a:p>
+        </p:txBody>
+      </p:sp>
+      <p:sp>
+        <p:nvSpPr>
+          <p:cNvPr id="9" name="Text 7"/>
+          <p:cNvSpPr/>
+          <p:nvPr/>
+        </p:nvSpPr>
+        <p:spPr>
+          <a:xfrm>
+            <a:off x="1371600" y="1892808"/>
+            <a:ext cx="7315200" cy="228600"/>
+          </a:xfrm>
+          <a:prstGeom prst="rect">
+            <a:avLst/>
+          </a:prstGeom>
+          <a:noFill/>
+          <a:ln/>
+        </p:spPr>
+        <p:txBody>
+          <a:bodyPr wrap="square" rtlCol="0" anchor="ctr"/>
+          <a:lstStyle/>
+          <a:p>
+            <a:pPr marL="0" indent="0">
+              <a:buNone/>
+            </a:pPr>
+            <a:r>
+              <a:rPr lang="en-US" sz="1200" dirty="0">
+                <a:solidFill>
+                  <a:srgbClr val="888888"/>
+                </a:solidFill>
+                <a:latin typeface="Arial" pitchFamily="34" charset="0"/>
+                <a:ea typeface="Arial" pitchFamily="34" charset="-122"/>
+                <a:cs typeface="Arial" pitchFamily="34" charset="-120"/>
+              </a:rPr>
+              <a:t>Foundation. Every member set up. GitHub branches created.</a:t>
+            </a:r>
+            <a:endParaRPr lang="en-US" sz="1200" dirty="0"/>
+          </a:p>
+        </p:txBody>
+      </p:sp>
+      <p:sp>
+        <p:nvSpPr>
+          <p:cNvPr id="10" name="Text 8"/>
+          <p:cNvSpPr/>
+          <p:nvPr/>
+        </p:nvSpPr>
+        <p:spPr>
+          <a:xfrm>
+            <a:off x="457200" y="2231136"/>
+            <a:ext cx="868680" cy="411480"/>
+          </a:xfrm>
+          <a:prstGeom prst="rect">
+            <a:avLst/>
+          </a:prstGeom>
+          <a:noFill/>
+          <a:ln/>
+        </p:spPr>
+        <p:txBody>
+          <a:bodyPr wrap="square" rtlCol="0" anchor="ctr">
+            <a:normAutofit/>
+          </a:bodyPr>
+          <a:lstStyle/>
+          <a:p>
+            <a:pPr marL="0" indent="0">
+              <a:buNone/>
+            </a:pPr>
+            <a:r>
+              <a:rPr lang="en-US" sz="2000" b="1" dirty="0">
+                <a:solidFill>
+                  <a:srgbClr val="FFCD00"/>
+                </a:solidFill>
+                <a:latin typeface="Arial Black" pitchFamily="34" charset="0"/>
+                <a:ea typeface="Arial Black" pitchFamily="34" charset="-122"/>
+                <a:cs typeface="Arial Black" pitchFamily="34" charset="-120"/>
+              </a:rPr>
+              <a:t>02</a:t>
+            </a:r>
+            <a:endParaRPr lang="en-US" sz="2000" dirty="0"/>
+          </a:p>
+        </p:txBody>
+      </p:sp>
+      <p:sp>
+        <p:nvSpPr>
+          <p:cNvPr id="11" name="Text 9"/>
+          <p:cNvSpPr/>
+          <p:nvPr/>
+        </p:nvSpPr>
+        <p:spPr>
+          <a:xfrm>
+            <a:off x="1371600" y="2212848"/>
+            <a:ext cx="7315200" cy="292608"/>
+          </a:xfrm>
+          <a:prstGeom prst="rect">
+            <a:avLst/>
+          </a:prstGeom>
+          <a:noFill/>
+          <a:ln/>
+        </p:spPr>
+        <p:txBody>
+          <a:bodyPr wrap="square" rtlCol="0" anchor="ctr"/>
+          <a:lstStyle/>
+          <a:p>
+            <a:pPr marL="0" indent="0">
+              <a:buNone/>
+            </a:pPr>
+            <a:r>
+              <a:rPr lang="en-US" sz="1700" b="1" dirty="0">
+                <a:solidFill>
+                  <a:srgbClr val="111111"/>
+                </a:solidFill>
+                <a:latin typeface="Arial Black" pitchFamily="34" charset="0"/>
+                <a:ea typeface="Arial Black" pitchFamily="34" charset="-122"/>
+                <a:cs typeface="Arial Black" pitchFamily="34" charset="-120"/>
+              </a:rPr>
+              <a:t>Sprint 2  —  Game engine</a:t>
+            </a:r>
+            <a:endParaRPr lang="en-US" sz="1700" dirty="0"/>
+          </a:p>
+        </p:txBody>
+      </p:sp>
+      <p:sp>
+        <p:nvSpPr>
+          <p:cNvPr id="12" name="Text 10"/>
+          <p:cNvSpPr/>
+          <p:nvPr/>
+        </p:nvSpPr>
+        <p:spPr>
+          <a:xfrm>
+            <a:off x="1371600" y="2514600"/>
+            <a:ext cx="7315200" cy="228600"/>
+          </a:xfrm>
+          <a:prstGeom prst="rect">
+            <a:avLst/>
+          </a:prstGeom>
+          <a:noFill/>
+          <a:ln/>
+        </p:spPr>
+        <p:txBody>
+          <a:bodyPr wrap="square" rtlCol="0" anchor="ctr"/>
+          <a:lstStyle/>
+          <a:p>
+            <a:pPr marL="0" indent="0">
+              <a:buNone/>
+            </a:pPr>
+            <a:r>
+              <a:rPr lang="en-US" sz="1200" dirty="0">
+                <a:solidFill>
+                  <a:srgbClr val="888888"/>
+                </a:solidFill>
+                <a:latin typeface="Arial" pitchFamily="34" charset="0"/>
+                <a:ea typeface="Arial" pitchFamily="34" charset="-122"/>
+                <a:cs typeface="Arial" pitchFamily="34" charset="-120"/>
+              </a:rPr>
+              <a:t>Core mechanics built. Daily check-ins via WhatsApp.</a:t>
+            </a:r>
+            <a:endParaRPr lang="en-US" sz="1200" dirty="0"/>
+          </a:p>
+        </p:txBody>
+      </p:sp>
+      <p:sp>
+        <p:nvSpPr>
+          <p:cNvPr id="13" name="Text 11"/>
+          <p:cNvSpPr/>
+          <p:nvPr/>
+        </p:nvSpPr>
+        <p:spPr>
+          <a:xfrm>
+            <a:off x="457200" y="2852928"/>
+            <a:ext cx="868680" cy="411480"/>
+          </a:xfrm>
+          <a:prstGeom prst="rect">
+            <a:avLst/>
+          </a:prstGeom>
+          <a:noFill/>
+          <a:ln/>
+        </p:spPr>
+        <p:txBody>
+          <a:bodyPr wrap="square" rtlCol="0" anchor="ctr">
+            <a:normAutofit/>
+          </a:bodyPr>
+          <a:lstStyle/>
+          <a:p>
+            <a:pPr marL="0" indent="0">
+              <a:buNone/>
+            </a:pPr>
+            <a:r>
+              <a:rPr lang="en-US" sz="2000" b="1" dirty="0">
+                <a:solidFill>
+                  <a:srgbClr val="FFCD00"/>
+                </a:solidFill>
+                <a:latin typeface="Arial Black" pitchFamily="34" charset="0"/>
+                <a:ea typeface="Arial Black" pitchFamily="34" charset="-122"/>
+                <a:cs typeface="Arial Black" pitchFamily="34" charset="-120"/>
+              </a:rPr>
+              <a:t>03</a:t>
+            </a:r>
+            <a:endParaRPr lang="en-US" sz="2000" dirty="0"/>
+          </a:p>
+        </p:txBody>
+      </p:sp>
+      <p:sp>
+        <p:nvSpPr>
+          <p:cNvPr id="14" name="Text 12"/>
+          <p:cNvSpPr/>
+          <p:nvPr/>
+        </p:nvSpPr>
+        <p:spPr>
+          <a:xfrm>
+            <a:off x="1371600" y="2834640"/>
+            <a:ext cx="7315200" cy="292608"/>
+          </a:xfrm>
+          <a:prstGeom prst="rect">
+            <a:avLst/>
+          </a:prstGeom>
+          <a:noFill/>
+          <a:ln/>
+        </p:spPr>
+        <p:txBody>
+          <a:bodyPr wrap="square" rtlCol="0" anchor="ctr"/>
+          <a:lstStyle/>
+          <a:p>
+            <a:pPr marL="0" indent="0">
+              <a:buNone/>
+            </a:pPr>
+            <a:r>
+              <a:rPr lang="en-US" sz="1700" b="1" dirty="0">
+                <a:solidFill>
+                  <a:srgbClr val="111111"/>
+                </a:solidFill>
+                <a:latin typeface="Arial Black" pitchFamily="34" charset="0"/>
+                <a:ea typeface="Arial Black" pitchFamily="34" charset="-122"/>
+                <a:cs typeface="Arial Black" pitchFamily="34" charset="-120"/>
+              </a:rPr>
+              <a:t>Sprint 3  —  Slicing &amp; sound</a:t>
+            </a:r>
+            <a:endParaRPr lang="en-US" sz="1700" dirty="0"/>
+          </a:p>
+        </p:txBody>
+      </p:sp>
+      <p:sp>
+        <p:nvSpPr>
+          <p:cNvPr id="15" name="Text 13"/>
+          <p:cNvSpPr/>
+          <p:nvPr/>
+        </p:nvSpPr>
+        <p:spPr>
+          <a:xfrm>
+            <a:off x="1371600" y="3136392"/>
+            <a:ext cx="7315200" cy="228600"/>
+          </a:xfrm>
+          <a:prstGeom prst="rect">
+            <a:avLst/>
+          </a:prstGeom>
+          <a:noFill/>
+          <a:ln/>
+        </p:spPr>
+        <p:txBody>
+          <a:bodyPr wrap="square" rtlCol="0" anchor="ctr"/>
+          <a:lstStyle/>
+          <a:p>
+            <a:pPr marL="0" indent="0">
+              <a:buNone/>
+            </a:pPr>
+            <a:r>
+              <a:rPr lang="en-US" sz="1200" dirty="0">
+                <a:solidFill>
+                  <a:srgbClr val="888888"/>
+                </a:solidFill>
+                <a:latin typeface="Arial" pitchFamily="34" charset="0"/>
+                <a:ea typeface="Arial" pitchFamily="34" charset="-122"/>
+                <a:cs typeface="Arial" pitchFamily="34" charset="-120"/>
+              </a:rPr>
+              <a:t>Visual integration. First merge conflicts resolved.</a:t>
+            </a:r>
+            <a:endParaRPr lang="en-US" sz="1200" dirty="0"/>
+          </a:p>
+        </p:txBody>
+      </p:sp>
+      <p:sp>
+        <p:nvSpPr>
+          <p:cNvPr id="16" name="Text 14"/>
+          <p:cNvSpPr/>
+          <p:nvPr/>
+        </p:nvSpPr>
+        <p:spPr>
+          <a:xfrm>
+            <a:off x="457200" y="3474720"/>
+            <a:ext cx="868680" cy="411480"/>
+          </a:xfrm>
+          <a:prstGeom prst="rect">
+            <a:avLst/>
+          </a:prstGeom>
+          <a:noFill/>
+          <a:ln/>
+        </p:spPr>
+        <p:txBody>
+          <a:bodyPr wrap="square" rtlCol="0" anchor="ctr">
+            <a:normAutofit/>
+          </a:bodyPr>
+          <a:lstStyle/>
+          <a:p>
+            <a:pPr marL="0" indent="0">
+              <a:buNone/>
+            </a:pPr>
+            <a:r>
+              <a:rPr lang="en-US" sz="2000" b="1" dirty="0">
+                <a:solidFill>
+                  <a:srgbClr val="FFCD00"/>
+                </a:solidFill>
+                <a:latin typeface="Arial Black" pitchFamily="34" charset="0"/>
+                <a:ea typeface="Arial Black" pitchFamily="34" charset="-122"/>
+                <a:cs typeface="Arial Black" pitchFamily="34" charset="-120"/>
+              </a:rPr>
+              <a:t>04</a:t>
+            </a:r>
+            <a:endParaRPr lang="en-US" sz="2000" dirty="0"/>
+          </a:p>
+        </p:txBody>
+      </p:sp>
+      <p:sp>
+        <p:nvSpPr>
+          <p:cNvPr id="17" name="Text 15"/>
+          <p:cNvSpPr/>
+          <p:nvPr/>
+        </p:nvSpPr>
+        <p:spPr>
+          <a:xfrm>
+            <a:off x="1371600" y="3456432"/>
+            <a:ext cx="7315200" cy="292608"/>
+          </a:xfrm>
+          <a:prstGeom prst="rect">
+            <a:avLst/>
+          </a:prstGeom>
+          <a:noFill/>
+          <a:ln/>
+        </p:spPr>
+        <p:txBody>
+          <a:bodyPr wrap="square" rtlCol="0" anchor="ctr"/>
+          <a:lstStyle/>
+          <a:p>
+            <a:pPr marL="0" indent="0">
+              <a:buNone/>
+            </a:pPr>
+            <a:r>
+              <a:rPr lang="en-US" sz="1700" b="1" dirty="0">
+                <a:solidFill>
+                  <a:srgbClr val="111111"/>
+                </a:solidFill>
+                <a:latin typeface="Arial Black" pitchFamily="34" charset="0"/>
+                <a:ea typeface="Arial Black" pitchFamily="34" charset="-122"/>
+                <a:cs typeface="Arial Black" pitchFamily="34" charset="-120"/>
+              </a:rPr>
+              <a:t>Sprint 4  —  Leaderboard</a:t>
+            </a:r>
+            <a:endParaRPr lang="en-US" sz="1700" dirty="0"/>
+          </a:p>
+        </p:txBody>
+      </p:sp>
+      <p:sp>
+        <p:nvSpPr>
+          <p:cNvPr id="18" name="Text 16"/>
+          <p:cNvSpPr/>
+          <p:nvPr/>
+        </p:nvSpPr>
+        <p:spPr>
+          <a:xfrm>
+            <a:off x="1371600" y="3758184"/>
+            <a:ext cx="7315200" cy="228600"/>
+          </a:xfrm>
+          <a:prstGeom prst="rect">
+            <a:avLst/>
+          </a:prstGeom>
+          <a:noFill/>
+          <a:ln/>
+        </p:spPr>
+        <p:txBody>
+          <a:bodyPr wrap="square" rtlCol="0" anchor="ctr"/>
+          <a:lstStyle/>
+          <a:p>
+            <a:pPr marL="0" indent="0">
+              <a:buNone/>
+            </a:pPr>
+            <a:r>
+              <a:rPr lang="en-US" sz="1200" dirty="0">
+                <a:solidFill>
+                  <a:srgbClr val="888888"/>
+                </a:solidFill>
+                <a:latin typeface="Arial" pitchFamily="34" charset="0"/>
+                <a:ea typeface="Arial" pitchFamily="34" charset="-122"/>
+                <a:cs typeface="Arial" pitchFamily="34" charset="-120"/>
+              </a:rPr>
+              <a:t>Peer testing begins. Feedback collected and logged.</a:t>
+            </a:r>
+            <a:endParaRPr lang="en-US" sz="1200" dirty="0"/>
+          </a:p>
+        </p:txBody>
+      </p:sp>
+      <p:sp>
+        <p:nvSpPr>
+          <p:cNvPr id="19" name="Text 17"/>
+          <p:cNvSpPr/>
+          <p:nvPr/>
+        </p:nvSpPr>
+        <p:spPr>
+          <a:xfrm>
+            <a:off x="457200" y="4096512"/>
+            <a:ext cx="868680" cy="411480"/>
+          </a:xfrm>
+          <a:prstGeom prst="rect">
+            <a:avLst/>
+          </a:prstGeom>
+          <a:noFill/>
+          <a:ln/>
+        </p:spPr>
+        <p:txBody>
+          <a:bodyPr wrap="square" rtlCol="0" anchor="ctr">
+            <a:normAutofit/>
+          </a:bodyPr>
+          <a:lstStyle/>
+          <a:p>
+            <a:pPr marL="0" indent="0">
+              <a:buNone/>
+            </a:pPr>
+            <a:r>
+              <a:rPr lang="en-US" sz="2000" b="1" dirty="0">
+                <a:solidFill>
+                  <a:srgbClr val="FFCD00"/>
+                </a:solidFill>
+                <a:latin typeface="Arial Black" pitchFamily="34" charset="0"/>
+                <a:ea typeface="Arial Black" pitchFamily="34" charset="-122"/>
+                <a:cs typeface="Arial Black" pitchFamily="34" charset="-120"/>
+              </a:rPr>
+              <a:t>05</a:t>
+            </a:r>
+            <a:endParaRPr lang="en-US" sz="2000" dirty="0"/>
+          </a:p>
+        </p:txBody>
+      </p:sp>
+      <p:sp>
+        <p:nvSpPr>
+          <p:cNvPr id="20" name="Text 18"/>
+          <p:cNvSpPr/>
+          <p:nvPr/>
+        </p:nvSpPr>
+        <p:spPr>
+          <a:xfrm>
+            <a:off x="1371600" y="4078224"/>
+            <a:ext cx="7315200" cy="292608"/>
+          </a:xfrm>
+          <a:prstGeom prst="rect">
+            <a:avLst/>
+          </a:prstGeom>
+          <a:noFill/>
+          <a:ln/>
+        </p:spPr>
+        <p:txBody>
+          <a:bodyPr wrap="square" rtlCol="0" anchor="ctr"/>
+          <a:lstStyle/>
+          <a:p>
+            <a:pPr marL="0" indent="0">
+              <a:buNone/>
+            </a:pPr>
+            <a:r>
+              <a:rPr lang="en-US" sz="1700" b="1" dirty="0">
+                <a:solidFill>
+                  <a:srgbClr val="111111"/>
+                </a:solidFill>
+                <a:latin typeface="Arial Black" pitchFamily="34" charset="0"/>
+                <a:ea typeface="Arial Black" pitchFamily="34" charset="-122"/>
+                <a:cs typeface="Arial Black" pitchFamily="34" charset="-120"/>
+              </a:rPr>
+              <a:t>Sprint 5  —  Testing &amp; polish</a:t>
+            </a:r>
+            <a:endParaRPr lang="en-US" sz="1700" dirty="0"/>
+          </a:p>
+        </p:txBody>
+      </p:sp>
+      <p:sp>
+        <p:nvSpPr>
+          <p:cNvPr id="21" name="Text 19"/>
+          <p:cNvSpPr/>
+          <p:nvPr/>
+        </p:nvSpPr>
+        <p:spPr>
+          <a:xfrm>
+            <a:off x="1371600" y="4379976"/>
+            <a:ext cx="7315200" cy="228600"/>
+          </a:xfrm>
+          <a:prstGeom prst="rect">
+            <a:avLst/>
+          </a:prstGeom>
+          <a:noFill/>
+          <a:ln/>
+        </p:spPr>
+        <p:txBody>
+          <a:bodyPr wrap="square" rtlCol="0" anchor="ctr"/>
+          <a:lstStyle/>
+          <a:p>
+            <a:pPr marL="0" indent="0">
+              <a:buNone/>
+            </a:pPr>
+            <a:r>
+              <a:rPr lang="en-US" sz="1200" dirty="0">
+                <a:solidFill>
+                  <a:srgbClr val="888888"/>
+                </a:solidFill>
+                <a:latin typeface="Arial" pitchFamily="34" charset="0"/>
+                <a:ea typeface="Arial" pitchFamily="34" charset="-122"/>
+                <a:cs typeface="Arial" pitchFamily="34" charset="-120"/>
+              </a:rPr>
+              <a:t>Bug hunt, final fixes, review before submission.</a:t>
+            </a:r>
+            <a:endParaRPr lang="en-US" sz="1200" dirty="0"/>
+          </a:p>
+        </p:txBody>
+      </p:sp>
+    </p:spTree>
+  </p:cSld>
+  <p:clrMapOvr>
+    <a:masterClrMapping/>
+  </p:clrMapOvr>
+</p:sld>
+</file>
+
+<file path=ppt/slides/slide9.xml><?xml version="1.0" encoding="utf-8"?>
+<p:sld xmlns:a="http://schemas.openxmlformats.org/drawingml/2006/main" xmlns:r="http://schemas.openxmlformats.org/officeDocument/2006/relationships" xmlns:p="http://schemas.openxmlformats.org/presentationml/2006/main">
+  <p:cSld>
+    <p:bg>
+      <p:bgPr>
+        <a:solidFill>
+          <a:srgbClr val="FFFFFF"/>
+        </a:solidFill>
+        <a:effectLst/>
+      </p:bgPr>
+    </p:bg>
+    <p:spTree>
+      <p:nvGrpSpPr>
+        <p:cNvPr id="1" name=""/>
+        <p:cNvGrpSpPr/>
+        <p:nvPr/>
+      </p:nvGrpSpPr>
+      <p:grpSpPr>
+        <a:xfrm>
+          <a:off x="0" y="0"/>
+          <a:ext cx="0" cy="0"/>
+          <a:chOff x="0" y="0"/>
+          <a:chExt cx="0" cy="0"/>
+        </a:xfrm>
+      </p:grpSpPr>
+      <p:sp>
+        <p:nvSpPr>
+          <p:cNvPr id="2" name="TextBox 1"/>
+          <p:cNvSpPr txBox="1"/>
+          <p:nvPr/>
+        </p:nvSpPr>
+        <p:spPr>
+          <a:xfrm>
+            <a:off x="457200" y="256032"/>
+            <a:ext cx="6400800" cy="256032"/>
+          </a:xfrm>
+          <a:prstGeom prst="rect">
+            <a:avLst/>
+          </a:prstGeom>
+          <a:noFill/>
+        </p:spPr>
+        <p:txBody>
+          <a:bodyPr wrap="square">
+            <a:spAutoFit/>
+          </a:bodyPr>
+          <a:lstStyle/>
+          <a:p>
+            <a:pPr algn="l"/>
+            <a:r>
+              <a:rPr sz="1000" b="1" i="0">
+                <a:solidFill>
+                  <a:srgbClr val="888888"/>
+                </a:solidFill>
+              </a:rPr>
+              <a:t>SPRINT OUTCOMES</a:t>
+            </a:r>
+          </a:p>
+        </p:txBody>
+      </p:sp>
+      <p:sp>
+        <p:nvSpPr>
+          <p:cNvPr id="3" name="TextBox 2"/>
+          <p:cNvSpPr txBox="1"/>
+          <p:nvPr/>
+        </p:nvSpPr>
+        <p:spPr>
+          <a:xfrm>
+            <a:off x="3657600" y="4919472"/>
+            <a:ext cx="5212080" cy="182880"/>
+          </a:xfrm>
+          <a:prstGeom prst="rect">
+            <a:avLst/>
+          </a:prstGeom>
+          <a:noFill/>
+        </p:spPr>
+        <p:txBody>
+          <a:bodyPr wrap="square">
+            <a:spAutoFit/>
+          </a:bodyPr>
+          <a:lstStyle/>
+          <a:p>
+            <a:pPr algn="l"/>
+            <a:r>
+              <a:rPr sz="800" b="0" i="0">
+                <a:solidFill>
+                  <a:srgbClr val="888888"/>
+                </a:solidFill>
+              </a:rPr>
+              <a:t>NINJA QUIZ  .  503IT</a:t>
+            </a:r>
+          </a:p>
+        </p:txBody>
+      </p:sp>
+      <p:sp>
+        <p:nvSpPr>
+          <p:cNvPr id="4" name="TextBox 3"/>
+          <p:cNvSpPr txBox="1"/>
+          <p:nvPr/>
+        </p:nvSpPr>
+        <p:spPr>
+          <a:xfrm>
+            <a:off x="457200" y="658368"/>
+            <a:ext cx="8229600" cy="365760"/>
+          </a:xfrm>
+          <a:prstGeom prst="rect">
+            <a:avLst/>
+          </a:prstGeom>
+          <a:noFill/>
+        </p:spPr>
+        <p:txBody>
+          <a:bodyPr wrap="square">
+            <a:spAutoFit/>
+          </a:bodyPr>
+          <a:lstStyle/>
+          <a:p>
+            <a:pPr algn="l"/>
+            <a:r>
+              <a:rPr sz="1500" b="1" i="0">
+                <a:solidFill>
+                  <a:srgbClr val="111111"/>
+                </a:solidFill>
+              </a:rPr>
+              <a:t>What each sprint delivered — and what it taught the team.</a:t>
+            </a:r>
+          </a:p>
+        </p:txBody>
+      </p:sp>
+      <p:sp>
+        <p:nvSpPr>
+          <p:cNvPr id="5" name="TextBox 4"/>
+          <p:cNvSpPr txBox="1"/>
+          <p:nvPr/>
+        </p:nvSpPr>
+        <p:spPr>
+          <a:xfrm>
+            <a:off x="457200" y="1188720"/>
+            <a:ext cx="640080" cy="274320"/>
+          </a:xfrm>
+          <a:prstGeom prst="rect">
+            <a:avLst/>
+          </a:prstGeom>
+          <a:noFill/>
+        </p:spPr>
+        <p:txBody>
+          <a:bodyPr wrap="square">
+            <a:spAutoFit/>
+          </a:bodyPr>
+          <a:lstStyle/>
+          <a:p>
+            <a:pPr algn="l"/>
+            <a:r>
+              <a:rPr sz="1200" b="1" i="0">
+                <a:solidFill>
+                  <a:srgbClr val="FFCD00"/>
+                </a:solidFill>
+              </a:rPr>
+              <a:t>01</a:t>
+            </a:r>
+          </a:p>
+        </p:txBody>
+      </p:sp>
+      <p:sp>
+        <p:nvSpPr>
+          <p:cNvPr id="6" name="TextBox 5"/>
+          <p:cNvSpPr txBox="1"/>
+          <p:nvPr/>
+        </p:nvSpPr>
+        <p:spPr>
+          <a:xfrm>
+            <a:off x="1188720" y="1188720"/>
+            <a:ext cx="3657600" cy="256032"/>
+          </a:xfrm>
+          <a:prstGeom prst="rect">
+            <a:avLst/>
+          </a:prstGeom>
+          <a:noFill/>
+        </p:spPr>
+        <p:txBody>
+          <a:bodyPr wrap="square">
+            <a:spAutoFit/>
+          </a:bodyPr>
+          <a:lstStyle/>
+          <a:p>
+            <a:pPr algn="l"/>
+            <a:r>
+              <a:rPr sz="1200" b="1" i="0">
+                <a:solidFill>
+                  <a:srgbClr val="111111"/>
+                </a:solidFill>
+              </a:rPr>
+              <a:t>Sprint 1 — Setup &amp; Login</a:t>
+            </a:r>
+          </a:p>
+        </p:txBody>
+      </p:sp>
+      <p:sp>
+        <p:nvSpPr>
+          <p:cNvPr id="7" name="TextBox 6"/>
+          <p:cNvSpPr txBox="1"/>
+          <p:nvPr/>
+        </p:nvSpPr>
+        <p:spPr>
+          <a:xfrm>
+            <a:off x="1188720" y="1463040"/>
+            <a:ext cx="7680960" cy="457200"/>
+          </a:xfrm>
+          <a:prstGeom prst="rect">
+            <a:avLst/>
+          </a:prstGeom>
+          <a:noFill/>
+        </p:spPr>
+        <p:txBody>
+          <a:bodyPr wrap="square">
+            <a:spAutoFit/>
+          </a:bodyPr>
+          <a:lstStyle/>
+          <a:p>
+            <a:pPr algn="l"/>
+            <a:r>
+              <a:rPr sz="900" b="0" i="0">
+                <a:solidFill>
+                  <a:srgbClr val="555555"/>
+                </a:solidFill>
+              </a:rPr>
+              <a:t>Built: auth system, GitHub branches, role structure.</a:t>
+            </a:r>
+          </a:p>
+          <a:p>
+            <a:pPr algn="l"/>
+            <a:r>
+              <a:rPr sz="900" b="0" i="0">
+                <a:solidFill>
+                  <a:srgbClr val="555555"/>
+                </a:solidFill>
+              </a:rPr>
+              <a:t>Learned: agreeing roles before coding prevented overlap and blame.</a:t>
+            </a:r>
+          </a:p>
+        </p:txBody>
+      </p:sp>
+      <p:sp>
+        <p:nvSpPr>
+          <p:cNvPr id="8" name="TextBox 7"/>
+          <p:cNvSpPr txBox="1"/>
+          <p:nvPr/>
+        </p:nvSpPr>
+        <p:spPr>
+          <a:xfrm>
+            <a:off x="457200" y="1938528"/>
+            <a:ext cx="640080" cy="274320"/>
+          </a:xfrm>
+          <a:prstGeom prst="rect">
+            <a:avLst/>
+          </a:prstGeom>
+          <a:noFill/>
+        </p:spPr>
+        <p:txBody>
+          <a:bodyPr wrap="square">
+            <a:spAutoFit/>
+          </a:bodyPr>
+          <a:lstStyle/>
+          <a:p>
+            <a:pPr algn="l"/>
+            <a:r>
+              <a:rPr sz="1200" b="1" i="0">
+                <a:solidFill>
+                  <a:srgbClr val="FFCD00"/>
+                </a:solidFill>
+              </a:rPr>
+              <a:t>02</a:t>
+            </a:r>
+          </a:p>
+        </p:txBody>
+      </p:sp>
+      <p:sp>
+        <p:nvSpPr>
+          <p:cNvPr id="9" name="TextBox 8"/>
+          <p:cNvSpPr txBox="1"/>
+          <p:nvPr/>
+        </p:nvSpPr>
+        <p:spPr>
+          <a:xfrm>
+            <a:off x="1188720" y="1938528"/>
+            <a:ext cx="3657600" cy="256032"/>
+          </a:xfrm>
+          <a:prstGeom prst="rect">
+            <a:avLst/>
+          </a:prstGeom>
+          <a:noFill/>
+        </p:spPr>
+        <p:txBody>
+          <a:bodyPr wrap="square">
+            <a:spAutoFit/>
+          </a:bodyPr>
+          <a:lstStyle/>
+          <a:p>
+            <a:pPr algn="l"/>
+            <a:r>
+              <a:rPr sz="1200" b="1" i="0">
+                <a:solidFill>
+                  <a:srgbClr val="111111"/>
+                </a:solidFill>
+              </a:rPr>
+              <a:t>Sprint 2 — Game Engine</a:t>
+            </a:r>
+          </a:p>
+        </p:txBody>
+      </p:sp>
+      <p:sp>
+        <p:nvSpPr>
+          <p:cNvPr id="10" name="TextBox 9"/>
+          <p:cNvSpPr txBox="1"/>
+          <p:nvPr/>
+        </p:nvSpPr>
+        <p:spPr>
+          <a:xfrm>
+            <a:off x="1188720" y="2212848"/>
+            <a:ext cx="7680960" cy="457200"/>
+          </a:xfrm>
+          <a:prstGeom prst="rect">
+            <a:avLst/>
+          </a:prstGeom>
+          <a:noFill/>
+        </p:spPr>
+        <p:txBody>
+          <a:bodyPr wrap="square">
+            <a:spAutoFit/>
+          </a:bodyPr>
+          <a:lstStyle/>
+          <a:p>
+            <a:pPr algn="l"/>
+            <a:r>
+              <a:rPr sz="900" b="0" i="0">
+                <a:solidFill>
+                  <a:srgbClr val="555555"/>
+                </a:solidFill>
+              </a:rPr>
+              <a:t>Built: core quiz loop, slash mechanic.</a:t>
+            </a:r>
+          </a:p>
+          <a:p>
+            <a:pPr algn="l"/>
+            <a:r>
+              <a:rPr sz="900" b="0" i="0">
+                <a:solidFill>
+                  <a:srgbClr val="555555"/>
+                </a:solidFill>
+              </a:rPr>
+              <a:t>Learned: daily WhatsApp check-ins replaced long weekly catch-ups and kept everyone unblocked.</a:t>
+            </a:r>
+          </a:p>
+        </p:txBody>
+      </p:sp>
+      <p:sp>
+        <p:nvSpPr>
+          <p:cNvPr id="11" name="TextBox 10"/>
+          <p:cNvSpPr txBox="1"/>
+          <p:nvPr/>
+        </p:nvSpPr>
+        <p:spPr>
+          <a:xfrm>
+            <a:off x="457200" y="2688336"/>
+            <a:ext cx="640080" cy="274320"/>
+          </a:xfrm>
+          <a:prstGeom prst="rect">
+            <a:avLst/>
+          </a:prstGeom>
+          <a:noFill/>
+        </p:spPr>
+        <p:txBody>
+          <a:bodyPr wrap="square">
+            <a:spAutoFit/>
+          </a:bodyPr>
+          <a:lstStyle/>
+          <a:p>
+            <a:pPr algn="l"/>
+            <a:r>
+              <a:rPr sz="1200" b="1" i="0">
+                <a:solidFill>
+                  <a:srgbClr val="FFCD00"/>
+                </a:solidFill>
+              </a:rPr>
+              <a:t>03</a:t>
+            </a:r>
+          </a:p>
+        </p:txBody>
+      </p:sp>
+      <p:sp>
+        <p:nvSpPr>
+          <p:cNvPr id="12" name="TextBox 11"/>
+          <p:cNvSpPr txBox="1"/>
+          <p:nvPr/>
+        </p:nvSpPr>
+        <p:spPr>
+          <a:xfrm>
+            <a:off x="1188720" y="2688336"/>
+            <a:ext cx="3657600" cy="256032"/>
+          </a:xfrm>
+          <a:prstGeom prst="rect">
+            <a:avLst/>
+          </a:prstGeom>
+          <a:noFill/>
+        </p:spPr>
+        <p:txBody>
+          <a:bodyPr wrap="square">
+            <a:spAutoFit/>
+          </a:bodyPr>
+          <a:lstStyle/>
+          <a:p>
+            <a:pPr algn="l"/>
+            <a:r>
+              <a:rPr sz="1200" b="1" i="0">
+                <a:solidFill>
+                  <a:srgbClr val="111111"/>
+                </a:solidFill>
+              </a:rPr>
+              <a:t>Sprint 3 — Slicing &amp; Sound</a:t>
+            </a:r>
+          </a:p>
+        </p:txBody>
+      </p:sp>
+      <p:sp>
+        <p:nvSpPr>
+          <p:cNvPr id="13" name="TextBox 12"/>
+          <p:cNvSpPr txBox="1"/>
+          <p:nvPr/>
+        </p:nvSpPr>
+        <p:spPr>
+          <a:xfrm>
+            <a:off x="1188720" y="2962656"/>
+            <a:ext cx="7680960" cy="457200"/>
+          </a:xfrm>
+          <a:prstGeom prst="rect">
+            <a:avLst/>
+          </a:prstGeom>
+          <a:noFill/>
+        </p:spPr>
+        <p:txBody>
+          <a:bodyPr wrap="square">
+            <a:spAutoFit/>
+          </a:bodyPr>
+          <a:lstStyle/>
+          <a:p>
+            <a:pPr algn="l"/>
+            <a:r>
+              <a:rPr sz="900" b="0" i="0">
+                <a:solidFill>
+                  <a:srgbClr val="555555"/>
+                </a:solidFill>
+              </a:rPr>
+              <a:t>Built: animations, visual effects, audio.</a:t>
+            </a:r>
+          </a:p>
+          <a:p>
+            <a:pPr algn="l"/>
+            <a:r>
+              <a:rPr sz="900" b="0" i="0">
+                <a:solidFill>
+                  <a:srgbClr val="555555"/>
+                </a:solidFill>
+              </a:rPr>
+              <a:t>Learned: first merge conflicts taught us to always pull before push — a discipline we kept.</a:t>
+            </a:r>
+          </a:p>
+        </p:txBody>
+      </p:sp>
+      <p:sp>
+        <p:nvSpPr>
+          <p:cNvPr id="14" name="TextBox 13"/>
+          <p:cNvSpPr txBox="1"/>
+          <p:nvPr/>
+        </p:nvSpPr>
+        <p:spPr>
+          <a:xfrm>
+            <a:off x="457200" y="3438144"/>
+            <a:ext cx="640080" cy="274320"/>
+          </a:xfrm>
+          <a:prstGeom prst="rect">
+            <a:avLst/>
+          </a:prstGeom>
+          <a:noFill/>
+        </p:spPr>
+        <p:txBody>
+          <a:bodyPr wrap="square">
+            <a:spAutoFit/>
+          </a:bodyPr>
+          <a:lstStyle/>
+          <a:p>
+            <a:pPr algn="l"/>
+            <a:r>
+              <a:rPr sz="1200" b="1" i="0">
+                <a:solidFill>
+                  <a:srgbClr val="FFCD00"/>
+                </a:solidFill>
+              </a:rPr>
+              <a:t>04</a:t>
+            </a:r>
+          </a:p>
+        </p:txBody>
+      </p:sp>
+      <p:sp>
+        <p:nvSpPr>
+          <p:cNvPr id="15" name="TextBox 14"/>
+          <p:cNvSpPr txBox="1"/>
+          <p:nvPr/>
+        </p:nvSpPr>
+        <p:spPr>
+          <a:xfrm>
+            <a:off x="1188720" y="3438144"/>
+            <a:ext cx="3657600" cy="256032"/>
+          </a:xfrm>
+          <a:prstGeom prst="rect">
+            <a:avLst/>
+          </a:prstGeom>
+          <a:noFill/>
+        </p:spPr>
+        <p:txBody>
+          <a:bodyPr wrap="square">
+            <a:spAutoFit/>
+          </a:bodyPr>
+          <a:lstStyle/>
+          <a:p>
+            <a:pPr algn="l"/>
+            <a:r>
+              <a:rPr sz="1200" b="1" i="0">
+                <a:solidFill>
+                  <a:srgbClr val="111111"/>
+                </a:solidFill>
+              </a:rPr>
+              <a:t>Sprint 4 — Leaderboard &amp; Test</a:t>
+            </a:r>
+          </a:p>
+        </p:txBody>
+      </p:sp>
+      <p:sp>
+        <p:nvSpPr>
+          <p:cNvPr id="16" name="TextBox 15"/>
+          <p:cNvSpPr txBox="1"/>
+          <p:nvPr/>
+        </p:nvSpPr>
+        <p:spPr>
+          <a:xfrm>
+            <a:off x="1188720" y="3712463"/>
+            <a:ext cx="7680960" cy="457200"/>
+          </a:xfrm>
+          <a:prstGeom prst="rect">
+            <a:avLst/>
+          </a:prstGeom>
+          <a:noFill/>
+        </p:spPr>
+        <p:txBody>
+          <a:bodyPr wrap="square">
+            <a:spAutoFit/>
+          </a:bodyPr>
+          <a:lstStyle/>
+          <a:p>
+            <a:pPr algn="l"/>
+            <a:r>
+              <a:rPr sz="900" b="0" i="0">
+                <a:solidFill>
+                  <a:srgbClr val="555555"/>
+                </a:solidFill>
+              </a:rPr>
+              <a:t>Built: scoring, peer testing sessions.</a:t>
+            </a:r>
+          </a:p>
+          <a:p>
+            <a:pPr algn="l"/>
+            <a:r>
+              <a:rPr sz="900" b="0" i="0">
+                <a:solidFill>
+                  <a:srgbClr val="555555"/>
+                </a:solidFill>
+              </a:rPr>
+              <a:t>Learned: external testers found issues we missed — peer testing is essential, not optional.</a:t>
+            </a:r>
+          </a:p>
+        </p:txBody>
+      </p:sp>
+      <p:sp>
+        <p:nvSpPr>
+          <p:cNvPr id="17" name="TextBox 16"/>
+          <p:cNvSpPr txBox="1"/>
+          <p:nvPr/>
+        </p:nvSpPr>
+        <p:spPr>
+          <a:xfrm>
+            <a:off x="457200" y="4187952"/>
+            <a:ext cx="640080" cy="274320"/>
+          </a:xfrm>
+          <a:prstGeom prst="rect">
+            <a:avLst/>
+          </a:prstGeom>
+          <a:noFill/>
+        </p:spPr>
+        <p:txBody>
+          <a:bodyPr wrap="square">
+            <a:spAutoFit/>
+          </a:bodyPr>
+          <a:lstStyle/>
+          <a:p>
+            <a:pPr algn="l"/>
+            <a:r>
+              <a:rPr sz="1200" b="1" i="0">
+                <a:solidFill>
+                  <a:srgbClr val="FFCD00"/>
+                </a:solidFill>
+              </a:rPr>
+              <a:t>05</a:t>
+            </a:r>
+          </a:p>
+        </p:txBody>
+      </p:sp>
+      <p:sp>
+        <p:nvSpPr>
+          <p:cNvPr id="18" name="TextBox 17"/>
+          <p:cNvSpPr txBox="1"/>
+          <p:nvPr/>
+        </p:nvSpPr>
+        <p:spPr>
+          <a:xfrm>
+            <a:off x="1188720" y="4187952"/>
+            <a:ext cx="3657600" cy="256032"/>
+          </a:xfrm>
+          <a:prstGeom prst="rect">
+            <a:avLst/>
+          </a:prstGeom>
+          <a:noFill/>
+        </p:spPr>
+        <p:txBody>
+          <a:bodyPr wrap="square">
+            <a:spAutoFit/>
+          </a:bodyPr>
+          <a:lstStyle/>
+          <a:p>
+            <a:pPr algn="l"/>
+            <a:r>
+              <a:rPr sz="1200" b="1" i="0">
+                <a:solidFill>
+                  <a:srgbClr val="111111"/>
+                </a:solidFill>
+              </a:rPr>
+              <a:t>Sprint 5 — Polish &amp; Submit</a:t>
+            </a:r>
+          </a:p>
+        </p:txBody>
+      </p:sp>
+      <p:sp>
+        <p:nvSpPr>
+          <p:cNvPr id="19" name="TextBox 18"/>
+          <p:cNvSpPr txBox="1"/>
+          <p:nvPr/>
+        </p:nvSpPr>
+        <p:spPr>
+          <a:xfrm>
+            <a:off x="1188720" y="4462272"/>
+            <a:ext cx="7680960" cy="457200"/>
+          </a:xfrm>
+          <a:prstGeom prst="rect">
+            <a:avLst/>
+          </a:prstGeom>
+          <a:noFill/>
+        </p:spPr>
+        <p:txBody>
+          <a:bodyPr wrap="square">
+            <a:spAutoFit/>
+          </a:bodyPr>
+          <a:lstStyle/>
+          <a:p>
+            <a:pPr algn="l"/>
+            <a:r>
+              <a:rPr sz="900" b="0" i="0">
+                <a:solidFill>
+                  <a:srgbClr val="555555"/>
+                </a:solidFill>
+              </a:rPr>
+              <a:t>Built: final bug fixes, documentation.</a:t>
+            </a:r>
+          </a:p>
+          <a:p>
+            <a:pPr algn="l"/>
+            <a:r>
+              <a:rPr sz="900" b="0" i="0">
+                <a:solidFill>
+                  <a:srgbClr val="555555"/>
+                </a:solidFill>
+              </a:rPr>
+              <a:t>Learned: a team that communicates daily ships on time. We did.</a:t>
+            </a:r>
           </a:p>
         </p:txBody>
       </p:sp>

</xml_diff>

<commit_message>
pptx: add THE BRIEF slide (slide 2) Insert context slide before the team section — covers the client, the problem (1 in 3 children face online risks), target audience, the ask, and constraints. Matches existing slide style exactly.
</commit_message>
<xml_diff>
--- a/NinjaQuiz-Presentation.pptx
+++ b/NinjaQuiz-Presentation.pptx
@@ -9,6 +9,7 @@
   </p:notesMasterIdLst>
   <p:sldIdLst>
     <p:sldId id="256" r:id="rId2"/>
+    <p:sldId id="277" r:id="rId26"/>
     <p:sldId id="258" r:id="rId3"/>
     <p:sldId id="259" r:id="rId4"/>
     <p:sldId id="260" r:id="rId5"/>
@@ -2264,6 +2265,706 @@
 
 <file path=ppt/slides/slide10.xml><?xml version="1.0" encoding="utf-8"?>
 <p:sld xmlns:a="http://schemas.openxmlformats.org/drawingml/2006/main" xmlns:r="http://schemas.openxmlformats.org/officeDocument/2006/relationships" xmlns:p="http://schemas.openxmlformats.org/presentationml/2006/main">
+  <p:cSld>
+    <p:bg>
+      <p:bgPr>
+        <a:solidFill>
+          <a:srgbClr val="FFFFFF"/>
+        </a:solidFill>
+        <a:effectLst/>
+      </p:bgPr>
+    </p:bg>
+    <p:spTree>
+      <p:nvGrpSpPr>
+        <p:cNvPr id="1" name=""/>
+        <p:cNvGrpSpPr/>
+        <p:nvPr/>
+      </p:nvGrpSpPr>
+      <p:grpSpPr>
+        <a:xfrm>
+          <a:off x="0" y="0"/>
+          <a:ext cx="0" cy="0"/>
+          <a:chOff x="0" y="0"/>
+          <a:chExt cx="0" cy="0"/>
+        </a:xfrm>
+      </p:grpSpPr>
+      <p:sp>
+        <p:nvSpPr>
+          <p:cNvPr id="2" name="TextBox 1"/>
+          <p:cNvSpPr txBox="1"/>
+          <p:nvPr/>
+        </p:nvSpPr>
+        <p:spPr>
+          <a:xfrm>
+            <a:off x="457200" y="256032"/>
+            <a:ext cx="6400800" cy="256032"/>
+          </a:xfrm>
+          <a:prstGeom prst="rect">
+            <a:avLst/>
+          </a:prstGeom>
+          <a:noFill/>
+        </p:spPr>
+        <p:txBody>
+          <a:bodyPr wrap="square">
+            <a:spAutoFit/>
+          </a:bodyPr>
+          <a:lstStyle/>
+          <a:p>
+            <a:pPr algn="l"/>
+            <a:r>
+              <a:rPr sz="1000" b="1" i="0">
+                <a:solidFill>
+                  <a:srgbClr val="888888"/>
+                </a:solidFill>
+              </a:rPr>
+              <a:t>SPRINT OUTCOMES</a:t>
+            </a:r>
+          </a:p>
+        </p:txBody>
+      </p:sp>
+      <p:sp>
+        <p:nvSpPr>
+          <p:cNvPr id="3" name="TextBox 2"/>
+          <p:cNvSpPr txBox="1"/>
+          <p:nvPr/>
+        </p:nvSpPr>
+        <p:spPr>
+          <a:xfrm>
+            <a:off x="3657600" y="4919472"/>
+            <a:ext cx="5212080" cy="182880"/>
+          </a:xfrm>
+          <a:prstGeom prst="rect">
+            <a:avLst/>
+          </a:prstGeom>
+          <a:noFill/>
+        </p:spPr>
+        <p:txBody>
+          <a:bodyPr wrap="square">
+            <a:spAutoFit/>
+          </a:bodyPr>
+          <a:lstStyle/>
+          <a:p>
+            <a:pPr algn="l"/>
+            <a:r>
+              <a:rPr sz="800" b="0" i="0">
+                <a:solidFill>
+                  <a:srgbClr val="888888"/>
+                </a:solidFill>
+              </a:rPr>
+              <a:t>NINJA QUIZ  .  503IT</a:t>
+            </a:r>
+          </a:p>
+        </p:txBody>
+      </p:sp>
+      <p:sp>
+        <p:nvSpPr>
+          <p:cNvPr id="4" name="TextBox 3"/>
+          <p:cNvSpPr txBox="1"/>
+          <p:nvPr/>
+        </p:nvSpPr>
+        <p:spPr>
+          <a:xfrm>
+            <a:off x="457200" y="658368"/>
+            <a:ext cx="8229600" cy="365760"/>
+          </a:xfrm>
+          <a:prstGeom prst="rect">
+            <a:avLst/>
+          </a:prstGeom>
+          <a:noFill/>
+        </p:spPr>
+        <p:txBody>
+          <a:bodyPr wrap="square">
+            <a:spAutoFit/>
+          </a:bodyPr>
+          <a:lstStyle/>
+          <a:p>
+            <a:pPr algn="l"/>
+            <a:r>
+              <a:rPr sz="1500" b="1" i="0">
+                <a:solidFill>
+                  <a:srgbClr val="111111"/>
+                </a:solidFill>
+              </a:rPr>
+              <a:t>What each sprint delivered — and what it taught the team.</a:t>
+            </a:r>
+          </a:p>
+        </p:txBody>
+      </p:sp>
+      <p:sp>
+        <p:nvSpPr>
+          <p:cNvPr id="5" name="TextBox 4"/>
+          <p:cNvSpPr txBox="1"/>
+          <p:nvPr/>
+        </p:nvSpPr>
+        <p:spPr>
+          <a:xfrm>
+            <a:off x="457200" y="1188720"/>
+            <a:ext cx="640080" cy="274320"/>
+          </a:xfrm>
+          <a:prstGeom prst="rect">
+            <a:avLst/>
+          </a:prstGeom>
+          <a:noFill/>
+        </p:spPr>
+        <p:txBody>
+          <a:bodyPr wrap="square">
+            <a:spAutoFit/>
+          </a:bodyPr>
+          <a:lstStyle/>
+          <a:p>
+            <a:pPr algn="l"/>
+            <a:r>
+              <a:rPr sz="1200" b="1" i="0">
+                <a:solidFill>
+                  <a:srgbClr val="FFCD00"/>
+                </a:solidFill>
+              </a:rPr>
+              <a:t>01</a:t>
+            </a:r>
+          </a:p>
+        </p:txBody>
+      </p:sp>
+      <p:sp>
+        <p:nvSpPr>
+          <p:cNvPr id="6" name="TextBox 5"/>
+          <p:cNvSpPr txBox="1"/>
+          <p:nvPr/>
+        </p:nvSpPr>
+        <p:spPr>
+          <a:xfrm>
+            <a:off x="1188720" y="1188720"/>
+            <a:ext cx="3657600" cy="256032"/>
+          </a:xfrm>
+          <a:prstGeom prst="rect">
+            <a:avLst/>
+          </a:prstGeom>
+          <a:noFill/>
+        </p:spPr>
+        <p:txBody>
+          <a:bodyPr wrap="square">
+            <a:spAutoFit/>
+          </a:bodyPr>
+          <a:lstStyle/>
+          <a:p>
+            <a:pPr algn="l"/>
+            <a:r>
+              <a:rPr sz="1200" b="1" i="0">
+                <a:solidFill>
+                  <a:srgbClr val="111111"/>
+                </a:solidFill>
+              </a:rPr>
+              <a:t>Sprint 1 — Setup &amp; Login</a:t>
+            </a:r>
+          </a:p>
+        </p:txBody>
+      </p:sp>
+      <p:sp>
+        <p:nvSpPr>
+          <p:cNvPr id="7" name="TextBox 6"/>
+          <p:cNvSpPr txBox="1"/>
+          <p:nvPr/>
+        </p:nvSpPr>
+        <p:spPr>
+          <a:xfrm>
+            <a:off x="1188720" y="1463040"/>
+            <a:ext cx="7680960" cy="457200"/>
+          </a:xfrm>
+          <a:prstGeom prst="rect">
+            <a:avLst/>
+          </a:prstGeom>
+          <a:noFill/>
+        </p:spPr>
+        <p:txBody>
+          <a:bodyPr wrap="square">
+            <a:spAutoFit/>
+          </a:bodyPr>
+          <a:lstStyle/>
+          <a:p>
+            <a:pPr algn="l"/>
+            <a:r>
+              <a:rPr sz="900" b="0" i="0">
+                <a:solidFill>
+                  <a:srgbClr val="555555"/>
+                </a:solidFill>
+              </a:rPr>
+              <a:t>Built: auth system, GitHub branches, role structure.</a:t>
+            </a:r>
+          </a:p>
+          <a:p>
+            <a:pPr algn="l"/>
+            <a:r>
+              <a:rPr sz="900" b="0" i="0">
+                <a:solidFill>
+                  <a:srgbClr val="555555"/>
+                </a:solidFill>
+              </a:rPr>
+              <a:t>Learned: agreeing roles before coding prevented overlap and blame.</a:t>
+            </a:r>
+          </a:p>
+        </p:txBody>
+      </p:sp>
+      <p:sp>
+        <p:nvSpPr>
+          <p:cNvPr id="8" name="TextBox 7"/>
+          <p:cNvSpPr txBox="1"/>
+          <p:nvPr/>
+        </p:nvSpPr>
+        <p:spPr>
+          <a:xfrm>
+            <a:off x="457200" y="1938528"/>
+            <a:ext cx="640080" cy="274320"/>
+          </a:xfrm>
+          <a:prstGeom prst="rect">
+            <a:avLst/>
+          </a:prstGeom>
+          <a:noFill/>
+        </p:spPr>
+        <p:txBody>
+          <a:bodyPr wrap="square">
+            <a:spAutoFit/>
+          </a:bodyPr>
+          <a:lstStyle/>
+          <a:p>
+            <a:pPr algn="l"/>
+            <a:r>
+              <a:rPr sz="1200" b="1" i="0">
+                <a:solidFill>
+                  <a:srgbClr val="FFCD00"/>
+                </a:solidFill>
+              </a:rPr>
+              <a:t>02</a:t>
+            </a:r>
+          </a:p>
+        </p:txBody>
+      </p:sp>
+      <p:sp>
+        <p:nvSpPr>
+          <p:cNvPr id="9" name="TextBox 8"/>
+          <p:cNvSpPr txBox="1"/>
+          <p:nvPr/>
+        </p:nvSpPr>
+        <p:spPr>
+          <a:xfrm>
+            <a:off x="1188720" y="1938528"/>
+            <a:ext cx="3657600" cy="256032"/>
+          </a:xfrm>
+          <a:prstGeom prst="rect">
+            <a:avLst/>
+          </a:prstGeom>
+          <a:noFill/>
+        </p:spPr>
+        <p:txBody>
+          <a:bodyPr wrap="square">
+            <a:spAutoFit/>
+          </a:bodyPr>
+          <a:lstStyle/>
+          <a:p>
+            <a:pPr algn="l"/>
+            <a:r>
+              <a:rPr sz="1200" b="1" i="0">
+                <a:solidFill>
+                  <a:srgbClr val="111111"/>
+                </a:solidFill>
+              </a:rPr>
+              <a:t>Sprint 2 — Game Engine</a:t>
+            </a:r>
+          </a:p>
+        </p:txBody>
+      </p:sp>
+      <p:sp>
+        <p:nvSpPr>
+          <p:cNvPr id="10" name="TextBox 9"/>
+          <p:cNvSpPr txBox="1"/>
+          <p:nvPr/>
+        </p:nvSpPr>
+        <p:spPr>
+          <a:xfrm>
+            <a:off x="1188720" y="2212848"/>
+            <a:ext cx="7680960" cy="457200"/>
+          </a:xfrm>
+          <a:prstGeom prst="rect">
+            <a:avLst/>
+          </a:prstGeom>
+          <a:noFill/>
+        </p:spPr>
+        <p:txBody>
+          <a:bodyPr wrap="square">
+            <a:spAutoFit/>
+          </a:bodyPr>
+          <a:lstStyle/>
+          <a:p>
+            <a:pPr algn="l"/>
+            <a:r>
+              <a:rPr sz="900" b="0" i="0">
+                <a:solidFill>
+                  <a:srgbClr val="555555"/>
+                </a:solidFill>
+              </a:rPr>
+              <a:t>Built: core quiz loop, slash mechanic.</a:t>
+            </a:r>
+          </a:p>
+          <a:p>
+            <a:pPr algn="l"/>
+            <a:r>
+              <a:rPr sz="900" b="0" i="0">
+                <a:solidFill>
+                  <a:srgbClr val="555555"/>
+                </a:solidFill>
+              </a:rPr>
+              <a:t>Learned: daily WhatsApp check-ins replaced long weekly catch-ups and kept everyone unblocked.</a:t>
+            </a:r>
+          </a:p>
+        </p:txBody>
+      </p:sp>
+      <p:sp>
+        <p:nvSpPr>
+          <p:cNvPr id="11" name="TextBox 10"/>
+          <p:cNvSpPr txBox="1"/>
+          <p:nvPr/>
+        </p:nvSpPr>
+        <p:spPr>
+          <a:xfrm>
+            <a:off x="457200" y="2688336"/>
+            <a:ext cx="640080" cy="274320"/>
+          </a:xfrm>
+          <a:prstGeom prst="rect">
+            <a:avLst/>
+          </a:prstGeom>
+          <a:noFill/>
+        </p:spPr>
+        <p:txBody>
+          <a:bodyPr wrap="square">
+            <a:spAutoFit/>
+          </a:bodyPr>
+          <a:lstStyle/>
+          <a:p>
+            <a:pPr algn="l"/>
+            <a:r>
+              <a:rPr sz="1200" b="1" i="0">
+                <a:solidFill>
+                  <a:srgbClr val="FFCD00"/>
+                </a:solidFill>
+              </a:rPr>
+              <a:t>03</a:t>
+            </a:r>
+          </a:p>
+        </p:txBody>
+      </p:sp>
+      <p:sp>
+        <p:nvSpPr>
+          <p:cNvPr id="12" name="TextBox 11"/>
+          <p:cNvSpPr txBox="1"/>
+          <p:nvPr/>
+        </p:nvSpPr>
+        <p:spPr>
+          <a:xfrm>
+            <a:off x="1188720" y="2688336"/>
+            <a:ext cx="3657600" cy="256032"/>
+          </a:xfrm>
+          <a:prstGeom prst="rect">
+            <a:avLst/>
+          </a:prstGeom>
+          <a:noFill/>
+        </p:spPr>
+        <p:txBody>
+          <a:bodyPr wrap="square">
+            <a:spAutoFit/>
+          </a:bodyPr>
+          <a:lstStyle/>
+          <a:p>
+            <a:pPr algn="l"/>
+            <a:r>
+              <a:rPr sz="1200" b="1" i="0">
+                <a:solidFill>
+                  <a:srgbClr val="111111"/>
+                </a:solidFill>
+              </a:rPr>
+              <a:t>Sprint 3 — Slicing &amp; Sound</a:t>
+            </a:r>
+          </a:p>
+        </p:txBody>
+      </p:sp>
+      <p:sp>
+        <p:nvSpPr>
+          <p:cNvPr id="13" name="TextBox 12"/>
+          <p:cNvSpPr txBox="1"/>
+          <p:nvPr/>
+        </p:nvSpPr>
+        <p:spPr>
+          <a:xfrm>
+            <a:off x="1188720" y="2962656"/>
+            <a:ext cx="7680960" cy="457200"/>
+          </a:xfrm>
+          <a:prstGeom prst="rect">
+            <a:avLst/>
+          </a:prstGeom>
+          <a:noFill/>
+        </p:spPr>
+        <p:txBody>
+          <a:bodyPr wrap="square">
+            <a:spAutoFit/>
+          </a:bodyPr>
+          <a:lstStyle/>
+          <a:p>
+            <a:pPr algn="l"/>
+            <a:r>
+              <a:rPr sz="900" b="0" i="0">
+                <a:solidFill>
+                  <a:srgbClr val="555555"/>
+                </a:solidFill>
+              </a:rPr>
+              <a:t>Built: animations, visual effects, audio.</a:t>
+            </a:r>
+          </a:p>
+          <a:p>
+            <a:pPr algn="l"/>
+            <a:r>
+              <a:rPr sz="900" b="0" i="0">
+                <a:solidFill>
+                  <a:srgbClr val="555555"/>
+                </a:solidFill>
+              </a:rPr>
+              <a:t>Learned: first merge conflicts taught us to always pull before push — a discipline we kept.</a:t>
+            </a:r>
+          </a:p>
+        </p:txBody>
+      </p:sp>
+      <p:sp>
+        <p:nvSpPr>
+          <p:cNvPr id="14" name="TextBox 13"/>
+          <p:cNvSpPr txBox="1"/>
+          <p:nvPr/>
+        </p:nvSpPr>
+        <p:spPr>
+          <a:xfrm>
+            <a:off x="457200" y="3438144"/>
+            <a:ext cx="640080" cy="274320"/>
+          </a:xfrm>
+          <a:prstGeom prst="rect">
+            <a:avLst/>
+          </a:prstGeom>
+          <a:noFill/>
+        </p:spPr>
+        <p:txBody>
+          <a:bodyPr wrap="square">
+            <a:spAutoFit/>
+          </a:bodyPr>
+          <a:lstStyle/>
+          <a:p>
+            <a:pPr algn="l"/>
+            <a:r>
+              <a:rPr sz="1200" b="1" i="0">
+                <a:solidFill>
+                  <a:srgbClr val="FFCD00"/>
+                </a:solidFill>
+              </a:rPr>
+              <a:t>04</a:t>
+            </a:r>
+          </a:p>
+        </p:txBody>
+      </p:sp>
+      <p:sp>
+        <p:nvSpPr>
+          <p:cNvPr id="15" name="TextBox 14"/>
+          <p:cNvSpPr txBox="1"/>
+          <p:nvPr/>
+        </p:nvSpPr>
+        <p:spPr>
+          <a:xfrm>
+            <a:off x="1188720" y="3438144"/>
+            <a:ext cx="3657600" cy="256032"/>
+          </a:xfrm>
+          <a:prstGeom prst="rect">
+            <a:avLst/>
+          </a:prstGeom>
+          <a:noFill/>
+        </p:spPr>
+        <p:txBody>
+          <a:bodyPr wrap="square">
+            <a:spAutoFit/>
+          </a:bodyPr>
+          <a:lstStyle/>
+          <a:p>
+            <a:pPr algn="l"/>
+            <a:r>
+              <a:rPr sz="1200" b="1" i="0">
+                <a:solidFill>
+                  <a:srgbClr val="111111"/>
+                </a:solidFill>
+              </a:rPr>
+              <a:t>Sprint 4 — Leaderboard &amp; Test</a:t>
+            </a:r>
+          </a:p>
+        </p:txBody>
+      </p:sp>
+      <p:sp>
+        <p:nvSpPr>
+          <p:cNvPr id="16" name="TextBox 15"/>
+          <p:cNvSpPr txBox="1"/>
+          <p:nvPr/>
+        </p:nvSpPr>
+        <p:spPr>
+          <a:xfrm>
+            <a:off x="1188720" y="3712463"/>
+            <a:ext cx="7680960" cy="457200"/>
+          </a:xfrm>
+          <a:prstGeom prst="rect">
+            <a:avLst/>
+          </a:prstGeom>
+          <a:noFill/>
+        </p:spPr>
+        <p:txBody>
+          <a:bodyPr wrap="square">
+            <a:spAutoFit/>
+          </a:bodyPr>
+          <a:lstStyle/>
+          <a:p>
+            <a:pPr algn="l"/>
+            <a:r>
+              <a:rPr sz="900" b="0" i="0">
+                <a:solidFill>
+                  <a:srgbClr val="555555"/>
+                </a:solidFill>
+              </a:rPr>
+              <a:t>Built: scoring, peer testing sessions.</a:t>
+            </a:r>
+          </a:p>
+          <a:p>
+            <a:pPr algn="l"/>
+            <a:r>
+              <a:rPr sz="900" b="0" i="0">
+                <a:solidFill>
+                  <a:srgbClr val="555555"/>
+                </a:solidFill>
+              </a:rPr>
+              <a:t>Learned: external testers found issues we missed — peer testing is essential, not optional.</a:t>
+            </a:r>
+          </a:p>
+        </p:txBody>
+      </p:sp>
+      <p:sp>
+        <p:nvSpPr>
+          <p:cNvPr id="17" name="TextBox 16"/>
+          <p:cNvSpPr txBox="1"/>
+          <p:nvPr/>
+        </p:nvSpPr>
+        <p:spPr>
+          <a:xfrm>
+            <a:off x="457200" y="4187952"/>
+            <a:ext cx="640080" cy="274320"/>
+          </a:xfrm>
+          <a:prstGeom prst="rect">
+            <a:avLst/>
+          </a:prstGeom>
+          <a:noFill/>
+        </p:spPr>
+        <p:txBody>
+          <a:bodyPr wrap="square">
+            <a:spAutoFit/>
+          </a:bodyPr>
+          <a:lstStyle/>
+          <a:p>
+            <a:pPr algn="l"/>
+            <a:r>
+              <a:rPr sz="1200" b="1" i="0">
+                <a:solidFill>
+                  <a:srgbClr val="FFCD00"/>
+                </a:solidFill>
+              </a:rPr>
+              <a:t>05</a:t>
+            </a:r>
+          </a:p>
+        </p:txBody>
+      </p:sp>
+      <p:sp>
+        <p:nvSpPr>
+          <p:cNvPr id="18" name="TextBox 17"/>
+          <p:cNvSpPr txBox="1"/>
+          <p:nvPr/>
+        </p:nvSpPr>
+        <p:spPr>
+          <a:xfrm>
+            <a:off x="1188720" y="4187952"/>
+            <a:ext cx="3657600" cy="256032"/>
+          </a:xfrm>
+          <a:prstGeom prst="rect">
+            <a:avLst/>
+          </a:prstGeom>
+          <a:noFill/>
+        </p:spPr>
+        <p:txBody>
+          <a:bodyPr wrap="square">
+            <a:spAutoFit/>
+          </a:bodyPr>
+          <a:lstStyle/>
+          <a:p>
+            <a:pPr algn="l"/>
+            <a:r>
+              <a:rPr sz="1200" b="1" i="0">
+                <a:solidFill>
+                  <a:srgbClr val="111111"/>
+                </a:solidFill>
+              </a:rPr>
+              <a:t>Sprint 5 — Polish &amp; Submit</a:t>
+            </a:r>
+          </a:p>
+        </p:txBody>
+      </p:sp>
+      <p:sp>
+        <p:nvSpPr>
+          <p:cNvPr id="19" name="TextBox 18"/>
+          <p:cNvSpPr txBox="1"/>
+          <p:nvPr/>
+        </p:nvSpPr>
+        <p:spPr>
+          <a:xfrm>
+            <a:off x="1188720" y="4462272"/>
+            <a:ext cx="7680960" cy="457200"/>
+          </a:xfrm>
+          <a:prstGeom prst="rect">
+            <a:avLst/>
+          </a:prstGeom>
+          <a:noFill/>
+        </p:spPr>
+        <p:txBody>
+          <a:bodyPr wrap="square">
+            <a:spAutoFit/>
+          </a:bodyPr>
+          <a:lstStyle/>
+          <a:p>
+            <a:pPr algn="l"/>
+            <a:r>
+              <a:rPr sz="900" b="0" i="0">
+                <a:solidFill>
+                  <a:srgbClr val="555555"/>
+                </a:solidFill>
+              </a:rPr>
+              <a:t>Built: final bug fixes, documentation.</a:t>
+            </a:r>
+          </a:p>
+          <a:p>
+            <a:pPr algn="l"/>
+            <a:r>
+              <a:rPr sz="900" b="0" i="0">
+                <a:solidFill>
+                  <a:srgbClr val="555555"/>
+                </a:solidFill>
+              </a:rPr>
+              <a:t>Learned: a team that communicates daily ships on time. We did.</a:t>
+            </a:r>
+          </a:p>
+        </p:txBody>
+      </p:sp>
+    </p:spTree>
+  </p:cSld>
+  <p:clrMapOvr>
+    <a:masterClrMapping/>
+  </p:clrMapOvr>
+</p:sld>
+</file>
+
+<file path=ppt/slides/slide11.xml><?xml version="1.0" encoding="utf-8"?>
+<p:sld xmlns:a="http://schemas.openxmlformats.org/drawingml/2006/main" xmlns:r="http://schemas.openxmlformats.org/officeDocument/2006/relationships" xmlns:p="http://schemas.openxmlformats.org/presentationml/2006/main">
   <p:cSld name="Slide 10">
     <p:bg>
       <p:bgPr>
@@ -2467,7 +3168,7 @@
 </p:sld>
 </file>
 
-<file path=ppt/slides/slide11.xml><?xml version="1.0" encoding="utf-8"?>
+<file path=ppt/slides/slide12.xml><?xml version="1.0" encoding="utf-8"?>
 <p:sld xmlns:a="http://schemas.openxmlformats.org/drawingml/2006/main" xmlns:r="http://schemas.openxmlformats.org/officeDocument/2006/relationships" xmlns:p="http://schemas.openxmlformats.org/presentationml/2006/main">
   <p:cSld name="Slide 11">
     <p:bg>
@@ -3142,7 +3843,7 @@
 </p:sld>
 </file>
 
-<file path=ppt/slides/slide12.xml><?xml version="1.0" encoding="utf-8"?>
+<file path=ppt/slides/slide13.xml><?xml version="1.0" encoding="utf-8"?>
 <p:sld xmlns:a="http://schemas.openxmlformats.org/drawingml/2006/main" xmlns:r="http://schemas.openxmlformats.org/officeDocument/2006/relationships" xmlns:p="http://schemas.openxmlformats.org/presentationml/2006/main">
   <p:cSld name="Slide 12">
     <p:bg>
@@ -3742,7 +4443,7 @@
 </p:sld>
 </file>
 
-<file path=ppt/slides/slide13.xml><?xml version="1.0" encoding="utf-8"?>
+<file path=ppt/slides/slide14.xml><?xml version="1.0" encoding="utf-8"?>
 <p:sld xmlns:a="http://schemas.openxmlformats.org/drawingml/2006/main" xmlns:r="http://schemas.openxmlformats.org/officeDocument/2006/relationships" xmlns:p="http://schemas.openxmlformats.org/presentationml/2006/main">
   <p:cSld name="Slide 13">
     <p:bg>
@@ -3947,7 +4648,7 @@
 </p:sld>
 </file>
 
-<file path=ppt/slides/slide14.xml><?xml version="1.0" encoding="utf-8"?>
+<file path=ppt/slides/slide15.xml><?xml version="1.0" encoding="utf-8"?>
 <p:sld xmlns:a="http://schemas.openxmlformats.org/drawingml/2006/main" xmlns:r="http://schemas.openxmlformats.org/officeDocument/2006/relationships" xmlns:p="http://schemas.openxmlformats.org/presentationml/2006/main">
   <p:cSld name="Slide 14">
     <p:bg>
@@ -4811,7 +5512,7 @@
 </p:sld>
 </file>
 
-<file path=ppt/slides/slide15.xml><?xml version="1.0" encoding="utf-8"?>
+<file path=ppt/slides/slide16.xml><?xml version="1.0" encoding="utf-8"?>
 <p:sld xmlns:a="http://schemas.openxmlformats.org/drawingml/2006/main" xmlns:r="http://schemas.openxmlformats.org/officeDocument/2006/relationships" xmlns:p="http://schemas.openxmlformats.org/presentationml/2006/main">
   <p:cSld name="Slide 15">
     <p:bg>
@@ -5504,7 +6205,7 @@
 </p:sld>
 </file>
 
-<file path=ppt/slides/slide16.xml><?xml version="1.0" encoding="utf-8"?>
+<file path=ppt/slides/slide17.xml><?xml version="1.0" encoding="utf-8"?>
 <p:sld xmlns:a="http://schemas.openxmlformats.org/drawingml/2006/main" xmlns:r="http://schemas.openxmlformats.org/officeDocument/2006/relationships" xmlns:p="http://schemas.openxmlformats.org/presentationml/2006/main">
   <p:cSld name="Slide 16">
     <p:bg>
@@ -5705,7 +6406,7 @@
 </p:sld>
 </file>
 
-<file path=ppt/slides/slide17.xml><?xml version="1.0" encoding="utf-8"?>
+<file path=ppt/slides/slide18.xml><?xml version="1.0" encoding="utf-8"?>
 <p:sld xmlns:a="http://schemas.openxmlformats.org/drawingml/2006/main" xmlns:r="http://schemas.openxmlformats.org/officeDocument/2006/relationships" xmlns:p="http://schemas.openxmlformats.org/presentationml/2006/main">
   <p:cSld name="Slide 17">
     <p:bg>
@@ -5965,7 +6666,7 @@
 </p:sld>
 </file>
 
-<file path=ppt/slides/slide18.xml><?xml version="1.0" encoding="utf-8"?>
+<file path=ppt/slides/slide19.xml><?xml version="1.0" encoding="utf-8"?>
 <p:sld xmlns:a="http://schemas.openxmlformats.org/drawingml/2006/main" xmlns:r="http://schemas.openxmlformats.org/officeDocument/2006/relationships" xmlns:p="http://schemas.openxmlformats.org/presentationml/2006/main">
   <p:cSld>
     <p:bg>
@@ -6383,7 +7084,863 @@
 </p:sld>
 </file>
 
-<file path=ppt/slides/slide19.xml><?xml version="1.0" encoding="utf-8"?>
+<file path=ppt/slides/slide2.xml><?xml version="1.0" encoding="utf-8"?>
+<p:sld xmlns:a="http://schemas.openxmlformats.org/drawingml/2006/main" xmlns:p="http://schemas.openxmlformats.org/presentationml/2006/main" xmlns:r="http://schemas.openxmlformats.org/officeDocument/2006/relationships">
+  <p:cSld>
+    <p:spTree>
+      <p:nvGrpSpPr>
+        <p:cNvPr id="1" name=""/>
+        <p:cNvGrpSpPr/>
+        <p:nvPr/>
+      </p:nvGrpSpPr>
+      <p:grpSpPr>
+        <a:xfrm>
+          <a:off x="0" y="0"/>
+          <a:ext cx="0" cy="0"/>
+          <a:chOff x="0" y="0"/>
+          <a:chExt cx="0" cy="0"/>
+        </a:xfrm>
+      </p:grpSpPr>
+      <p:sp>
+        <p:nvSpPr>
+          <p:cNvPr id="2" name="Shape 0"/>
+          <p:cNvSpPr/>
+          <p:nvPr/>
+        </p:nvSpPr>
+        <p:spPr>
+          <a:xfrm>
+            <a:off x="8458200" y="201168"/>
+            <a:ext cx="256032" cy="256032"/>
+          </a:xfrm>
+          <a:prstGeom prst="ellipse">
+            <a:avLst/>
+          </a:prstGeom>
+          <a:solidFill>
+            <a:srgbClr val="DDDDDD"/>
+          </a:solidFill>
+          <a:ln/>
+        </p:spPr>
+        <p:txBody>
+          <a:bodyPr/>
+          <a:lstStyle/>
+          <a:p>
+            <a:endParaRPr lang="en-GB"/>
+          </a:p>
+        </p:txBody>
+      </p:sp>
+      <p:sp>
+        <p:nvSpPr>
+          <p:cNvPr id="3" name="Text 1"/>
+          <p:cNvSpPr/>
+          <p:nvPr/>
+        </p:nvSpPr>
+        <p:spPr>
+          <a:xfrm>
+            <a:off x="457200" y="274320"/>
+            <a:ext cx="6400800" cy="228600"/>
+          </a:xfrm>
+          <a:prstGeom prst="rect">
+            <a:avLst/>
+          </a:prstGeom>
+          <a:noFill/>
+          <a:ln/>
+        </p:spPr>
+        <p:txBody>
+          <a:bodyPr wrap="square" rtlCol="0" anchor="ctr"/>
+          <a:lstStyle/>
+          <a:p>
+            <a:pPr marL="0" indent="0">
+              <a:buNone/>
+            </a:pPr>
+            <a:r>
+              <a:rPr lang="en-US" sz="1000" b="1" kern="0" spc="200" dirty="0">
+                <a:solidFill>
+                  <a:srgbClr val="888888"/>
+                </a:solidFill>
+                <a:latin typeface="Arial" pitchFamily="34" charset="0"/>
+                <a:ea typeface="Arial" pitchFamily="34" charset="-122"/>
+                <a:cs typeface="Arial" pitchFamily="34" charset="-120"/>
+              </a:rPr>
+              <a:t>THE BRIEF</a:t>
+            </a:r>
+            <a:endParaRPr lang="en-US" sz="1000" dirty="0"/>
+          </a:p>
+        </p:txBody>
+      </p:sp>
+      <p:sp>
+        <p:nvSpPr>
+          <p:cNvPr id="4" name="Text 2"/>
+          <p:cNvSpPr/>
+          <p:nvPr/>
+        </p:nvSpPr>
+        <p:spPr>
+          <a:xfrm>
+            <a:off x="3657600" y="4919472"/>
+            <a:ext cx="5212080" cy="182880"/>
+          </a:xfrm>
+          <a:prstGeom prst="rect">
+            <a:avLst/>
+          </a:prstGeom>
+          <a:noFill/>
+          <a:ln/>
+        </p:spPr>
+        <p:txBody>
+          <a:bodyPr wrap="square" rtlCol="0" anchor="ctr"/>
+          <a:lstStyle/>
+          <a:p>
+            <a:pPr marL="0" indent="0" algn="r">
+              <a:buNone/>
+            </a:pPr>
+            <a:r>
+              <a:rPr lang="en-US" sz="900" dirty="0">
+                <a:solidFill>
+                  <a:srgbClr val="888888"/>
+                </a:solidFill>
+                <a:latin typeface="Arial" pitchFamily="34" charset="0"/>
+                <a:ea typeface="Arial" pitchFamily="34" charset="-122"/>
+                <a:cs typeface="Arial" pitchFamily="34" charset="-120"/>
+              </a:rPr>
+              <a:t>NINJA QUIZ  .  503IT  .  02 / 18</a:t>
+            </a:r>
+            <a:endParaRPr lang="en-US" sz="900" dirty="0"/>
+          </a:p>
+        </p:txBody>
+      </p:sp>
+      <p:sp>
+        <p:nvSpPr>
+          <p:cNvPr id="5" name="Text 3"/>
+          <p:cNvSpPr/>
+          <p:nvPr/>
+        </p:nvSpPr>
+        <p:spPr>
+          <a:xfrm>
+            <a:off x="457200" y="685800"/>
+            <a:ext cx="8229600" cy="965200"/>
+          </a:xfrm>
+          <a:prstGeom prst="rect">
+            <a:avLst/>
+          </a:prstGeom>
+          <a:noFill/>
+          <a:ln/>
+        </p:spPr>
+        <p:txBody>
+          <a:bodyPr wrap="square" rtlCol="0" anchor="ctr"/>
+          <a:lstStyle/>
+          <a:p>
+            <a:pPr marL="0" indent="0">
+              <a:buNone/>
+            </a:pPr>
+            <a:r>
+              <a:rPr lang="en-US" sz="3800" b="1" dirty="0">
+                <a:solidFill>
+                  <a:srgbClr val="111111"/>
+                </a:solidFill>
+                <a:latin typeface="Arial Black" pitchFamily="34" charset="0"/>
+                <a:ea typeface="Arial Black" pitchFamily="34" charset="-122"/>
+                <a:cs typeface="Arial Black" pitchFamily="34" charset="-120"/>
+              </a:rPr>
+              <a:t>What we were asked to build.</a:t>
+            </a:r>
+            <a:endParaRPr lang="en-US" sz="3800" dirty="0"/>
+          </a:p>
+        </p:txBody>
+      </p:sp>
+      <p:sp>
+        <p:nvSpPr>
+          <p:cNvPr id="6" name="Shape 4"/>
+          <p:cNvSpPr/>
+          <p:nvPr/>
+        </p:nvSpPr>
+        <p:spPr>
+          <a:xfrm>
+            <a:off x="457200" y="1463040"/>
+            <a:ext cx="8229600" cy="10973"/>
+          </a:xfrm>
+          <a:prstGeom prst="rect">
+            <a:avLst/>
+          </a:prstGeom>
+          <a:solidFill>
+            <a:srgbClr val="EEEEEE"/>
+          </a:solidFill>
+          <a:ln/>
+        </p:spPr>
+        <p:txBody>
+          <a:bodyPr/>
+          <a:lstStyle/>
+          <a:p>
+            <a:endParaRPr lang="en-GB"/>
+          </a:p>
+        </p:txBody>
+      </p:sp>
+      <p:sp>
+        <p:nvSpPr>
+          <p:cNvPr id="7" name="Shape 5"/>
+          <p:cNvSpPr/>
+          <p:nvPr/>
+        </p:nvSpPr>
+        <p:spPr>
+          <a:xfrm>
+            <a:off x="457200" y="1700784"/>
+            <a:ext cx="128016" cy="128016"/>
+          </a:xfrm>
+          <a:prstGeom prst="rect">
+            <a:avLst/>
+          </a:prstGeom>
+          <a:solidFill>
+            <a:srgbClr val="FFCD00"/>
+          </a:solidFill>
+          <a:ln/>
+        </p:spPr>
+        <p:txBody>
+          <a:bodyPr/>
+          <a:lstStyle/>
+          <a:p>
+            <a:endParaRPr lang="en-GB"/>
+          </a:p>
+        </p:txBody>
+      </p:sp>
+      <p:sp>
+        <p:nvSpPr>
+          <p:cNvPr id="8" name="Text 6"/>
+          <p:cNvSpPr/>
+          <p:nvPr/>
+        </p:nvSpPr>
+        <p:spPr>
+          <a:xfrm>
+            <a:off x="749808" y="1572768"/>
+            <a:ext cx="4206240" cy="411480"/>
+          </a:xfrm>
+          <a:prstGeom prst="rect">
+            <a:avLst/>
+          </a:prstGeom>
+          <a:noFill/>
+          <a:ln/>
+        </p:spPr>
+        <p:txBody>
+          <a:bodyPr wrap="square" rtlCol="0" anchor="ctr"/>
+          <a:lstStyle/>
+          <a:p>
+            <a:pPr marL="0" indent="0">
+              <a:buNone/>
+            </a:pPr>
+            <a:r>
+              <a:rPr lang="en-US" sz="1400" b="1" dirty="0">
+                <a:solidFill>
+                  <a:srgbClr val="111111"/>
+                </a:solidFill>
+                <a:latin typeface="Arial Black" pitchFamily="34" charset="0"/>
+                <a:ea typeface="Arial Black" pitchFamily="34" charset="-122"/>
+                <a:cs typeface="Arial Black" pitchFamily="34" charset="-120"/>
+              </a:rPr>
+              <a:t>The client</a:t>
+            </a:r>
+            <a:endParaRPr lang="en-US" sz="1400" dirty="0"/>
+          </a:p>
+        </p:txBody>
+      </p:sp>
+      <p:sp>
+        <p:nvSpPr>
+          <p:cNvPr id="9" name="Text 7"/>
+          <p:cNvSpPr/>
+          <p:nvPr/>
+        </p:nvSpPr>
+        <p:spPr>
+          <a:xfrm>
+            <a:off x="5074920" y="1572768"/>
+            <a:ext cx="3657600" cy="411480"/>
+          </a:xfrm>
+          <a:prstGeom prst="rect">
+            <a:avLst/>
+          </a:prstGeom>
+          <a:noFill/>
+          <a:ln/>
+        </p:spPr>
+        <p:txBody>
+          <a:bodyPr wrap="square" rtlCol="0" anchor="ctr"/>
+          <a:lstStyle/>
+          <a:p>
+            <a:pPr marL="0" indent="0">
+              <a:buNone/>
+            </a:pPr>
+            <a:r>
+              <a:rPr lang="en-US" sz="1300" dirty="0">
+                <a:solidFill>
+                  <a:srgbClr val="888888"/>
+                </a:solidFill>
+                <a:latin typeface="Arial" pitchFamily="34" charset="0"/>
+                <a:ea typeface="Arial" pitchFamily="34" charset="-122"/>
+                <a:cs typeface="Arial" pitchFamily="34" charset="-120"/>
+              </a:rPr>
+              <a:t>Coventry University · 503IT module · build a cyber security learning game for young users</a:t>
+            </a:r>
+            <a:endParaRPr lang="en-US" sz="1300" dirty="0"/>
+          </a:p>
+        </p:txBody>
+      </p:sp>
+      <p:sp>
+        <p:nvSpPr>
+          <p:cNvPr id="10" name="Shape 8"/>
+          <p:cNvSpPr/>
+          <p:nvPr/>
+        </p:nvSpPr>
+        <p:spPr>
+          <a:xfrm>
+            <a:off x="457200" y="2029968"/>
+            <a:ext cx="8229600" cy="10973"/>
+          </a:xfrm>
+          <a:prstGeom prst="rect">
+            <a:avLst/>
+          </a:prstGeom>
+          <a:solidFill>
+            <a:srgbClr val="EEEEEE"/>
+          </a:solidFill>
+          <a:ln/>
+        </p:spPr>
+        <p:txBody>
+          <a:bodyPr/>
+          <a:lstStyle/>
+          <a:p>
+            <a:endParaRPr lang="en-GB"/>
+          </a:p>
+        </p:txBody>
+      </p:sp>
+      <p:sp>
+        <p:nvSpPr>
+          <p:cNvPr id="11" name="Shape 9"/>
+          <p:cNvSpPr/>
+          <p:nvPr/>
+        </p:nvSpPr>
+        <p:spPr>
+          <a:xfrm>
+            <a:off x="457200" y="2276856"/>
+            <a:ext cx="128016" cy="128016"/>
+          </a:xfrm>
+          <a:prstGeom prst="rect">
+            <a:avLst/>
+          </a:prstGeom>
+          <a:solidFill>
+            <a:srgbClr val="FFCD00"/>
+          </a:solidFill>
+          <a:ln/>
+        </p:spPr>
+        <p:txBody>
+          <a:bodyPr/>
+          <a:lstStyle/>
+          <a:p>
+            <a:endParaRPr lang="en-GB"/>
+          </a:p>
+        </p:txBody>
+      </p:sp>
+      <p:sp>
+        <p:nvSpPr>
+          <p:cNvPr id="12" name="Text 10"/>
+          <p:cNvSpPr/>
+          <p:nvPr/>
+        </p:nvSpPr>
+        <p:spPr>
+          <a:xfrm>
+            <a:off x="749808" y="2148840"/>
+            <a:ext cx="4206240" cy="411480"/>
+          </a:xfrm>
+          <a:prstGeom prst="rect">
+            <a:avLst/>
+          </a:prstGeom>
+          <a:noFill/>
+          <a:ln/>
+        </p:spPr>
+        <p:txBody>
+          <a:bodyPr wrap="square" rtlCol="0" anchor="ctr"/>
+          <a:lstStyle/>
+          <a:p>
+            <a:pPr marL="0" indent="0">
+              <a:buNone/>
+            </a:pPr>
+            <a:r>
+              <a:rPr lang="en-US" sz="1400" b="1" dirty="0">
+                <a:solidFill>
+                  <a:srgbClr val="111111"/>
+                </a:solidFill>
+                <a:latin typeface="Arial Black" pitchFamily="34" charset="0"/>
+                <a:ea typeface="Arial Black" pitchFamily="34" charset="-122"/>
+                <a:cs typeface="Arial Black" pitchFamily="34" charset="-120"/>
+              </a:rPr>
+              <a:t>The problem</a:t>
+            </a:r>
+            <a:endParaRPr lang="en-US" sz="1400" dirty="0"/>
+          </a:p>
+        </p:txBody>
+      </p:sp>
+      <p:sp>
+        <p:nvSpPr>
+          <p:cNvPr id="13" name="Text 11"/>
+          <p:cNvSpPr/>
+          <p:nvPr/>
+        </p:nvSpPr>
+        <p:spPr>
+          <a:xfrm>
+            <a:off x="5074920" y="2148840"/>
+            <a:ext cx="3657600" cy="411480"/>
+          </a:xfrm>
+          <a:prstGeom prst="rect">
+            <a:avLst/>
+          </a:prstGeom>
+          <a:noFill/>
+          <a:ln/>
+        </p:spPr>
+        <p:txBody>
+          <a:bodyPr wrap="square" rtlCol="0" anchor="ctr"/>
+          <a:lstStyle/>
+          <a:p>
+            <a:pPr marL="0" indent="0">
+              <a:buNone/>
+            </a:pPr>
+            <a:r>
+              <a:rPr lang="en-US" sz="1300" dirty="0">
+                <a:solidFill>
+                  <a:srgbClr val="888888"/>
+                </a:solidFill>
+                <a:latin typeface="Arial" pitchFamily="34" charset="0"/>
+                <a:ea typeface="Arial" pitchFamily="34" charset="-122"/>
+                <a:cs typeface="Arial" pitchFamily="34" charset="-120"/>
+              </a:rPr>
+              <a:t>1 in 3 children have already faced an online risk — yet traditional education fails to engage them</a:t>
+            </a:r>
+            <a:endParaRPr lang="en-US" sz="1300" dirty="0"/>
+          </a:p>
+        </p:txBody>
+      </p:sp>
+      <p:sp>
+        <p:nvSpPr>
+          <p:cNvPr id="14" name="Shape 12"/>
+          <p:cNvSpPr/>
+          <p:nvPr/>
+        </p:nvSpPr>
+        <p:spPr>
+          <a:xfrm>
+            <a:off x="457200" y="2606040"/>
+            <a:ext cx="8229600" cy="10973"/>
+          </a:xfrm>
+          <a:prstGeom prst="rect">
+            <a:avLst/>
+          </a:prstGeom>
+          <a:solidFill>
+            <a:srgbClr val="EEEEEE"/>
+          </a:solidFill>
+          <a:ln/>
+        </p:spPr>
+        <p:txBody>
+          <a:bodyPr/>
+          <a:lstStyle/>
+          <a:p>
+            <a:endParaRPr lang="en-GB"/>
+          </a:p>
+        </p:txBody>
+      </p:sp>
+      <p:sp>
+        <p:nvSpPr>
+          <p:cNvPr id="15" name="Shape 13"/>
+          <p:cNvSpPr/>
+          <p:nvPr/>
+        </p:nvSpPr>
+        <p:spPr>
+          <a:xfrm>
+            <a:off x="457200" y="2852928"/>
+            <a:ext cx="128016" cy="128016"/>
+          </a:xfrm>
+          <a:prstGeom prst="rect">
+            <a:avLst/>
+          </a:prstGeom>
+          <a:solidFill>
+            <a:srgbClr val="FFCD00"/>
+          </a:solidFill>
+          <a:ln/>
+        </p:spPr>
+        <p:txBody>
+          <a:bodyPr/>
+          <a:lstStyle/>
+          <a:p>
+            <a:endParaRPr lang="en-GB"/>
+          </a:p>
+        </p:txBody>
+      </p:sp>
+      <p:sp>
+        <p:nvSpPr>
+          <p:cNvPr id="16" name="Text 14"/>
+          <p:cNvSpPr/>
+          <p:nvPr/>
+        </p:nvSpPr>
+        <p:spPr>
+          <a:xfrm>
+            <a:off x="749808" y="2724912"/>
+            <a:ext cx="4206240" cy="411480"/>
+          </a:xfrm>
+          <a:prstGeom prst="rect">
+            <a:avLst/>
+          </a:prstGeom>
+          <a:noFill/>
+          <a:ln/>
+        </p:spPr>
+        <p:txBody>
+          <a:bodyPr wrap="square" rtlCol="0" anchor="ctr"/>
+          <a:lstStyle/>
+          <a:p>
+            <a:pPr marL="0" indent="0">
+              <a:buNone/>
+            </a:pPr>
+            <a:r>
+              <a:rPr lang="en-US" sz="1400" b="1" dirty="0">
+                <a:solidFill>
+                  <a:srgbClr val="111111"/>
+                </a:solidFill>
+                <a:latin typeface="Arial Black" pitchFamily="34" charset="0"/>
+                <a:ea typeface="Arial Black" pitchFamily="34" charset="-122"/>
+                <a:cs typeface="Arial Black" pitchFamily="34" charset="-120"/>
+              </a:rPr>
+              <a:t>The audience</a:t>
+            </a:r>
+            <a:endParaRPr lang="en-US" sz="1400" dirty="0"/>
+          </a:p>
+        </p:txBody>
+      </p:sp>
+      <p:sp>
+        <p:nvSpPr>
+          <p:cNvPr id="17" name="Text 15"/>
+          <p:cNvSpPr/>
+          <p:nvPr/>
+        </p:nvSpPr>
+        <p:spPr>
+          <a:xfrm>
+            <a:off x="5074920" y="2724912"/>
+            <a:ext cx="3657600" cy="411480"/>
+          </a:xfrm>
+          <a:prstGeom prst="rect">
+            <a:avLst/>
+          </a:prstGeom>
+          <a:noFill/>
+          <a:ln/>
+        </p:spPr>
+        <p:txBody>
+          <a:bodyPr wrap="square" rtlCol="0" anchor="ctr"/>
+          <a:lstStyle/>
+          <a:p>
+            <a:pPr marL="0" indent="0">
+              <a:buNone/>
+            </a:pPr>
+            <a:r>
+              <a:rPr lang="en-US" sz="1300" dirty="0">
+                <a:solidFill>
+                  <a:srgbClr val="888888"/>
+                </a:solidFill>
+                <a:latin typeface="Arial" pitchFamily="34" charset="0"/>
+                <a:ea typeface="Arial" pitchFamily="34" charset="-122"/>
+                <a:cs typeface="Arial" pitchFamily="34" charset="-120"/>
+              </a:rPr>
+              <a:t>Children aged 8–16 · schools and educators · parents seeking safe, educational content</a:t>
+            </a:r>
+            <a:endParaRPr lang="en-US" sz="1300" dirty="0"/>
+          </a:p>
+        </p:txBody>
+      </p:sp>
+      <p:sp>
+        <p:nvSpPr>
+          <p:cNvPr id="18" name="Shape 16"/>
+          <p:cNvSpPr/>
+          <p:nvPr/>
+        </p:nvSpPr>
+        <p:spPr>
+          <a:xfrm>
+            <a:off x="457200" y="3182112"/>
+            <a:ext cx="8229600" cy="10973"/>
+          </a:xfrm>
+          <a:prstGeom prst="rect">
+            <a:avLst/>
+          </a:prstGeom>
+          <a:solidFill>
+            <a:srgbClr val="EEEEEE"/>
+          </a:solidFill>
+          <a:ln/>
+        </p:spPr>
+        <p:txBody>
+          <a:bodyPr/>
+          <a:lstStyle/>
+          <a:p>
+            <a:endParaRPr lang="en-GB"/>
+          </a:p>
+        </p:txBody>
+      </p:sp>
+      <p:sp>
+        <p:nvSpPr>
+          <p:cNvPr id="19" name="Shape 17"/>
+          <p:cNvSpPr/>
+          <p:nvPr/>
+        </p:nvSpPr>
+        <p:spPr>
+          <a:xfrm>
+            <a:off x="457200" y="3429000"/>
+            <a:ext cx="128016" cy="128016"/>
+          </a:xfrm>
+          <a:prstGeom prst="rect">
+            <a:avLst/>
+          </a:prstGeom>
+          <a:solidFill>
+            <a:srgbClr val="FFCD00"/>
+          </a:solidFill>
+          <a:ln/>
+        </p:spPr>
+        <p:txBody>
+          <a:bodyPr/>
+          <a:lstStyle/>
+          <a:p>
+            <a:endParaRPr lang="en-GB"/>
+          </a:p>
+        </p:txBody>
+      </p:sp>
+      <p:sp>
+        <p:nvSpPr>
+          <p:cNvPr id="20" name="Text 18"/>
+          <p:cNvSpPr/>
+          <p:nvPr/>
+        </p:nvSpPr>
+        <p:spPr>
+          <a:xfrm>
+            <a:off x="749808" y="3300984"/>
+            <a:ext cx="4206240" cy="411480"/>
+          </a:xfrm>
+          <a:prstGeom prst="rect">
+            <a:avLst/>
+          </a:prstGeom>
+          <a:noFill/>
+          <a:ln/>
+        </p:spPr>
+        <p:txBody>
+          <a:bodyPr wrap="square" rtlCol="0" anchor="ctr"/>
+          <a:lstStyle/>
+          <a:p>
+            <a:pPr marL="0" indent="0">
+              <a:buNone/>
+            </a:pPr>
+            <a:r>
+              <a:rPr lang="en-US" sz="1400" b="1" dirty="0">
+                <a:solidFill>
+                  <a:srgbClr val="111111"/>
+                </a:solidFill>
+                <a:latin typeface="Arial Black" pitchFamily="34" charset="0"/>
+                <a:ea typeface="Arial Black" pitchFamily="34" charset="-122"/>
+                <a:cs typeface="Arial Black" pitchFamily="34" charset="-120"/>
+              </a:rPr>
+              <a:t>The ask</a:t>
+            </a:r>
+            <a:endParaRPr lang="en-US" sz="1400" dirty="0"/>
+          </a:p>
+        </p:txBody>
+      </p:sp>
+      <p:sp>
+        <p:nvSpPr>
+          <p:cNvPr id="21" name="Text 19"/>
+          <p:cNvSpPr/>
+          <p:nvPr/>
+        </p:nvSpPr>
+        <p:spPr>
+          <a:xfrm>
+            <a:off x="5074920" y="3300984"/>
+            <a:ext cx="3657600" cy="411480"/>
+          </a:xfrm>
+          <a:prstGeom prst="rect">
+            <a:avLst/>
+          </a:prstGeom>
+          <a:noFill/>
+          <a:ln/>
+        </p:spPr>
+        <p:txBody>
+          <a:bodyPr wrap="square" rtlCol="0" anchor="ctr"/>
+          <a:lstStyle/>
+          <a:p>
+            <a:pPr marL="0" indent="0">
+              <a:buNone/>
+            </a:pPr>
+            <a:r>
+              <a:rPr lang="en-US" sz="1300" dirty="0">
+                <a:solidFill>
+                  <a:srgbClr val="888888"/>
+                </a:solidFill>
+                <a:latin typeface="Arial" pitchFamily="34" charset="0"/>
+                <a:ea typeface="Arial" pitchFamily="34" charset="-122"/>
+                <a:cs typeface="Arial" pitchFamily="34" charset="-120"/>
+              </a:rPr>
+              <a:t>A working browser game that teaches cyber safety through play — five people, four weeks</a:t>
+            </a:r>
+            <a:endParaRPr lang="en-US" sz="1300" dirty="0"/>
+          </a:p>
+        </p:txBody>
+      </p:sp>
+      <p:sp>
+        <p:nvSpPr>
+          <p:cNvPr id="22" name="Shape 20"/>
+          <p:cNvSpPr/>
+          <p:nvPr/>
+        </p:nvSpPr>
+        <p:spPr>
+          <a:xfrm>
+            <a:off x="457200" y="3758184"/>
+            <a:ext cx="8229600" cy="10973"/>
+          </a:xfrm>
+          <a:prstGeom prst="rect">
+            <a:avLst/>
+          </a:prstGeom>
+          <a:solidFill>
+            <a:srgbClr val="EEEEEE"/>
+          </a:solidFill>
+          <a:ln/>
+        </p:spPr>
+        <p:txBody>
+          <a:bodyPr/>
+          <a:lstStyle/>
+          <a:p>
+            <a:endParaRPr lang="en-GB"/>
+          </a:p>
+        </p:txBody>
+      </p:sp>
+      <p:sp>
+        <p:nvSpPr>
+          <p:cNvPr id="23" name="Shape 21"/>
+          <p:cNvSpPr/>
+          <p:nvPr/>
+        </p:nvSpPr>
+        <p:spPr>
+          <a:xfrm>
+            <a:off x="457200" y="4005072"/>
+            <a:ext cx="128016" cy="128016"/>
+          </a:xfrm>
+          <a:prstGeom prst="rect">
+            <a:avLst/>
+          </a:prstGeom>
+          <a:solidFill>
+            <a:srgbClr val="FFCD00"/>
+          </a:solidFill>
+          <a:ln/>
+        </p:spPr>
+        <p:txBody>
+          <a:bodyPr/>
+          <a:lstStyle/>
+          <a:p>
+            <a:endParaRPr lang="en-GB"/>
+          </a:p>
+        </p:txBody>
+      </p:sp>
+      <p:sp>
+        <p:nvSpPr>
+          <p:cNvPr id="24" name="Text 22"/>
+          <p:cNvSpPr/>
+          <p:nvPr/>
+        </p:nvSpPr>
+        <p:spPr>
+          <a:xfrm>
+            <a:off x="749808" y="3877056"/>
+            <a:ext cx="4206240" cy="411480"/>
+          </a:xfrm>
+          <a:prstGeom prst="rect">
+            <a:avLst/>
+          </a:prstGeom>
+          <a:noFill/>
+          <a:ln/>
+        </p:spPr>
+        <p:txBody>
+          <a:bodyPr wrap="square" rtlCol="0" anchor="ctr"/>
+          <a:lstStyle/>
+          <a:p>
+            <a:pPr marL="0" indent="0">
+              <a:buNone/>
+            </a:pPr>
+            <a:r>
+              <a:rPr lang="en-US" sz="1400" b="1" dirty="0">
+                <a:solidFill>
+                  <a:srgbClr val="111111"/>
+                </a:solidFill>
+                <a:latin typeface="Arial Black" pitchFamily="34" charset="0"/>
+                <a:ea typeface="Arial Black" pitchFamily="34" charset="-122"/>
+                <a:cs typeface="Arial Black" pitchFamily="34" charset="-120"/>
+              </a:rPr>
+              <a:t>The constraint</a:t>
+            </a:r>
+            <a:endParaRPr lang="en-US" sz="1400" dirty="0"/>
+          </a:p>
+        </p:txBody>
+      </p:sp>
+      <p:sp>
+        <p:nvSpPr>
+          <p:cNvPr id="25" name="Text 23"/>
+          <p:cNvSpPr/>
+          <p:nvPr/>
+        </p:nvSpPr>
+        <p:spPr>
+          <a:xfrm>
+            <a:off x="5074920" y="3877056"/>
+            <a:ext cx="3657600" cy="411480"/>
+          </a:xfrm>
+          <a:prstGeom prst="rect">
+            <a:avLst/>
+          </a:prstGeom>
+          <a:noFill/>
+          <a:ln/>
+        </p:spPr>
+        <p:txBody>
+          <a:bodyPr wrap="square" rtlCol="0" anchor="ctr"/>
+          <a:lstStyle/>
+          <a:p>
+            <a:pPr marL="0" indent="0">
+              <a:buNone/>
+            </a:pPr>
+            <a:r>
+              <a:rPr lang="en-US" sz="1300" dirty="0">
+                <a:solidFill>
+                  <a:srgbClr val="888888"/>
+                </a:solidFill>
+                <a:latin typeface="Arial" pitchFamily="34" charset="0"/>
+                <a:ea typeface="Arial" pitchFamily="34" charset="-122"/>
+                <a:cs typeface="Arial" pitchFamily="34" charset="-120"/>
+              </a:rPr>
+              <a:t>University resources only · HTML, CSS, JavaScript · 4-week delivery window</a:t>
+            </a:r>
+            <a:endParaRPr lang="en-US" sz="1300" dirty="0"/>
+          </a:p>
+        </p:txBody>
+      </p:sp>
+      <p:sp>
+        <p:nvSpPr>
+          <p:cNvPr id="26" name="Shape 24"/>
+          <p:cNvSpPr/>
+          <p:nvPr/>
+        </p:nvSpPr>
+        <p:spPr>
+          <a:xfrm>
+            <a:off x="457200" y="4334256"/>
+            <a:ext cx="8229600" cy="10973"/>
+          </a:xfrm>
+          <a:prstGeom prst="rect">
+            <a:avLst/>
+          </a:prstGeom>
+          <a:solidFill>
+            <a:srgbClr val="EEEEEE"/>
+          </a:solidFill>
+          <a:ln/>
+        </p:spPr>
+        <p:txBody>
+          <a:bodyPr/>
+          <a:lstStyle/>
+          <a:p>
+            <a:endParaRPr lang="en-GB"/>
+          </a:p>
+        </p:txBody>
+      </p:sp>
+    </p:spTree>
+  </p:cSld>
+  <p:clrMapOvr>
+    <a:masterClrMapping/>
+  </p:clrMapOvr>
+</p:sld>
+</file>
+
+<file path=ppt/slides/slide20.xml><?xml version="1.0" encoding="utf-8"?>
 <p:sld xmlns:a="http://schemas.openxmlformats.org/drawingml/2006/main" xmlns:r="http://schemas.openxmlformats.org/officeDocument/2006/relationships" xmlns:p="http://schemas.openxmlformats.org/presentationml/2006/main">
   <p:cSld name="Slide 18">
     <p:bg>
@@ -6587,7 +8144,7 @@
 </p:sld>
 </file>
 
-<file path=ppt/slides/slide2.xml><?xml version="1.0" encoding="utf-8"?>
+<file path=ppt/slides/slide3.xml><?xml version="1.0" encoding="utf-8"?>
 <p:sld xmlns:a="http://schemas.openxmlformats.org/drawingml/2006/main" xmlns:r="http://schemas.openxmlformats.org/officeDocument/2006/relationships" xmlns:p="http://schemas.openxmlformats.org/presentationml/2006/main">
   <p:cSld name="Slide 3">
     <p:bg>
@@ -6792,7 +8349,7 @@
 </p:sld>
 </file>
 
-<file path=ppt/slides/slide3.xml><?xml version="1.0" encoding="utf-8"?>
+<file path=ppt/slides/slide4.xml><?xml version="1.0" encoding="utf-8"?>
 <p:sld xmlns:a="http://schemas.openxmlformats.org/drawingml/2006/main" xmlns:r="http://schemas.openxmlformats.org/officeDocument/2006/relationships" xmlns:p="http://schemas.openxmlformats.org/presentationml/2006/main">
   <p:cSld name="Slide 4">
     <p:bg>
@@ -7591,7 +9148,7 @@
 </p:sld>
 </file>
 
-<file path=ppt/slides/slide4.xml><?xml version="1.0" encoding="utf-8"?>
+<file path=ppt/slides/slide5.xml><?xml version="1.0" encoding="utf-8"?>
 <p:sld xmlns:a="http://schemas.openxmlformats.org/drawingml/2006/main" xmlns:r="http://schemas.openxmlformats.org/officeDocument/2006/relationships" xmlns:p="http://schemas.openxmlformats.org/presentationml/2006/main">
   <p:cSld name="Slide 5">
     <p:bg>
@@ -7818,7 +9375,7 @@
 </p:sld>
 </file>
 
-<file path=ppt/slides/slide5.xml><?xml version="1.0" encoding="utf-8"?>
+<file path=ppt/slides/slide6.xml><?xml version="1.0" encoding="utf-8"?>
 <p:sld xmlns:a="http://schemas.openxmlformats.org/drawingml/2006/main" xmlns:r="http://schemas.openxmlformats.org/officeDocument/2006/relationships" xmlns:p="http://schemas.openxmlformats.org/presentationml/2006/main">
   <p:cSld name="Slide 6">
     <p:bg>
@@ -8472,7 +10029,7 @@
 </p:sld>
 </file>
 
-<file path=ppt/slides/slide6.xml><?xml version="1.0" encoding="utf-8"?>
+<file path=ppt/slides/slide7.xml><?xml version="1.0" encoding="utf-8"?>
 <p:sld xmlns:a="http://schemas.openxmlformats.org/drawingml/2006/main" xmlns:r="http://schemas.openxmlformats.org/officeDocument/2006/relationships" xmlns:p="http://schemas.openxmlformats.org/presentationml/2006/main">
   <p:cSld name="Slide 7">
     <p:bg>
@@ -8951,7 +10508,7 @@
 </p:sld>
 </file>
 
-<file path=ppt/slides/slide7.xml><?xml version="1.0" encoding="utf-8"?>
+<file path=ppt/slides/slide8.xml><?xml version="1.0" encoding="utf-8"?>
 <p:sld xmlns:a="http://schemas.openxmlformats.org/drawingml/2006/main" xmlns:r="http://schemas.openxmlformats.org/officeDocument/2006/relationships" xmlns:p="http://schemas.openxmlformats.org/presentationml/2006/main">
   <p:cSld name="Slide 8">
     <p:bg>
@@ -9710,7 +11267,7 @@
 </p:sld>
 </file>
 
-<file path=ppt/slides/slide8.xml><?xml version="1.0" encoding="utf-8"?>
+<file path=ppt/slides/slide9.xml><?xml version="1.0" encoding="utf-8"?>
 <p:sld xmlns:a="http://schemas.openxmlformats.org/drawingml/2006/main" xmlns:r="http://schemas.openxmlformats.org/officeDocument/2006/relationships" xmlns:p="http://schemas.openxmlformats.org/presentationml/2006/main">
   <p:cSld name="Slide 9">
     <p:bg>
@@ -10498,706 +12055,6 @@
               <a:t>Bug hunt, final fixes, review before submission.</a:t>
             </a:r>
             <a:endParaRPr lang="en-US" sz="1200" dirty="0"/>
-          </a:p>
-        </p:txBody>
-      </p:sp>
-    </p:spTree>
-  </p:cSld>
-  <p:clrMapOvr>
-    <a:masterClrMapping/>
-  </p:clrMapOvr>
-</p:sld>
-</file>
-
-<file path=ppt/slides/slide9.xml><?xml version="1.0" encoding="utf-8"?>
-<p:sld xmlns:a="http://schemas.openxmlformats.org/drawingml/2006/main" xmlns:r="http://schemas.openxmlformats.org/officeDocument/2006/relationships" xmlns:p="http://schemas.openxmlformats.org/presentationml/2006/main">
-  <p:cSld>
-    <p:bg>
-      <p:bgPr>
-        <a:solidFill>
-          <a:srgbClr val="FFFFFF"/>
-        </a:solidFill>
-        <a:effectLst/>
-      </p:bgPr>
-    </p:bg>
-    <p:spTree>
-      <p:nvGrpSpPr>
-        <p:cNvPr id="1" name=""/>
-        <p:cNvGrpSpPr/>
-        <p:nvPr/>
-      </p:nvGrpSpPr>
-      <p:grpSpPr>
-        <a:xfrm>
-          <a:off x="0" y="0"/>
-          <a:ext cx="0" cy="0"/>
-          <a:chOff x="0" y="0"/>
-          <a:chExt cx="0" cy="0"/>
-        </a:xfrm>
-      </p:grpSpPr>
-      <p:sp>
-        <p:nvSpPr>
-          <p:cNvPr id="2" name="TextBox 1"/>
-          <p:cNvSpPr txBox="1"/>
-          <p:nvPr/>
-        </p:nvSpPr>
-        <p:spPr>
-          <a:xfrm>
-            <a:off x="457200" y="256032"/>
-            <a:ext cx="6400800" cy="256032"/>
-          </a:xfrm>
-          <a:prstGeom prst="rect">
-            <a:avLst/>
-          </a:prstGeom>
-          <a:noFill/>
-        </p:spPr>
-        <p:txBody>
-          <a:bodyPr wrap="square">
-            <a:spAutoFit/>
-          </a:bodyPr>
-          <a:lstStyle/>
-          <a:p>
-            <a:pPr algn="l"/>
-            <a:r>
-              <a:rPr sz="1000" b="1" i="0">
-                <a:solidFill>
-                  <a:srgbClr val="888888"/>
-                </a:solidFill>
-              </a:rPr>
-              <a:t>SPRINT OUTCOMES</a:t>
-            </a:r>
-          </a:p>
-        </p:txBody>
-      </p:sp>
-      <p:sp>
-        <p:nvSpPr>
-          <p:cNvPr id="3" name="TextBox 2"/>
-          <p:cNvSpPr txBox="1"/>
-          <p:nvPr/>
-        </p:nvSpPr>
-        <p:spPr>
-          <a:xfrm>
-            <a:off x="3657600" y="4919472"/>
-            <a:ext cx="5212080" cy="182880"/>
-          </a:xfrm>
-          <a:prstGeom prst="rect">
-            <a:avLst/>
-          </a:prstGeom>
-          <a:noFill/>
-        </p:spPr>
-        <p:txBody>
-          <a:bodyPr wrap="square">
-            <a:spAutoFit/>
-          </a:bodyPr>
-          <a:lstStyle/>
-          <a:p>
-            <a:pPr algn="l"/>
-            <a:r>
-              <a:rPr sz="800" b="0" i="0">
-                <a:solidFill>
-                  <a:srgbClr val="888888"/>
-                </a:solidFill>
-              </a:rPr>
-              <a:t>NINJA QUIZ  .  503IT</a:t>
-            </a:r>
-          </a:p>
-        </p:txBody>
-      </p:sp>
-      <p:sp>
-        <p:nvSpPr>
-          <p:cNvPr id="4" name="TextBox 3"/>
-          <p:cNvSpPr txBox="1"/>
-          <p:nvPr/>
-        </p:nvSpPr>
-        <p:spPr>
-          <a:xfrm>
-            <a:off x="457200" y="658368"/>
-            <a:ext cx="8229600" cy="365760"/>
-          </a:xfrm>
-          <a:prstGeom prst="rect">
-            <a:avLst/>
-          </a:prstGeom>
-          <a:noFill/>
-        </p:spPr>
-        <p:txBody>
-          <a:bodyPr wrap="square">
-            <a:spAutoFit/>
-          </a:bodyPr>
-          <a:lstStyle/>
-          <a:p>
-            <a:pPr algn="l"/>
-            <a:r>
-              <a:rPr sz="1500" b="1" i="0">
-                <a:solidFill>
-                  <a:srgbClr val="111111"/>
-                </a:solidFill>
-              </a:rPr>
-              <a:t>What each sprint delivered — and what it taught the team.</a:t>
-            </a:r>
-          </a:p>
-        </p:txBody>
-      </p:sp>
-      <p:sp>
-        <p:nvSpPr>
-          <p:cNvPr id="5" name="TextBox 4"/>
-          <p:cNvSpPr txBox="1"/>
-          <p:nvPr/>
-        </p:nvSpPr>
-        <p:spPr>
-          <a:xfrm>
-            <a:off x="457200" y="1188720"/>
-            <a:ext cx="640080" cy="274320"/>
-          </a:xfrm>
-          <a:prstGeom prst="rect">
-            <a:avLst/>
-          </a:prstGeom>
-          <a:noFill/>
-        </p:spPr>
-        <p:txBody>
-          <a:bodyPr wrap="square">
-            <a:spAutoFit/>
-          </a:bodyPr>
-          <a:lstStyle/>
-          <a:p>
-            <a:pPr algn="l"/>
-            <a:r>
-              <a:rPr sz="1200" b="1" i="0">
-                <a:solidFill>
-                  <a:srgbClr val="FFCD00"/>
-                </a:solidFill>
-              </a:rPr>
-              <a:t>01</a:t>
-            </a:r>
-          </a:p>
-        </p:txBody>
-      </p:sp>
-      <p:sp>
-        <p:nvSpPr>
-          <p:cNvPr id="6" name="TextBox 5"/>
-          <p:cNvSpPr txBox="1"/>
-          <p:nvPr/>
-        </p:nvSpPr>
-        <p:spPr>
-          <a:xfrm>
-            <a:off x="1188720" y="1188720"/>
-            <a:ext cx="3657600" cy="256032"/>
-          </a:xfrm>
-          <a:prstGeom prst="rect">
-            <a:avLst/>
-          </a:prstGeom>
-          <a:noFill/>
-        </p:spPr>
-        <p:txBody>
-          <a:bodyPr wrap="square">
-            <a:spAutoFit/>
-          </a:bodyPr>
-          <a:lstStyle/>
-          <a:p>
-            <a:pPr algn="l"/>
-            <a:r>
-              <a:rPr sz="1200" b="1" i="0">
-                <a:solidFill>
-                  <a:srgbClr val="111111"/>
-                </a:solidFill>
-              </a:rPr>
-              <a:t>Sprint 1 — Setup &amp; Login</a:t>
-            </a:r>
-          </a:p>
-        </p:txBody>
-      </p:sp>
-      <p:sp>
-        <p:nvSpPr>
-          <p:cNvPr id="7" name="TextBox 6"/>
-          <p:cNvSpPr txBox="1"/>
-          <p:nvPr/>
-        </p:nvSpPr>
-        <p:spPr>
-          <a:xfrm>
-            <a:off x="1188720" y="1463040"/>
-            <a:ext cx="7680960" cy="457200"/>
-          </a:xfrm>
-          <a:prstGeom prst="rect">
-            <a:avLst/>
-          </a:prstGeom>
-          <a:noFill/>
-        </p:spPr>
-        <p:txBody>
-          <a:bodyPr wrap="square">
-            <a:spAutoFit/>
-          </a:bodyPr>
-          <a:lstStyle/>
-          <a:p>
-            <a:pPr algn="l"/>
-            <a:r>
-              <a:rPr sz="900" b="0" i="0">
-                <a:solidFill>
-                  <a:srgbClr val="555555"/>
-                </a:solidFill>
-              </a:rPr>
-              <a:t>Built: auth system, GitHub branches, role structure.</a:t>
-            </a:r>
-          </a:p>
-          <a:p>
-            <a:pPr algn="l"/>
-            <a:r>
-              <a:rPr sz="900" b="0" i="0">
-                <a:solidFill>
-                  <a:srgbClr val="555555"/>
-                </a:solidFill>
-              </a:rPr>
-              <a:t>Learned: agreeing roles before coding prevented overlap and blame.</a:t>
-            </a:r>
-          </a:p>
-        </p:txBody>
-      </p:sp>
-      <p:sp>
-        <p:nvSpPr>
-          <p:cNvPr id="8" name="TextBox 7"/>
-          <p:cNvSpPr txBox="1"/>
-          <p:nvPr/>
-        </p:nvSpPr>
-        <p:spPr>
-          <a:xfrm>
-            <a:off x="457200" y="1938528"/>
-            <a:ext cx="640080" cy="274320"/>
-          </a:xfrm>
-          <a:prstGeom prst="rect">
-            <a:avLst/>
-          </a:prstGeom>
-          <a:noFill/>
-        </p:spPr>
-        <p:txBody>
-          <a:bodyPr wrap="square">
-            <a:spAutoFit/>
-          </a:bodyPr>
-          <a:lstStyle/>
-          <a:p>
-            <a:pPr algn="l"/>
-            <a:r>
-              <a:rPr sz="1200" b="1" i="0">
-                <a:solidFill>
-                  <a:srgbClr val="FFCD00"/>
-                </a:solidFill>
-              </a:rPr>
-              <a:t>02</a:t>
-            </a:r>
-          </a:p>
-        </p:txBody>
-      </p:sp>
-      <p:sp>
-        <p:nvSpPr>
-          <p:cNvPr id="9" name="TextBox 8"/>
-          <p:cNvSpPr txBox="1"/>
-          <p:nvPr/>
-        </p:nvSpPr>
-        <p:spPr>
-          <a:xfrm>
-            <a:off x="1188720" y="1938528"/>
-            <a:ext cx="3657600" cy="256032"/>
-          </a:xfrm>
-          <a:prstGeom prst="rect">
-            <a:avLst/>
-          </a:prstGeom>
-          <a:noFill/>
-        </p:spPr>
-        <p:txBody>
-          <a:bodyPr wrap="square">
-            <a:spAutoFit/>
-          </a:bodyPr>
-          <a:lstStyle/>
-          <a:p>
-            <a:pPr algn="l"/>
-            <a:r>
-              <a:rPr sz="1200" b="1" i="0">
-                <a:solidFill>
-                  <a:srgbClr val="111111"/>
-                </a:solidFill>
-              </a:rPr>
-              <a:t>Sprint 2 — Game Engine</a:t>
-            </a:r>
-          </a:p>
-        </p:txBody>
-      </p:sp>
-      <p:sp>
-        <p:nvSpPr>
-          <p:cNvPr id="10" name="TextBox 9"/>
-          <p:cNvSpPr txBox="1"/>
-          <p:nvPr/>
-        </p:nvSpPr>
-        <p:spPr>
-          <a:xfrm>
-            <a:off x="1188720" y="2212848"/>
-            <a:ext cx="7680960" cy="457200"/>
-          </a:xfrm>
-          <a:prstGeom prst="rect">
-            <a:avLst/>
-          </a:prstGeom>
-          <a:noFill/>
-        </p:spPr>
-        <p:txBody>
-          <a:bodyPr wrap="square">
-            <a:spAutoFit/>
-          </a:bodyPr>
-          <a:lstStyle/>
-          <a:p>
-            <a:pPr algn="l"/>
-            <a:r>
-              <a:rPr sz="900" b="0" i="0">
-                <a:solidFill>
-                  <a:srgbClr val="555555"/>
-                </a:solidFill>
-              </a:rPr>
-              <a:t>Built: core quiz loop, slash mechanic.</a:t>
-            </a:r>
-          </a:p>
-          <a:p>
-            <a:pPr algn="l"/>
-            <a:r>
-              <a:rPr sz="900" b="0" i="0">
-                <a:solidFill>
-                  <a:srgbClr val="555555"/>
-                </a:solidFill>
-              </a:rPr>
-              <a:t>Learned: daily WhatsApp check-ins replaced long weekly catch-ups and kept everyone unblocked.</a:t>
-            </a:r>
-          </a:p>
-        </p:txBody>
-      </p:sp>
-      <p:sp>
-        <p:nvSpPr>
-          <p:cNvPr id="11" name="TextBox 10"/>
-          <p:cNvSpPr txBox="1"/>
-          <p:nvPr/>
-        </p:nvSpPr>
-        <p:spPr>
-          <a:xfrm>
-            <a:off x="457200" y="2688336"/>
-            <a:ext cx="640080" cy="274320"/>
-          </a:xfrm>
-          <a:prstGeom prst="rect">
-            <a:avLst/>
-          </a:prstGeom>
-          <a:noFill/>
-        </p:spPr>
-        <p:txBody>
-          <a:bodyPr wrap="square">
-            <a:spAutoFit/>
-          </a:bodyPr>
-          <a:lstStyle/>
-          <a:p>
-            <a:pPr algn="l"/>
-            <a:r>
-              <a:rPr sz="1200" b="1" i="0">
-                <a:solidFill>
-                  <a:srgbClr val="FFCD00"/>
-                </a:solidFill>
-              </a:rPr>
-              <a:t>03</a:t>
-            </a:r>
-          </a:p>
-        </p:txBody>
-      </p:sp>
-      <p:sp>
-        <p:nvSpPr>
-          <p:cNvPr id="12" name="TextBox 11"/>
-          <p:cNvSpPr txBox="1"/>
-          <p:nvPr/>
-        </p:nvSpPr>
-        <p:spPr>
-          <a:xfrm>
-            <a:off x="1188720" y="2688336"/>
-            <a:ext cx="3657600" cy="256032"/>
-          </a:xfrm>
-          <a:prstGeom prst="rect">
-            <a:avLst/>
-          </a:prstGeom>
-          <a:noFill/>
-        </p:spPr>
-        <p:txBody>
-          <a:bodyPr wrap="square">
-            <a:spAutoFit/>
-          </a:bodyPr>
-          <a:lstStyle/>
-          <a:p>
-            <a:pPr algn="l"/>
-            <a:r>
-              <a:rPr sz="1200" b="1" i="0">
-                <a:solidFill>
-                  <a:srgbClr val="111111"/>
-                </a:solidFill>
-              </a:rPr>
-              <a:t>Sprint 3 — Slicing &amp; Sound</a:t>
-            </a:r>
-          </a:p>
-        </p:txBody>
-      </p:sp>
-      <p:sp>
-        <p:nvSpPr>
-          <p:cNvPr id="13" name="TextBox 12"/>
-          <p:cNvSpPr txBox="1"/>
-          <p:nvPr/>
-        </p:nvSpPr>
-        <p:spPr>
-          <a:xfrm>
-            <a:off x="1188720" y="2962656"/>
-            <a:ext cx="7680960" cy="457200"/>
-          </a:xfrm>
-          <a:prstGeom prst="rect">
-            <a:avLst/>
-          </a:prstGeom>
-          <a:noFill/>
-        </p:spPr>
-        <p:txBody>
-          <a:bodyPr wrap="square">
-            <a:spAutoFit/>
-          </a:bodyPr>
-          <a:lstStyle/>
-          <a:p>
-            <a:pPr algn="l"/>
-            <a:r>
-              <a:rPr sz="900" b="0" i="0">
-                <a:solidFill>
-                  <a:srgbClr val="555555"/>
-                </a:solidFill>
-              </a:rPr>
-              <a:t>Built: animations, visual effects, audio.</a:t>
-            </a:r>
-          </a:p>
-          <a:p>
-            <a:pPr algn="l"/>
-            <a:r>
-              <a:rPr sz="900" b="0" i="0">
-                <a:solidFill>
-                  <a:srgbClr val="555555"/>
-                </a:solidFill>
-              </a:rPr>
-              <a:t>Learned: first merge conflicts taught us to always pull before push — a discipline we kept.</a:t>
-            </a:r>
-          </a:p>
-        </p:txBody>
-      </p:sp>
-      <p:sp>
-        <p:nvSpPr>
-          <p:cNvPr id="14" name="TextBox 13"/>
-          <p:cNvSpPr txBox="1"/>
-          <p:nvPr/>
-        </p:nvSpPr>
-        <p:spPr>
-          <a:xfrm>
-            <a:off x="457200" y="3438144"/>
-            <a:ext cx="640080" cy="274320"/>
-          </a:xfrm>
-          <a:prstGeom prst="rect">
-            <a:avLst/>
-          </a:prstGeom>
-          <a:noFill/>
-        </p:spPr>
-        <p:txBody>
-          <a:bodyPr wrap="square">
-            <a:spAutoFit/>
-          </a:bodyPr>
-          <a:lstStyle/>
-          <a:p>
-            <a:pPr algn="l"/>
-            <a:r>
-              <a:rPr sz="1200" b="1" i="0">
-                <a:solidFill>
-                  <a:srgbClr val="FFCD00"/>
-                </a:solidFill>
-              </a:rPr>
-              <a:t>04</a:t>
-            </a:r>
-          </a:p>
-        </p:txBody>
-      </p:sp>
-      <p:sp>
-        <p:nvSpPr>
-          <p:cNvPr id="15" name="TextBox 14"/>
-          <p:cNvSpPr txBox="1"/>
-          <p:nvPr/>
-        </p:nvSpPr>
-        <p:spPr>
-          <a:xfrm>
-            <a:off x="1188720" y="3438144"/>
-            <a:ext cx="3657600" cy="256032"/>
-          </a:xfrm>
-          <a:prstGeom prst="rect">
-            <a:avLst/>
-          </a:prstGeom>
-          <a:noFill/>
-        </p:spPr>
-        <p:txBody>
-          <a:bodyPr wrap="square">
-            <a:spAutoFit/>
-          </a:bodyPr>
-          <a:lstStyle/>
-          <a:p>
-            <a:pPr algn="l"/>
-            <a:r>
-              <a:rPr sz="1200" b="1" i="0">
-                <a:solidFill>
-                  <a:srgbClr val="111111"/>
-                </a:solidFill>
-              </a:rPr>
-              <a:t>Sprint 4 — Leaderboard &amp; Test</a:t>
-            </a:r>
-          </a:p>
-        </p:txBody>
-      </p:sp>
-      <p:sp>
-        <p:nvSpPr>
-          <p:cNvPr id="16" name="TextBox 15"/>
-          <p:cNvSpPr txBox="1"/>
-          <p:nvPr/>
-        </p:nvSpPr>
-        <p:spPr>
-          <a:xfrm>
-            <a:off x="1188720" y="3712463"/>
-            <a:ext cx="7680960" cy="457200"/>
-          </a:xfrm>
-          <a:prstGeom prst="rect">
-            <a:avLst/>
-          </a:prstGeom>
-          <a:noFill/>
-        </p:spPr>
-        <p:txBody>
-          <a:bodyPr wrap="square">
-            <a:spAutoFit/>
-          </a:bodyPr>
-          <a:lstStyle/>
-          <a:p>
-            <a:pPr algn="l"/>
-            <a:r>
-              <a:rPr sz="900" b="0" i="0">
-                <a:solidFill>
-                  <a:srgbClr val="555555"/>
-                </a:solidFill>
-              </a:rPr>
-              <a:t>Built: scoring, peer testing sessions.</a:t>
-            </a:r>
-          </a:p>
-          <a:p>
-            <a:pPr algn="l"/>
-            <a:r>
-              <a:rPr sz="900" b="0" i="0">
-                <a:solidFill>
-                  <a:srgbClr val="555555"/>
-                </a:solidFill>
-              </a:rPr>
-              <a:t>Learned: external testers found issues we missed — peer testing is essential, not optional.</a:t>
-            </a:r>
-          </a:p>
-        </p:txBody>
-      </p:sp>
-      <p:sp>
-        <p:nvSpPr>
-          <p:cNvPr id="17" name="TextBox 16"/>
-          <p:cNvSpPr txBox="1"/>
-          <p:nvPr/>
-        </p:nvSpPr>
-        <p:spPr>
-          <a:xfrm>
-            <a:off x="457200" y="4187952"/>
-            <a:ext cx="640080" cy="274320"/>
-          </a:xfrm>
-          <a:prstGeom prst="rect">
-            <a:avLst/>
-          </a:prstGeom>
-          <a:noFill/>
-        </p:spPr>
-        <p:txBody>
-          <a:bodyPr wrap="square">
-            <a:spAutoFit/>
-          </a:bodyPr>
-          <a:lstStyle/>
-          <a:p>
-            <a:pPr algn="l"/>
-            <a:r>
-              <a:rPr sz="1200" b="1" i="0">
-                <a:solidFill>
-                  <a:srgbClr val="FFCD00"/>
-                </a:solidFill>
-              </a:rPr>
-              <a:t>05</a:t>
-            </a:r>
-          </a:p>
-        </p:txBody>
-      </p:sp>
-      <p:sp>
-        <p:nvSpPr>
-          <p:cNvPr id="18" name="TextBox 17"/>
-          <p:cNvSpPr txBox="1"/>
-          <p:nvPr/>
-        </p:nvSpPr>
-        <p:spPr>
-          <a:xfrm>
-            <a:off x="1188720" y="4187952"/>
-            <a:ext cx="3657600" cy="256032"/>
-          </a:xfrm>
-          <a:prstGeom prst="rect">
-            <a:avLst/>
-          </a:prstGeom>
-          <a:noFill/>
-        </p:spPr>
-        <p:txBody>
-          <a:bodyPr wrap="square">
-            <a:spAutoFit/>
-          </a:bodyPr>
-          <a:lstStyle/>
-          <a:p>
-            <a:pPr algn="l"/>
-            <a:r>
-              <a:rPr sz="1200" b="1" i="0">
-                <a:solidFill>
-                  <a:srgbClr val="111111"/>
-                </a:solidFill>
-              </a:rPr>
-              <a:t>Sprint 5 — Polish &amp; Submit</a:t>
-            </a:r>
-          </a:p>
-        </p:txBody>
-      </p:sp>
-      <p:sp>
-        <p:nvSpPr>
-          <p:cNvPr id="19" name="TextBox 18"/>
-          <p:cNvSpPr txBox="1"/>
-          <p:nvPr/>
-        </p:nvSpPr>
-        <p:spPr>
-          <a:xfrm>
-            <a:off x="1188720" y="4462272"/>
-            <a:ext cx="7680960" cy="457200"/>
-          </a:xfrm>
-          <a:prstGeom prst="rect">
-            <a:avLst/>
-          </a:prstGeom>
-          <a:noFill/>
-        </p:spPr>
-        <p:txBody>
-          <a:bodyPr wrap="square">
-            <a:spAutoFit/>
-          </a:bodyPr>
-          <a:lstStyle/>
-          <a:p>
-            <a:pPr algn="l"/>
-            <a:r>
-              <a:rPr sz="900" b="0" i="0">
-                <a:solidFill>
-                  <a:srgbClr val="555555"/>
-                </a:solidFill>
-              </a:rPr>
-              <a:t>Built: final bug fixes, documentation.</a:t>
-            </a:r>
-          </a:p>
-          <a:p>
-            <a:pPr algn="l"/>
-            <a:r>
-              <a:rPr sz="900" b="0" i="0">
-                <a:solidFill>
-                  <a:srgbClr val="555555"/>
-                </a:solidFill>
-              </a:rPr>
-              <a:t>Learned: a team that communicates daily ships on time. We did.</a:t>
-            </a:r>
           </a:p>
         </p:txBody>
       </p:sp>

</xml_diff>

<commit_message>
pptx: add Belbin roles to all team members on slide 4
</commit_message>
<xml_diff>
--- a/NinjaQuiz-Presentation.pptx
+++ b/NinjaQuiz-Presentation.pptx
@@ -8777,7 +8777,7 @@
                 <a:ea typeface="Arial" pitchFamily="34" charset="-122"/>
                 <a:cs typeface="Arial" pitchFamily="34" charset="-120"/>
               </a:rPr>
-              <a:t>Login and registration system</a:t>
+              <a:t>Implementer — login and registration system</a:t>
             </a:r>
             <a:endParaRPr lang="en-US" sz="1200" dirty="0"/>
           </a:p>
@@ -8896,7 +8896,7 @@
                 <a:ea typeface="Arial" pitchFamily="34" charset="-122"/>
                 <a:cs typeface="Arial" pitchFamily="34" charset="-120"/>
               </a:rPr>
-              <a:t>Question system and countdown timer</a:t>
+              <a:t>Specialist — question system and countdown timer</a:t>
             </a:r>
             <a:endParaRPr lang="en-US" sz="1200" dirty="0"/>
           </a:p>
@@ -9015,7 +9015,7 @@
                 <a:ea typeface="Arial" pitchFamily="34" charset="-122"/>
                 <a:cs typeface="Arial" pitchFamily="34" charset="-120"/>
               </a:rPr>
-              <a:t>Slicing mechanics and visual effects</a:t>
+              <a:t>Completer Finisher — slicing mechanics and visual effects</a:t>
             </a:r>
             <a:endParaRPr lang="en-US" sz="1200" dirty="0"/>
           </a:p>
@@ -9134,7 +9134,7 @@
                 <a:ea typeface="Arial" pitchFamily="34" charset="-122"/>
                 <a:cs typeface="Arial" pitchFamily="34" charset="-120"/>
               </a:rPr>
-              <a:t>Scoring system and results screen</a:t>
+              <a:t>Plant — scoring system and results screen</a:t>
             </a:r>
             <a:endParaRPr lang="en-US" sz="1200" dirty="0"/>
           </a:p>

</xml_diff>